<commit_message>
Switch Unified Team Strategy deck to Optimist Display / Optimist Sans
Co-Authored-By: Claude Opus 5.5 <noreply@anthropic.com>
Claude-Session: https://claude.ai/code/session_01JXKaD9UU8MgeRWUr7sq4Za
</commit_message>
<xml_diff>
--- a/Unified Team Strategy.pptx
+++ b/Unified Team Strategy.pptx
@@ -115,27 +115,27 @@
   <p:extLst>
     <p:ext uri="{521415D9-36F7-43E2-AB2F-B90AF26B5E84}">
       <p14:sectionLst xmlns:p14="http://schemas.microsoft.com/office/powerpoint/2010/main">
-        <p14:section name="Why combine" id="{8ab3bafe-f1e9-d98e-e1cf-756a3fde9200}">
+        <p14:section name="Why combine" id="{133c6a6f-61d8-183a-4696-aa2fb3cf5ae4}">
           <p14:sldIdLst>
             <p14:sldId id="256"/>
             <p14:sldId id="257"/>
           </p14:sldIdLst>
         </p14:section>
-        <p14:section name="How we organize" id="{a2ed3e44-986b-d39b-768d-1a3e900c6768}">
+        <p14:section name="How we organize" id="{76974712-220d-693e-98a6-53b28bd7c958}">
           <p14:sldIdLst>
             <p14:sldId id="258"/>
             <p14:sldId id="259"/>
             <p14:sldId id="260"/>
           </p14:sldIdLst>
         </p14:section>
-        <p14:section name="What we do and how we grow" id="{72fc09b2-23d5-81fa-a102-ed54b486b482}">
+        <p14:section name="What we do and how we grow" id="{503e1cf9-d8a1-6f62-7037-427bc285a78d}">
           <p14:sldIdLst>
             <p14:sldId id="261"/>
             <p14:sldId id="262"/>
             <p14:sldId id="263"/>
           </p14:sldIdLst>
         </p14:section>
-        <p14:section name="Asks" id="{4a88db08-c148-1b6f-7013-fbcbb5285108}">
+        <p14:section name="Asks" id="{58a758c0-5dfe-f639-241f-98e7961de3bc}">
           <p14:sldIdLst>
             <p14:sldId id="264"/>
           </p14:sldIdLst>
@@ -1372,9 +1372,9 @@
                 <a:solidFill>
                   <a:srgbClr val="14213D"/>
                 </a:solidFill>
-                <a:latin typeface="Cambria" pitchFamily="34" charset="0"/>
-                <a:ea typeface="Cambria" pitchFamily="34" charset="-122"/>
-                <a:cs typeface="Cambria" pitchFamily="34" charset="-120"/>
+                <a:latin typeface="Optimist Display" pitchFamily="34" charset="0"/>
+                <a:ea typeface="Optimist Display" pitchFamily="34" charset="-122"/>
+                <a:cs typeface="Optimist Display" pitchFamily="34" charset="-120"/>
               </a:defRPr>
             </a:lvl1pPr>
           </a:lstStyle>
@@ -1418,9 +1418,9 @@
                 <a:solidFill>
                   <a:srgbClr val="6B7280"/>
                 </a:solidFill>
-                <a:latin typeface="Calibri"/>
-                <a:ea typeface="Calibri"/>
-                <a:cs typeface="Calibri"/>
+                <a:latin typeface="Optimist Sans"/>
+                <a:ea typeface="Optimist Sans"/>
+                <a:cs typeface="Optimist Sans"/>
               </a:defRPr>
             </a:lvl1pPr>
           </a:lstStyle>
@@ -1494,9 +1494,9 @@
                 <a:solidFill>
                   <a:srgbClr val="14213D"/>
                 </a:solidFill>
-                <a:latin typeface="Cambria" pitchFamily="34" charset="0"/>
-                <a:ea typeface="Cambria" pitchFamily="34" charset="-122"/>
-                <a:cs typeface="Cambria" pitchFamily="34" charset="-120"/>
+                <a:latin typeface="Optimist Display" pitchFamily="34" charset="0"/>
+                <a:ea typeface="Optimist Display" pitchFamily="34" charset="-122"/>
+                <a:cs typeface="Optimist Display" pitchFamily="34" charset="-120"/>
               </a:defRPr>
             </a:lvl1pPr>
           </a:lstStyle>
@@ -1540,9 +1540,9 @@
                 <a:solidFill>
                   <a:srgbClr val="6B7280"/>
                 </a:solidFill>
-                <a:latin typeface="Calibri"/>
-                <a:ea typeface="Calibri"/>
-                <a:cs typeface="Calibri"/>
+                <a:latin typeface="Optimist Sans"/>
+                <a:ea typeface="Optimist Sans"/>
+                <a:cs typeface="Optimist Sans"/>
               </a:defRPr>
             </a:lvl1pPr>
           </a:lstStyle>
@@ -1645,9 +1645,9 @@
                 <a:solidFill>
                   <a:srgbClr val="6B7280"/>
                 </a:solidFill>
-                <a:latin typeface="Calibri"/>
-                <a:ea typeface="Calibri"/>
-                <a:cs typeface="Calibri"/>
+                <a:latin typeface="Optimist Sans"/>
+                <a:ea typeface="Optimist Sans"/>
+                <a:cs typeface="Optimist Sans"/>
               </a:defRPr>
             </a:lvl1pPr>
           </a:lstStyle>
@@ -1973,9 +1973,9 @@
                 <a:solidFill>
                   <a:srgbClr val="E3A86B"/>
                 </a:solidFill>
-                <a:latin typeface="Calibri" pitchFamily="34" charset="0"/>
-                <a:ea typeface="Calibri" pitchFamily="34" charset="-122"/>
-                <a:cs typeface="Calibri" pitchFamily="34" charset="-120"/>
+                <a:latin typeface="Optimist Sans" pitchFamily="34" charset="0"/>
+                <a:ea typeface="Optimist Sans" pitchFamily="34" charset="-122"/>
+                <a:cs typeface="Optimist Sans" pitchFamily="34" charset="-120"/>
               </a:rPr>
               <a:t>[TEAM NAME] · LEADERSHIP STRATEGY DISCUSSION</a:t>
             </a:r>
@@ -2015,9 +2015,9 @@
                 <a:solidFill>
                   <a:srgbClr val="F7F6F2"/>
                 </a:solidFill>
-                <a:latin typeface="Cambria" pitchFamily="34" charset="0"/>
-                <a:ea typeface="Cambria" pitchFamily="34" charset="-122"/>
-                <a:cs typeface="Cambria" pitchFamily="34" charset="-120"/>
+                <a:latin typeface="Optimist Display" pitchFamily="34" charset="0"/>
+                <a:ea typeface="Optimist Display" pitchFamily="34" charset="-122"/>
+                <a:cs typeface="Optimist Display" pitchFamily="34" charset="-120"/>
               </a:rPr>
               <a:t>Bringing modeling and infrastructure together builds one team for the AI era</a:t>
             </a:r>
@@ -2057,9 +2057,9 @@
                 <a:solidFill>
                   <a:srgbClr val="BFCAD9"/>
                 </a:solidFill>
-                <a:latin typeface="Calibri" pitchFamily="34" charset="0"/>
-                <a:ea typeface="Calibri" pitchFamily="34" charset="-122"/>
-                <a:cs typeface="Calibri" pitchFamily="34" charset="-120"/>
+                <a:latin typeface="Optimist Sans" pitchFamily="34" charset="0"/>
+                <a:ea typeface="Optimist Sans" pitchFamily="34" charset="-122"/>
+                <a:cs typeface="Optimist Sans" pitchFamily="34" charset="-120"/>
               </a:rPr>
               <a:t>A proposal on why we combine, how we organize, and what we do first</a:t>
             </a:r>
@@ -2099,9 +2099,9 @@
                 <a:solidFill>
                   <a:srgbClr val="BFCAD9"/>
                 </a:solidFill>
-                <a:latin typeface="Calibri" pitchFamily="34" charset="0"/>
-                <a:ea typeface="Calibri" pitchFamily="34" charset="-122"/>
-                <a:cs typeface="Calibri" pitchFamily="34" charset="-120"/>
+                <a:latin typeface="Optimist Sans" pitchFamily="34" charset="0"/>
+                <a:ea typeface="Optimist Sans" pitchFamily="34" charset="-122"/>
+                <a:cs typeface="Optimist Sans" pitchFamily="34" charset="-120"/>
               </a:rPr>
               <a:t>[Presenter] · [Organization] · [Date] · Working draft</a:t>
             </a:r>
@@ -2166,9 +2166,9 @@
                 <a:solidFill>
                   <a:srgbClr val="A0521A"/>
                 </a:solidFill>
-                <a:latin typeface="Calibri" pitchFamily="34" charset="0"/>
-                <a:ea typeface="Calibri" pitchFamily="34" charset="-122"/>
-                <a:cs typeface="Calibri" pitchFamily="34" charset="-120"/>
+                <a:latin typeface="Optimist Sans" pitchFamily="34" charset="0"/>
+                <a:ea typeface="Optimist Sans" pitchFamily="34" charset="-122"/>
+                <a:cs typeface="Optimist Sans" pitchFamily="34" charset="-120"/>
               </a:rPr>
               <a:t>WHY COMBINE</a:t>
             </a:r>
@@ -2207,9 +2207,9 @@
                 <a:solidFill>
                   <a:srgbClr val="14213D"/>
                 </a:solidFill>
-                <a:latin typeface="Cambria" pitchFamily="34" charset="0"/>
-                <a:ea typeface="Cambria" pitchFamily="34" charset="-122"/>
-                <a:cs typeface="Cambria" pitchFamily="34" charset="-120"/>
+                <a:latin typeface="Optimist Display" pitchFamily="34" charset="0"/>
+                <a:ea typeface="Optimist Display" pitchFamily="34" charset="-122"/>
+                <a:cs typeface="Optimist Display" pitchFamily="34" charset="-120"/>
               </a:rPr>
               <a:t>Combining the teams pays off long term if we manage three near-term costs deliberately</a:t>
             </a:r>
@@ -2271,9 +2271,9 @@
                 <a:solidFill>
                   <a:srgbClr val="F2C089"/>
                 </a:solidFill>
-                <a:latin typeface="Calibri" pitchFamily="34" charset="0"/>
-                <a:ea typeface="Calibri" pitchFamily="34" charset="-122"/>
-                <a:cs typeface="Calibri" pitchFamily="34" charset="-120"/>
+                <a:latin typeface="Optimist Sans" pitchFamily="34" charset="0"/>
+                <a:ea typeface="Optimist Sans" pitchFamily="34" charset="-122"/>
+                <a:cs typeface="Optimist Sans" pitchFamily="34" charset="-120"/>
               </a:rPr>
               <a:t>LONG-TERM BENEFITS</a:t>
             </a:r>
@@ -2337,9 +2337,9 @@
                 <a:solidFill>
                   <a:srgbClr val="F7F6F2"/>
                 </a:solidFill>
-                <a:latin typeface="Calibri" pitchFamily="34" charset="0"/>
-                <a:ea typeface="Calibri" pitchFamily="34" charset="-122"/>
-                <a:cs typeface="Calibri" pitchFamily="34" charset="-120"/>
+                <a:latin typeface="Optimist Sans" pitchFamily="34" charset="0"/>
+                <a:ea typeface="Optimist Sans" pitchFamily="34" charset="-122"/>
+                <a:cs typeface="Optimist Sans" pitchFamily="34" charset="-120"/>
               </a:rPr>
               <a:t>One owner for AI initiatives</a:t>
             </a:r>
@@ -2379,9 +2379,9 @@
                 <a:solidFill>
                   <a:srgbClr val="D6E4E6"/>
                 </a:solidFill>
-                <a:latin typeface="Calibri" pitchFamily="34" charset="0"/>
-                <a:ea typeface="Calibri" pitchFamily="34" charset="-122"/>
-                <a:cs typeface="Calibri" pitchFamily="34" charset="-120"/>
+                <a:latin typeface="Optimist Sans" pitchFamily="34" charset="0"/>
+                <a:ea typeface="Optimist Sans" pitchFamily="34" charset="-122"/>
+                <a:cs typeface="Optimist Sans" pitchFamily="34" charset="-120"/>
               </a:rPr>
               <a:t>Key AI projects in one org, fewer hand-offs</a:t>
             </a:r>
@@ -2445,9 +2445,9 @@
                 <a:solidFill>
                   <a:srgbClr val="F7F6F2"/>
                 </a:solidFill>
-                <a:latin typeface="Calibri" pitchFamily="34" charset="0"/>
-                <a:ea typeface="Calibri" pitchFamily="34" charset="-122"/>
-                <a:cs typeface="Calibri" pitchFamily="34" charset="-120"/>
+                <a:latin typeface="Optimist Sans" pitchFamily="34" charset="0"/>
+                <a:ea typeface="Optimist Sans" pitchFamily="34" charset="-122"/>
+                <a:cs typeface="Optimist Sans" pitchFamily="34" charset="-120"/>
               </a:rPr>
               <a:t>Less friction</a:t>
             </a:r>
@@ -2487,9 +2487,9 @@
                 <a:solidFill>
                   <a:srgbClr val="D6E4E6"/>
                 </a:solidFill>
-                <a:latin typeface="Calibri" pitchFamily="34" charset="0"/>
-                <a:ea typeface="Calibri" pitchFamily="34" charset="-122"/>
-                <a:cs typeface="Calibri" pitchFamily="34" charset="-120"/>
+                <a:latin typeface="Optimist Sans" pitchFamily="34" charset="0"/>
+                <a:ea typeface="Optimist Sans" pitchFamily="34" charset="-122"/>
+                <a:cs typeface="Optimist Sans" pitchFamily="34" charset="-120"/>
               </a:rPr>
               <a:t>Modelers are no longer an internal customer</a:t>
             </a:r>
@@ -2553,9 +2553,9 @@
                 <a:solidFill>
                   <a:srgbClr val="F7F6F2"/>
                 </a:solidFill>
-                <a:latin typeface="Calibri" pitchFamily="34" charset="0"/>
-                <a:ea typeface="Calibri" pitchFamily="34" charset="-122"/>
-                <a:cs typeface="Calibri" pitchFamily="34" charset="-120"/>
+                <a:latin typeface="Optimist Sans" pitchFamily="34" charset="0"/>
+                <a:ea typeface="Optimist Sans" pitchFamily="34" charset="-122"/>
+                <a:cs typeface="Optimist Sans" pitchFamily="34" charset="-120"/>
               </a:rPr>
               <a:t>One flexible talent pool</a:t>
             </a:r>
@@ -2595,9 +2595,9 @@
                 <a:solidFill>
                   <a:srgbClr val="D6E4E6"/>
                 </a:solidFill>
-                <a:latin typeface="Calibri" pitchFamily="34" charset="0"/>
-                <a:ea typeface="Calibri" pitchFamily="34" charset="-122"/>
-                <a:cs typeface="Calibri" pitchFamily="34" charset="-120"/>
+                <a:latin typeface="Optimist Sans" pitchFamily="34" charset="0"/>
+                <a:ea typeface="Optimist Sans" pitchFamily="34" charset="-122"/>
+                <a:cs typeface="Optimist Sans" pitchFamily="34" charset="-120"/>
               </a:rPr>
               <a:t>Focus on critical work; leaner and nimbler</a:t>
             </a:r>
@@ -2637,9 +2637,9 @@
                 <a:solidFill>
                   <a:srgbClr val="A0521A"/>
                 </a:solidFill>
-                <a:latin typeface="Calibri" pitchFamily="34" charset="0"/>
-                <a:ea typeface="Calibri" pitchFamily="34" charset="-122"/>
-                <a:cs typeface="Calibri" pitchFamily="34" charset="-120"/>
+                <a:latin typeface="Optimist Sans" pitchFamily="34" charset="0"/>
+                <a:ea typeface="Optimist Sans" pitchFamily="34" charset="-122"/>
+                <a:cs typeface="Optimist Sans" pitchFamily="34" charset="-120"/>
               </a:rPr>
               <a:t>NEAR-TERM COST</a:t>
             </a:r>
@@ -2679,9 +2679,9 @@
                 <a:solidFill>
                   <a:srgbClr val="155563"/>
                 </a:solidFill>
-                <a:latin typeface="Calibri" pitchFamily="34" charset="0"/>
-                <a:ea typeface="Calibri" pitchFamily="34" charset="-122"/>
-                <a:cs typeface="Calibri" pitchFamily="34" charset="-120"/>
+                <a:latin typeface="Optimist Sans" pitchFamily="34" charset="0"/>
+                <a:ea typeface="Optimist Sans" pitchFamily="34" charset="-122"/>
+                <a:cs typeface="Optimist Sans" pitchFamily="34" charset="-120"/>
               </a:rPr>
               <a:t>HOW WE ADDRESS IT</a:t>
             </a:r>
@@ -2748,9 +2748,9 @@
                 <a:solidFill>
                   <a:srgbClr val="14213D"/>
                 </a:solidFill>
-                <a:latin typeface="Calibri" pitchFamily="34" charset="0"/>
-                <a:ea typeface="Calibri" pitchFamily="34" charset="-122"/>
-                <a:cs typeface="Calibri" pitchFamily="34" charset="-120"/>
+                <a:latin typeface="Optimist Sans" pitchFamily="34" charset="0"/>
+                <a:ea typeface="Optimist Sans" pitchFamily="34" charset="-122"/>
+                <a:cs typeface="Optimist Sans" pitchFamily="34" charset="-120"/>
               </a:rPr>
               <a:t>Large new model scope</a:t>
             </a:r>
@@ -2790,9 +2790,9 @@
                 <a:solidFill>
                   <a:srgbClr val="4A5568"/>
                 </a:solidFill>
-                <a:latin typeface="Calibri" pitchFamily="34" charset="0"/>
-                <a:ea typeface="Calibri" pitchFamily="34" charset="-122"/>
-                <a:cs typeface="Calibri" pitchFamily="34" charset="-120"/>
+                <a:latin typeface="Optimist Sans" pitchFamily="34" charset="0"/>
+                <a:ea typeface="Optimist Sans" pitchFamily="34" charset="-122"/>
+                <a:cs typeface="Optimist Sans" pitchFamily="34" charset="-120"/>
               </a:rPr>
               <a:t>Dual Risk Rating models</a:t>
             </a:r>
@@ -2879,9 +2879,9 @@
                 <a:solidFill>
                   <a:srgbClr val="155563"/>
                 </a:solidFill>
-                <a:latin typeface="Calibri" pitchFamily="34" charset="0"/>
-                <a:ea typeface="Calibri" pitchFamily="34" charset="-122"/>
-                <a:cs typeface="Calibri" pitchFamily="34" charset="-120"/>
+                <a:latin typeface="Optimist Sans" pitchFamily="34" charset="0"/>
+                <a:ea typeface="Optimist Sans" pitchFamily="34" charset="-122"/>
+                <a:cs typeface="Optimist Sans" pitchFamily="34" charset="-120"/>
               </a:rPr>
               <a:t>[e.g., phased handover; lean on DRR experts in the team]</a:t>
             </a:r>
@@ -2948,9 +2948,9 @@
                 <a:solidFill>
                   <a:srgbClr val="14213D"/>
                 </a:solidFill>
-                <a:latin typeface="Calibri" pitchFamily="34" charset="0"/>
-                <a:ea typeface="Calibri" pitchFamily="34" charset="-122"/>
-                <a:cs typeface="Calibri" pitchFamily="34" charset="-120"/>
+                <a:latin typeface="Optimist Sans" pitchFamily="34" charset="0"/>
+                <a:ea typeface="Optimist Sans" pitchFamily="34" charset="-122"/>
+                <a:cs typeface="Optimist Sans" pitchFamily="34" charset="-120"/>
               </a:rPr>
               <a:t>Leadership gap</a:t>
             </a:r>
@@ -2990,9 +2990,9 @@
                 <a:solidFill>
                   <a:srgbClr val="4A5568"/>
                 </a:solidFill>
-                <a:latin typeface="Calibri" pitchFamily="34" charset="0"/>
-                <a:ea typeface="Calibri" pitchFamily="34" charset="-122"/>
-                <a:cs typeface="Calibri" pitchFamily="34" charset="-120"/>
+                <a:latin typeface="Optimist Sans" pitchFamily="34" charset="0"/>
+                <a:ea typeface="Optimist Sans" pitchFamily="34" charset="-122"/>
+                <a:cs typeface="Optimist Sans" pitchFamily="34" charset="-120"/>
               </a:rPr>
               <a:t>Interim leads left the team</a:t>
             </a:r>
@@ -3079,9 +3079,9 @@
                 <a:solidFill>
                   <a:srgbClr val="155563"/>
                 </a:solidFill>
-                <a:latin typeface="Calibri" pitchFamily="34" charset="0"/>
-                <a:ea typeface="Calibri" pitchFamily="34" charset="-122"/>
-                <a:cs typeface="Calibri" pitchFamily="34" charset="-120"/>
+                <a:latin typeface="Optimist Sans" pitchFamily="34" charset="0"/>
+                <a:ea typeface="Optimist Sans" pitchFamily="34" charset="-122"/>
+                <a:cs typeface="Optimist Sans" pitchFamily="34" charset="-120"/>
               </a:rPr>
               <a:t>[e.g., coaching and backup for direct reports in stretch roles]</a:t>
             </a:r>
@@ -3148,9 +3148,9 @@
                 <a:solidFill>
                   <a:srgbClr val="14213D"/>
                 </a:solidFill>
-                <a:latin typeface="Calibri" pitchFamily="34" charset="0"/>
-                <a:ea typeface="Calibri" pitchFamily="34" charset="-122"/>
-                <a:cs typeface="Calibri" pitchFamily="34" charset="-120"/>
+                <a:latin typeface="Optimist Sans" pitchFamily="34" charset="0"/>
+                <a:ea typeface="Optimist Sans" pitchFamily="34" charset="-122"/>
+                <a:cs typeface="Optimist Sans" pitchFamily="34" charset="-120"/>
               </a:rPr>
               <a:t>Growth and stretch pain</a:t>
             </a:r>
@@ -3190,9 +3190,9 @@
                 <a:solidFill>
                   <a:srgbClr val="4A5568"/>
                 </a:solidFill>
-                <a:latin typeface="Calibri" pitchFamily="34" charset="0"/>
-                <a:ea typeface="Calibri" pitchFamily="34" charset="-122"/>
-                <a:cs typeface="Calibri" pitchFamily="34" charset="-120"/>
+                <a:latin typeface="Optimist Sans" pitchFamily="34" charset="0"/>
+                <a:ea typeface="Optimist Sans" pitchFamily="34" charset="-122"/>
+                <a:cs typeface="Optimist Sans" pitchFamily="34" charset="-120"/>
               </a:rPr>
               <a:t>Load rises as we adapt</a:t>
             </a:r>
@@ -3279,9 +3279,9 @@
                 <a:solidFill>
                   <a:srgbClr val="155563"/>
                 </a:solidFill>
-                <a:latin typeface="Calibri" pitchFamily="34" charset="0"/>
-                <a:ea typeface="Calibri" pitchFamily="34" charset="-122"/>
-                <a:cs typeface="Calibri" pitchFamily="34" charset="-120"/>
+                <a:latin typeface="Optimist Sans" pitchFamily="34" charset="0"/>
+                <a:ea typeface="Optimist Sans" pitchFamily="34" charset="-122"/>
+                <a:cs typeface="Optimist Sans" pitchFamily="34" charset="-120"/>
               </a:rPr>
               <a:t>[e.g., sequence priorities; protect BAU capacity]</a:t>
             </a:r>
@@ -3321,9 +3321,9 @@
                 <a:solidFill>
                   <a:srgbClr val="6B7280"/>
                 </a:solidFill>
-                <a:latin typeface="Calibri" pitchFamily="34" charset="0"/>
-                <a:ea typeface="Calibri" pitchFamily="34" charset="-122"/>
-                <a:cs typeface="Calibri" pitchFamily="34" charset="-120"/>
+                <a:latin typeface="Optimist Sans" pitchFamily="34" charset="0"/>
+                <a:ea typeface="Optimist Sans" pitchFamily="34" charset="-122"/>
+                <a:cs typeface="Optimist Sans" pitchFamily="34" charset="-120"/>
               </a:rPr>
               <a:t>Draft for discussion · Dashed boxes are placeholders to fill</a:t>
             </a:r>
@@ -3363,9 +3363,9 @@
                 <a:solidFill>
                   <a:srgbClr val="6B7280"/>
                 </a:solidFill>
-                <a:latin typeface="Calibri"/>
-                <a:ea typeface="Calibri"/>
-                <a:cs typeface="Calibri"/>
+                <a:latin typeface="Optimist Sans"/>
+                <a:ea typeface="Optimist Sans"/>
+                <a:cs typeface="Optimist Sans"/>
               </a:defRPr>
             </a:lvl1pPr>
           </a:lstStyle>
@@ -3436,9 +3436,9 @@
                 <a:solidFill>
                   <a:srgbClr val="A0521A"/>
                 </a:solidFill>
-                <a:latin typeface="Calibri" pitchFamily="34" charset="0"/>
-                <a:ea typeface="Calibri" pitchFamily="34" charset="-122"/>
-                <a:cs typeface="Calibri" pitchFamily="34" charset="-120"/>
+                <a:latin typeface="Optimist Sans" pitchFamily="34" charset="0"/>
+                <a:ea typeface="Optimist Sans" pitchFamily="34" charset="-122"/>
+                <a:cs typeface="Optimist Sans" pitchFamily="34" charset="-120"/>
               </a:rPr>
               <a:t>TEAM STRUCTURE</a:t>
             </a:r>
@@ -3477,9 +3477,9 @@
                 <a:solidFill>
                   <a:srgbClr val="14213D"/>
                 </a:solidFill>
-                <a:latin typeface="Cambria" pitchFamily="34" charset="0"/>
-                <a:ea typeface="Cambria" pitchFamily="34" charset="-122"/>
-                <a:cs typeface="Cambria" pitchFamily="34" charset="-120"/>
+                <a:latin typeface="Optimist Display" pitchFamily="34" charset="0"/>
+                <a:ea typeface="Optimist Display" pitchFamily="34" charset="-122"/>
+                <a:cs typeface="Optimist Display" pitchFamily="34" charset="-120"/>
               </a:rPr>
               <a:t>Four functions report to one team lead, from run-the-business to change-the-business</a:t>
             </a:r>
@@ -3541,9 +3541,9 @@
                 <a:solidFill>
                   <a:srgbClr val="F7F6F2"/>
                 </a:solidFill>
-                <a:latin typeface="Calibri" pitchFamily="34" charset="0"/>
-                <a:ea typeface="Calibri" pitchFamily="34" charset="-122"/>
-                <a:cs typeface="Calibri" pitchFamily="34" charset="-120"/>
+                <a:latin typeface="Optimist Sans" pitchFamily="34" charset="0"/>
+                <a:ea typeface="Optimist Sans" pitchFamily="34" charset="-122"/>
+                <a:cs typeface="Optimist Sans" pitchFamily="34" charset="-120"/>
               </a:rPr>
               <a:t>[Team] Lead</a:t>
             </a:r>
@@ -3748,9 +3748,9 @@
                 <a:solidFill>
                   <a:srgbClr val="14213D"/>
                 </a:solidFill>
-                <a:latin typeface="Calibri" pitchFamily="34" charset="0"/>
-                <a:ea typeface="Calibri" pitchFamily="34" charset="-122"/>
-                <a:cs typeface="Calibri" pitchFamily="34" charset="-120"/>
+                <a:latin typeface="Optimist Sans" pitchFamily="34" charset="0"/>
+                <a:ea typeface="Optimist Sans" pitchFamily="34" charset="-122"/>
+                <a:cs typeface="Optimist Sans" pitchFamily="34" charset="-120"/>
               </a:rPr>
               <a:t>Modeling &amp; Automation</a:t>
             </a:r>
@@ -3790,9 +3790,9 @@
                 <a:solidFill>
                   <a:srgbClr val="4A5568"/>
                 </a:solidFill>
-                <a:latin typeface="Calibri" pitchFamily="34" charset="0"/>
-                <a:ea typeface="Calibri" pitchFamily="34" charset="-122"/>
-                <a:cs typeface="Calibri" pitchFamily="34" charset="-120"/>
+                <a:latin typeface="Optimist Sans" pitchFamily="34" charset="0"/>
+                <a:ea typeface="Optimist Sans" pitchFamily="34" charset="-122"/>
+                <a:cs typeface="Optimist Sans" pitchFamily="34" charset="-120"/>
               </a:rPr>
               <a:t>Leaner modeling, automated with AI</a:t>
             </a:r>
@@ -3832,9 +3832,9 @@
                 <a:solidFill>
                   <a:srgbClr val="6B7280"/>
                 </a:solidFill>
-                <a:latin typeface="Calibri" pitchFamily="34" charset="0"/>
-                <a:ea typeface="Calibri" pitchFamily="34" charset="-122"/>
-                <a:cs typeface="Calibri" pitchFamily="34" charset="-120"/>
+                <a:latin typeface="Optimist Sans" pitchFamily="34" charset="0"/>
+                <a:ea typeface="Optimist Sans" pitchFamily="34" charset="-122"/>
+                <a:cs typeface="Optimist Sans" pitchFamily="34" charset="-120"/>
               </a:rPr>
               <a:t>Built from</a:t>
             </a:r>
@@ -3896,9 +3896,9 @@
                 <a:solidFill>
                   <a:srgbClr val="14213D"/>
                 </a:solidFill>
-                <a:latin typeface="Calibri" pitchFamily="34" charset="0"/>
-                <a:ea typeface="Calibri" pitchFamily="34" charset="-122"/>
-                <a:cs typeface="Calibri" pitchFamily="34" charset="-120"/>
+                <a:latin typeface="Optimist Sans" pitchFamily="34" charset="0"/>
+                <a:ea typeface="Optimist Sans" pitchFamily="34" charset="-122"/>
+                <a:cs typeface="Optimist Sans" pitchFamily="34" charset="-120"/>
               </a:rPr>
               <a:t>Modeling</a:t>
             </a:r>
@@ -3960,9 +3960,9 @@
                 <a:solidFill>
                   <a:srgbClr val="14213D"/>
                 </a:solidFill>
-                <a:latin typeface="Calibri" pitchFamily="34" charset="0"/>
-                <a:ea typeface="Calibri" pitchFamily="34" charset="-122"/>
-                <a:cs typeface="Calibri" pitchFamily="34" charset="-120"/>
+                <a:latin typeface="Optimist Sans" pitchFamily="34" charset="0"/>
+                <a:ea typeface="Optimist Sans" pitchFamily="34" charset="-122"/>
+                <a:cs typeface="Optimist Sans" pitchFamily="34" charset="-120"/>
               </a:rPr>
               <a:t>Tool build</a:t>
             </a:r>
@@ -4029,9 +4029,9 @@
                 <a:solidFill>
                   <a:srgbClr val="14213D"/>
                 </a:solidFill>
-                <a:latin typeface="Calibri" pitchFamily="34" charset="0"/>
-                <a:ea typeface="Calibri" pitchFamily="34" charset="-122"/>
-                <a:cs typeface="Calibri" pitchFamily="34" charset="-120"/>
+                <a:latin typeface="Optimist Sans" pitchFamily="34" charset="0"/>
+                <a:ea typeface="Optimist Sans" pitchFamily="34" charset="-122"/>
+                <a:cs typeface="Optimist Sans" pitchFamily="34" charset="-120"/>
               </a:rPr>
               <a:t>Data Foundation</a:t>
             </a:r>
@@ -4071,9 +4071,9 @@
                 <a:solidFill>
                   <a:srgbClr val="4A5568"/>
                 </a:solidFill>
-                <a:latin typeface="Calibri" pitchFamily="34" charset="0"/>
-                <a:ea typeface="Calibri" pitchFamily="34" charset="-122"/>
-                <a:cs typeface="Calibri" pitchFamily="34" charset="-120"/>
+                <a:latin typeface="Optimist Sans" pitchFamily="34" charset="0"/>
+                <a:ea typeface="Optimist Sans" pitchFamily="34" charset="-122"/>
+                <a:cs typeface="Optimist Sans" pitchFamily="34" charset="-120"/>
               </a:rPr>
               <a:t>The base every team relies on; may need investment</a:t>
             </a:r>
@@ -4113,9 +4113,9 @@
                 <a:solidFill>
                   <a:srgbClr val="6B7280"/>
                 </a:solidFill>
-                <a:latin typeface="Calibri" pitchFamily="34" charset="0"/>
-                <a:ea typeface="Calibri" pitchFamily="34" charset="-122"/>
-                <a:cs typeface="Calibri" pitchFamily="34" charset="-120"/>
+                <a:latin typeface="Optimist Sans" pitchFamily="34" charset="0"/>
+                <a:ea typeface="Optimist Sans" pitchFamily="34" charset="-122"/>
+                <a:cs typeface="Optimist Sans" pitchFamily="34" charset="-120"/>
               </a:rPr>
               <a:t>Built from</a:t>
             </a:r>
@@ -4177,9 +4177,9 @@
                 <a:solidFill>
                   <a:srgbClr val="14213D"/>
                 </a:solidFill>
-                <a:latin typeface="Calibri" pitchFamily="34" charset="0"/>
-                <a:ea typeface="Calibri" pitchFamily="34" charset="-122"/>
-                <a:cs typeface="Calibri" pitchFamily="34" charset="-120"/>
+                <a:latin typeface="Optimist Sans" pitchFamily="34" charset="0"/>
+                <a:ea typeface="Optimist Sans" pitchFamily="34" charset="-122"/>
+                <a:cs typeface="Optimist Sans" pitchFamily="34" charset="-120"/>
               </a:rPr>
               <a:t>Data team</a:t>
             </a:r>
@@ -4246,9 +4246,9 @@
                 <a:solidFill>
                   <a:srgbClr val="14213D"/>
                 </a:solidFill>
-                <a:latin typeface="Calibri" pitchFamily="34" charset="0"/>
-                <a:ea typeface="Calibri" pitchFamily="34" charset="-122"/>
-                <a:cs typeface="Calibri" pitchFamily="34" charset="-120"/>
+                <a:latin typeface="Optimist Sans" pitchFamily="34" charset="0"/>
+                <a:ea typeface="Optimist Sans" pitchFamily="34" charset="-122"/>
+                <a:cs typeface="Optimist Sans" pitchFamily="34" charset="-120"/>
               </a:rPr>
               <a:t>Platform &amp; Deployment</a:t>
             </a:r>
@@ -4288,9 +4288,9 @@
                 <a:solidFill>
                   <a:srgbClr val="4A5568"/>
                 </a:solidFill>
-                <a:latin typeface="Calibri" pitchFamily="34" charset="0"/>
-                <a:ea typeface="Calibri" pitchFamily="34" charset="-122"/>
-                <a:cs typeface="Calibri" pitchFamily="34" charset="-120"/>
+                <a:latin typeface="Optimist Sans" pitchFamily="34" charset="0"/>
+                <a:ea typeface="Optimist Sans" pitchFamily="34" charset="-122"/>
+                <a:cs typeface="Optimist Sans" pitchFamily="34" charset="-120"/>
               </a:rPr>
               <a:t>Closest to product tech; runs large projects</a:t>
             </a:r>
@@ -4330,9 +4330,9 @@
                 <a:solidFill>
                   <a:srgbClr val="6B7280"/>
                 </a:solidFill>
-                <a:latin typeface="Calibri" pitchFamily="34" charset="0"/>
-                <a:ea typeface="Calibri" pitchFamily="34" charset="-122"/>
-                <a:cs typeface="Calibri" pitchFamily="34" charset="-120"/>
+                <a:latin typeface="Optimist Sans" pitchFamily="34" charset="0"/>
+                <a:ea typeface="Optimist Sans" pitchFamily="34" charset="-122"/>
+                <a:cs typeface="Optimist Sans" pitchFamily="34" charset="-120"/>
               </a:rPr>
               <a:t>Built from</a:t>
             </a:r>
@@ -4394,9 +4394,9 @@
                 <a:solidFill>
                   <a:srgbClr val="14213D"/>
                 </a:solidFill>
-                <a:latin typeface="Calibri" pitchFamily="34" charset="0"/>
-                <a:ea typeface="Calibri" pitchFamily="34" charset="-122"/>
-                <a:cs typeface="Calibri" pitchFamily="34" charset="-120"/>
+                <a:latin typeface="Optimist Sans" pitchFamily="34" charset="0"/>
+                <a:ea typeface="Optimist Sans" pitchFamily="34" charset="-122"/>
+                <a:cs typeface="Optimist Sans" pitchFamily="34" charset="-120"/>
               </a:rPr>
               <a:t>R&amp;D</a:t>
             </a:r>
@@ -4458,9 +4458,9 @@
                 <a:solidFill>
                   <a:srgbClr val="14213D"/>
                 </a:solidFill>
-                <a:latin typeface="Calibri" pitchFamily="34" charset="0"/>
-                <a:ea typeface="Calibri" pitchFamily="34" charset="-122"/>
-                <a:cs typeface="Calibri" pitchFamily="34" charset="-120"/>
+                <a:latin typeface="Optimist Sans" pitchFamily="34" charset="0"/>
+                <a:ea typeface="Optimist Sans" pitchFamily="34" charset="-122"/>
+                <a:cs typeface="Optimist Sans" pitchFamily="34" charset="-120"/>
               </a:rPr>
               <a:t>Deployment</a:t>
             </a:r>
@@ -4527,9 +4527,9 @@
                 <a:solidFill>
                   <a:srgbClr val="F7F6F2"/>
                 </a:solidFill>
-                <a:latin typeface="Calibri" pitchFamily="34" charset="0"/>
-                <a:ea typeface="Calibri" pitchFamily="34" charset="-122"/>
-                <a:cs typeface="Calibri" pitchFamily="34" charset="-120"/>
+                <a:latin typeface="Optimist Sans" pitchFamily="34" charset="0"/>
+                <a:ea typeface="Optimist Sans" pitchFamily="34" charset="-122"/>
+                <a:cs typeface="Optimist Sans" pitchFamily="34" charset="-120"/>
               </a:rPr>
               <a:t>AI Enablement</a:t>
             </a:r>
@@ -4569,9 +4569,9 @@
                 <a:solidFill>
                   <a:srgbClr val="E3E8F0"/>
                 </a:solidFill>
-                <a:latin typeface="Calibri" pitchFamily="34" charset="0"/>
-                <a:ea typeface="Calibri" pitchFamily="34" charset="-122"/>
-                <a:cs typeface="Calibri" pitchFamily="34" charset="-120"/>
+                <a:latin typeface="Optimist Sans" pitchFamily="34" charset="0"/>
+                <a:ea typeface="Optimist Sans" pitchFamily="34" charset="-122"/>
+                <a:cs typeface="Optimist Sans" pitchFamily="34" charset="-120"/>
               </a:rPr>
               <a:t>Builds tools that speed up the other three</a:t>
             </a:r>
@@ -4611,9 +4611,9 @@
                 <a:solidFill>
                   <a:srgbClr val="BFCAD9"/>
                 </a:solidFill>
-                <a:latin typeface="Calibri" pitchFamily="34" charset="0"/>
-                <a:ea typeface="Calibri" pitchFamily="34" charset="-122"/>
-                <a:cs typeface="Calibri" pitchFamily="34" charset="-120"/>
+                <a:latin typeface="Optimist Sans" pitchFamily="34" charset="0"/>
+                <a:ea typeface="Optimist Sans" pitchFamily="34" charset="-122"/>
+                <a:cs typeface="Optimist Sans" pitchFamily="34" charset="-120"/>
               </a:rPr>
               <a:t>Built from</a:t>
             </a:r>
@@ -4675,9 +4675,9 @@
                 <a:solidFill>
                   <a:srgbClr val="14213D"/>
                 </a:solidFill>
-                <a:latin typeface="Calibri" pitchFamily="34" charset="0"/>
-                <a:ea typeface="Calibri" pitchFamily="34" charset="-122"/>
-                <a:cs typeface="Calibri" pitchFamily="34" charset="-120"/>
+                <a:latin typeface="Optimist Sans" pitchFamily="34" charset="0"/>
+                <a:ea typeface="Optimist Sans" pitchFamily="34" charset="-122"/>
+                <a:cs typeface="Optimist Sans" pitchFamily="34" charset="-120"/>
               </a:rPr>
               <a:t>New team</a:t>
             </a:r>
@@ -5517,9 +5517,9 @@
                 <a:solidFill>
                   <a:srgbClr val="4A5568"/>
                 </a:solidFill>
-                <a:latin typeface="Calibri" pitchFamily="34" charset="0"/>
-                <a:ea typeface="Calibri" pitchFamily="34" charset="-122"/>
-                <a:cs typeface="Calibri" pitchFamily="34" charset="-120"/>
+                <a:latin typeface="Optimist Sans" pitchFamily="34" charset="0"/>
+                <a:ea typeface="Optimist Sans" pitchFamily="34" charset="-122"/>
+                <a:cs typeface="Optimist Sans" pitchFamily="34" charset="-120"/>
               </a:rPr>
               <a:t>← Run the business: BAU-heavy</a:t>
             </a:r>
@@ -5559,9 +5559,9 @@
                 <a:solidFill>
                   <a:srgbClr val="4A5568"/>
                 </a:solidFill>
-                <a:latin typeface="Calibri" pitchFamily="34" charset="0"/>
-                <a:ea typeface="Calibri" pitchFamily="34" charset="-122"/>
-                <a:cs typeface="Calibri" pitchFamily="34" charset="-120"/>
+                <a:latin typeface="Optimist Sans" pitchFamily="34" charset="0"/>
+                <a:ea typeface="Optimist Sans" pitchFamily="34" charset="-122"/>
+                <a:cs typeface="Optimist Sans" pitchFamily="34" charset="-120"/>
               </a:rPr>
               <a:t>Change the business: least BAU →</a:t>
             </a:r>
@@ -5601,9 +5601,9 @@
                 <a:solidFill>
                   <a:srgbClr val="6B7280"/>
                 </a:solidFill>
-                <a:latin typeface="Calibri" pitchFamily="34" charset="0"/>
-                <a:ea typeface="Calibri" pitchFamily="34" charset="-122"/>
-                <a:cs typeface="Calibri" pitchFamily="34" charset="-120"/>
+                <a:latin typeface="Optimist Sans" pitchFamily="34" charset="0"/>
+                <a:ea typeface="Optimist Sans" pitchFamily="34" charset="-122"/>
+                <a:cs typeface="Optimist Sans" pitchFamily="34" charset="-120"/>
               </a:rPr>
               <a:t>Draft for discussion</a:t>
             </a:r>
@@ -5643,9 +5643,9 @@
                 <a:solidFill>
                   <a:srgbClr val="6B7280"/>
                 </a:solidFill>
-                <a:latin typeface="Calibri"/>
-                <a:ea typeface="Calibri"/>
-                <a:cs typeface="Calibri"/>
+                <a:latin typeface="Optimist Sans"/>
+                <a:ea typeface="Optimist Sans"/>
+                <a:cs typeface="Optimist Sans"/>
               </a:defRPr>
             </a:lvl1pPr>
           </a:lstStyle>
@@ -5716,9 +5716,9 @@
                 <a:solidFill>
                   <a:srgbClr val="A0521A"/>
                 </a:solidFill>
-                <a:latin typeface="Calibri" pitchFamily="34" charset="0"/>
-                <a:ea typeface="Calibri" pitchFamily="34" charset="-122"/>
-                <a:cs typeface="Calibri" pitchFamily="34" charset="-120"/>
+                <a:latin typeface="Optimist Sans" pitchFamily="34" charset="0"/>
+                <a:ea typeface="Optimist Sans" pitchFamily="34" charset="-122"/>
+                <a:cs typeface="Optimist Sans" pitchFamily="34" charset="-120"/>
               </a:rPr>
               <a:t>HEADCOUNT STRATEGY</a:t>
             </a:r>
@@ -5757,9 +5757,9 @@
                 <a:solidFill>
                   <a:srgbClr val="14213D"/>
                 </a:solidFill>
-                <a:latin typeface="Cambria" pitchFamily="34" charset="0"/>
-                <a:ea typeface="Cambria" pitchFamily="34" charset="-122"/>
-                <a:cs typeface="Cambria" pitchFamily="34" charset="-120"/>
+                <a:latin typeface="Optimist Display" pitchFamily="34" charset="0"/>
+                <a:ea typeface="Optimist Display" pitchFamily="34" charset="-122"/>
+                <a:cs typeface="Optimist Display" pitchFamily="34" charset="-120"/>
               </a:rPr>
               <a:t>AI shrinks BAU down to a firm risk floor, and the freed capacity builds AI work from near zero</a:t>
             </a:r>
@@ -5799,9 +5799,9 @@
                 <a:solidFill>
                   <a:srgbClr val="14213D"/>
                 </a:solidFill>
-                <a:latin typeface="Calibri" pitchFamily="34" charset="0"/>
-                <a:ea typeface="Calibri" pitchFamily="34" charset="-122"/>
-                <a:cs typeface="Calibri" pitchFamily="34" charset="-120"/>
+                <a:latin typeface="Optimist Sans" pitchFamily="34" charset="0"/>
+                <a:ea typeface="Optimist Sans" pitchFamily="34" charset="-122"/>
+                <a:cs typeface="Optimist Sans" pitchFamily="34" charset="-120"/>
               </a:rPr>
               <a:t>Today</a:t>
             </a:r>
@@ -5841,9 +5841,9 @@
                 <a:solidFill>
                   <a:srgbClr val="6B7280"/>
                 </a:solidFill>
-                <a:latin typeface="Calibri" pitchFamily="34" charset="0"/>
-                <a:ea typeface="Calibri" pitchFamily="34" charset="-122"/>
-                <a:cs typeface="Calibri" pitchFamily="34" charset="-120"/>
+                <a:latin typeface="Optimist Sans" pitchFamily="34" charset="0"/>
+                <a:ea typeface="Optimist Sans" pitchFamily="34" charset="-122"/>
+                <a:cs typeface="Optimist Sans" pitchFamily="34" charset="-120"/>
               </a:rPr>
               <a:t>~[30] associates</a:t>
             </a:r>
@@ -5903,9 +5903,9 @@
                 <a:solidFill>
                   <a:srgbClr val="F7F6F2"/>
                 </a:solidFill>
-                <a:latin typeface="Calibri" pitchFamily="34" charset="0"/>
-                <a:ea typeface="Calibri" pitchFamily="34" charset="-122"/>
-                <a:cs typeface="Calibri" pitchFamily="34" charset="-120"/>
+                <a:latin typeface="Optimist Sans" pitchFamily="34" charset="0"/>
+                <a:ea typeface="Optimist Sans" pitchFamily="34" charset="-122"/>
+                <a:cs typeface="Optimist Sans" pitchFamily="34" charset="-120"/>
               </a:rPr>
               <a:t>BAU / run the business · ~100%</a:t>
             </a:r>
@@ -5965,9 +5965,9 @@
                 <a:solidFill>
                   <a:srgbClr val="8A4514"/>
                 </a:solidFill>
-                <a:latin typeface="Calibri" pitchFamily="34" charset="0"/>
-                <a:ea typeface="Calibri" pitchFamily="34" charset="-122"/>
-                <a:cs typeface="Calibri" pitchFamily="34" charset="-120"/>
+                <a:latin typeface="Optimist Sans" pitchFamily="34" charset="0"/>
+                <a:ea typeface="Optimist Sans" pitchFamily="34" charset="-122"/>
+                <a:cs typeface="Optimist Sans" pitchFamily="34" charset="-120"/>
               </a:rPr>
               <a:t>AI ≈ 0</a:t>
             </a:r>
@@ -6007,9 +6007,9 @@
                 <a:solidFill>
                   <a:srgbClr val="14213D"/>
                 </a:solidFill>
-                <a:latin typeface="Calibri" pitchFamily="34" charset="0"/>
-                <a:ea typeface="Calibri" pitchFamily="34" charset="-122"/>
-                <a:cs typeface="Calibri" pitchFamily="34" charset="-120"/>
+                <a:latin typeface="Optimist Sans" pitchFamily="34" charset="0"/>
+                <a:ea typeface="Optimist Sans" pitchFamily="34" charset="-122"/>
+                <a:cs typeface="Optimist Sans" pitchFamily="34" charset="-120"/>
               </a:rPr>
               <a:t>Target</a:t>
             </a:r>
@@ -6049,9 +6049,9 @@
                 <a:solidFill>
                   <a:srgbClr val="6B7280"/>
                 </a:solidFill>
-                <a:latin typeface="Calibri" pitchFamily="34" charset="0"/>
-                <a:ea typeface="Calibri" pitchFamily="34" charset="-122"/>
-                <a:cs typeface="Calibri" pitchFamily="34" charset="-120"/>
+                <a:latin typeface="Optimist Sans" pitchFamily="34" charset="0"/>
+                <a:ea typeface="Optimist Sans" pitchFamily="34" charset="-122"/>
+                <a:cs typeface="Optimist Sans" pitchFamily="34" charset="-120"/>
               </a:rPr>
               <a:t>~[__] associates</a:t>
             </a:r>
@@ -6111,9 +6111,9 @@
                 <a:solidFill>
                   <a:srgbClr val="F7F6F2"/>
                 </a:solidFill>
-                <a:latin typeface="Calibri" pitchFamily="34" charset="0"/>
-                <a:ea typeface="Calibri" pitchFamily="34" charset="-122"/>
-                <a:cs typeface="Calibri" pitchFamily="34" charset="-120"/>
+                <a:latin typeface="Optimist Sans" pitchFamily="34" charset="0"/>
+                <a:ea typeface="Optimist Sans" pitchFamily="34" charset="-122"/>
+                <a:cs typeface="Optimist Sans" pitchFamily="34" charset="-120"/>
               </a:rPr>
               <a:t>BAU · [__]%</a:t>
             </a:r>
@@ -6173,9 +6173,9 @@
                 <a:solidFill>
                   <a:srgbClr val="14213D"/>
                 </a:solidFill>
-                <a:latin typeface="Calibri" pitchFamily="34" charset="0"/>
-                <a:ea typeface="Calibri" pitchFamily="34" charset="-122"/>
-                <a:cs typeface="Calibri" pitchFamily="34" charset="-120"/>
+                <a:latin typeface="Optimist Sans" pitchFamily="34" charset="0"/>
+                <a:ea typeface="Optimist Sans" pitchFamily="34" charset="-122"/>
+                <a:cs typeface="Optimist Sans" pitchFamily="34" charset="-120"/>
               </a:rPr>
               <a:t>AI &amp; change · [__]%</a:t>
             </a:r>
@@ -6240,9 +6240,9 @@
                 <a:solidFill>
                   <a:srgbClr val="4A5568"/>
                 </a:solidFill>
-                <a:latin typeface="Calibri" pitchFamily="34" charset="0"/>
-                <a:ea typeface="Calibri" pitchFamily="34" charset="-122"/>
-                <a:cs typeface="Calibri" pitchFamily="34" charset="-120"/>
+                <a:latin typeface="Optimist Sans" pitchFamily="34" charset="0"/>
+                <a:ea typeface="Optimist Sans" pitchFamily="34" charset="-122"/>
+                <a:cs typeface="Optimist Sans" pitchFamily="34" charset="-120"/>
               </a:rPr>
               <a:t>Net −?</a:t>
             </a:r>
@@ -6302,9 +6302,9 @@
                 <a:solidFill>
                   <a:srgbClr val="8A4514"/>
                 </a:solidFill>
-                <a:latin typeface="Calibri" pitchFamily="34" charset="0"/>
-                <a:ea typeface="Calibri" pitchFamily="34" charset="-122"/>
-                <a:cs typeface="Calibri" pitchFamily="34" charset="-120"/>
+                <a:latin typeface="Optimist Sans" pitchFamily="34" charset="0"/>
+                <a:ea typeface="Optimist Sans" pitchFamily="34" charset="-122"/>
+                <a:cs typeface="Optimist Sans" pitchFamily="34" charset="-120"/>
               </a:rPr>
               <a:t>↑ BAU floor: key-person / op risk</a:t>
             </a:r>
@@ -6344,9 +6344,9 @@
                 <a:solidFill>
                   <a:srgbClr val="6B7280"/>
                 </a:solidFill>
-                <a:latin typeface="Calibri" pitchFamily="34" charset="0"/>
-                <a:ea typeface="Calibri" pitchFamily="34" charset="-122"/>
-                <a:cs typeface="Calibri" pitchFamily="34" charset="-120"/>
+                <a:latin typeface="Optimist Sans" pitchFamily="34" charset="0"/>
+                <a:ea typeface="Optimist Sans" pitchFamily="34" charset="-122"/>
+                <a:cs typeface="Optimist Sans" pitchFamily="34" charset="-120"/>
               </a:rPr>
               <a:t>Illustrative mix; fill with actual shares. BAU can shrink to the floor, never below it.</a:t>
             </a:r>
@@ -6437,9 +6437,9 @@
                 <a:solidFill>
                   <a:srgbClr val="14213D"/>
                 </a:solidFill>
-                <a:latin typeface="Calibri" pitchFamily="34" charset="0"/>
-                <a:ea typeface="Calibri" pitchFamily="34" charset="-122"/>
-                <a:cs typeface="Calibri" pitchFamily="34" charset="-120"/>
+                <a:latin typeface="Optimist Sans" pitchFamily="34" charset="0"/>
+                <a:ea typeface="Optimist Sans" pitchFamily="34" charset="-122"/>
+                <a:cs typeface="Optimist Sans" pitchFamily="34" charset="-120"/>
               </a:rPr>
               <a:t>AI shrinks BAU effort</a:t>
             </a:r>
@@ -6479,9 +6479,9 @@
                 <a:solidFill>
                   <a:srgbClr val="4A5568"/>
                 </a:solidFill>
-                <a:latin typeface="Calibri" pitchFamily="34" charset="0"/>
-                <a:ea typeface="Calibri" pitchFamily="34" charset="-122"/>
-                <a:cs typeface="Calibri" pitchFamily="34" charset="-120"/>
+                <a:latin typeface="Optimist Sans" pitchFamily="34" charset="0"/>
+                <a:ea typeface="Optimist Sans" pitchFamily="34" charset="-122"/>
+                <a:cs typeface="Optimist Sans" pitchFamily="34" charset="-120"/>
               </a:rPr>
               <a:t>Automation and new tools cut the people needed to run today’s work.</a:t>
             </a:r>
@@ -6572,9 +6572,9 @@
                 <a:solidFill>
                   <a:srgbClr val="F7F6F2"/>
                 </a:solidFill>
-                <a:latin typeface="Calibri" pitchFamily="34" charset="0"/>
-                <a:ea typeface="Calibri" pitchFamily="34" charset="-122"/>
-                <a:cs typeface="Calibri" pitchFamily="34" charset="-120"/>
+                <a:latin typeface="Optimist Sans" pitchFamily="34" charset="0"/>
+                <a:ea typeface="Optimist Sans" pitchFamily="34" charset="-122"/>
+                <a:cs typeface="Optimist Sans" pitchFamily="34" charset="-120"/>
               </a:rPr>
               <a:t>…but BAU has a firm floor</a:t>
             </a:r>
@@ -6614,9 +6614,9 @@
                 <a:solidFill>
                   <a:srgbClr val="E3EEF0"/>
                 </a:solidFill>
-                <a:latin typeface="Calibri" pitchFamily="34" charset="0"/>
-                <a:ea typeface="Calibri" pitchFamily="34" charset="-122"/>
-                <a:cs typeface="Calibri" pitchFamily="34" charset="-120"/>
+                <a:latin typeface="Optimist Sans" pitchFamily="34" charset="0"/>
+                <a:ea typeface="Optimist Sans" pitchFamily="34" charset="-122"/>
+                <a:cs typeface="Optimist Sans" pitchFamily="34" charset="-120"/>
               </a:rPr>
               <a:t>Set by operational risk: no critical function (e.g., deployment) rests on one person.</a:t>
             </a:r>
@@ -6707,9 +6707,9 @@
                 <a:solidFill>
                   <a:srgbClr val="14213D"/>
                 </a:solidFill>
-                <a:latin typeface="Calibri" pitchFamily="34" charset="0"/>
-                <a:ea typeface="Calibri" pitchFamily="34" charset="-122"/>
-                <a:cs typeface="Calibri" pitchFamily="34" charset="-120"/>
+                <a:latin typeface="Optimist Sans" pitchFamily="34" charset="0"/>
+                <a:ea typeface="Optimist Sans" pitchFamily="34" charset="-122"/>
+                <a:cs typeface="Optimist Sans" pitchFamily="34" charset="-120"/>
               </a:rPr>
               <a:t>Freed capacity builds AI</a:t>
             </a:r>
@@ -6749,9 +6749,9 @@
                 <a:solidFill>
                   <a:srgbClr val="4A5568"/>
                 </a:solidFill>
-                <a:latin typeface="Calibri" pitchFamily="34" charset="0"/>
-                <a:ea typeface="Calibri" pitchFamily="34" charset="-122"/>
-                <a:cs typeface="Calibri" pitchFamily="34" charset="-120"/>
+                <a:latin typeface="Optimist Sans" pitchFamily="34" charset="0"/>
+                <a:ea typeface="Optimist Sans" pitchFamily="34" charset="-122"/>
+                <a:cs typeface="Optimist Sans" pitchFamily="34" charset="-120"/>
               </a:rPr>
               <a:t>From near zero today to AI Enablement and Platform (previous slide).</a:t>
             </a:r>
@@ -6791,9 +6791,9 @@
                 <a:solidFill>
                   <a:srgbClr val="6B7280"/>
                 </a:solidFill>
-                <a:latin typeface="Calibri" pitchFamily="34" charset="0"/>
-                <a:ea typeface="Calibri" pitchFamily="34" charset="-122"/>
-                <a:cs typeface="Calibri" pitchFamily="34" charset="-120"/>
+                <a:latin typeface="Optimist Sans" pitchFamily="34" charset="0"/>
+                <a:ea typeface="Optimist Sans" pitchFamily="34" charset="-122"/>
+                <a:cs typeface="Optimist Sans" pitchFamily="34" charset="-120"/>
               </a:rPr>
               <a:t>Draft for discussion</a:t>
             </a:r>
@@ -6833,9 +6833,9 @@
                 <a:solidFill>
                   <a:srgbClr val="6B7280"/>
                 </a:solidFill>
-                <a:latin typeface="Calibri"/>
-                <a:ea typeface="Calibri"/>
-                <a:cs typeface="Calibri"/>
+                <a:latin typeface="Optimist Sans"/>
+                <a:ea typeface="Optimist Sans"/>
+                <a:cs typeface="Optimist Sans"/>
               </a:defRPr>
             </a:lvl1pPr>
           </a:lstStyle>
@@ -6906,9 +6906,9 @@
                 <a:solidFill>
                   <a:srgbClr val="A0521A"/>
                 </a:solidFill>
-                <a:latin typeface="Calibri" pitchFamily="34" charset="0"/>
-                <a:ea typeface="Calibri" pitchFamily="34" charset="-122"/>
-                <a:cs typeface="Calibri" pitchFamily="34" charset="-120"/>
+                <a:latin typeface="Optimist Sans" pitchFamily="34" charset="0"/>
+                <a:ea typeface="Optimist Sans" pitchFamily="34" charset="-122"/>
+                <a:cs typeface="Optimist Sans" pitchFamily="34" charset="-120"/>
               </a:rPr>
               <a:t>LOCATION STRATEGY</a:t>
             </a:r>
@@ -6947,9 +6947,9 @@
                 <a:solidFill>
                   <a:srgbClr val="14213D"/>
                 </a:solidFill>
-                <a:latin typeface="Cambria" pitchFamily="34" charset="0"/>
-                <a:ea typeface="Cambria" pitchFamily="34" charset="-122"/>
-                <a:cs typeface="Cambria" pitchFamily="34" charset="-120"/>
+                <a:latin typeface="Optimist Display" pitchFamily="34" charset="0"/>
+                <a:ea typeface="Optimist Display" pitchFamily="34" charset="-122"/>
+                <a:cs typeface="Optimist Display" pitchFamily="34" charset="-120"/>
               </a:rPr>
               <a:t>Two hubs co-locate each function with the partners it works with most</a:t>
             </a:r>
@@ -7040,9 +7040,9 @@
                 <a:solidFill>
                   <a:srgbClr val="14213D"/>
                 </a:solidFill>
-                <a:latin typeface="Calibri" pitchFamily="34" charset="0"/>
-                <a:ea typeface="Calibri" pitchFamily="34" charset="-122"/>
-                <a:cs typeface="Calibri" pitchFamily="34" charset="-120"/>
+                <a:latin typeface="Optimist Sans" pitchFamily="34" charset="0"/>
+                <a:ea typeface="Optimist Sans" pitchFamily="34" charset="-122"/>
+                <a:cs typeface="Optimist Sans" pitchFamily="34" charset="-120"/>
               </a:rPr>
               <a:t>[Office A]</a:t>
             </a:r>
@@ -7082,9 +7082,9 @@
                 <a:solidFill>
                   <a:srgbClr val="155563"/>
                 </a:solidFill>
-                <a:latin typeface="Calibri" pitchFamily="34" charset="0"/>
-                <a:ea typeface="Calibri" pitchFamily="34" charset="-122"/>
-                <a:cs typeface="Calibri" pitchFamily="34" charset="-120"/>
+                <a:latin typeface="Optimist Sans" pitchFamily="34" charset="0"/>
+                <a:ea typeface="Optimist Sans" pitchFamily="34" charset="-122"/>
+                <a:cs typeface="Optimist Sans" pitchFamily="34" charset="-120"/>
               </a:rPr>
               <a:t>STAYS WHERE IT IS TODAY</a:t>
             </a:r>
@@ -7146,9 +7146,9 @@
                 <a:solidFill>
                   <a:srgbClr val="F7F6F2"/>
                 </a:solidFill>
-                <a:latin typeface="Calibri" pitchFamily="34" charset="0"/>
-                <a:ea typeface="Calibri" pitchFamily="34" charset="-122"/>
-                <a:cs typeface="Calibri" pitchFamily="34" charset="-120"/>
+                <a:latin typeface="Optimist Sans" pitchFamily="34" charset="0"/>
+                <a:ea typeface="Optimist Sans" pitchFamily="34" charset="-122"/>
+                <a:cs typeface="Optimist Sans" pitchFamily="34" charset="-120"/>
               </a:rPr>
               <a:t>Modeling &amp; Automation</a:t>
             </a:r>
@@ -7188,9 +7188,9 @@
                 <a:solidFill>
                   <a:srgbClr val="14213D"/>
                 </a:solidFill>
-                <a:latin typeface="Calibri" pitchFamily="34" charset="0"/>
-                <a:ea typeface="Calibri" pitchFamily="34" charset="-122"/>
-                <a:cs typeface="Calibri" pitchFamily="34" charset="-120"/>
+                <a:latin typeface="Optimist Sans" pitchFamily="34" charset="0"/>
+                <a:ea typeface="Optimist Sans" pitchFamily="34" charset="-122"/>
+                <a:cs typeface="Optimist Sans" pitchFamily="34" charset="-120"/>
               </a:rPr>
               <a:t>Why: </a:t>
             </a:r>
@@ -7205,9 +7205,9 @@
                 <a:solidFill>
                   <a:srgbClr val="14213D"/>
                 </a:solidFill>
-                <a:latin typeface="Calibri" pitchFamily="34" charset="0"/>
-                <a:ea typeface="Calibri" pitchFamily="34" charset="-122"/>
-                <a:cs typeface="Calibri" pitchFamily="34" charset="-120"/>
+                <a:latin typeface="Optimist Sans" pitchFamily="34" charset="0"/>
+                <a:ea typeface="Optimist Sans" pitchFamily="34" charset="-122"/>
+                <a:cs typeface="Optimist Sans" pitchFamily="34" charset="-120"/>
               </a:rPr>
               <a:t>the modeling team is already based here. Keeping it here avoids disruption and keeps its expertise.</a:t>
             </a:r>
@@ -7298,9 +7298,9 @@
                 <a:solidFill>
                   <a:srgbClr val="14213D"/>
                 </a:solidFill>
-                <a:latin typeface="Calibri" pitchFamily="34" charset="0"/>
-                <a:ea typeface="Calibri" pitchFamily="34" charset="-122"/>
-                <a:cs typeface="Calibri" pitchFamily="34" charset="-120"/>
+                <a:latin typeface="Optimist Sans" pitchFamily="34" charset="0"/>
+                <a:ea typeface="Optimist Sans" pitchFamily="34" charset="-122"/>
+                <a:cs typeface="Optimist Sans" pitchFamily="34" charset="-120"/>
               </a:rPr>
               <a:t>[Office B]</a:t>
             </a:r>
@@ -7340,9 +7340,9 @@
                 <a:solidFill>
                   <a:srgbClr val="8A4514"/>
                 </a:solidFill>
-                <a:latin typeface="Calibri" pitchFamily="34" charset="0"/>
-                <a:ea typeface="Calibri" pitchFamily="34" charset="-122"/>
-                <a:cs typeface="Calibri" pitchFamily="34" charset="-120"/>
+                <a:latin typeface="Optimist Sans" pitchFamily="34" charset="0"/>
+                <a:ea typeface="Optimist Sans" pitchFamily="34" charset="-122"/>
+                <a:cs typeface="Optimist Sans" pitchFamily="34" charset="-120"/>
               </a:rPr>
               <a:t>CENTERED HERE GOING FORWARD</a:t>
             </a:r>
@@ -7404,9 +7404,9 @@
                 <a:solidFill>
                   <a:srgbClr val="14213D"/>
                 </a:solidFill>
-                <a:latin typeface="Calibri" pitchFamily="34" charset="0"/>
-                <a:ea typeface="Calibri" pitchFamily="34" charset="-122"/>
-                <a:cs typeface="Calibri" pitchFamily="34" charset="-120"/>
+                <a:latin typeface="Optimist Sans" pitchFamily="34" charset="0"/>
+                <a:ea typeface="Optimist Sans" pitchFamily="34" charset="-122"/>
+                <a:cs typeface="Optimist Sans" pitchFamily="34" charset="-120"/>
               </a:rPr>
               <a:t>Data Foundation</a:t>
             </a:r>
@@ -7468,9 +7468,9 @@
                 <a:solidFill>
                   <a:srgbClr val="14213D"/>
                 </a:solidFill>
-                <a:latin typeface="Calibri" pitchFamily="34" charset="0"/>
-                <a:ea typeface="Calibri" pitchFamily="34" charset="-122"/>
-                <a:cs typeface="Calibri" pitchFamily="34" charset="-120"/>
+                <a:latin typeface="Optimist Sans" pitchFamily="34" charset="0"/>
+                <a:ea typeface="Optimist Sans" pitchFamily="34" charset="-122"/>
+                <a:cs typeface="Optimist Sans" pitchFamily="34" charset="-120"/>
               </a:rPr>
               <a:t>Platform &amp; Deployment</a:t>
             </a:r>
@@ -7532,9 +7532,9 @@
                 <a:solidFill>
                   <a:srgbClr val="F7F6F2"/>
                 </a:solidFill>
-                <a:latin typeface="Calibri" pitchFamily="34" charset="0"/>
-                <a:ea typeface="Calibri" pitchFamily="34" charset="-122"/>
-                <a:cs typeface="Calibri" pitchFamily="34" charset="-120"/>
+                <a:latin typeface="Optimist Sans" pitchFamily="34" charset="0"/>
+                <a:ea typeface="Optimist Sans" pitchFamily="34" charset="-122"/>
+                <a:cs typeface="Optimist Sans" pitchFamily="34" charset="-120"/>
               </a:rPr>
               <a:t>AI Enablement</a:t>
             </a:r>
@@ -7574,9 +7574,9 @@
                 <a:solidFill>
                   <a:srgbClr val="14213D"/>
                 </a:solidFill>
-                <a:latin typeface="Calibri" pitchFamily="34" charset="0"/>
-                <a:ea typeface="Calibri" pitchFamily="34" charset="-122"/>
-                <a:cs typeface="Calibri" pitchFamily="34" charset="-120"/>
+                <a:latin typeface="Optimist Sans" pitchFamily="34" charset="0"/>
+                <a:ea typeface="Optimist Sans" pitchFamily="34" charset="-122"/>
+                <a:cs typeface="Optimist Sans" pitchFamily="34" charset="-120"/>
               </a:rPr>
               <a:t>Why: </a:t>
             </a:r>
@@ -7591,9 +7591,9 @@
                 <a:solidFill>
                   <a:srgbClr val="14213D"/>
                 </a:solidFill>
-                <a:latin typeface="Calibri" pitchFamily="34" charset="0"/>
-                <a:ea typeface="Calibri" pitchFamily="34" charset="-122"/>
-                <a:cs typeface="Calibri" pitchFamily="34" charset="-120"/>
+                <a:latin typeface="Optimist Sans" pitchFamily="34" charset="0"/>
+                <a:ea typeface="Optimist Sans" pitchFamily="34" charset="-122"/>
+                <a:cs typeface="Optimist Sans" pitchFamily="34" charset="-120"/>
               </a:rPr>
               <a:t>sits with technology partners and the wider company, and matches where these teams already are.</a:t>
             </a:r>
@@ -7658,9 +7658,9 @@
                 <a:solidFill>
                   <a:srgbClr val="6B7280"/>
                 </a:solidFill>
-                <a:latin typeface="Calibri" pitchFamily="34" charset="0"/>
-                <a:ea typeface="Calibri" pitchFamily="34" charset="-122"/>
-                <a:cs typeface="Calibri" pitchFamily="34" charset="-120"/>
+                <a:latin typeface="Optimist Sans" pitchFamily="34" charset="0"/>
+                <a:ea typeface="Optimist Sans" pitchFamily="34" charset="-122"/>
+                <a:cs typeface="Optimist Sans" pitchFamily="34" charset="-120"/>
               </a:rPr>
               <a:t>One team</a:t>
             </a:r>
@@ -7700,9 +7700,9 @@
                 <a:solidFill>
                   <a:srgbClr val="6B7280"/>
                 </a:solidFill>
-                <a:latin typeface="Calibri" pitchFamily="34" charset="0"/>
-                <a:ea typeface="Calibri" pitchFamily="34" charset="-122"/>
-                <a:cs typeface="Calibri" pitchFamily="34" charset="-120"/>
+                <a:latin typeface="Optimist Sans" pitchFamily="34" charset="0"/>
+                <a:ea typeface="Optimist Sans" pitchFamily="34" charset="-122"/>
+                <a:cs typeface="Optimist Sans" pitchFamily="34" charset="-120"/>
               </a:rPr>
               <a:t>[Sync cadence]</a:t>
             </a:r>
@@ -7742,9 +7742,9 @@
                 <a:solidFill>
                   <a:srgbClr val="6B7280"/>
                 </a:solidFill>
-                <a:latin typeface="Calibri" pitchFamily="34" charset="0"/>
-                <a:ea typeface="Calibri" pitchFamily="34" charset="-122"/>
-                <a:cs typeface="Calibri" pitchFamily="34" charset="-120"/>
+                <a:latin typeface="Optimist Sans" pitchFamily="34" charset="0"/>
+                <a:ea typeface="Optimist Sans" pitchFamily="34" charset="-122"/>
+                <a:cs typeface="Optimist Sans" pitchFamily="34" charset="-120"/>
               </a:rPr>
               <a:t>Draft for discussion · [Or another office for Office B]</a:t>
             </a:r>
@@ -7784,9 +7784,9 @@
                 <a:solidFill>
                   <a:srgbClr val="6B7280"/>
                 </a:solidFill>
-                <a:latin typeface="Calibri"/>
-                <a:ea typeface="Calibri"/>
-                <a:cs typeface="Calibri"/>
+                <a:latin typeface="Optimist Sans"/>
+                <a:ea typeface="Optimist Sans"/>
+                <a:cs typeface="Optimist Sans"/>
               </a:defRPr>
             </a:lvl1pPr>
           </a:lstStyle>
@@ -7857,9 +7857,9 @@
                 <a:solidFill>
                   <a:srgbClr val="A0521A"/>
                 </a:solidFill>
-                <a:latin typeface="Calibri" pitchFamily="34" charset="0"/>
-                <a:ea typeface="Calibri" pitchFamily="34" charset="-122"/>
-                <a:cs typeface="Calibri" pitchFamily="34" charset="-120"/>
+                <a:latin typeface="Optimist Sans" pitchFamily="34" charset="0"/>
+                <a:ea typeface="Optimist Sans" pitchFamily="34" charset="-122"/>
+                <a:cs typeface="Optimist Sans" pitchFamily="34" charset="-120"/>
               </a:rPr>
               <a:t>PRIORITIES</a:t>
             </a:r>
@@ -7898,9 +7898,9 @@
                 <a:solidFill>
                   <a:srgbClr val="14213D"/>
                 </a:solidFill>
-                <a:latin typeface="Cambria" pitchFamily="34" charset="0"/>
-                <a:ea typeface="Cambria" pitchFamily="34" charset="-122"/>
-                <a:cs typeface="Cambria" pitchFamily="34" charset="-120"/>
+                <a:latin typeface="Optimist Display" pitchFamily="34" charset="0"/>
+                <a:ea typeface="Optimist Display" pitchFamily="34" charset="-122"/>
+                <a:cs typeface="Optimist Display" pitchFamily="34" charset="-120"/>
               </a:rPr>
               <a:t>Four priorities move us from improving today’s work to reinventing it</a:t>
             </a:r>
@@ -7960,9 +7960,9 @@
                 <a:solidFill>
                   <a:srgbClr val="155563"/>
                 </a:solidFill>
-                <a:latin typeface="Calibri" pitchFamily="34" charset="0"/>
-                <a:ea typeface="Calibri" pitchFamily="34" charset="-122"/>
-                <a:cs typeface="Calibri" pitchFamily="34" charset="-120"/>
+                <a:latin typeface="Optimist Sans" pitchFamily="34" charset="0"/>
+                <a:ea typeface="Optimist Sans" pitchFamily="34" charset="-122"/>
+                <a:cs typeface="Optimist Sans" pitchFamily="34" charset="-120"/>
               </a:rPr>
               <a:t>Improve how we work today</a:t>
             </a:r>
@@ -8022,9 +8022,9 @@
                 <a:solidFill>
                   <a:srgbClr val="8A4514"/>
                 </a:solidFill>
-                <a:latin typeface="Calibri" pitchFamily="34" charset="0"/>
-                <a:ea typeface="Calibri" pitchFamily="34" charset="-122"/>
-                <a:cs typeface="Calibri" pitchFamily="34" charset="-120"/>
+                <a:latin typeface="Optimist Sans" pitchFamily="34" charset="0"/>
+                <a:ea typeface="Optimist Sans" pitchFamily="34" charset="-122"/>
+                <a:cs typeface="Optimist Sans" pitchFamily="34" charset="-120"/>
               </a:rPr>
               <a:t>Reinvent, outside in</a:t>
             </a:r>
@@ -8084,9 +8084,9 @@
                 <a:solidFill>
                   <a:srgbClr val="14213D"/>
                 </a:solidFill>
-                <a:latin typeface="Calibri" pitchFamily="34" charset="0"/>
-                <a:ea typeface="Calibri" pitchFamily="34" charset="-122"/>
-                <a:cs typeface="Calibri" pitchFamily="34" charset="-120"/>
+                <a:latin typeface="Optimist Sans" pitchFamily="34" charset="0"/>
+                <a:ea typeface="Optimist Sans" pitchFamily="34" charset="-122"/>
+                <a:cs typeface="Optimist Sans" pitchFamily="34" charset="-120"/>
               </a:rPr>
               <a:t>Enable the team</a:t>
             </a:r>
@@ -8177,9 +8177,9 @@
                 <a:solidFill>
                   <a:srgbClr val="14213D"/>
                 </a:solidFill>
-                <a:latin typeface="Calibri" pitchFamily="34" charset="0"/>
-                <a:ea typeface="Calibri" pitchFamily="34" charset="-122"/>
-                <a:cs typeface="Calibri" pitchFamily="34" charset="-120"/>
+                <a:latin typeface="Optimist Sans" pitchFamily="34" charset="0"/>
+                <a:ea typeface="Optimist Sans" pitchFamily="34" charset="-122"/>
+                <a:cs typeface="Optimist Sans" pitchFamily="34" charset="-120"/>
               </a:rPr>
               <a:t>Sharpen model strategy</a:t>
             </a:r>
@@ -8219,9 +8219,9 @@
                 <a:solidFill>
                   <a:srgbClr val="4A5568"/>
                 </a:solidFill>
-                <a:latin typeface="Calibri" pitchFamily="34" charset="0"/>
-                <a:ea typeface="Calibri" pitchFamily="34" charset="-122"/>
-                <a:cs typeface="Calibri" pitchFamily="34" charset="-120"/>
+                <a:latin typeface="Optimist Sans" pitchFamily="34" charset="0"/>
+                <a:ea typeface="Optimist Sans" pitchFamily="34" charset="-122"/>
+                <a:cs typeface="Optimist Sans" pitchFamily="34" charset="-120"/>
               </a:rPr>
               <a:t>Build on today’s defined strategy.</a:t>
             </a:r>
@@ -8262,9 +8262,9 @@
                 <a:solidFill>
                   <a:srgbClr val="4A5568"/>
                 </a:solidFill>
-                <a:latin typeface="Calibri" pitchFamily="34" charset="0"/>
-                <a:ea typeface="Calibri" pitchFamily="34" charset="-122"/>
-                <a:cs typeface="Calibri" pitchFamily="34" charset="-120"/>
+                <a:latin typeface="Optimist Sans" pitchFamily="34" charset="0"/>
+                <a:ea typeface="Optimist Sans" pitchFamily="34" charset="-122"/>
+                <a:cs typeface="Optimist Sans" pitchFamily="34" charset="-120"/>
               </a:rPr>
               <a:t>Model consolidation [scope]</a:t>
             </a:r>
@@ -8283,9 +8283,9 @@
                 <a:solidFill>
                   <a:srgbClr val="4A5568"/>
                 </a:solidFill>
-                <a:latin typeface="Calibri" pitchFamily="34" charset="0"/>
-                <a:ea typeface="Calibri" pitchFamily="34" charset="-122"/>
-                <a:cs typeface="Calibri" pitchFamily="34" charset="-120"/>
+                <a:latin typeface="Optimist Sans" pitchFamily="34" charset="0"/>
+                <a:ea typeface="Optimist Sans" pitchFamily="34" charset="-122"/>
+                <a:cs typeface="Optimist Sans" pitchFamily="34" charset="-120"/>
               </a:rPr>
               <a:t>Re-leveling [scope]</a:t>
             </a:r>
@@ -8304,9 +8304,9 @@
                 <a:solidFill>
                   <a:srgbClr val="4A5568"/>
                 </a:solidFill>
-                <a:latin typeface="Calibri" pitchFamily="34" charset="0"/>
-                <a:ea typeface="Calibri" pitchFamily="34" charset="-122"/>
-                <a:cs typeface="Calibri" pitchFamily="34" charset="-120"/>
+                <a:latin typeface="Optimist Sans" pitchFamily="34" charset="0"/>
+                <a:ea typeface="Optimist Sans" pitchFamily="34" charset="-122"/>
+                <a:cs typeface="Optimist Sans" pitchFamily="34" charset="-120"/>
               </a:rPr>
               <a:t>[Further optimization]</a:t>
             </a:r>
@@ -8397,9 +8397,9 @@
                 <a:solidFill>
                   <a:srgbClr val="14213D"/>
                 </a:solidFill>
-                <a:latin typeface="Calibri" pitchFamily="34" charset="0"/>
-                <a:ea typeface="Calibri" pitchFamily="34" charset="-122"/>
-                <a:cs typeface="Calibri" pitchFamily="34" charset="-120"/>
+                <a:latin typeface="Optimist Sans" pitchFamily="34" charset="0"/>
+                <a:ea typeface="Optimist Sans" pitchFamily="34" charset="-122"/>
+                <a:cs typeface="Optimist Sans" pitchFamily="34" charset="-120"/>
               </a:rPr>
               <a:t>Clean our house</a:t>
             </a:r>
@@ -8439,9 +8439,9 @@
                 <a:solidFill>
                   <a:srgbClr val="4A5568"/>
                 </a:solidFill>
-                <a:latin typeface="Calibri" pitchFamily="34" charset="0"/>
-                <a:ea typeface="Calibri" pitchFamily="34" charset="-122"/>
-                <a:cs typeface="Calibri" pitchFamily="34" charset="-120"/>
+                <a:latin typeface="Optimist Sans" pitchFamily="34" charset="0"/>
+                <a:ea typeface="Optimist Sans" pitchFamily="34" charset="-122"/>
+                <a:cs typeface="Optimist Sans" pitchFamily="34" charset="-120"/>
               </a:rPr>
               <a:t>Standardize and streamline current work.</a:t>
             </a:r>
@@ -8482,9 +8482,9 @@
                 <a:solidFill>
                   <a:srgbClr val="4A5568"/>
                 </a:solidFill>
-                <a:latin typeface="Calibri" pitchFamily="34" charset="0"/>
-                <a:ea typeface="Calibri" pitchFamily="34" charset="-122"/>
-                <a:cs typeface="Calibri" pitchFamily="34" charset="-120"/>
+                <a:latin typeface="Optimist Sans" pitchFamily="34" charset="0"/>
+                <a:ea typeface="Optimist Sans" pitchFamily="34" charset="-122"/>
+                <a:cs typeface="Optimist Sans" pitchFamily="34" charset="-120"/>
               </a:rPr>
               <a:t>Standard tooling [tool name]</a:t>
             </a:r>
@@ -8503,9 +8503,9 @@
                 <a:solidFill>
                   <a:srgbClr val="4A5568"/>
                 </a:solidFill>
-                <a:latin typeface="Calibri" pitchFamily="34" charset="0"/>
-                <a:ea typeface="Calibri" pitchFamily="34" charset="-122"/>
-                <a:cs typeface="Calibri" pitchFamily="34" charset="-120"/>
+                <a:latin typeface="Optimist Sans" pitchFamily="34" charset="0"/>
+                <a:ea typeface="Optimist Sans" pitchFamily="34" charset="-122"/>
+                <a:cs typeface="Optimist Sans" pitchFamily="34" charset="-120"/>
               </a:rPr>
               <a:t>Process optimization [areas]</a:t>
             </a:r>
@@ -8524,9 +8524,9 @@
                 <a:solidFill>
                   <a:srgbClr val="4A5568"/>
                 </a:solidFill>
-                <a:latin typeface="Calibri" pitchFamily="34" charset="0"/>
-                <a:ea typeface="Calibri" pitchFamily="34" charset="-122"/>
-                <a:cs typeface="Calibri" pitchFamily="34" charset="-120"/>
+                <a:latin typeface="Optimist Sans" pitchFamily="34" charset="0"/>
+                <a:ea typeface="Optimist Sans" pitchFamily="34" charset="-122"/>
+                <a:cs typeface="Optimist Sans" pitchFamily="34" charset="-120"/>
               </a:rPr>
               <a:t>[Item]</a:t>
             </a:r>
@@ -8617,9 +8617,9 @@
                 <a:solidFill>
                   <a:srgbClr val="14213D"/>
                 </a:solidFill>
-                <a:latin typeface="Calibri" pitchFamily="34" charset="0"/>
-                <a:ea typeface="Calibri" pitchFamily="34" charset="-122"/>
-                <a:cs typeface="Calibri" pitchFamily="34" charset="-120"/>
+                <a:latin typeface="Optimist Sans" pitchFamily="34" charset="0"/>
+                <a:ea typeface="Optimist Sans" pitchFamily="34" charset="-122"/>
+                <a:cs typeface="Optimist Sans" pitchFamily="34" charset="-120"/>
               </a:rPr>
               <a:t>Rethink with AI</a:t>
             </a:r>
@@ -8659,9 +8659,9 @@
                 <a:solidFill>
                   <a:srgbClr val="4A5568"/>
                 </a:solidFill>
-                <a:latin typeface="Calibri" pitchFamily="34" charset="0"/>
-                <a:ea typeface="Calibri" pitchFamily="34" charset="-122"/>
-                <a:cs typeface="Calibri" pitchFamily="34" charset="-120"/>
+                <a:latin typeface="Optimist Sans" pitchFamily="34" charset="0"/>
+                <a:ea typeface="Optimist Sans" pitchFamily="34" charset="-122"/>
+                <a:cs typeface="Optimist Sans" pitchFamily="34" charset="-120"/>
               </a:rPr>
               <a:t>If we built the team today, what would differ?</a:t>
             </a:r>
@@ -8702,9 +8702,9 @@
                 <a:solidFill>
                   <a:srgbClr val="4A5568"/>
                 </a:solidFill>
-                <a:latin typeface="Calibri" pitchFamily="34" charset="0"/>
-                <a:ea typeface="Calibri" pitchFamily="34" charset="-122"/>
-                <a:cs typeface="Calibri" pitchFamily="34" charset="-120"/>
+                <a:latin typeface="Optimist Sans" pitchFamily="34" charset="0"/>
+                <a:ea typeface="Optimist Sans" pitchFamily="34" charset="-122"/>
+                <a:cs typeface="Optimist Sans" pitchFamily="34" charset="-120"/>
               </a:rPr>
               <a:t>[Opportunity 1]</a:t>
             </a:r>
@@ -8723,9 +8723,9 @@
                 <a:solidFill>
                   <a:srgbClr val="4A5568"/>
                 </a:solidFill>
-                <a:latin typeface="Calibri" pitchFamily="34" charset="0"/>
-                <a:ea typeface="Calibri" pitchFamily="34" charset="-122"/>
-                <a:cs typeface="Calibri" pitchFamily="34" charset="-120"/>
+                <a:latin typeface="Optimist Sans" pitchFamily="34" charset="0"/>
+                <a:ea typeface="Optimist Sans" pitchFamily="34" charset="-122"/>
+                <a:cs typeface="Optimist Sans" pitchFamily="34" charset="-120"/>
               </a:rPr>
               <a:t>[Opportunity 2]</a:t>
             </a:r>
@@ -8744,9 +8744,9 @@
                 <a:solidFill>
                   <a:srgbClr val="4A5568"/>
                 </a:solidFill>
-                <a:latin typeface="Calibri" pitchFamily="34" charset="0"/>
-                <a:ea typeface="Calibri" pitchFamily="34" charset="-122"/>
-                <a:cs typeface="Calibri" pitchFamily="34" charset="-120"/>
+                <a:latin typeface="Optimist Sans" pitchFamily="34" charset="0"/>
+                <a:ea typeface="Optimist Sans" pitchFamily="34" charset="-122"/>
+                <a:cs typeface="Optimist Sans" pitchFamily="34" charset="-120"/>
               </a:rPr>
               <a:t>[Opportunity 3]</a:t>
             </a:r>
@@ -8837,9 +8837,9 @@
                 <a:solidFill>
                   <a:srgbClr val="14213D"/>
                 </a:solidFill>
-                <a:latin typeface="Calibri" pitchFamily="34" charset="0"/>
-                <a:ea typeface="Calibri" pitchFamily="34" charset="-122"/>
-                <a:cs typeface="Calibri" pitchFamily="34" charset="-120"/>
+                <a:latin typeface="Optimist Sans" pitchFamily="34" charset="0"/>
+                <a:ea typeface="Optimist Sans" pitchFamily="34" charset="-122"/>
+                <a:cs typeface="Optimist Sans" pitchFamily="34" charset="-120"/>
               </a:rPr>
               <a:t>Build an AI-era team</a:t>
             </a:r>
@@ -8879,9 +8879,9 @@
                 <a:solidFill>
                   <a:srgbClr val="4A5568"/>
                 </a:solidFill>
-                <a:latin typeface="Calibri" pitchFamily="34" charset="0"/>
-                <a:ea typeface="Calibri" pitchFamily="34" charset="-122"/>
-                <a:cs typeface="Calibri" pitchFamily="34" charset="-120"/>
+                <a:latin typeface="Optimist Sans" pitchFamily="34" charset="0"/>
+                <a:ea typeface="Optimist Sans" pitchFamily="34" charset="-122"/>
+                <a:cs typeface="Optimist Sans" pitchFamily="34" charset="-120"/>
               </a:rPr>
               <a:t>Structure and talent for ~30 associates.</a:t>
             </a:r>
@@ -8922,9 +8922,9 @@
                 <a:solidFill>
                   <a:srgbClr val="4A5568"/>
                 </a:solidFill>
-                <a:latin typeface="Calibri" pitchFamily="34" charset="0"/>
-                <a:ea typeface="Calibri" pitchFamily="34" charset="-122"/>
-                <a:cs typeface="Calibri" pitchFamily="34" charset="-120"/>
+                <a:latin typeface="Optimist Sans" pitchFamily="34" charset="0"/>
+                <a:ea typeface="Optimist Sans" pitchFamily="34" charset="-122"/>
+                <a:cs typeface="Optimist Sans" pitchFamily="34" charset="-120"/>
               </a:rPr>
               <a:t>Flatter structure</a:t>
             </a:r>
@@ -8943,9 +8943,9 @@
                 <a:solidFill>
                   <a:srgbClr val="4A5568"/>
                 </a:solidFill>
-                <a:latin typeface="Calibri" pitchFamily="34" charset="0"/>
-                <a:ea typeface="Calibri" pitchFamily="34" charset="-122"/>
-                <a:cs typeface="Calibri" pitchFamily="34" charset="-120"/>
+                <a:latin typeface="Optimist Sans" pitchFamily="34" charset="0"/>
+                <a:ea typeface="Optimist Sans" pitchFamily="34" charset="-122"/>
+                <a:cs typeface="Optimist Sans" pitchFamily="34" charset="-120"/>
               </a:rPr>
               <a:t>Next-gen leader pipeline</a:t>
             </a:r>
@@ -8964,9 +8964,9 @@
                 <a:solidFill>
                   <a:srgbClr val="4A5568"/>
                 </a:solidFill>
-                <a:latin typeface="Calibri" pitchFamily="34" charset="0"/>
-                <a:ea typeface="Calibri" pitchFamily="34" charset="-122"/>
-                <a:cs typeface="Calibri" pitchFamily="34" charset="-120"/>
+                <a:latin typeface="Optimist Sans" pitchFamily="34" charset="0"/>
+                <a:ea typeface="Optimist Sans" pitchFamily="34" charset="-122"/>
+                <a:cs typeface="Optimist Sans" pitchFamily="34" charset="-120"/>
               </a:rPr>
               <a:t>[Item]</a:t>
             </a:r>
@@ -9006,9 +9006,9 @@
                 <a:solidFill>
                   <a:srgbClr val="6B7280"/>
                 </a:solidFill>
-                <a:latin typeface="Calibri" pitchFamily="34" charset="0"/>
-                <a:ea typeface="Calibri" pitchFamily="34" charset="-122"/>
-                <a:cs typeface="Calibri" pitchFamily="34" charset="-120"/>
+                <a:latin typeface="Optimist Sans" pitchFamily="34" charset="0"/>
+                <a:ea typeface="Optimist Sans" pitchFamily="34" charset="-122"/>
+                <a:cs typeface="Optimist Sans" pitchFamily="34" charset="-120"/>
               </a:rPr>
               <a:t>Draft for discussion</a:t>
             </a:r>
@@ -9048,9 +9048,9 @@
                 <a:solidFill>
                   <a:srgbClr val="6B7280"/>
                 </a:solidFill>
-                <a:latin typeface="Calibri"/>
-                <a:ea typeface="Calibri"/>
-                <a:cs typeface="Calibri"/>
+                <a:latin typeface="Optimist Sans"/>
+                <a:ea typeface="Optimist Sans"/>
+                <a:cs typeface="Optimist Sans"/>
               </a:defRPr>
             </a:lvl1pPr>
           </a:lstStyle>
@@ -9121,9 +9121,9 @@
                 <a:solidFill>
                   <a:srgbClr val="A0521A"/>
                 </a:solidFill>
-                <a:latin typeface="Calibri" pitchFamily="34" charset="0"/>
-                <a:ea typeface="Calibri" pitchFamily="34" charset="-122"/>
-                <a:cs typeface="Calibri" pitchFamily="34" charset="-120"/>
+                <a:latin typeface="Optimist Sans" pitchFamily="34" charset="0"/>
+                <a:ea typeface="Optimist Sans" pitchFamily="34" charset="-122"/>
+                <a:cs typeface="Optimist Sans" pitchFamily="34" charset="-120"/>
               </a:rPr>
               <a:t>TEAM FOR THE AI ERA · 1 GROWTH</a:t>
             </a:r>
@@ -9162,9 +9162,9 @@
                 <a:solidFill>
                   <a:srgbClr val="14213D"/>
                 </a:solidFill>
-                <a:latin typeface="Cambria" pitchFamily="34" charset="0"/>
-                <a:ea typeface="Cambria" pitchFamily="34" charset="-122"/>
-                <a:cs typeface="Cambria" pitchFamily="34" charset="-120"/>
+                <a:latin typeface="Optimist Display" pitchFamily="34" charset="0"/>
+                <a:ea typeface="Optimist Display" pitchFamily="34" charset="-122"/>
+                <a:cs typeface="Optimist Display" pitchFamily="34" charset="-120"/>
               </a:rPr>
               <a:t>Two clear career paths show every associate how to grow in the AI era</a:t>
             </a:r>
@@ -9226,9 +9226,9 @@
                 <a:solidFill>
                   <a:srgbClr val="F7F6F2"/>
                 </a:solidFill>
-                <a:latin typeface="Calibri" pitchFamily="34" charset="0"/>
-                <a:ea typeface="Calibri" pitchFamily="34" charset="-122"/>
-                <a:cs typeface="Calibri" pitchFamily="34" charset="-120"/>
+                <a:latin typeface="Optimist Sans" pitchFamily="34" charset="0"/>
+                <a:ea typeface="Optimist Sans" pitchFamily="34" charset="-122"/>
+                <a:cs typeface="Optimist Sans" pitchFamily="34" charset="-120"/>
               </a:rPr>
               <a:t>Associate</a:t>
             </a:r>
@@ -9389,9 +9389,9 @@
                 <a:solidFill>
                   <a:srgbClr val="155563"/>
                 </a:solidFill>
-                <a:latin typeface="Calibri" pitchFamily="34" charset="0"/>
-                <a:ea typeface="Calibri" pitchFamily="34" charset="-122"/>
-                <a:cs typeface="Calibri" pitchFamily="34" charset="-120"/>
+                <a:latin typeface="Optimist Sans" pitchFamily="34" charset="0"/>
+                <a:ea typeface="Optimist Sans" pitchFamily="34" charset="-122"/>
+                <a:cs typeface="Optimist Sans" pitchFamily="34" charset="-120"/>
               </a:rPr>
               <a:t>PATH 1</a:t>
             </a:r>
@@ -9431,9 +9431,9 @@
                 <a:solidFill>
                   <a:srgbClr val="14213D"/>
                 </a:solidFill>
-                <a:latin typeface="Calibri" pitchFamily="34" charset="0"/>
-                <a:ea typeface="Calibri" pitchFamily="34" charset="-122"/>
-                <a:cs typeface="Calibri" pitchFamily="34" charset="-120"/>
+                <a:latin typeface="Optimist Sans" pitchFamily="34" charset="0"/>
+                <a:ea typeface="Optimist Sans" pitchFamily="34" charset="-122"/>
+                <a:cs typeface="Optimist Sans" pitchFamily="34" charset="-120"/>
               </a:rPr>
               <a:t>Senior individual contributor</a:t>
             </a:r>
@@ -9473,9 +9473,9 @@
                 <a:solidFill>
                   <a:srgbClr val="14213D"/>
                 </a:solidFill>
-                <a:latin typeface="Calibri" pitchFamily="34" charset="0"/>
-                <a:ea typeface="Calibri" pitchFamily="34" charset="-122"/>
-                <a:cs typeface="Calibri" pitchFamily="34" charset="-120"/>
+                <a:latin typeface="Optimist Sans" pitchFamily="34" charset="0"/>
+                <a:ea typeface="Optimist Sans" pitchFamily="34" charset="-122"/>
+                <a:cs typeface="Optimist Sans" pitchFamily="34" charset="-120"/>
               </a:rPr>
               <a:t>Focus: </a:t>
             </a:r>
@@ -9490,9 +9490,9 @@
                 <a:solidFill>
                   <a:srgbClr val="14213D"/>
                 </a:solidFill>
-                <a:latin typeface="Calibri" pitchFamily="34" charset="0"/>
-                <a:ea typeface="Calibri" pitchFamily="34" charset="-122"/>
-                <a:cs typeface="Calibri" pitchFamily="34" charset="-120"/>
+                <a:latin typeface="Optimist Sans" pitchFamily="34" charset="0"/>
+                <a:ea typeface="Optimist Sans" pitchFamily="34" charset="-122"/>
+                <a:cs typeface="Optimist Sans" pitchFamily="34" charset="-120"/>
               </a:rPr>
               <a:t>personal leverage, using AI to deliver more and go deeper.</a:t>
             </a:r>
@@ -9532,9 +9532,9 @@
                 <a:solidFill>
                   <a:srgbClr val="4A5568"/>
                 </a:solidFill>
-                <a:latin typeface="Calibri" pitchFamily="34" charset="0"/>
-                <a:ea typeface="Calibri" pitchFamily="34" charset="-122"/>
-                <a:cs typeface="Calibri" pitchFamily="34" charset="-120"/>
+                <a:latin typeface="Optimist Sans" pitchFamily="34" charset="0"/>
+                <a:ea typeface="Optimist Sans" pitchFamily="34" charset="-122"/>
+                <a:cs typeface="Optimist Sans" pitchFamily="34" charset="-120"/>
               </a:rPr>
               <a:t>Grows by: </a:t>
             </a:r>
@@ -9549,9 +9549,9 @@
                 <a:solidFill>
                   <a:srgbClr val="4A5568"/>
                 </a:solidFill>
-                <a:latin typeface="Calibri" pitchFamily="34" charset="0"/>
-                <a:ea typeface="Calibri" pitchFamily="34" charset="-122"/>
-                <a:cs typeface="Calibri" pitchFamily="34" charset="-120"/>
+                <a:latin typeface="Optimist Sans" pitchFamily="34" charset="0"/>
+                <a:ea typeface="Optimist Sans" pitchFamily="34" charset="-122"/>
+                <a:cs typeface="Optimist Sans" pitchFamily="34" charset="-120"/>
               </a:rPr>
               <a:t>[scope, complexity, technical influence]</a:t>
             </a:r>
@@ -9618,9 +9618,9 @@
                 <a:solidFill>
                   <a:srgbClr val="8A4514"/>
                 </a:solidFill>
-                <a:latin typeface="Calibri" pitchFamily="34" charset="0"/>
-                <a:ea typeface="Calibri" pitchFamily="34" charset="-122"/>
-                <a:cs typeface="Calibri" pitchFamily="34" charset="-120"/>
+                <a:latin typeface="Optimist Sans" pitchFamily="34" charset="0"/>
+                <a:ea typeface="Optimist Sans" pitchFamily="34" charset="-122"/>
+                <a:cs typeface="Optimist Sans" pitchFamily="34" charset="-120"/>
               </a:rPr>
               <a:t>PATH 2</a:t>
             </a:r>
@@ -9660,9 +9660,9 @@
                 <a:solidFill>
                   <a:srgbClr val="14213D"/>
                 </a:solidFill>
-                <a:latin typeface="Calibri" pitchFamily="34" charset="0"/>
-                <a:ea typeface="Calibri" pitchFamily="34" charset="-122"/>
-                <a:cs typeface="Calibri" pitchFamily="34" charset="-120"/>
+                <a:latin typeface="Optimist Sans" pitchFamily="34" charset="0"/>
+                <a:ea typeface="Optimist Sans" pitchFamily="34" charset="-122"/>
+                <a:cs typeface="Optimist Sans" pitchFamily="34" charset="-120"/>
               </a:rPr>
               <a:t>People manager</a:t>
             </a:r>
@@ -9702,9 +9702,9 @@
                 <a:solidFill>
                   <a:srgbClr val="14213D"/>
                 </a:solidFill>
-                <a:latin typeface="Calibri" pitchFamily="34" charset="0"/>
-                <a:ea typeface="Calibri" pitchFamily="34" charset="-122"/>
-                <a:cs typeface="Calibri" pitchFamily="34" charset="-120"/>
+                <a:latin typeface="Optimist Sans" pitchFamily="34" charset="0"/>
+                <a:ea typeface="Optimist Sans" pitchFamily="34" charset="-122"/>
+                <a:cs typeface="Optimist Sans" pitchFamily="34" charset="-120"/>
               </a:rPr>
               <a:t>Focus: </a:t>
             </a:r>
@@ -9719,9 +9719,9 @@
                 <a:solidFill>
                   <a:srgbClr val="14213D"/>
                 </a:solidFill>
-                <a:latin typeface="Calibri" pitchFamily="34" charset="0"/>
-                <a:ea typeface="Calibri" pitchFamily="34" charset="-122"/>
-                <a:cs typeface="Calibri" pitchFamily="34" charset="-120"/>
+                <a:latin typeface="Optimist Sans" pitchFamily="34" charset="0"/>
+                <a:ea typeface="Optimist Sans" pitchFamily="34" charset="-122"/>
+                <a:cs typeface="Optimist Sans" pitchFamily="34" charset="-120"/>
               </a:rPr>
               <a:t>people, strategy and connecting teams; less on technical efficiency.</a:t>
             </a:r>
@@ -9761,9 +9761,9 @@
                 <a:solidFill>
                   <a:srgbClr val="4A5568"/>
                 </a:solidFill>
-                <a:latin typeface="Calibri" pitchFamily="34" charset="0"/>
-                <a:ea typeface="Calibri" pitchFamily="34" charset="-122"/>
-                <a:cs typeface="Calibri" pitchFamily="34" charset="-120"/>
+                <a:latin typeface="Optimist Sans" pitchFamily="34" charset="0"/>
+                <a:ea typeface="Optimist Sans" pitchFamily="34" charset="-122"/>
+                <a:cs typeface="Optimist Sans" pitchFamily="34" charset="-120"/>
               </a:rPr>
               <a:t>Grows by: </a:t>
             </a:r>
@@ -9778,9 +9778,9 @@
                 <a:solidFill>
                   <a:srgbClr val="4A5568"/>
                 </a:solidFill>
-                <a:latin typeface="Calibri" pitchFamily="34" charset="0"/>
-                <a:ea typeface="Calibri" pitchFamily="34" charset="-122"/>
-                <a:cs typeface="Calibri" pitchFamily="34" charset="-120"/>
+                <a:latin typeface="Optimist Sans" pitchFamily="34" charset="0"/>
+                <a:ea typeface="Optimist Sans" pitchFamily="34" charset="-122"/>
+                <a:cs typeface="Optimist Sans" pitchFamily="34" charset="-120"/>
               </a:rPr>
               <a:t>[team scope, span, strategic impact]</a:t>
             </a:r>
@@ -9866,9 +9866,9 @@
                 <a:solidFill>
                   <a:srgbClr val="14213D"/>
                 </a:solidFill>
-                <a:latin typeface="Calibri" pitchFamily="34" charset="0"/>
-                <a:ea typeface="Calibri" pitchFamily="34" charset="-122"/>
-                <a:cs typeface="Calibri" pitchFamily="34" charset="-120"/>
+                <a:latin typeface="Optimist Sans" pitchFamily="34" charset="0"/>
+                <a:ea typeface="Optimist Sans" pitchFamily="34" charset="-122"/>
+                <a:cs typeface="Optimist Sans" pitchFamily="34" charset="-120"/>
               </a:rPr>
               <a:t>Rethink performance management</a:t>
             </a:r>
@@ -9908,9 +9908,9 @@
                 <a:solidFill>
                   <a:srgbClr val="4A5568"/>
                 </a:solidFill>
-                <a:latin typeface="Calibri" pitchFamily="34" charset="0"/>
-                <a:ea typeface="Calibri" pitchFamily="34" charset="-122"/>
-                <a:cs typeface="Calibri" pitchFamily="34" charset="-120"/>
+                <a:latin typeface="Optimist Sans" pitchFamily="34" charset="0"/>
+                <a:ea typeface="Optimist Sans" pitchFamily="34" charset="-122"/>
+                <a:cs typeface="Optimist Sans" pitchFamily="34" charset="-120"/>
               </a:rPr>
               <a:t>As everyone gets more efficient, forcing a distribution pits peers against each other. That hurts sustainable growth and culture.</a:t>
             </a:r>
@@ -9950,9 +9950,9 @@
                 <a:solidFill>
                   <a:srgbClr val="155563"/>
                 </a:solidFill>
-                <a:latin typeface="Calibri" pitchFamily="34" charset="0"/>
-                <a:ea typeface="Calibri" pitchFamily="34" charset="-122"/>
-                <a:cs typeface="Calibri" pitchFamily="34" charset="-120"/>
+                <a:latin typeface="Optimist Sans" pitchFamily="34" charset="0"/>
+                <a:ea typeface="Optimist Sans" pitchFamily="34" charset="-122"/>
+                <a:cs typeface="Optimist Sans" pitchFamily="34" charset="-120"/>
               </a:rPr>
               <a:t>[Proposal, e.g., measure impact against goals]</a:t>
             </a:r>
@@ -9992,9 +9992,9 @@
                 <a:solidFill>
                   <a:srgbClr val="6B7280"/>
                 </a:solidFill>
-                <a:latin typeface="Calibri" pitchFamily="34" charset="0"/>
-                <a:ea typeface="Calibri" pitchFamily="34" charset="-122"/>
-                <a:cs typeface="Calibri" pitchFamily="34" charset="-120"/>
+                <a:latin typeface="Optimist Sans" pitchFamily="34" charset="0"/>
+                <a:ea typeface="Optimist Sans" pitchFamily="34" charset="-122"/>
+                <a:cs typeface="Optimist Sans" pitchFamily="34" charset="-120"/>
               </a:rPr>
               <a:t>Draft for discussion · These two paths shape the team structure on the next slide</a:t>
             </a:r>
@@ -10034,9 +10034,9 @@
                 <a:solidFill>
                   <a:srgbClr val="6B7280"/>
                 </a:solidFill>
-                <a:latin typeface="Calibri"/>
-                <a:ea typeface="Calibri"/>
-                <a:cs typeface="Calibri"/>
+                <a:latin typeface="Optimist Sans"/>
+                <a:ea typeface="Optimist Sans"/>
+                <a:cs typeface="Optimist Sans"/>
               </a:defRPr>
             </a:lvl1pPr>
           </a:lstStyle>
@@ -10107,9 +10107,9 @@
                 <a:solidFill>
                   <a:srgbClr val="A0521A"/>
                 </a:solidFill>
-                <a:latin typeface="Calibri" pitchFamily="34" charset="0"/>
-                <a:ea typeface="Calibri" pitchFamily="34" charset="-122"/>
-                <a:cs typeface="Calibri" pitchFamily="34" charset="-120"/>
+                <a:latin typeface="Optimist Sans" pitchFamily="34" charset="0"/>
+                <a:ea typeface="Optimist Sans" pitchFamily="34" charset="-122"/>
+                <a:cs typeface="Optimist Sans" pitchFamily="34" charset="-120"/>
               </a:rPr>
               <a:t>TEAM FOR THE AI ERA · 2 STRUCTURE</a:t>
             </a:r>
@@ -10148,9 +10148,9 @@
                 <a:solidFill>
                   <a:srgbClr val="14213D"/>
                 </a:solidFill>
-                <a:latin typeface="Cambria" pitchFamily="34" charset="0"/>
-                <a:ea typeface="Cambria" pitchFamily="34" charset="-122"/>
-                <a:cs typeface="Cambria" pitchFamily="34" charset="-120"/>
+                <a:latin typeface="Optimist Display" pitchFamily="34" charset="0"/>
+                <a:ea typeface="Optimist Display" pitchFamily="34" charset="-122"/>
+                <a:cs typeface="Optimist Display" pitchFamily="34" charset="-120"/>
               </a:rPr>
               <a:t>The two paths lead to a flatter team built around senior ICs who lead AI agents</a:t>
             </a:r>
@@ -10190,9 +10190,9 @@
                 <a:solidFill>
                   <a:srgbClr val="6B7280"/>
                 </a:solidFill>
-                <a:latin typeface="Calibri" pitchFamily="34" charset="0"/>
-                <a:ea typeface="Calibri" pitchFamily="34" charset="-122"/>
-                <a:cs typeface="Calibri" pitchFamily="34" charset="-120"/>
+                <a:latin typeface="Optimist Sans" pitchFamily="34" charset="0"/>
+                <a:ea typeface="Optimist Sans" pitchFamily="34" charset="-122"/>
+                <a:cs typeface="Optimist Sans" pitchFamily="34" charset="-120"/>
               </a:rPr>
               <a:t>TODAY · PYRAMID</a:t>
             </a:r>
@@ -10254,9 +10254,9 @@
                 <a:solidFill>
                   <a:srgbClr val="F7F6F2"/>
                 </a:solidFill>
-                <a:latin typeface="Calibri" pitchFamily="34" charset="0"/>
-                <a:ea typeface="Calibri" pitchFamily="34" charset="-122"/>
-                <a:cs typeface="Calibri" pitchFamily="34" charset="-120"/>
+                <a:latin typeface="Optimist Sans" pitchFamily="34" charset="0"/>
+                <a:ea typeface="Optimist Sans" pitchFamily="34" charset="-122"/>
+                <a:cs typeface="Optimist Sans" pitchFamily="34" charset="-120"/>
               </a:rPr>
               <a:t>Lead</a:t>
             </a:r>
@@ -10318,9 +10318,9 @@
                 <a:solidFill>
                   <a:srgbClr val="14213D"/>
                 </a:solidFill>
-                <a:latin typeface="Calibri" pitchFamily="34" charset="0"/>
-                <a:ea typeface="Calibri" pitchFamily="34" charset="-122"/>
-                <a:cs typeface="Calibri" pitchFamily="34" charset="-120"/>
+                <a:latin typeface="Optimist Sans" pitchFamily="34" charset="0"/>
+                <a:ea typeface="Optimist Sans" pitchFamily="34" charset="-122"/>
+                <a:cs typeface="Optimist Sans" pitchFamily="34" charset="-120"/>
               </a:rPr>
               <a:t>Managers</a:t>
             </a:r>
@@ -10382,9 +10382,9 @@
                 <a:solidFill>
                   <a:srgbClr val="14213D"/>
                 </a:solidFill>
-                <a:latin typeface="Calibri" pitchFamily="34" charset="0"/>
-                <a:ea typeface="Calibri" pitchFamily="34" charset="-122"/>
-                <a:cs typeface="Calibri" pitchFamily="34" charset="-120"/>
+                <a:latin typeface="Optimist Sans" pitchFamily="34" charset="0"/>
+                <a:ea typeface="Optimist Sans" pitchFamily="34" charset="-122"/>
+                <a:cs typeface="Optimist Sans" pitchFamily="34" charset="-120"/>
               </a:rPr>
               <a:t>Seniors</a:t>
             </a:r>
@@ -10446,9 +10446,9 @@
                 <a:solidFill>
                   <a:srgbClr val="14213D"/>
                 </a:solidFill>
-                <a:latin typeface="Calibri" pitchFamily="34" charset="0"/>
-                <a:ea typeface="Calibri" pitchFamily="34" charset="-122"/>
-                <a:cs typeface="Calibri" pitchFamily="34" charset="-120"/>
+                <a:latin typeface="Optimist Sans" pitchFamily="34" charset="0"/>
+                <a:ea typeface="Optimist Sans" pitchFamily="34" charset="-122"/>
+                <a:cs typeface="Optimist Sans" pitchFamily="34" charset="-120"/>
               </a:rPr>
               <a:t>Juniors</a:t>
             </a:r>
@@ -10488,9 +10488,9 @@
                 <a:solidFill>
                   <a:srgbClr val="4A5568"/>
                 </a:solidFill>
-                <a:latin typeface="Calibri" pitchFamily="34" charset="0"/>
-                <a:ea typeface="Calibri" pitchFamily="34" charset="-122"/>
-                <a:cs typeface="Calibri" pitchFamily="34" charset="-120"/>
+                <a:latin typeface="Optimist Sans" pitchFamily="34" charset="0"/>
+                <a:ea typeface="Optimist Sans" pitchFamily="34" charset="-122"/>
+                <a:cs typeface="Optimist Sans" pitchFamily="34" charset="-120"/>
               </a:rPr>
               <a:t>Narrow spans, more layers</a:t>
             </a:r>
@@ -10550,9 +10550,9 @@
                 <a:solidFill>
                   <a:srgbClr val="155563"/>
                 </a:solidFill>
-                <a:latin typeface="Calibri" pitchFamily="34" charset="0"/>
-                <a:ea typeface="Calibri" pitchFamily="34" charset="-122"/>
-                <a:cs typeface="Calibri" pitchFamily="34" charset="-120"/>
+                <a:latin typeface="Optimist Sans" pitchFamily="34" charset="0"/>
+                <a:ea typeface="Optimist Sans" pitchFamily="34" charset="-122"/>
+                <a:cs typeface="Optimist Sans" pitchFamily="34" charset="-120"/>
               </a:rPr>
               <a:t>MOVING TO · FLATTER</a:t>
             </a:r>
@@ -10614,9 +10614,9 @@
                 <a:solidFill>
                   <a:srgbClr val="F7F6F2"/>
                 </a:solidFill>
-                <a:latin typeface="Calibri" pitchFamily="34" charset="0"/>
-                <a:ea typeface="Calibri" pitchFamily="34" charset="-122"/>
-                <a:cs typeface="Calibri" pitchFamily="34" charset="-120"/>
+                <a:latin typeface="Optimist Sans" pitchFamily="34" charset="0"/>
+                <a:ea typeface="Optimist Sans" pitchFamily="34" charset="-122"/>
+                <a:cs typeface="Optimist Sans" pitchFamily="34" charset="-120"/>
               </a:rPr>
               <a:t>Lead</a:t>
             </a:r>
@@ -10678,9 +10678,9 @@
                 <a:solidFill>
                   <a:srgbClr val="14213D"/>
                 </a:solidFill>
-                <a:latin typeface="Calibri" pitchFamily="34" charset="0"/>
-                <a:ea typeface="Calibri" pitchFamily="34" charset="-122"/>
-                <a:cs typeface="Calibri" pitchFamily="34" charset="-120"/>
+                <a:latin typeface="Optimist Sans" pitchFamily="34" charset="0"/>
+                <a:ea typeface="Optimist Sans" pitchFamily="34" charset="-122"/>
+                <a:cs typeface="Optimist Sans" pitchFamily="34" charset="-120"/>
               </a:rPr>
               <a:t>Managers, wider spans</a:t>
             </a:r>
@@ -10742,9 +10742,9 @@
                 <a:solidFill>
                   <a:srgbClr val="F7F6F2"/>
                 </a:solidFill>
-                <a:latin typeface="Calibri" pitchFamily="34" charset="0"/>
-                <a:ea typeface="Calibri" pitchFamily="34" charset="-122"/>
-                <a:cs typeface="Calibri" pitchFamily="34" charset="-120"/>
+                <a:latin typeface="Optimist Sans" pitchFamily="34" charset="0"/>
+                <a:ea typeface="Optimist Sans" pitchFamily="34" charset="-122"/>
+                <a:cs typeface="Optimist Sans" pitchFamily="34" charset="-120"/>
               </a:rPr>
               <a:t>Senior ICs + AI agents</a:t>
             </a:r>
@@ -10806,9 +10806,9 @@
                 <a:solidFill>
                   <a:srgbClr val="14213D"/>
                 </a:solidFill>
-                <a:latin typeface="Calibri" pitchFamily="34" charset="0"/>
-                <a:ea typeface="Calibri" pitchFamily="34" charset="-122"/>
-                <a:cs typeface="Calibri" pitchFamily="34" charset="-120"/>
+                <a:latin typeface="Optimist Sans" pitchFamily="34" charset="0"/>
+                <a:ea typeface="Optimist Sans" pitchFamily="34" charset="-122"/>
+                <a:cs typeface="Optimist Sans" pitchFamily="34" charset="-120"/>
               </a:rPr>
               <a:t>Juniors</a:t>
             </a:r>
@@ -10848,9 +10848,9 @@
                 <a:solidFill>
                   <a:srgbClr val="4A5568"/>
                 </a:solidFill>
-                <a:latin typeface="Calibri" pitchFamily="34" charset="0"/>
-                <a:ea typeface="Calibri" pitchFamily="34" charset="-122"/>
-                <a:cs typeface="Calibri" pitchFamily="34" charset="-120"/>
+                <a:latin typeface="Optimist Sans" pitchFamily="34" charset="0"/>
+                <a:ea typeface="Optimist Sans" pitchFamily="34" charset="-122"/>
+                <a:cs typeface="Optimist Sans" pitchFamily="34" charset="-120"/>
               </a:rPr>
               <a:t>Fewer layers, more senior mix</a:t>
             </a:r>
@@ -10917,9 +10917,9 @@
                 <a:solidFill>
                   <a:srgbClr val="14213D"/>
                 </a:solidFill>
-                <a:latin typeface="Calibri" pitchFamily="34" charset="0"/>
-                <a:ea typeface="Calibri" pitchFamily="34" charset="-122"/>
-                <a:cs typeface="Calibri" pitchFamily="34" charset="-120"/>
+                <a:latin typeface="Optimist Sans" pitchFamily="34" charset="0"/>
+                <a:ea typeface="Optimist Sans" pitchFamily="34" charset="-122"/>
+                <a:cs typeface="Optimist Sans" pitchFamily="34" charset="-120"/>
               </a:rPr>
               <a:t>What changes</a:t>
             </a:r>
@@ -10959,9 +10959,9 @@
                 <a:solidFill>
                   <a:srgbClr val="8A4514"/>
                 </a:solidFill>
-                <a:latin typeface="Calibri" pitchFamily="34" charset="0"/>
-                <a:ea typeface="Calibri" pitchFamily="34" charset="-122"/>
-                <a:cs typeface="Calibri" pitchFamily="34" charset="-120"/>
+                <a:latin typeface="Optimist Sans" pitchFamily="34" charset="0"/>
+                <a:ea typeface="Optimist Sans" pitchFamily="34" charset="-122"/>
+                <a:cs typeface="Optimist Sans" pitchFamily="34" charset="-120"/>
               </a:rPr>
               <a:t>Manager path </a:t>
             </a:r>
@@ -10976,9 +10976,9 @@
                 <a:solidFill>
                   <a:srgbClr val="4A5568"/>
                 </a:solidFill>
-                <a:latin typeface="Calibri" pitchFamily="34" charset="0"/>
-                <a:ea typeface="Calibri" pitchFamily="34" charset="-122"/>
-                <a:cs typeface="Calibri" pitchFamily="34" charset="-120"/>
+                <a:latin typeface="Optimist Sans" pitchFamily="34" charset="0"/>
+                <a:ea typeface="Optimist Sans" pitchFamily="34" charset="-122"/>
+                <a:cs typeface="Optimist Sans" pitchFamily="34" charset="-120"/>
               </a:rPr>
               <a:t>carries wider spans</a:t>
             </a:r>
@@ -11018,9 +11018,9 @@
                 <a:solidFill>
                   <a:srgbClr val="155563"/>
                 </a:solidFill>
-                <a:latin typeface="Calibri" pitchFamily="34" charset="0"/>
-                <a:ea typeface="Calibri" pitchFamily="34" charset="-122"/>
-                <a:cs typeface="Calibri" pitchFamily="34" charset="-120"/>
+                <a:latin typeface="Optimist Sans" pitchFamily="34" charset="0"/>
+                <a:ea typeface="Optimist Sans" pitchFamily="34" charset="-122"/>
+                <a:cs typeface="Optimist Sans" pitchFamily="34" charset="-120"/>
               </a:rPr>
               <a:t>IC path </a:t>
             </a:r>
@@ -11035,9 +11035,9 @@
                 <a:solidFill>
                   <a:srgbClr val="4A5568"/>
                 </a:solidFill>
-                <a:latin typeface="Calibri" pitchFamily="34" charset="0"/>
-                <a:ea typeface="Calibri" pitchFamily="34" charset="-122"/>
-                <a:cs typeface="Calibri" pitchFamily="34" charset="-120"/>
+                <a:latin typeface="Optimist Sans" pitchFamily="34" charset="0"/>
+                <a:ea typeface="Optimist Sans" pitchFamily="34" charset="-122"/>
+                <a:cs typeface="Optimist Sans" pitchFamily="34" charset="-120"/>
               </a:rPr>
               <a:t>becomes the core: seniors directing agents</a:t>
             </a:r>
@@ -11077,9 +11077,9 @@
                 <a:solidFill>
                   <a:srgbClr val="4A5568"/>
                 </a:solidFill>
-                <a:latin typeface="Calibri" pitchFamily="34" charset="0"/>
-                <a:ea typeface="Calibri" pitchFamily="34" charset="-122"/>
-                <a:cs typeface="Calibri" pitchFamily="34" charset="-120"/>
+                <a:latin typeface="Optimist Sans" pitchFamily="34" charset="0"/>
+                <a:ea typeface="Optimist Sans" pitchFamily="34" charset="-122"/>
+                <a:cs typeface="Optimist Sans" pitchFamily="34" charset="-120"/>
               </a:rPr>
               <a:t>Open question: </a:t>
             </a:r>
@@ -11094,9 +11094,9 @@
                 <a:solidFill>
                   <a:srgbClr val="4A5568"/>
                 </a:solidFill>
-                <a:latin typeface="Calibri" pitchFamily="34" charset="0"/>
-                <a:ea typeface="Calibri" pitchFamily="34" charset="-122"/>
-                <a:cs typeface="Calibri" pitchFamily="34" charset="-120"/>
+                <a:latin typeface="Optimist Sans" pitchFamily="34" charset="0"/>
+                <a:ea typeface="Optimist Sans" pitchFamily="34" charset="-122"/>
+                <a:cs typeface="Optimist Sans" pitchFamily="34" charset="-120"/>
               </a:rPr>
               <a:t>how do juniors build judgment when agents do entry-level work?</a:t>
             </a:r>
@@ -11136,9 +11136,9 @@
                 <a:solidFill>
                   <a:srgbClr val="A0521A"/>
                 </a:solidFill>
-                <a:latin typeface="Calibri" pitchFamily="34" charset="0"/>
-                <a:ea typeface="Calibri" pitchFamily="34" charset="-122"/>
-                <a:cs typeface="Calibri" pitchFamily="34" charset="-120"/>
+                <a:latin typeface="Optimist Sans" pitchFamily="34" charset="0"/>
+                <a:ea typeface="Optimist Sans" pitchFamily="34" charset="-122"/>
+                <a:cs typeface="Optimist Sans" pitchFamily="34" charset="-120"/>
               </a:rPr>
               <a:t>→ [Junior pipeline approach]</a:t>
             </a:r>
@@ -11178,9 +11178,9 @@
                 <a:solidFill>
                   <a:srgbClr val="6B7280"/>
                 </a:solidFill>
-                <a:latin typeface="Calibri" pitchFamily="34" charset="0"/>
-                <a:ea typeface="Calibri" pitchFamily="34" charset="-122"/>
-                <a:cs typeface="Calibri" pitchFamily="34" charset="-120"/>
+                <a:latin typeface="Optimist Sans" pitchFamily="34" charset="0"/>
+                <a:ea typeface="Optimist Sans" pitchFamily="34" charset="-122"/>
+                <a:cs typeface="Optimist Sans" pitchFamily="34" charset="-120"/>
               </a:rPr>
               <a:t>Draft for discussion · Shapes are illustrative</a:t>
             </a:r>
@@ -11220,9 +11220,9 @@
                 <a:solidFill>
                   <a:srgbClr val="6B7280"/>
                 </a:solidFill>
-                <a:latin typeface="Calibri"/>
-                <a:ea typeface="Calibri"/>
-                <a:cs typeface="Calibri"/>
+                <a:latin typeface="Optimist Sans"/>
+                <a:ea typeface="Optimist Sans"/>
+                <a:cs typeface="Optimist Sans"/>
               </a:defRPr>
             </a:lvl1pPr>
           </a:lstStyle>
@@ -11293,9 +11293,9 @@
                 <a:solidFill>
                   <a:srgbClr val="A0521A"/>
                 </a:solidFill>
-                <a:latin typeface="Calibri" pitchFamily="34" charset="0"/>
-                <a:ea typeface="Calibri" pitchFamily="34" charset="-122"/>
-                <a:cs typeface="Calibri" pitchFamily="34" charset="-120"/>
+                <a:latin typeface="Optimist Sans" pitchFamily="34" charset="0"/>
+                <a:ea typeface="Optimist Sans" pitchFamily="34" charset="-122"/>
+                <a:cs typeface="Optimist Sans" pitchFamily="34" charset="-120"/>
               </a:rPr>
               <a:t>NEXT STEPS</a:t>
             </a:r>
@@ -11334,9 +11334,9 @@
                 <a:solidFill>
                   <a:srgbClr val="14213D"/>
                 </a:solidFill>
-                <a:latin typeface="Cambria" pitchFamily="34" charset="0"/>
-                <a:ea typeface="Cambria" pitchFamily="34" charset="-122"/>
-                <a:cs typeface="Cambria" pitchFamily="34" charset="-120"/>
+                <a:latin typeface="Optimist Display" pitchFamily="34" charset="0"/>
+                <a:ea typeface="Optimist Display" pitchFamily="34" charset="-122"/>
+                <a:cs typeface="Optimist Display" pitchFamily="34" charset="-120"/>
               </a:rPr>
               <a:t>We are asking leadership to align on the vision and four near-term decisions</a:t>
             </a:r>
@@ -11399,9 +11399,9 @@
                 <a:solidFill>
                   <a:srgbClr val="1F6F7E"/>
                 </a:solidFill>
-                <a:latin typeface="Cambria" pitchFamily="34" charset="0"/>
-                <a:ea typeface="Cambria" pitchFamily="34" charset="-122"/>
-                <a:cs typeface="Cambria" pitchFamily="34" charset="-120"/>
+                <a:latin typeface="Optimist Display" pitchFamily="34" charset="0"/>
+                <a:ea typeface="Optimist Display" pitchFamily="34" charset="-122"/>
+                <a:cs typeface="Optimist Display" pitchFamily="34" charset="-120"/>
               </a:rPr>
               <a:t>1</a:t>
             </a:r>
@@ -11441,9 +11441,9 @@
                 <a:solidFill>
                   <a:srgbClr val="14213D"/>
                 </a:solidFill>
-                <a:latin typeface="Calibri" pitchFamily="34" charset="0"/>
-                <a:ea typeface="Calibri" pitchFamily="34" charset="-122"/>
-                <a:cs typeface="Calibri" pitchFamily="34" charset="-120"/>
+                <a:latin typeface="Optimist Sans" pitchFamily="34" charset="0"/>
+                <a:ea typeface="Optimist Sans" pitchFamily="34" charset="-122"/>
+                <a:cs typeface="Optimist Sans" pitchFamily="34" charset="-120"/>
               </a:rPr>
               <a:t>Endorse the combined vision and four-function structure</a:t>
             </a:r>
@@ -11483,9 +11483,9 @@
                 <a:solidFill>
                   <a:srgbClr val="4A5568"/>
                 </a:solidFill>
-                <a:latin typeface="Calibri" pitchFamily="34" charset="0"/>
-                <a:ea typeface="Calibri" pitchFamily="34" charset="-122"/>
-                <a:cs typeface="Calibri" pitchFamily="34" charset="-120"/>
+                <a:latin typeface="Optimist Sans" pitchFamily="34" charset="0"/>
+                <a:ea typeface="Optimist Sans" pitchFamily="34" charset="-122"/>
+                <a:cs typeface="Optimist Sans" pitchFamily="34" charset="-120"/>
               </a:rPr>
               <a:t>Modeling &amp; Automation, Data Foundation, Platform &amp; Deployment, AI Enablement</a:t>
             </a:r>
@@ -11548,9 +11548,9 @@
                 <a:solidFill>
                   <a:srgbClr val="1F6F7E"/>
                 </a:solidFill>
-                <a:latin typeface="Cambria" pitchFamily="34" charset="0"/>
-                <a:ea typeface="Cambria" pitchFamily="34" charset="-122"/>
-                <a:cs typeface="Cambria" pitchFamily="34" charset="-120"/>
+                <a:latin typeface="Optimist Display" pitchFamily="34" charset="0"/>
+                <a:ea typeface="Optimist Display" pitchFamily="34" charset="-122"/>
+                <a:cs typeface="Optimist Display" pitchFamily="34" charset="-120"/>
               </a:rPr>
               <a:t>2</a:t>
             </a:r>
@@ -11590,9 +11590,9 @@
                 <a:solidFill>
                   <a:srgbClr val="14213D"/>
                 </a:solidFill>
-                <a:latin typeface="Calibri" pitchFamily="34" charset="0"/>
-                <a:ea typeface="Calibri" pitchFamily="34" charset="-122"/>
-                <a:cs typeface="Calibri" pitchFamily="34" charset="-120"/>
+                <a:latin typeface="Optimist Sans" pitchFamily="34" charset="0"/>
+                <a:ea typeface="Optimist Sans" pitchFamily="34" charset="-122"/>
+                <a:cs typeface="Optimist Sans" pitchFamily="34" charset="-120"/>
               </a:rPr>
               <a:t>Support leaders stepping into stretch roles</a:t>
             </a:r>
@@ -11632,9 +11632,9 @@
                 <a:solidFill>
                   <a:srgbClr val="4A5568"/>
                 </a:solidFill>
-                <a:latin typeface="Calibri" pitchFamily="34" charset="0"/>
-                <a:ea typeface="Calibri" pitchFamily="34" charset="-122"/>
-                <a:cs typeface="Calibri" pitchFamily="34" charset="-120"/>
+                <a:latin typeface="Optimist Sans" pitchFamily="34" charset="0"/>
+                <a:ea typeface="Optimist Sans" pitchFamily="34" charset="-122"/>
+                <a:cs typeface="Optimist Sans" pitchFamily="34" charset="-120"/>
               </a:rPr>
               <a:t>[Interim coverage, coaching or hiring plan for vacated lead roles]</a:t>
             </a:r>
@@ -11697,9 +11697,9 @@
                 <a:solidFill>
                   <a:srgbClr val="1F6F7E"/>
                 </a:solidFill>
-                <a:latin typeface="Cambria" pitchFamily="34" charset="0"/>
-                <a:ea typeface="Cambria" pitchFamily="34" charset="-122"/>
-                <a:cs typeface="Cambria" pitchFamily="34" charset="-120"/>
+                <a:latin typeface="Optimist Display" pitchFamily="34" charset="0"/>
+                <a:ea typeface="Optimist Display" pitchFamily="34" charset="-122"/>
+                <a:cs typeface="Optimist Display" pitchFamily="34" charset="-120"/>
               </a:rPr>
               <a:t>3</a:t>
             </a:r>
@@ -11739,9 +11739,9 @@
                 <a:solidFill>
                   <a:srgbClr val="14213D"/>
                 </a:solidFill>
-                <a:latin typeface="Calibri" pitchFamily="34" charset="0"/>
-                <a:ea typeface="Calibri" pitchFamily="34" charset="-122"/>
-                <a:cs typeface="Calibri" pitchFamily="34" charset="-120"/>
+                <a:latin typeface="Optimist Sans" pitchFamily="34" charset="0"/>
+                <a:ea typeface="Optimist Sans" pitchFamily="34" charset="-122"/>
+                <a:cs typeface="Optimist Sans" pitchFamily="34" charset="-120"/>
               </a:rPr>
               <a:t>Endorse redeploying freed capacity to AI work</a:t>
             </a:r>
@@ -11781,9 +11781,9 @@
                 <a:solidFill>
                   <a:srgbClr val="4A5568"/>
                 </a:solidFill>
-                <a:latin typeface="Calibri" pitchFamily="34" charset="0"/>
-                <a:ea typeface="Calibri" pitchFamily="34" charset="-122"/>
-                <a:cs typeface="Calibri" pitchFamily="34" charset="-120"/>
+                <a:latin typeface="Optimist Sans" pitchFamily="34" charset="0"/>
+                <a:ea typeface="Optimist Sans" pitchFamily="34" charset="-122"/>
+                <a:cs typeface="Optimist Sans" pitchFamily="34" charset="-120"/>
               </a:rPr>
               <a:t>Plus investment in the data foundation: [headcount or funding needed]</a:t>
             </a:r>
@@ -11846,9 +11846,9 @@
                 <a:solidFill>
                   <a:srgbClr val="1F6F7E"/>
                 </a:solidFill>
-                <a:latin typeface="Cambria" pitchFamily="34" charset="0"/>
-                <a:ea typeface="Cambria" pitchFamily="34" charset="-122"/>
-                <a:cs typeface="Cambria" pitchFamily="34" charset="-120"/>
+                <a:latin typeface="Optimist Display" pitchFamily="34" charset="0"/>
+                <a:ea typeface="Optimist Display" pitchFamily="34" charset="-122"/>
+                <a:cs typeface="Optimist Display" pitchFamily="34" charset="-120"/>
               </a:rPr>
               <a:t>4</a:t>
             </a:r>
@@ -11888,9 +11888,9 @@
                 <a:solidFill>
                   <a:srgbClr val="14213D"/>
                 </a:solidFill>
-                <a:latin typeface="Calibri" pitchFamily="34" charset="0"/>
-                <a:ea typeface="Calibri" pitchFamily="34" charset="-122"/>
-                <a:cs typeface="Calibri" pitchFamily="34" charset="-120"/>
+                <a:latin typeface="Optimist Sans" pitchFamily="34" charset="0"/>
+                <a:ea typeface="Optimist Sans" pitchFamily="34" charset="-122"/>
+                <a:cs typeface="Optimist Sans" pitchFamily="34" charset="-120"/>
               </a:rPr>
               <a:t>Agree on a transition timeline and checkpoints</a:t>
             </a:r>
@@ -11930,9 +11930,9 @@
                 <a:solidFill>
                   <a:srgbClr val="4A5568"/>
                 </a:solidFill>
-                <a:latin typeface="Calibri" pitchFamily="34" charset="0"/>
-                <a:ea typeface="Calibri" pitchFamily="34" charset="-122"/>
-                <a:cs typeface="Calibri" pitchFamily="34" charset="-120"/>
+                <a:latin typeface="Optimist Sans" pitchFamily="34" charset="0"/>
+                <a:ea typeface="Optimist Sans" pitchFamily="34" charset="-122"/>
+                <a:cs typeface="Optimist Sans" pitchFamily="34" charset="-120"/>
               </a:rPr>
               <a:t>[30/60/90-day milestones and review cadence]</a:t>
             </a:r>
@@ -11995,9 +11995,9 @@
                 <a:solidFill>
                   <a:srgbClr val="6B7280"/>
                 </a:solidFill>
-                <a:latin typeface="Calibri" pitchFamily="34" charset="0"/>
-                <a:ea typeface="Calibri" pitchFamily="34" charset="-122"/>
-                <a:cs typeface="Calibri" pitchFamily="34" charset="-120"/>
+                <a:latin typeface="Optimist Sans" pitchFamily="34" charset="0"/>
+                <a:ea typeface="Optimist Sans" pitchFamily="34" charset="-122"/>
+                <a:cs typeface="Optimist Sans" pitchFamily="34" charset="-120"/>
               </a:rPr>
               <a:t>Draft for discussion</a:t>
             </a:r>
@@ -12037,9 +12037,9 @@
                 <a:solidFill>
                   <a:srgbClr val="6B7280"/>
                 </a:solidFill>
-                <a:latin typeface="Calibri"/>
-                <a:ea typeface="Calibri"/>
-                <a:cs typeface="Calibri"/>
+                <a:latin typeface="Optimist Sans"/>
+                <a:ea typeface="Optimist Sans"/>
+                <a:cs typeface="Optimist Sans"/>
               </a:defRPr>
             </a:lvl1pPr>
           </a:lstStyle>
@@ -12104,7 +12104,7 @@
     </a:clrScheme>
     <a:fontScheme name="Unified Team Strategy">
       <a:majorFont>
-        <a:latin typeface="Cambria"/>
+        <a:latin typeface="Optimist Display"/>
         <a:ea typeface=""/>
         <a:cs typeface=""/>
         <a:font script="Jpan" typeface="游ゴシック Light"/>
@@ -12156,7 +12156,7 @@
         <a:font script="Tfng" typeface="Ebrima"/>
       </a:majorFont>
       <a:minorFont>
-        <a:latin typeface="Calibri"/>
+        <a:latin typeface="Optimist Sans"/>
         <a:ea typeface=""/>
         <a:cs typeface=""/>
         <a:font script="Jpan" typeface="游ゴシック"/>

</xml_diff>

<commit_message>
Rewrite benefits on Why-combine slide of Unified Team Strategy deck
Co-Authored-By: Claude Opus 5.5 <noreply@anthropic.com>
Claude-Session: https://claude.ai/code/session_01JXKaD9UU8MgeRWUr7sq4Za
</commit_message>
<xml_diff>
--- a/Unified Team Strategy.pptx
+++ b/Unified Team Strategy.pptx
@@ -115,27 +115,27 @@
   <p:extLst>
     <p:ext uri="{521415D9-36F7-43E2-AB2F-B90AF26B5E84}">
       <p14:sectionLst xmlns:p14="http://schemas.microsoft.com/office/powerpoint/2010/main">
-        <p14:section name="Why combine" id="{133c6a6f-61d8-183a-4696-aa2fb3cf5ae4}">
+        <p14:section name="Why combine" id="{14b54796-c006-2b29-73e0-c674af4ffb27}">
           <p14:sldIdLst>
             <p14:sldId id="256"/>
             <p14:sldId id="257"/>
           </p14:sldIdLst>
         </p14:section>
-        <p14:section name="How we organize" id="{76974712-220d-693e-98a6-53b28bd7c958}">
+        <p14:section name="How we organize" id="{382d21b2-6495-ce76-40d3-edd1d1f410e6}">
           <p14:sldIdLst>
             <p14:sldId id="258"/>
             <p14:sldId id="259"/>
             <p14:sldId id="260"/>
           </p14:sldIdLst>
         </p14:section>
-        <p14:section name="What we do and how we grow" id="{503e1cf9-d8a1-6f62-7037-427bc285a78d}">
+        <p14:section name="What we do and how we grow" id="{a45363a9-852d-d5be-7da3-693654eb719d}">
           <p14:sldIdLst>
             <p14:sldId id="261"/>
             <p14:sldId id="262"/>
             <p14:sldId id="263"/>
           </p14:sldIdLst>
         </p14:section>
-        <p14:section name="Asks" id="{58a758c0-5dfe-f639-241f-98e7961de3bc}">
+        <p14:section name="Asks" id="{1b9b985f-bf71-86c9-a350-deb3864db75b}">
           <p14:sldIdLst>
             <p14:sldId id="264"/>
           </p14:sldIdLst>
@@ -632,7 +632,7 @@
           <a:p>
             <a:r>
               <a:rPr lang="en-US" dirty="0"/>
-              <a:t>Friction today is modest, not a crisis — frame it as removing recurring overhead. The stretch roles are both an opportunity and a risk for the people in them. The point of this slide: every near-term cost has a named mitigation.</a:t>
+              <a:t>Benefit 1 is the biggest. Today the modeling team is led from the business side and model developers work closely with several business analysts. Real-time customer feedback is valuable, but decisions lean toward the business view and can miss technical risks only data scientists see. A leader with a technical background balances the two, so we build analytical products that meet business needs and technical standards, with less technical debt later. Benefit 2: hand-offs and support sit under one leader and one vision. Instead of the infrastructure team pushing modelers to adopt AI or data initiatives, the leader drives them and the whole team takes part. Benefit 3: a bigger talent pool means more internal mobility, aligned performance management, and the flexibility to concentrate people on a priority project at short notice. The stretch roles are both an opportunity and a risk for the people in them. The point of this slide: every near-term cost has a named mitigation.</a:t>
             </a:r>
             <a:endParaRPr lang="en-US" dirty="0"/>
           </a:p>
@@ -2297,7 +2297,7 @@
         </p:blipFill>
         <p:spPr>
           <a:xfrm>
-            <a:off x="1016000" y="3035300"/>
+            <a:off x="1016000" y="3009900"/>
             <a:ext cx="228600" cy="228600"/>
           </a:xfrm>
           <a:prstGeom prst="rect">
@@ -2313,7 +2313,7 @@
         </p:nvSpPr>
         <p:spPr>
           <a:xfrm>
-            <a:off x="1371600" y="3022600"/>
+            <a:off x="1371600" y="2997200"/>
             <a:ext cx="2857500" cy="254000"/>
           </a:xfrm>
           <a:prstGeom prst="rect">
@@ -2341,7 +2341,7 @@
                 <a:ea typeface="Optimist Sans" pitchFamily="34" charset="-122"/>
                 <a:cs typeface="Optimist Sans" pitchFamily="34" charset="-120"/>
               </a:rPr>
-              <a:t>One owner for AI initiatives</a:t>
+              <a:t>Balanced model decisions</a:t>
             </a:r>
             <a:endParaRPr lang="en-US" sz="1400" dirty="0"/>
           </a:p>
@@ -2355,8 +2355,8 @@
         </p:nvSpPr>
         <p:spPr>
           <a:xfrm>
-            <a:off x="1371600" y="3302000"/>
-            <a:ext cx="2857500" cy="444500"/>
+            <a:off x="1371600" y="3276600"/>
+            <a:ext cx="2857500" cy="584200"/>
           </a:xfrm>
           <a:prstGeom prst="rect">
             <a:avLst/>
@@ -2383,7 +2383,7 @@
                 <a:ea typeface="Optimist Sans" pitchFamily="34" charset="-122"/>
                 <a:cs typeface="Optimist Sans" pitchFamily="34" charset="-120"/>
               </a:rPr>
-              <a:t>Key AI projects in one org, fewer hand-offs</a:t>
+              <a:t>Technical rigor balances business input: sturdier models, less tech debt</a:t>
             </a:r>
             <a:endParaRPr lang="en-US" sz="1200" dirty="0"/>
           </a:p>
@@ -2405,7 +2405,7 @@
         </p:blipFill>
         <p:spPr>
           <a:xfrm>
-            <a:off x="1016000" y="3886200"/>
+            <a:off x="1016000" y="3898900"/>
             <a:ext cx="228600" cy="228600"/>
           </a:xfrm>
           <a:prstGeom prst="rect">
@@ -2421,7 +2421,7 @@
         </p:nvSpPr>
         <p:spPr>
           <a:xfrm>
-            <a:off x="1371600" y="3873500"/>
+            <a:off x="1371600" y="3886200"/>
             <a:ext cx="2857500" cy="254000"/>
           </a:xfrm>
           <a:prstGeom prst="rect">
@@ -2449,7 +2449,7 @@
                 <a:ea typeface="Optimist Sans" pitchFamily="34" charset="-122"/>
                 <a:cs typeface="Optimist Sans" pitchFamily="34" charset="-120"/>
               </a:rPr>
-              <a:t>Less friction</a:t>
+              <a:t>One leader, one agenda</a:t>
             </a:r>
             <a:endParaRPr lang="en-US" sz="1400" dirty="0"/>
           </a:p>
@@ -2463,8 +2463,8 @@
         </p:nvSpPr>
         <p:spPr>
           <a:xfrm>
-            <a:off x="1371600" y="4152900"/>
-            <a:ext cx="2857500" cy="444500"/>
+            <a:off x="1371600" y="4165600"/>
+            <a:ext cx="2857500" cy="584200"/>
           </a:xfrm>
           <a:prstGeom prst="rect">
             <a:avLst/>
@@ -2491,7 +2491,7 @@
                 <a:ea typeface="Optimist Sans" pitchFamily="34" charset="-122"/>
                 <a:cs typeface="Optimist Sans" pitchFamily="34" charset="-120"/>
               </a:rPr>
-              <a:t>Modelers are no longer an internal customer</a:t>
+              <a:t>AI and data work driven from within, not pushed across team lines</a:t>
             </a:r>
             <a:endParaRPr lang="en-US" sz="1200" dirty="0"/>
           </a:p>
@@ -2513,7 +2513,7 @@
         </p:blipFill>
         <p:spPr>
           <a:xfrm>
-            <a:off x="1016000" y="4737100"/>
+            <a:off x="1016000" y="4787900"/>
             <a:ext cx="228600" cy="228600"/>
           </a:xfrm>
           <a:prstGeom prst="rect">
@@ -2529,7 +2529,7 @@
         </p:nvSpPr>
         <p:spPr>
           <a:xfrm>
-            <a:off x="1371600" y="4724400"/>
+            <a:off x="1371600" y="4775200"/>
             <a:ext cx="2857500" cy="254000"/>
           </a:xfrm>
           <a:prstGeom prst="rect">
@@ -2571,8 +2571,8 @@
         </p:nvSpPr>
         <p:spPr>
           <a:xfrm>
-            <a:off x="1371600" y="5003800"/>
-            <a:ext cx="2857500" cy="444500"/>
+            <a:off x="1371600" y="5054600"/>
+            <a:ext cx="2857500" cy="584200"/>
           </a:xfrm>
           <a:prstGeom prst="rect">
             <a:avLst/>
@@ -2599,7 +2599,7 @@
                 <a:ea typeface="Optimist Sans" pitchFamily="34" charset="-122"/>
                 <a:cs typeface="Optimist Sans" pitchFamily="34" charset="-120"/>
               </a:rPr>
-              <a:t>Focus on critical work; leaner and nimbler</a:t>
+              <a:t>More mobility, aligned performance management, fast redeployment</a:t>
             </a:r>
             <a:endParaRPr lang="en-US" sz="1200" dirty="0"/>
           </a:p>

</xml_diff>

<commit_message>
Rewrite near-term costs and mitigations on Why-combine slide
Co-Authored-By: Claude Opus 5.5 <noreply@anthropic.com>
Claude-Session: https://claude.ai/code/session_01JXKaD9UU8MgeRWUr7sq4Za
</commit_message>
<xml_diff>
--- a/Unified Team Strategy.pptx
+++ b/Unified Team Strategy.pptx
@@ -115,27 +115,27 @@
   <p:extLst>
     <p:ext uri="{521415D9-36F7-43E2-AB2F-B90AF26B5E84}">
       <p14:sectionLst xmlns:p14="http://schemas.microsoft.com/office/powerpoint/2010/main">
-        <p14:section name="Why combine" id="{14b54796-c006-2b29-73e0-c674af4ffb27}">
+        <p14:section name="Why combine" id="{11bab82d-bf3a-dad3-1238-60455fd61e1e}">
           <p14:sldIdLst>
             <p14:sldId id="256"/>
             <p14:sldId id="257"/>
           </p14:sldIdLst>
         </p14:section>
-        <p14:section name="How we organize" id="{382d21b2-6495-ce76-40d3-edd1d1f410e6}">
+        <p14:section name="How we organize" id="{6edda9af-58a8-fb5f-8577-c70a54bdf3f8}">
           <p14:sldIdLst>
             <p14:sldId id="258"/>
             <p14:sldId id="259"/>
             <p14:sldId id="260"/>
           </p14:sldIdLst>
         </p14:section>
-        <p14:section name="What we do and how we grow" id="{a45363a9-852d-d5be-7da3-693654eb719d}">
+        <p14:section name="What we do and how we grow" id="{262ebd2e-93f1-7195-9ae9-8bdba9784195}">
           <p14:sldIdLst>
             <p14:sldId id="261"/>
             <p14:sldId id="262"/>
             <p14:sldId id="263"/>
           </p14:sldIdLst>
         </p14:section>
-        <p14:section name="Asks" id="{1b9b985f-bf71-86c9-a350-deb3864db75b}">
+        <p14:section name="Asks" id="{f7415e6b-23eb-d4ef-51d6-4dc9cfaa0197}">
           <p14:sldIdLst>
             <p14:sldId id="264"/>
           </p14:sldIdLst>
@@ -632,7 +632,7 @@
           <a:p>
             <a:r>
               <a:rPr lang="en-US" dirty="0"/>
-              <a:t>Benefit 1 is the biggest. Today the modeling team is led from the business side and model developers work closely with several business analysts. Real-time customer feedback is valuable, but decisions lean toward the business view and can miss technical risks only data scientists see. A leader with a technical background balances the two, so we build analytical products that meet business needs and technical standards, with less technical debt later. Benefit 2: hand-offs and support sit under one leader and one vision. Instead of the infrastructure team pushing modelers to adopt AI or data initiatives, the leader drives them and the whole team takes part. Benefit 3: a bigger talent pool means more internal mobility, aligned performance management, and the flexibility to concentrate people on a priority project at short notice. The stretch roles are both an opportunity and a risk for the people in them. The point of this slide: every near-term cost has a named mitigation.</a:t>
+              <a:t>Benefit 1 is the biggest. Today the modeling team is led from the business side and model developers work closely with several business analysts. Real-time customer feedback is valuable, but decisions lean toward the business view and can miss technical risks only data scientists see. A leader with a technical background balances the two, so we build analytical products that meet business needs and technical standards, with less technical debt later. Benefit 2: hand-offs and support sit under one leader and one vision. Instead of the infrastructure team pushing modelers to adopt AI or data initiatives, the leader drives them and the whole team takes part. Benefit 3: a bigger talent pool means more internal mobility, aligned performance management, and the flexibility to concentrate people on a priority project at short notice. Costs: (1) With mid-level managers gone, the people stepping up, including the team lead, cover a broader scope; how we support them is still open. (2) Every lead takes on unfamiliar areas, for example Dual Risk Rating modeling and its business stakeholders. This is expected reorg pain; we lean on business analysts and former team members who know the area. (3) The new vision changes some earlier decisions (modeling choices, integration plans, tool development), which can cause rework and frustration. The answer is transparent communication of the vision to the whole team, not only to senior leaders; that is on the team lead to do well.</a:t>
             </a:r>
             <a:endParaRPr lang="en-US" dirty="0"/>
           </a:p>
@@ -2698,11 +2698,11 @@
         <p:spPr>
           <a:xfrm>
             <a:off x="4673600" y="2768600"/>
-            <a:ext cx="2667000" cy="812800"/>
+            <a:ext cx="2667000" cy="889000"/>
           </a:xfrm>
           <a:prstGeom prst="roundRect">
             <a:avLst>
-              <a:gd name="adj" fmla="val 11250"/>
+              <a:gd name="adj" fmla="val 10286"/>
             </a:avLst>
           </a:prstGeom>
           <a:solidFill>
@@ -2724,7 +2724,7 @@
         </p:nvSpPr>
         <p:spPr>
           <a:xfrm>
-            <a:off x="4826000" y="2895600"/>
+            <a:off x="4826000" y="2870200"/>
             <a:ext cx="2413000" cy="254000"/>
           </a:xfrm>
           <a:prstGeom prst="rect">
@@ -2752,7 +2752,7 @@
                 <a:ea typeface="Optimist Sans" pitchFamily="34" charset="-122"/>
                 <a:cs typeface="Optimist Sans" pitchFamily="34" charset="-120"/>
               </a:rPr>
-              <a:t>Large new model scope</a:t>
+              <a:t>Stretched leadership</a:t>
             </a:r>
             <a:endParaRPr lang="en-US" sz="1400" dirty="0"/>
           </a:p>
@@ -2766,8 +2766,8 @@
         </p:nvSpPr>
         <p:spPr>
           <a:xfrm>
-            <a:off x="4826000" y="3187700"/>
-            <a:ext cx="2413000" cy="254000"/>
+            <a:off x="4826000" y="3149600"/>
+            <a:ext cx="2413000" cy="444500"/>
           </a:xfrm>
           <a:prstGeom prst="rect">
             <a:avLst/>
@@ -2794,7 +2794,7 @@
                 <a:ea typeface="Optimist Sans" pitchFamily="34" charset="-122"/>
                 <a:cs typeface="Optimist Sans" pitchFamily="34" charset="-120"/>
               </a:rPr>
-              <a:t>Dual Risk Rating models</a:t>
+              <a:t>Mid-level managers left; leads cover more</a:t>
             </a:r>
             <a:endParaRPr lang="en-US" sz="1200" dirty="0"/>
           </a:p>
@@ -2808,7 +2808,7 @@
         </p:nvSpPr>
         <p:spPr>
           <a:xfrm>
-            <a:off x="7493000" y="3073400"/>
+            <a:off x="7493000" y="3111500"/>
             <a:ext cx="406400" cy="203200"/>
           </a:xfrm>
           <a:prstGeom prst="rightArrow">
@@ -2829,11 +2829,11 @@
         <p:spPr>
           <a:xfrm>
             <a:off x="8051800" y="2768600"/>
-            <a:ext cx="3327400" cy="812800"/>
+            <a:ext cx="3327400" cy="889000"/>
           </a:xfrm>
           <a:prstGeom prst="roundRect">
             <a:avLst>
-              <a:gd name="adj" fmla="val 11250"/>
+              <a:gd name="adj" fmla="val 10286"/>
             </a:avLst>
           </a:prstGeom>
           <a:solidFill>
@@ -2855,8 +2855,8 @@
         </p:nvSpPr>
         <p:spPr>
           <a:xfrm>
-            <a:off x="8204200" y="2895600"/>
-            <a:ext cx="3022600" cy="571500"/>
+            <a:off x="8204200" y="2870200"/>
+            <a:ext cx="3022600" cy="685800"/>
           </a:xfrm>
           <a:prstGeom prst="rect">
             <a:avLst/>
@@ -2883,7 +2883,7 @@
                 <a:ea typeface="Optimist Sans" pitchFamily="34" charset="-122"/>
                 <a:cs typeface="Optimist Sans" pitchFamily="34" charset="-120"/>
               </a:rPr>
-              <a:t>[e.g., phased handover; lean on DRR experts in the team]</a:t>
+              <a:t>[TBD: support model for stretched leads]</a:t>
             </a:r>
             <a:endParaRPr lang="en-US" sz="1200" dirty="0"/>
           </a:p>
@@ -2897,12 +2897,12 @@
         </p:nvSpPr>
         <p:spPr>
           <a:xfrm>
-            <a:off x="4673600" y="3759200"/>
-            <a:ext cx="2667000" cy="812800"/>
+            <a:off x="4673600" y="3784600"/>
+            <a:ext cx="2667000" cy="889000"/>
           </a:xfrm>
           <a:prstGeom prst="roundRect">
             <a:avLst>
-              <a:gd name="adj" fmla="val 11250"/>
+              <a:gd name="adj" fmla="val 10286"/>
             </a:avLst>
           </a:prstGeom>
           <a:solidFill>
@@ -2952,7 +2952,7 @@
                 <a:ea typeface="Optimist Sans" pitchFamily="34" charset="-122"/>
                 <a:cs typeface="Optimist Sans" pitchFamily="34" charset="-120"/>
               </a:rPr>
-              <a:t>Leadership gap</a:t>
+              <a:t>Steep learning curve</a:t>
             </a:r>
             <a:endParaRPr lang="en-US" sz="1400" dirty="0"/>
           </a:p>
@@ -2966,8 +2966,8 @@
         </p:nvSpPr>
         <p:spPr>
           <a:xfrm>
-            <a:off x="4826000" y="4178300"/>
-            <a:ext cx="2413000" cy="254000"/>
+            <a:off x="4826000" y="4165600"/>
+            <a:ext cx="2413000" cy="444500"/>
           </a:xfrm>
           <a:prstGeom prst="rect">
             <a:avLst/>
@@ -2994,7 +2994,7 @@
                 <a:ea typeface="Optimist Sans" pitchFamily="34" charset="-122"/>
                 <a:cs typeface="Optimist Sans" pitchFamily="34" charset="-120"/>
               </a:rPr>
-              <a:t>Interim leads left the team</a:t>
+              <a:t>New areas for leads, e.g., DRR and its stakeholders</a:t>
             </a:r>
             <a:endParaRPr lang="en-US" sz="1200" dirty="0"/>
           </a:p>
@@ -3008,7 +3008,7 @@
         </p:nvSpPr>
         <p:spPr>
           <a:xfrm>
-            <a:off x="7493000" y="4064000"/>
+            <a:off x="7493000" y="4127500"/>
             <a:ext cx="406400" cy="203200"/>
           </a:xfrm>
           <a:prstGeom prst="rightArrow">
@@ -3028,22 +3028,22 @@
         </p:nvSpPr>
         <p:spPr>
           <a:xfrm>
-            <a:off x="8051800" y="3759200"/>
-            <a:ext cx="3327400" cy="812800"/>
+            <a:off x="8051800" y="3784600"/>
+            <a:ext cx="3327400" cy="889000"/>
           </a:xfrm>
           <a:prstGeom prst="roundRect">
             <a:avLst>
-              <a:gd name="adj" fmla="val 11250"/>
+              <a:gd name="adj" fmla="val 10286"/>
             </a:avLst>
           </a:prstGeom>
           <a:solidFill>
-            <a:srgbClr val="FDFCF9"/>
+            <a:srgbClr val="E1EEF0"/>
           </a:solidFill>
           <a:ln w="19050">
             <a:solidFill>
               <a:srgbClr val="1F6F7E"/>
             </a:solidFill>
-            <a:prstDash val="dash"/>
+            <a:prstDash val="solid"/>
           </a:ln>
         </p:spPr>
       </p:sp>
@@ -3056,7 +3056,7 @@
         <p:spPr>
           <a:xfrm>
             <a:off x="8204200" y="3886200"/>
-            <a:ext cx="3022600" cy="571500"/>
+            <a:ext cx="3022600" cy="685800"/>
           </a:xfrm>
           <a:prstGeom prst="rect">
             <a:avLst/>
@@ -3077,13 +3077,13 @@
             <a:r>
               <a:rPr lang="en-US" sz="1200" dirty="0">
                 <a:solidFill>
-                  <a:srgbClr val="155563"/>
-                </a:solidFill>
-                <a:latin typeface="Optimist Sans" pitchFamily="34" charset="0"/>
-                <a:ea typeface="Optimist Sans" pitchFamily="34" charset="-122"/>
-                <a:cs typeface="Optimist Sans" pitchFamily="34" charset="-120"/>
-              </a:rPr>
-              <a:t>[e.g., coaching and backup for direct reports in stretch roles]</a:t>
+                  <a:srgbClr val="14213D"/>
+                </a:solidFill>
+                <a:latin typeface="Optimist Sans" pitchFamily="34" charset="0"/>
+                <a:ea typeface="Optimist Sans" pitchFamily="34" charset="-122"/>
+                <a:cs typeface="Optimist Sans" pitchFamily="34" charset="-120"/>
+              </a:rPr>
+              <a:t>Lean on experts: business analysts and prior team members</a:t>
             </a:r>
             <a:endParaRPr lang="en-US" sz="1200" dirty="0"/>
           </a:p>
@@ -3097,12 +3097,12 @@
         </p:nvSpPr>
         <p:spPr>
           <a:xfrm>
-            <a:off x="4673600" y="4749800"/>
-            <a:ext cx="2667000" cy="812800"/>
+            <a:off x="4673600" y="4800600"/>
+            <a:ext cx="2667000" cy="889000"/>
           </a:xfrm>
           <a:prstGeom prst="roundRect">
             <a:avLst>
-              <a:gd name="adj" fmla="val 11250"/>
+              <a:gd name="adj" fmla="val 10286"/>
             </a:avLst>
           </a:prstGeom>
           <a:solidFill>
@@ -3124,7 +3124,7 @@
         </p:nvSpPr>
         <p:spPr>
           <a:xfrm>
-            <a:off x="4826000" y="4876800"/>
+            <a:off x="4826000" y="4902200"/>
             <a:ext cx="2413000" cy="254000"/>
           </a:xfrm>
           <a:prstGeom prst="rect">
@@ -3152,7 +3152,7 @@
                 <a:ea typeface="Optimist Sans" pitchFamily="34" charset="-122"/>
                 <a:cs typeface="Optimist Sans" pitchFamily="34" charset="-120"/>
               </a:rPr>
-              <a:t>Growth and stretch pain</a:t>
+              <a:t>Rework and frustration</a:t>
             </a:r>
             <a:endParaRPr lang="en-US" sz="1400" dirty="0"/>
           </a:p>
@@ -3166,8 +3166,8 @@
         </p:nvSpPr>
         <p:spPr>
           <a:xfrm>
-            <a:off x="4826000" y="5168900"/>
-            <a:ext cx="2413000" cy="254000"/>
+            <a:off x="4826000" y="5181600"/>
+            <a:ext cx="2413000" cy="444500"/>
           </a:xfrm>
           <a:prstGeom prst="rect">
             <a:avLst/>
@@ -3194,7 +3194,7 @@
                 <a:ea typeface="Optimist Sans" pitchFamily="34" charset="-122"/>
                 <a:cs typeface="Optimist Sans" pitchFamily="34" charset="-120"/>
               </a:rPr>
-              <a:t>Load rises as we adapt</a:t>
+              <a:t>Vision revisits past model, integration, tool choices</a:t>
             </a:r>
             <a:endParaRPr lang="en-US" sz="1200" dirty="0"/>
           </a:p>
@@ -3208,7 +3208,7 @@
         </p:nvSpPr>
         <p:spPr>
           <a:xfrm>
-            <a:off x="7493000" y="5054600"/>
+            <a:off x="7493000" y="5143500"/>
             <a:ext cx="406400" cy="203200"/>
           </a:xfrm>
           <a:prstGeom prst="rightArrow">
@@ -3228,22 +3228,22 @@
         </p:nvSpPr>
         <p:spPr>
           <a:xfrm>
-            <a:off x="8051800" y="4749800"/>
-            <a:ext cx="3327400" cy="812800"/>
+            <a:off x="8051800" y="4800600"/>
+            <a:ext cx="3327400" cy="889000"/>
           </a:xfrm>
           <a:prstGeom prst="roundRect">
             <a:avLst>
-              <a:gd name="adj" fmla="val 11250"/>
+              <a:gd name="adj" fmla="val 10286"/>
             </a:avLst>
           </a:prstGeom>
           <a:solidFill>
-            <a:srgbClr val="FDFCF9"/>
+            <a:srgbClr val="E1EEF0"/>
           </a:solidFill>
           <a:ln w="19050">
             <a:solidFill>
               <a:srgbClr val="1F6F7E"/>
             </a:solidFill>
-            <a:prstDash val="dash"/>
+            <a:prstDash val="solid"/>
           </a:ln>
         </p:spPr>
       </p:sp>
@@ -3255,8 +3255,8 @@
         </p:nvSpPr>
         <p:spPr>
           <a:xfrm>
-            <a:off x="8204200" y="4876800"/>
-            <a:ext cx="3022600" cy="571500"/>
+            <a:off x="8204200" y="4902200"/>
+            <a:ext cx="3022600" cy="685800"/>
           </a:xfrm>
           <a:prstGeom prst="rect">
             <a:avLst/>
@@ -3277,13 +3277,13 @@
             <a:r>
               <a:rPr lang="en-US" sz="1200" dirty="0">
                 <a:solidFill>
-                  <a:srgbClr val="155563"/>
-                </a:solidFill>
-                <a:latin typeface="Optimist Sans" pitchFamily="34" charset="0"/>
-                <a:ea typeface="Optimist Sans" pitchFamily="34" charset="-122"/>
-                <a:cs typeface="Optimist Sans" pitchFamily="34" charset="-120"/>
-              </a:rPr>
-              <a:t>[e.g., sequence priorities; protect BAU capacity]</a:t>
+                  <a:srgbClr val="14213D"/>
+                </a:solidFill>
+                <a:latin typeface="Optimist Sans" pitchFamily="34" charset="0"/>
+                <a:ea typeface="Optimist Sans" pitchFamily="34" charset="-122"/>
+                <a:cs typeface="Optimist Sans" pitchFamily="34" charset="-120"/>
+              </a:rPr>
+              <a:t>Share the vision openly with the whole team, not just senior leaders</a:t>
             </a:r>
             <a:endParaRPr lang="en-US" sz="1200" dirty="0"/>
           </a:p>
@@ -3325,7 +3325,7 @@
                 <a:ea typeface="Optimist Sans" pitchFamily="34" charset="-122"/>
                 <a:cs typeface="Optimist Sans" pitchFamily="34" charset="-120"/>
               </a:rPr>
-              <a:t>Draft for discussion · Dashed boxes are placeholders to fill</a:t>
+              <a:t>Draft for discussion · Dashed box is still to be decided</a:t>
             </a:r>
             <a:endParaRPr lang="en-US" sz="1200" dirty="0"/>
           </a:p>

</xml_diff>

<commit_message>
Clarify equal career paths; refine near-term cost wording
Co-Authored-By: Claude Opus 5.5 <noreply@anthropic.com>
Claude-Session: https://claude.ai/code/session_01JXKaD9UU8MgeRWUr7sq4Za
</commit_message>
<xml_diff>
--- a/Unified Team Strategy.pptx
+++ b/Unified Team Strategy.pptx
@@ -115,27 +115,27 @@
   <p:extLst>
     <p:ext uri="{521415D9-36F7-43E2-AB2F-B90AF26B5E84}">
       <p14:sectionLst xmlns:p14="http://schemas.microsoft.com/office/powerpoint/2010/main">
-        <p14:section name="Why combine" id="{11bab82d-bf3a-dad3-1238-60455fd61e1e}">
+        <p14:section name="Why combine" id="{d05d4c85-240c-0061-3c77-97f495c31951}">
           <p14:sldIdLst>
             <p14:sldId id="256"/>
             <p14:sldId id="257"/>
           </p14:sldIdLst>
         </p14:section>
-        <p14:section name="How we organize" id="{6edda9af-58a8-fb5f-8577-c70a54bdf3f8}">
+        <p14:section name="How we organize" id="{b7afe13d-d96e-8d62-de6d-58687db432c5}">
           <p14:sldIdLst>
             <p14:sldId id="258"/>
             <p14:sldId id="259"/>
             <p14:sldId id="260"/>
           </p14:sldIdLst>
         </p14:section>
-        <p14:section name="What we do and how we grow" id="{262ebd2e-93f1-7195-9ae9-8bdba9784195}">
+        <p14:section name="What we do and how we grow" id="{e541194e-9854-2815-f5a1-55f4422a093a}">
           <p14:sldIdLst>
             <p14:sldId id="261"/>
             <p14:sldId id="262"/>
             <p14:sldId id="263"/>
           </p14:sldIdLst>
         </p14:section>
-        <p14:section name="Asks" id="{f7415e6b-23eb-d4ef-51d6-4dc9cfaa0197}">
+        <p14:section name="Asks" id="{7f2d9508-67e9-e45c-841f-e2e592b91e76}">
           <p14:sldIdLst>
             <p14:sldId id="264"/>
           </p14:sldIdLst>
@@ -632,7 +632,7 @@
           <a:p>
             <a:r>
               <a:rPr lang="en-US" dirty="0"/>
-              <a:t>Benefit 1 is the biggest. Today the modeling team is led from the business side and model developers work closely with several business analysts. Real-time customer feedback is valuable, but decisions lean toward the business view and can miss technical risks only data scientists see. A leader with a technical background balances the two, so we build analytical products that meet business needs and technical standards, with less technical debt later. Benefit 2: hand-offs and support sit under one leader and one vision. Instead of the infrastructure team pushing modelers to adopt AI or data initiatives, the leader drives them and the whole team takes part. Benefit 3: a bigger talent pool means more internal mobility, aligned performance management, and the flexibility to concentrate people on a priority project at short notice. Costs: (1) With mid-level managers gone, the people stepping up, including the team lead, cover a broader scope; how we support them is still open. (2) Every lead takes on unfamiliar areas, for example Dual Risk Rating modeling and its business stakeholders. This is expected reorg pain; we lean on business analysts and former team members who know the area. (3) The new vision changes some earlier decisions (modeling choices, integration plans, tool development), which can cause rework and frustration. The answer is transparent communication of the vision to the whole team, not only to senior leaders; that is on the team lead to do well.</a:t>
+              <a:t>Benefit 1 is the biggest. Today the modeling team is led from the business side and model developers work closely with several business analysts. Real-time customer feedback is valuable, but decisions lean toward the business view and can miss technical risks only data scientists see. A leader with a technical background balances the two, so we build analytical products that meet business needs and technical standards, with less technical debt later. Benefit 2: hand-offs and support sit under one leader and one vision. Instead of the infrastructure team pushing modelers to adopt AI or data initiatives, the leader drives them and the whole team takes part. Benefit 3: a bigger talent pool means more internal mobility, aligned performance management, and the flexibility to concentrate people on a priority project at short notice. Costs: (1) With mid-level managers gone, the people stepping up, including the team lead, cover a broader scope; how we support them is still open. (2) Every lead takes on unfamiliar areas, for example Dual Risk Rating modeling and its business stakeholders. This is expected reorg pain; we lean on business analysts and former team members who know the area. (3) The new vision revisits some earlier decisions, such as tooling development and model consolidation, which can cause rework and frustration. This is a smaller concern than it looks: the vision now comes from the team’s own lead rather than from a partner team, so buy-in follows more naturally. We still share the vision openly with the whole team from day one and are clear about what each person is doing and why.</a:t>
             </a:r>
             <a:endParaRPr lang="en-US" dirty="0"/>
           </a:p>
@@ -1072,7 +1072,7 @@
           <a:p>
             <a:r>
               <a:rPr lang="en-US" dirty="0"/>
-              <a:t>Start with the people: junior associates need to see where they can go. Both paths are equally valued and both lead to senior levels. The IC path is about personal efficiency and leverage with AI; the manager path is about people, strategy and connecting teams. On performance: in a small, highly efficient team, forced ranking rewards out-competing peers rather than team growth — a dangerous culture over the long run. Transition: if many associates take the senior IC path and managers carry wider spans, the org naturally flattens — next slide.</a:t>
+              <a:t>Start with the people: junior associates need to see where they can go. Both paths are equally valued, with an equal chance of success, and both lead to senior levels. We expect more associates than in the past to choose the IC path, so it must be a real destination, not a consolation prize. The IC path is about personal efficiency and leverage with AI; the manager path is about people, strategy and connecting teams. On performance: in a small, highly efficient team, forced ranking rewards out-competing peers rather than team growth — a dangerous culture over the long run. Transition: if many associates take the senior IC path and managers carry wider spans, the org naturally flattens — next slide.</a:t>
             </a:r>
             <a:endParaRPr lang="en-US" dirty="0"/>
           </a:p>
@@ -2952,7 +2952,7 @@
                 <a:ea typeface="Optimist Sans" pitchFamily="34" charset="-122"/>
                 <a:cs typeface="Optimist Sans" pitchFamily="34" charset="-120"/>
               </a:rPr>
-              <a:t>Steep learning curve</a:t>
+              <a:t>New areas for leads</a:t>
             </a:r>
             <a:endParaRPr lang="en-US" sz="1400" dirty="0"/>
           </a:p>
@@ -2994,7 +2994,7 @@
                 <a:ea typeface="Optimist Sans" pitchFamily="34" charset="-122"/>
                 <a:cs typeface="Optimist Sans" pitchFamily="34" charset="-120"/>
               </a:rPr>
-              <a:t>New areas for leads, e.g., DRR and its stakeholders</a:t>
+              <a:t>e.g., DRR modeling and its business stakeholders</a:t>
             </a:r>
             <a:endParaRPr lang="en-US" sz="1200" dirty="0"/>
           </a:p>
@@ -3194,7 +3194,7 @@
                 <a:ea typeface="Optimist Sans" pitchFamily="34" charset="-122"/>
                 <a:cs typeface="Optimist Sans" pitchFamily="34" charset="-120"/>
               </a:rPr>
-              <a:t>Vision revisits past model, integration, tool choices</a:t>
+              <a:t>Revisits past tooling and consolidation choices</a:t>
             </a:r>
             <a:endParaRPr lang="en-US" sz="1200" dirty="0"/>
           </a:p>
@@ -3283,7 +3283,7 @@
                 <a:ea typeface="Optimist Sans" pitchFamily="34" charset="-122"/>
                 <a:cs typeface="Optimist Sans" pitchFamily="34" charset="-120"/>
               </a:rPr>
-              <a:t>Share the vision openly with the whole team, not just senior leaders</a:t>
+              <a:t>Share the vision from day one; leading the team, not partnering with it, makes buy-in easier</a:t>
             </a:r>
             <a:endParaRPr lang="en-US" sz="1200" dirty="0"/>
           </a:p>
@@ -9166,7 +9166,7 @@
                 <a:ea typeface="Optimist Display" pitchFamily="34" charset="-122"/>
                 <a:cs typeface="Optimist Display" pitchFamily="34" charset="-120"/>
               </a:rPr>
-              <a:t>Two clear career paths show every associate how to grow in the AI era</a:t>
+              <a:t>Two equally valued career paths give every associate a clear way to grow</a:t>
             </a:r>
             <a:endParaRPr lang="en-US" sz="3200" dirty="0"/>
           </a:p>
@@ -9339,11 +9339,11 @@
         <p:spPr>
           <a:xfrm>
             <a:off x="812800" y="2984500"/>
-            <a:ext cx="3238500" cy="2794000"/>
+            <a:ext cx="3238500" cy="2222500"/>
           </a:xfrm>
           <a:prstGeom prst="roundRect">
             <a:avLst>
-              <a:gd name="adj" fmla="val 1964"/>
+              <a:gd name="adj" fmla="val 2469"/>
             </a:avLst>
           </a:prstGeom>
           <a:solidFill>
@@ -9365,7 +9365,7 @@
         </p:nvSpPr>
         <p:spPr>
           <a:xfrm>
-            <a:off x="1016000" y="3187700"/>
+            <a:off x="1016000" y="3162300"/>
             <a:ext cx="2832100" cy="228600"/>
           </a:xfrm>
           <a:prstGeom prst="rect">
@@ -9393,7 +9393,7 @@
                 <a:ea typeface="Optimist Sans" pitchFamily="34" charset="-122"/>
                 <a:cs typeface="Optimist Sans" pitchFamily="34" charset="-120"/>
               </a:rPr>
-              <a:t>PATH 1</a:t>
+              <a:t>PATH 1 · MORE COMMON NOW</a:t>
             </a:r>
             <a:endParaRPr lang="en-US" sz="1200" dirty="0"/>
           </a:p>
@@ -9407,7 +9407,108 @@
         </p:nvSpPr>
         <p:spPr>
           <a:xfrm>
-            <a:off x="1016000" y="3467100"/>
+            <a:off x="1016000" y="3441700"/>
+            <a:ext cx="2832100" cy="304800"/>
+          </a:xfrm>
+          <a:prstGeom prst="rect">
+            <a:avLst/>
+          </a:prstGeom>
+          <a:noFill/>
+          <a:ln/>
+        </p:spPr>
+        <p:txBody>
+          <a:bodyPr wrap="square" lIns="0" tIns="0" rIns="0" bIns="0" rtlCol="0" anchor="t"/>
+          <a:lstStyle/>
+          <a:p>
+            <a:pPr algn="l" indent="0" marL="0">
+              <a:lnSpc>
+                <a:spcPct val="115000"/>
+              </a:lnSpc>
+              <a:buNone/>
+            </a:pPr>
+            <a:r>
+              <a:rPr lang="en-US" sz="1600" b="1" dirty="0">
+                <a:solidFill>
+                  <a:srgbClr val="14213D"/>
+                </a:solidFill>
+                <a:latin typeface="Optimist Sans" pitchFamily="34" charset="0"/>
+                <a:ea typeface="Optimist Sans" pitchFamily="34" charset="-122"/>
+                <a:cs typeface="Optimist Sans" pitchFamily="34" charset="-120"/>
+              </a:rPr>
+              <a:t>Individual contributor</a:t>
+            </a:r>
+            <a:endParaRPr lang="en-US" sz="1600" dirty="0"/>
+          </a:p>
+        </p:txBody>
+      </p:sp>
+      <p:sp>
+        <p:nvSpPr>
+          <p:cNvPr id="13" name="Text 11"/>
+          <p:cNvSpPr txBox="1"/>
+          <p:nvPr/>
+        </p:nvSpPr>
+        <p:spPr>
+          <a:xfrm>
+            <a:off x="1016000" y="3822700"/>
+            <a:ext cx="2832100" cy="635000"/>
+          </a:xfrm>
+          <a:prstGeom prst="rect">
+            <a:avLst/>
+          </a:prstGeom>
+          <a:noFill/>
+          <a:ln/>
+        </p:spPr>
+        <p:txBody>
+          <a:bodyPr wrap="square" lIns="0" tIns="0" rIns="0" bIns="0" rtlCol="0" anchor="t"/>
+          <a:lstStyle/>
+          <a:p>
+            <a:pPr algn="l" indent="0" marL="0">
+              <a:lnSpc>
+                <a:spcPct val="120000"/>
+              </a:lnSpc>
+              <a:buNone/>
+            </a:pPr>
+            <a:r>
+              <a:rPr lang="en-US" sz="1300" b="1" dirty="0">
+                <a:solidFill>
+                  <a:srgbClr val="14213D"/>
+                </a:solidFill>
+                <a:latin typeface="Optimist Sans" pitchFamily="34" charset="0"/>
+                <a:ea typeface="Optimist Sans" pitchFamily="34" charset="-122"/>
+                <a:cs typeface="Optimist Sans" pitchFamily="34" charset="-120"/>
+              </a:rPr>
+              <a:t>Focus: </a:t>
+            </a:r>
+            <a:pPr algn="l" indent="0" marL="0">
+              <a:lnSpc>
+                <a:spcPct val="120000"/>
+              </a:lnSpc>
+              <a:buNone/>
+            </a:pPr>
+            <a:r>
+              <a:rPr lang="en-US" sz="1300" dirty="0">
+                <a:solidFill>
+                  <a:srgbClr val="14213D"/>
+                </a:solidFill>
+                <a:latin typeface="Optimist Sans" pitchFamily="34" charset="0"/>
+                <a:ea typeface="Optimist Sans" pitchFamily="34" charset="-122"/>
+                <a:cs typeface="Optimist Sans" pitchFamily="34" charset="-120"/>
+              </a:rPr>
+              <a:t>personal leverage, using AI to deliver more and go deeper.</a:t>
+            </a:r>
+            <a:endParaRPr lang="en-US" sz="1300" dirty="0"/>
+          </a:p>
+        </p:txBody>
+      </p:sp>
+      <p:sp>
+        <p:nvSpPr>
+          <p:cNvPr id="14" name="Text 12"/>
+          <p:cNvSpPr txBox="1"/>
+          <p:nvPr/>
+        </p:nvSpPr>
+        <p:spPr>
+          <a:xfrm>
+            <a:off x="1016000" y="4533900"/>
             <a:ext cx="2832100" cy="571500"/>
           </a:xfrm>
           <a:prstGeom prst="rect">
@@ -9422,114 +9523,13 @@
           <a:p>
             <a:pPr algn="l" indent="0" marL="0">
               <a:lnSpc>
-                <a:spcPct val="115000"/>
-              </a:lnSpc>
-              <a:buNone/>
-            </a:pPr>
-            <a:r>
-              <a:rPr lang="en-US" sz="1600" b="1" dirty="0">
-                <a:solidFill>
-                  <a:srgbClr val="14213D"/>
-                </a:solidFill>
-                <a:latin typeface="Optimist Sans" pitchFamily="34" charset="0"/>
-                <a:ea typeface="Optimist Sans" pitchFamily="34" charset="-122"/>
-                <a:cs typeface="Optimist Sans" pitchFamily="34" charset="-120"/>
-              </a:rPr>
-              <a:t>Senior individual contributor</a:t>
-            </a:r>
-            <a:endParaRPr lang="en-US" sz="1600" dirty="0"/>
-          </a:p>
-        </p:txBody>
-      </p:sp>
-      <p:sp>
-        <p:nvSpPr>
-          <p:cNvPr id="13" name="Text 11"/>
-          <p:cNvSpPr txBox="1"/>
-          <p:nvPr/>
-        </p:nvSpPr>
-        <p:spPr>
-          <a:xfrm>
-            <a:off x="1016000" y="4127500"/>
-            <a:ext cx="2832100" cy="762000"/>
-          </a:xfrm>
-          <a:prstGeom prst="rect">
-            <a:avLst/>
-          </a:prstGeom>
-          <a:noFill/>
-          <a:ln/>
-        </p:spPr>
-        <p:txBody>
-          <a:bodyPr wrap="square" lIns="0" tIns="0" rIns="0" bIns="0" rtlCol="0" anchor="t"/>
-          <a:lstStyle/>
-          <a:p>
-            <a:pPr algn="l" indent="0" marL="0">
-              <a:lnSpc>
-                <a:spcPct val="125000"/>
+                <a:spcPct val="120000"/>
               </a:lnSpc>
               <a:buNone/>
             </a:pPr>
             <a:r>
               <a:rPr lang="en-US" sz="1300" b="1" dirty="0">
                 <a:solidFill>
-                  <a:srgbClr val="14213D"/>
-                </a:solidFill>
-                <a:latin typeface="Optimist Sans" pitchFamily="34" charset="0"/>
-                <a:ea typeface="Optimist Sans" pitchFamily="34" charset="-122"/>
-                <a:cs typeface="Optimist Sans" pitchFamily="34" charset="-120"/>
-              </a:rPr>
-              <a:t>Focus: </a:t>
-            </a:r>
-            <a:pPr algn="l" indent="0" marL="0">
-              <a:lnSpc>
-                <a:spcPct val="125000"/>
-              </a:lnSpc>
-              <a:buNone/>
-            </a:pPr>
-            <a:r>
-              <a:rPr lang="en-US" sz="1300" dirty="0">
-                <a:solidFill>
-                  <a:srgbClr val="14213D"/>
-                </a:solidFill>
-                <a:latin typeface="Optimist Sans" pitchFamily="34" charset="0"/>
-                <a:ea typeface="Optimist Sans" pitchFamily="34" charset="-122"/>
-                <a:cs typeface="Optimist Sans" pitchFamily="34" charset="-120"/>
-              </a:rPr>
-              <a:t>personal leverage, using AI to deliver more and go deeper.</a:t>
-            </a:r>
-            <a:endParaRPr lang="en-US" sz="1300" dirty="0"/>
-          </a:p>
-        </p:txBody>
-      </p:sp>
-      <p:sp>
-        <p:nvSpPr>
-          <p:cNvPr id="14" name="Text 12"/>
-          <p:cNvSpPr txBox="1"/>
-          <p:nvPr/>
-        </p:nvSpPr>
-        <p:spPr>
-          <a:xfrm>
-            <a:off x="1016000" y="5016500"/>
-            <a:ext cx="2832100" cy="635000"/>
-          </a:xfrm>
-          <a:prstGeom prst="rect">
-            <a:avLst/>
-          </a:prstGeom>
-          <a:noFill/>
-          <a:ln/>
-        </p:spPr>
-        <p:txBody>
-          <a:bodyPr wrap="square" lIns="0" tIns="0" rIns="0" bIns="0" rtlCol="0" anchor="t"/>
-          <a:lstStyle/>
-          <a:p>
-            <a:pPr algn="l" indent="0" marL="0">
-              <a:lnSpc>
-                <a:spcPct val="125000"/>
-              </a:lnSpc>
-              <a:buNone/>
-            </a:pPr>
-            <a:r>
-              <a:rPr lang="en-US" sz="1300" b="1" dirty="0">
-                <a:solidFill>
                   <a:srgbClr val="4A5568"/>
                 </a:solidFill>
                 <a:latin typeface="Optimist Sans" pitchFamily="34" charset="0"/>
@@ -9540,7 +9540,7 @@
             </a:r>
             <a:pPr algn="l" indent="0" marL="0">
               <a:lnSpc>
-                <a:spcPct val="125000"/>
+                <a:spcPct val="120000"/>
               </a:lnSpc>
               <a:buNone/>
             </a:pPr>
@@ -9568,11 +9568,11 @@
         <p:spPr>
           <a:xfrm>
             <a:off x="4305300" y="2984500"/>
-            <a:ext cx="3238500" cy="2794000"/>
+            <a:ext cx="3238500" cy="2222500"/>
           </a:xfrm>
           <a:prstGeom prst="roundRect">
             <a:avLst>
-              <a:gd name="adj" fmla="val 1964"/>
+              <a:gd name="adj" fmla="val 2469"/>
             </a:avLst>
           </a:prstGeom>
           <a:solidFill>
@@ -9594,7 +9594,7 @@
         </p:nvSpPr>
         <p:spPr>
           <a:xfrm>
-            <a:off x="4508500" y="3187700"/>
+            <a:off x="4508500" y="3162300"/>
             <a:ext cx="2832100" cy="228600"/>
           </a:xfrm>
           <a:prstGeom prst="rect">
@@ -9636,7 +9636,108 @@
         </p:nvSpPr>
         <p:spPr>
           <a:xfrm>
-            <a:off x="4508500" y="3467100"/>
+            <a:off x="4508500" y="3441700"/>
+            <a:ext cx="2832100" cy="304800"/>
+          </a:xfrm>
+          <a:prstGeom prst="rect">
+            <a:avLst/>
+          </a:prstGeom>
+          <a:noFill/>
+          <a:ln/>
+        </p:spPr>
+        <p:txBody>
+          <a:bodyPr wrap="square" lIns="0" tIns="0" rIns="0" bIns="0" rtlCol="0" anchor="t"/>
+          <a:lstStyle/>
+          <a:p>
+            <a:pPr algn="l" indent="0" marL="0">
+              <a:lnSpc>
+                <a:spcPct val="115000"/>
+              </a:lnSpc>
+              <a:buNone/>
+            </a:pPr>
+            <a:r>
+              <a:rPr lang="en-US" sz="1600" b="1" dirty="0">
+                <a:solidFill>
+                  <a:srgbClr val="14213D"/>
+                </a:solidFill>
+                <a:latin typeface="Optimist Sans" pitchFamily="34" charset="0"/>
+                <a:ea typeface="Optimist Sans" pitchFamily="34" charset="-122"/>
+                <a:cs typeface="Optimist Sans" pitchFamily="34" charset="-120"/>
+              </a:rPr>
+              <a:t>People manager</a:t>
+            </a:r>
+            <a:endParaRPr lang="en-US" sz="1600" dirty="0"/>
+          </a:p>
+        </p:txBody>
+      </p:sp>
+      <p:sp>
+        <p:nvSpPr>
+          <p:cNvPr id="18" name="Text 16"/>
+          <p:cNvSpPr txBox="1"/>
+          <p:nvPr/>
+        </p:nvSpPr>
+        <p:spPr>
+          <a:xfrm>
+            <a:off x="4508500" y="3822700"/>
+            <a:ext cx="2832100" cy="635000"/>
+          </a:xfrm>
+          <a:prstGeom prst="rect">
+            <a:avLst/>
+          </a:prstGeom>
+          <a:noFill/>
+          <a:ln/>
+        </p:spPr>
+        <p:txBody>
+          <a:bodyPr wrap="square" lIns="0" tIns="0" rIns="0" bIns="0" rtlCol="0" anchor="t"/>
+          <a:lstStyle/>
+          <a:p>
+            <a:pPr algn="l" indent="0" marL="0">
+              <a:lnSpc>
+                <a:spcPct val="120000"/>
+              </a:lnSpc>
+              <a:buNone/>
+            </a:pPr>
+            <a:r>
+              <a:rPr lang="en-US" sz="1300" b="1" dirty="0">
+                <a:solidFill>
+                  <a:srgbClr val="14213D"/>
+                </a:solidFill>
+                <a:latin typeface="Optimist Sans" pitchFamily="34" charset="0"/>
+                <a:ea typeface="Optimist Sans" pitchFamily="34" charset="-122"/>
+                <a:cs typeface="Optimist Sans" pitchFamily="34" charset="-120"/>
+              </a:rPr>
+              <a:t>Focus: </a:t>
+            </a:r>
+            <a:pPr algn="l" indent="0" marL="0">
+              <a:lnSpc>
+                <a:spcPct val="120000"/>
+              </a:lnSpc>
+              <a:buNone/>
+            </a:pPr>
+            <a:r>
+              <a:rPr lang="en-US" sz="1300" dirty="0">
+                <a:solidFill>
+                  <a:srgbClr val="14213D"/>
+                </a:solidFill>
+                <a:latin typeface="Optimist Sans" pitchFamily="34" charset="0"/>
+                <a:ea typeface="Optimist Sans" pitchFamily="34" charset="-122"/>
+                <a:cs typeface="Optimist Sans" pitchFamily="34" charset="-120"/>
+              </a:rPr>
+              <a:t>people, strategy and connecting teams; less on technical efficiency.</a:t>
+            </a:r>
+            <a:endParaRPr lang="en-US" sz="1300" dirty="0"/>
+          </a:p>
+        </p:txBody>
+      </p:sp>
+      <p:sp>
+        <p:nvSpPr>
+          <p:cNvPr id="19" name="Text 17"/>
+          <p:cNvSpPr txBox="1"/>
+          <p:nvPr/>
+        </p:nvSpPr>
+        <p:spPr>
+          <a:xfrm>
+            <a:off x="4508500" y="4533900"/>
             <a:ext cx="2832100" cy="571500"/>
           </a:xfrm>
           <a:prstGeom prst="rect">
@@ -9651,12 +9752,138 @@
           <a:p>
             <a:pPr algn="l" indent="0" marL="0">
               <a:lnSpc>
-                <a:spcPct val="115000"/>
-              </a:lnSpc>
-              <a:buNone/>
-            </a:pPr>
-            <a:r>
-              <a:rPr lang="en-US" sz="1600" b="1" dirty="0">
+                <a:spcPct val="120000"/>
+              </a:lnSpc>
+              <a:buNone/>
+            </a:pPr>
+            <a:r>
+              <a:rPr lang="en-US" sz="1300" b="1" dirty="0">
+                <a:solidFill>
+                  <a:srgbClr val="4A5568"/>
+                </a:solidFill>
+                <a:latin typeface="Optimist Sans" pitchFamily="34" charset="0"/>
+                <a:ea typeface="Optimist Sans" pitchFamily="34" charset="-122"/>
+                <a:cs typeface="Optimist Sans" pitchFamily="34" charset="-120"/>
+              </a:rPr>
+              <a:t>Grows by: </a:t>
+            </a:r>
+            <a:pPr algn="l" indent="0" marL="0">
+              <a:lnSpc>
+                <a:spcPct val="120000"/>
+              </a:lnSpc>
+              <a:buNone/>
+            </a:pPr>
+            <a:r>
+              <a:rPr lang="en-US" sz="1300" dirty="0">
+                <a:solidFill>
+                  <a:srgbClr val="4A5568"/>
+                </a:solidFill>
+                <a:latin typeface="Optimist Sans" pitchFamily="34" charset="0"/>
+                <a:ea typeface="Optimist Sans" pitchFamily="34" charset="-122"/>
+                <a:cs typeface="Optimist Sans" pitchFamily="34" charset="-120"/>
+              </a:rPr>
+              <a:t>[team scope, span, strategic impact]</a:t>
+            </a:r>
+            <a:endParaRPr lang="en-US" sz="1300" dirty="0"/>
+          </a:p>
+        </p:txBody>
+      </p:sp>
+      <p:sp>
+        <p:nvSpPr>
+          <p:cNvPr id="20" name="Shape 18"/>
+          <p:cNvSpPr/>
+          <p:nvPr/>
+        </p:nvSpPr>
+        <p:spPr>
+          <a:xfrm>
+            <a:off x="3975100" y="3892550"/>
+            <a:ext cx="406400" cy="406400"/>
+          </a:xfrm>
+          <a:prstGeom prst="ellipse">
+            <a:avLst/>
+          </a:prstGeom>
+          <a:solidFill>
+            <a:srgbClr val="14213D"/>
+          </a:solidFill>
+          <a:ln w="38100">
+            <a:solidFill>
+              <a:srgbClr val="F7F6F2"/>
+            </a:solidFill>
+            <a:prstDash val="solid"/>
+          </a:ln>
+        </p:spPr>
+      </p:sp>
+      <p:sp>
+        <p:nvSpPr>
+          <p:cNvPr id="21" name="Text 19"/>
+          <p:cNvSpPr txBox="1"/>
+          <p:nvPr/>
+        </p:nvSpPr>
+        <p:spPr>
+          <a:xfrm>
+            <a:off x="3975100" y="3892550"/>
+            <a:ext cx="406400" cy="406400"/>
+          </a:xfrm>
+          <a:prstGeom prst="rect">
+            <a:avLst/>
+          </a:prstGeom>
+          <a:noFill/>
+          <a:ln/>
+        </p:spPr>
+        <p:txBody>
+          <a:bodyPr wrap="square" lIns="0" tIns="0" rIns="0" bIns="0" rtlCol="0" anchor="ctr"/>
+          <a:lstStyle/>
+          <a:p>
+            <a:pPr algn="ctr" indent="0" marL="0">
+              <a:lnSpc>
+                <a:spcPct val="115000"/>
+              </a:lnSpc>
+              <a:buNone/>
+            </a:pPr>
+            <a:r>
+              <a:rPr lang="en-US" sz="2200" b="1" dirty="0">
+                <a:solidFill>
+                  <a:srgbClr val="F7F6F2"/>
+                </a:solidFill>
+                <a:latin typeface="Optimist Sans" pitchFamily="34" charset="0"/>
+                <a:ea typeface="Optimist Sans" pitchFamily="34" charset="-122"/>
+                <a:cs typeface="Optimist Sans" pitchFamily="34" charset="-120"/>
+              </a:rPr>
+              <a:t>=</a:t>
+            </a:r>
+            <a:endParaRPr lang="en-US" sz="2200" dirty="0"/>
+          </a:p>
+        </p:txBody>
+      </p:sp>
+      <p:sp>
+        <p:nvSpPr>
+          <p:cNvPr id="22" name="Text 20"/>
+          <p:cNvSpPr txBox="1"/>
+          <p:nvPr/>
+        </p:nvSpPr>
+        <p:spPr>
+          <a:xfrm>
+            <a:off x="812800" y="5334000"/>
+            <a:ext cx="6731000" cy="444500"/>
+          </a:xfrm>
+          <a:prstGeom prst="rect">
+            <a:avLst/>
+          </a:prstGeom>
+          <a:noFill/>
+          <a:ln/>
+        </p:spPr>
+        <p:txBody>
+          <a:bodyPr wrap="square" lIns="0" tIns="0" rIns="0" bIns="0" rtlCol="0" anchor="t"/>
+          <a:lstStyle/>
+          <a:p>
+            <a:pPr algn="l" indent="0" marL="0">
+              <a:lnSpc>
+                <a:spcPct val="120000"/>
+              </a:lnSpc>
+              <a:buNone/>
+            </a:pPr>
+            <a:r>
+              <a:rPr lang="en-US" sz="1200" b="1" dirty="0">
                 <a:solidFill>
                   <a:srgbClr val="14213D"/>
                 </a:solidFill>
@@ -9664,100 +9891,16 @@
                 <a:ea typeface="Optimist Sans" pitchFamily="34" charset="-122"/>
                 <a:cs typeface="Optimist Sans" pitchFamily="34" charset="-120"/>
               </a:rPr>
-              <a:t>People manager</a:t>
-            </a:r>
-            <a:endParaRPr lang="en-US" sz="1600" dirty="0"/>
-          </a:p>
-        </p:txBody>
-      </p:sp>
-      <p:sp>
-        <p:nvSpPr>
-          <p:cNvPr id="18" name="Text 16"/>
-          <p:cNvSpPr txBox="1"/>
-          <p:nvPr/>
-        </p:nvSpPr>
-        <p:spPr>
-          <a:xfrm>
-            <a:off x="4508500" y="4127500"/>
-            <a:ext cx="2832100" cy="762000"/>
-          </a:xfrm>
-          <a:prstGeom prst="rect">
-            <a:avLst/>
-          </a:prstGeom>
-          <a:noFill/>
-          <a:ln/>
-        </p:spPr>
-        <p:txBody>
-          <a:bodyPr wrap="square" lIns="0" tIns="0" rIns="0" bIns="0" rtlCol="0" anchor="t"/>
-          <a:lstStyle/>
-          <a:p>
-            <a:pPr algn="l" indent="0" marL="0">
-              <a:lnSpc>
-                <a:spcPct val="125000"/>
-              </a:lnSpc>
-              <a:buNone/>
-            </a:pPr>
-            <a:r>
-              <a:rPr lang="en-US" sz="1300" b="1" dirty="0">
-                <a:solidFill>
-                  <a:srgbClr val="14213D"/>
-                </a:solidFill>
-                <a:latin typeface="Optimist Sans" pitchFamily="34" charset="0"/>
-                <a:ea typeface="Optimist Sans" pitchFamily="34" charset="-122"/>
-                <a:cs typeface="Optimist Sans" pitchFamily="34" charset="-120"/>
-              </a:rPr>
-              <a:t>Focus: </a:t>
-            </a:r>
-            <a:pPr algn="l" indent="0" marL="0">
-              <a:lnSpc>
-                <a:spcPct val="125000"/>
-              </a:lnSpc>
-              <a:buNone/>
-            </a:pPr>
-            <a:r>
-              <a:rPr lang="en-US" sz="1300" dirty="0">
-                <a:solidFill>
-                  <a:srgbClr val="14213D"/>
-                </a:solidFill>
-                <a:latin typeface="Optimist Sans" pitchFamily="34" charset="0"/>
-                <a:ea typeface="Optimist Sans" pitchFamily="34" charset="-122"/>
-                <a:cs typeface="Optimist Sans" pitchFamily="34" charset="-120"/>
-              </a:rPr>
-              <a:t>people, strategy and connecting teams; less on technical efficiency.</a:t>
-            </a:r>
-            <a:endParaRPr lang="en-US" sz="1300" dirty="0"/>
-          </a:p>
-        </p:txBody>
-      </p:sp>
-      <p:sp>
-        <p:nvSpPr>
-          <p:cNvPr id="19" name="Text 17"/>
-          <p:cNvSpPr txBox="1"/>
-          <p:nvPr/>
-        </p:nvSpPr>
-        <p:spPr>
-          <a:xfrm>
-            <a:off x="4508500" y="5016500"/>
-            <a:ext cx="2832100" cy="635000"/>
-          </a:xfrm>
-          <a:prstGeom prst="rect">
-            <a:avLst/>
-          </a:prstGeom>
-          <a:noFill/>
-          <a:ln/>
-        </p:spPr>
-        <p:txBody>
-          <a:bodyPr wrap="square" lIns="0" tIns="0" rIns="0" bIns="0" rtlCol="0" anchor="t"/>
-          <a:lstStyle/>
-          <a:p>
-            <a:pPr algn="l" indent="0" marL="0">
-              <a:lnSpc>
-                <a:spcPct val="125000"/>
-              </a:lnSpc>
-              <a:buNone/>
-            </a:pPr>
-            <a:r>
-              <a:rPr lang="en-US" sz="1300" b="1" dirty="0">
+              <a:t>Equal chance of success on both paths. </a:t>
+            </a:r>
+            <a:pPr algn="l" indent="0" marL="0">
+              <a:lnSpc>
+                <a:spcPct val="120000"/>
+              </a:lnSpc>
+              <a:buNone/>
+            </a:pPr>
+            <a:r>
+              <a:rPr lang="en-US" sz="1200" dirty="0">
                 <a:solidFill>
                   <a:srgbClr val="4A5568"/>
                 </a:solidFill>
@@ -9765,32 +9908,15 @@
                 <a:ea typeface="Optimist Sans" pitchFamily="34" charset="-122"/>
                 <a:cs typeface="Optimist Sans" pitchFamily="34" charset="-120"/>
               </a:rPr>
-              <a:t>Grows by: </a:t>
-            </a:r>
-            <a:pPr algn="l" indent="0" marL="0">
-              <a:lnSpc>
-                <a:spcPct val="125000"/>
-              </a:lnSpc>
-              <a:buNone/>
-            </a:pPr>
-            <a:r>
-              <a:rPr lang="en-US" sz="1300" dirty="0">
-                <a:solidFill>
-                  <a:srgbClr val="4A5568"/>
-                </a:solidFill>
-                <a:latin typeface="Optimist Sans" pitchFamily="34" charset="0"/>
-                <a:ea typeface="Optimist Sans" pitchFamily="34" charset="-122"/>
-                <a:cs typeface="Optimist Sans" pitchFamily="34" charset="-120"/>
-              </a:rPr>
-              <a:t>[team scope, span, strategic impact]</a:t>
-            </a:r>
-            <a:endParaRPr lang="en-US" sz="1300" dirty="0"/>
-          </a:p>
-        </p:txBody>
-      </p:sp>
-      <p:sp>
-        <p:nvSpPr>
-          <p:cNvPr id="20" name="Shape 18"/>
+              <a:t>We expect more associates to choose the IC path than in the past.</a:t>
+            </a:r>
+            <a:endParaRPr lang="en-US" sz="1200" dirty="0"/>
+          </a:p>
+        </p:txBody>
+      </p:sp>
+      <p:sp>
+        <p:nvSpPr>
+          <p:cNvPr id="23" name="Shape 21"/>
           <p:cNvSpPr/>
           <p:nvPr/>
         </p:nvSpPr>
@@ -9812,7 +9938,7 @@
       </p:sp>
       <p:pic>
         <p:nvPicPr>
-          <p:cNvPr id="21" name="Image 0" descr="preencoded.png">    </p:cNvPr>
+          <p:cNvPr id="24" name="Image 0" descr="preencoded.png">    </p:cNvPr>
           <p:cNvPicPr>
             <a:picLocks noChangeAspect="1"/>
           </p:cNvPicPr>
@@ -9836,7 +9962,7 @@
       </p:pic>
       <p:sp>
         <p:nvSpPr>
-          <p:cNvPr id="22" name="Text 19"/>
+          <p:cNvPr id="25" name="Text 22"/>
           <p:cNvSpPr txBox="1"/>
           <p:nvPr/>
         </p:nvSpPr>
@@ -9878,7 +10004,7 @@
       </p:sp>
       <p:sp>
         <p:nvSpPr>
-          <p:cNvPr id="23" name="Text 20"/>
+          <p:cNvPr id="26" name="Text 23"/>
           <p:cNvSpPr txBox="1"/>
           <p:nvPr/>
         </p:nvSpPr>
@@ -9920,7 +10046,7 @@
       </p:sp>
       <p:sp>
         <p:nvSpPr>
-          <p:cNvPr id="24" name="Text 21"/>
+          <p:cNvPr id="27" name="Text 24"/>
           <p:cNvSpPr txBox="1"/>
           <p:nvPr/>
         </p:nvSpPr>
@@ -9962,7 +10088,7 @@
       </p:sp>
       <p:sp>
         <p:nvSpPr>
-          <p:cNvPr id="25" name="Text 22"/>
+          <p:cNvPr id="28" name="Text 25"/>
           <p:cNvSpPr txBox="1"/>
           <p:nvPr/>
         </p:nvSpPr>

</xml_diff>

<commit_message>
Reframe performance-management point around fair development paths
Co-Authored-By: Claude Opus 5.5 <noreply@anthropic.com>
Claude-Session: https://claude.ai/code/session_01JXKaD9UU8MgeRWUr7sq4Za
</commit_message>
<xml_diff>
--- a/Unified Team Strategy.pptx
+++ b/Unified Team Strategy.pptx
@@ -115,27 +115,27 @@
   <p:extLst>
     <p:ext uri="{521415D9-36F7-43E2-AB2F-B90AF26B5E84}">
       <p14:sectionLst xmlns:p14="http://schemas.microsoft.com/office/powerpoint/2010/main">
-        <p14:section name="Why combine" id="{d05d4c85-240c-0061-3c77-97f495c31951}">
+        <p14:section name="Why combine" id="{d8159adf-9c83-f076-062a-40ed630167cb}">
           <p14:sldIdLst>
             <p14:sldId id="256"/>
             <p14:sldId id="257"/>
           </p14:sldIdLst>
         </p14:section>
-        <p14:section name="How we organize" id="{b7afe13d-d96e-8d62-de6d-58687db432c5}">
+        <p14:section name="How we organize" id="{43f0070a-cf92-7843-559f-489a12552dfd}">
           <p14:sldIdLst>
             <p14:sldId id="258"/>
             <p14:sldId id="259"/>
             <p14:sldId id="260"/>
           </p14:sldIdLst>
         </p14:section>
-        <p14:section name="What we do and how we grow" id="{e541194e-9854-2815-f5a1-55f4422a093a}">
+        <p14:section name="What we do and how we grow" id="{e6007ca2-5782-33bd-67a6-55688e911616}">
           <p14:sldIdLst>
             <p14:sldId id="261"/>
             <p14:sldId id="262"/>
             <p14:sldId id="263"/>
           </p14:sldIdLst>
         </p14:section>
-        <p14:section name="Asks" id="{7f2d9508-67e9-e45c-841f-e2e592b91e76}">
+        <p14:section name="Asks" id="{ea0e3f69-1330-f766-e51b-9fa1b2b154dc}">
           <p14:sldIdLst>
             <p14:sldId id="264"/>
           </p14:sldIdLst>
@@ -1072,7 +1072,7 @@
           <a:p>
             <a:r>
               <a:rPr lang="en-US" dirty="0"/>
-              <a:t>Start with the people: junior associates need to see where they can go. Both paths are equally valued, with an equal chance of success, and both lead to senior levels. We expect more associates than in the past to choose the IC path, so it must be a real destination, not a consolation prize. The IC path is about personal efficiency and leverage with AI; the manager path is about people, strategy and connecting teams. On performance: in a small, highly efficient team, forced ranking rewards out-competing peers rather than team growth — a dangerous culture over the long run. Transition: if many associates take the senior IC path and managers carry wider spans, the org naturally flattens — next slide.</a:t>
+              <a:t>Start with the people: junior associates need to see where they can go. Both paths are equally valued, with an equal chance of success, and both lead to senior levels. We expect more associates than in the past to choose the IC path, so it must be a real destination, not a consolation prize. The IC path is about personal efficiency and leverage with AI; the manager path is about people, strategy and connecting teams. On performance: as everyone gets better with AI, fitting a distribution gets harder, so benchmarks must stay reasonable. The fix is not a new scoring method; it is a clear, fair development path on both the IC and manager tracks, so people feel fairly treated. With that in place, performance management stays consistent even as it becomes more dynamic. Transition: if many associates take the senior IC path and managers carry wider spans, the org naturally flattens — next slide.</a:t>
             </a:r>
             <a:endParaRPr lang="en-US" dirty="0"/>
           </a:p>
@@ -10010,8 +10010,8 @@
         </p:nvSpPr>
         <p:spPr>
           <a:xfrm>
-            <a:off x="8051800" y="3556000"/>
-            <a:ext cx="3124200" cy="1270000"/>
+            <a:off x="8051800" y="3619500"/>
+            <a:ext cx="3124200" cy="825500"/>
           </a:xfrm>
           <a:prstGeom prst="rect">
             <a:avLst/>
@@ -10025,7 +10025,7 @@
           <a:p>
             <a:pPr algn="l" indent="0" marL="0">
               <a:lnSpc>
-                <a:spcPct val="125000"/>
+                <a:spcPct val="120000"/>
               </a:lnSpc>
               <a:buNone/>
             </a:pPr>
@@ -10038,7 +10038,7 @@
                 <a:ea typeface="Optimist Sans" pitchFamily="34" charset="-122"/>
                 <a:cs typeface="Optimist Sans" pitchFamily="34" charset="-120"/>
               </a:rPr>
-              <a:t>As everyone gets more efficient, forcing a distribution pits peers against each other. That hurts sustainable growth and culture.</a:t>
+              <a:t>Everyone is getting better, yet we still fit a distribution. We must keep benchmarks reasonable.</a:t>
             </a:r>
             <a:endParaRPr lang="en-US" sz="1300" dirty="0"/>
           </a:p>
@@ -10046,41 +10046,80 @@
       </p:sp>
       <p:sp>
         <p:nvSpPr>
-          <p:cNvPr id="27" name="Text 24"/>
-          <p:cNvSpPr txBox="1"/>
-          <p:nvPr/>
-        </p:nvSpPr>
-        <p:spPr>
-          <a:xfrm>
-            <a:off x="8051800" y="5016500"/>
-            <a:ext cx="3124200" cy="571500"/>
-          </a:xfrm>
-          <a:prstGeom prst="rect">
-            <a:avLst/>
-          </a:prstGeom>
-          <a:noFill/>
-          <a:ln/>
-        </p:spPr>
-        <p:txBody>
-          <a:bodyPr wrap="square" lIns="0" tIns="0" rIns="0" bIns="0" rtlCol="0" anchor="t"/>
-          <a:lstStyle/>
-          <a:p>
-            <a:pPr algn="l" indent="0" marL="0">
-              <a:lnSpc>
-                <a:spcPct val="115000"/>
+          <p:cNvPr id="27" name="Shape 24"/>
+          <p:cNvSpPr/>
+          <p:nvPr/>
+        </p:nvSpPr>
+        <p:spPr>
+          <a:xfrm>
+            <a:off x="8001000" y="4546600"/>
+            <a:ext cx="3225800" cy="1143000"/>
+          </a:xfrm>
+          <a:prstGeom prst="roundRect">
+            <a:avLst>
+              <a:gd name="adj" fmla="val 6400"/>
+            </a:avLst>
+          </a:prstGeom>
+          <a:solidFill>
+            <a:srgbClr val="E1EEF0"/>
+          </a:solidFill>
+          <a:ln/>
+        </p:spPr>
+      </p:sp>
+      <p:sp>
+        <p:nvSpPr>
+          <p:cNvPr id="28" name="Text 25"/>
+          <p:cNvSpPr txBox="1"/>
+          <p:nvPr/>
+        </p:nvSpPr>
+        <p:spPr>
+          <a:xfrm>
+            <a:off x="8153400" y="4648200"/>
+            <a:ext cx="2921000" cy="952500"/>
+          </a:xfrm>
+          <a:prstGeom prst="rect">
+            <a:avLst/>
+          </a:prstGeom>
+          <a:noFill/>
+          <a:ln/>
+        </p:spPr>
+        <p:txBody>
+          <a:bodyPr wrap="square" lIns="0" tIns="0" rIns="0" bIns="0" rtlCol="0" anchor="ctr"/>
+          <a:lstStyle/>
+          <a:p>
+            <a:pPr algn="l" indent="0" marL="0">
+              <a:lnSpc>
+                <a:spcPct val="120000"/>
+              </a:lnSpc>
+              <a:buNone/>
+            </a:pPr>
+            <a:r>
+              <a:rPr lang="en-US" sz="1300" b="1" dirty="0">
+                <a:solidFill>
+                  <a:srgbClr val="14213D"/>
+                </a:solidFill>
+                <a:latin typeface="Optimist Sans" pitchFamily="34" charset="0"/>
+                <a:ea typeface="Optimist Sans" pitchFamily="34" charset="-122"/>
+                <a:cs typeface="Optimist Sans" pitchFamily="34" charset="-120"/>
+              </a:rPr>
+              <a:t>Our answer: </a:t>
+            </a:r>
+            <a:pPr algn="l" indent="0" marL="0">
+              <a:lnSpc>
+                <a:spcPct val="120000"/>
               </a:lnSpc>
               <a:buNone/>
             </a:pPr>
             <a:r>
               <a:rPr lang="en-US" sz="1300" dirty="0">
                 <a:solidFill>
-                  <a:srgbClr val="155563"/>
-                </a:solidFill>
-                <a:latin typeface="Optimist Sans" pitchFamily="34" charset="0"/>
-                <a:ea typeface="Optimist Sans" pitchFamily="34" charset="-122"/>
-                <a:cs typeface="Optimist Sans" pitchFamily="34" charset="-120"/>
-              </a:rPr>
-              <a:t>[Proposal, e.g., measure impact against goals]</a:t>
+                  <a:srgbClr val="14213D"/>
+                </a:solidFill>
+                <a:latin typeface="Optimist Sans" pitchFamily="34" charset="0"/>
+                <a:ea typeface="Optimist Sans" pitchFamily="34" charset="-122"/>
+                <a:cs typeface="Optimist Sans" pitchFamily="34" charset="-120"/>
+              </a:rPr>
+              <a:t>a clear, fair development path on both tracks, so people feel treated fairly as expectations evolve.</a:t>
             </a:r>
             <a:endParaRPr lang="en-US" sz="1300" dirty="0"/>
           </a:p>
@@ -10088,7 +10127,7 @@
       </p:sp>
       <p:sp>
         <p:nvSpPr>
-          <p:cNvPr id="28" name="Text 25"/>
+          <p:cNvPr id="29" name="Text 26"/>
           <p:cNvSpPr txBox="1"/>
           <p:nvPr/>
         </p:nvSpPr>

</xml_diff>

<commit_message>
Add junior judgment-building approach to flatter-structure slide
Co-Authored-By: Claude Opus 5.5 <noreply@anthropic.com>
Claude-Session: https://claude.ai/code/session_01JXKaD9UU8MgeRWUr7sq4Za
</commit_message>
<xml_diff>
--- a/Unified Team Strategy.pptx
+++ b/Unified Team Strategy.pptx
@@ -115,27 +115,27 @@
   <p:extLst>
     <p:ext uri="{521415D9-36F7-43E2-AB2F-B90AF26B5E84}">
       <p14:sectionLst xmlns:p14="http://schemas.microsoft.com/office/powerpoint/2010/main">
-        <p14:section name="Why combine" id="{d8159adf-9c83-f076-062a-40ed630167cb}">
+        <p14:section name="Why combine" id="{c00ee715-e501-fe74-2395-cfdca3b0038a}">
           <p14:sldIdLst>
             <p14:sldId id="256"/>
             <p14:sldId id="257"/>
           </p14:sldIdLst>
         </p14:section>
-        <p14:section name="How we organize" id="{43f0070a-cf92-7843-559f-489a12552dfd}">
+        <p14:section name="How we organize" id="{82be4e55-7fe7-1522-d963-c753cc5c2a06}">
           <p14:sldIdLst>
             <p14:sldId id="258"/>
             <p14:sldId id="259"/>
             <p14:sldId id="260"/>
           </p14:sldIdLst>
         </p14:section>
-        <p14:section name="What we do and how we grow" id="{e6007ca2-5782-33bd-67a6-55688e911616}">
+        <p14:section name="What we do and how we grow" id="{9a62c8f1-1fee-5fcf-d49f-5ccfd47c4861}">
           <p14:sldIdLst>
             <p14:sldId id="261"/>
             <p14:sldId id="262"/>
             <p14:sldId id="263"/>
           </p14:sldIdLst>
         </p14:section>
-        <p14:section name="Asks" id="{ea0e3f69-1330-f766-e51b-9fa1b2b154dc}">
+        <p14:section name="Asks" id="{80b59eba-9efa-a11b-b36f-4aab0af745bb}">
           <p14:sldIdLst>
             <p14:sldId id="264"/>
           </p14:sldIdLst>
@@ -1160,7 +1160,7 @@
           <a:p>
             <a:r>
               <a:rPr lang="en-US" dirty="0"/>
-              <a:t>Core logic: when every IC manages a set of agents, senior experience creates the most leverage and managers can carry more direct reports — so the team gets flatter. The colors tie back to the two paths on the previous slide. The tension: the entry-level work that once trained juniors shrinks, so growing the next generation of leaders has to be deliberate.</a:t>
+              <a:t>Core logic: when every IC manages a set of agents, senior experience creates the most leverage and managers can carry more direct reports — so the team gets flatter. The colors tie back to the two paths on the previous slide. The tension: the entry-level work that once trained juniors shrinks, so growing the next generation of leaders has to be deliberate. Our approach: (1) juniors are the first reviewers of agent output — they check it against data, business logic and model fundamentals and explain why they accept or reject it, which builds judgment faster than production did; (2) each junior periodically hand-builds something end to end, like a small segment model or pipeline, because you cannot supervise an agent on work you have never done; (3) juniors pair with senior ICs to see how they frame problems, direct agents and decide what is good enough, then own small real decisions, including stakeholder conversations, earlier than before.</a:t>
             </a:r>
             <a:endParaRPr lang="en-US" dirty="0"/>
           </a:p>
@@ -11212,14 +11212,78 @@
       </p:sp>
       <p:sp>
         <p:nvSpPr>
-          <p:cNvPr id="29" name="Text 27"/>
-          <p:cNvSpPr txBox="1"/>
-          <p:nvPr/>
-        </p:nvSpPr>
-        <p:spPr>
-          <a:xfrm>
-            <a:off x="8229600" y="4102100"/>
-            <a:ext cx="2946400" cy="762000"/>
+          <p:cNvPr id="29" name="Shape 27"/>
+          <p:cNvSpPr/>
+          <p:nvPr/>
+        </p:nvSpPr>
+        <p:spPr>
+          <a:xfrm>
+            <a:off x="8178800" y="4102100"/>
+            <a:ext cx="3048000" cy="533400"/>
+          </a:xfrm>
+          <a:prstGeom prst="roundRect">
+            <a:avLst>
+              <a:gd name="adj" fmla="val 20571"/>
+            </a:avLst>
+          </a:prstGeom>
+          <a:solidFill>
+            <a:srgbClr val="E1EEF0"/>
+          </a:solidFill>
+          <a:ln/>
+        </p:spPr>
+      </p:sp>
+      <p:sp>
+        <p:nvSpPr>
+          <p:cNvPr id="30" name="Text 28"/>
+          <p:cNvSpPr txBox="1"/>
+          <p:nvPr/>
+        </p:nvSpPr>
+        <p:spPr>
+          <a:xfrm>
+            <a:off x="8280400" y="4102100"/>
+            <a:ext cx="2895600" cy="533400"/>
+          </a:xfrm>
+          <a:prstGeom prst="rect">
+            <a:avLst/>
+          </a:prstGeom>
+          <a:noFill/>
+          <a:ln/>
+        </p:spPr>
+        <p:txBody>
+          <a:bodyPr wrap="square" lIns="0" tIns="0" rIns="0" bIns="0" rtlCol="0" anchor="ctr"/>
+          <a:lstStyle/>
+          <a:p>
+            <a:pPr algn="l" indent="0" marL="0">
+              <a:lnSpc>
+                <a:spcPct val="115000"/>
+              </a:lnSpc>
+              <a:buNone/>
+            </a:pPr>
+            <a:r>
+              <a:rPr lang="en-US" sz="1200" b="1" dirty="0">
+                <a:solidFill>
+                  <a:srgbClr val="14213D"/>
+                </a:solidFill>
+                <a:latin typeface="Optimist Sans" pitchFamily="34" charset="0"/>
+                <a:ea typeface="Optimist Sans" pitchFamily="34" charset="-122"/>
+                <a:cs typeface="Optimist Sans" pitchFamily="34" charset="-120"/>
+              </a:rPr>
+              <a:t>Juniors learn by judging, not just doing:</a:t>
+            </a:r>
+            <a:endParaRPr lang="en-US" sz="1200" dirty="0"/>
+          </a:p>
+        </p:txBody>
+      </p:sp>
+      <p:sp>
+        <p:nvSpPr>
+          <p:cNvPr id="31" name="Text 29"/>
+          <p:cNvSpPr txBox="1"/>
+          <p:nvPr/>
+        </p:nvSpPr>
+        <p:spPr>
+          <a:xfrm>
+            <a:off x="8229600" y="4749800"/>
+            <a:ext cx="2946400" cy="952500"/>
           </a:xfrm>
           <a:prstGeom prst="rect">
             <a:avLst/>
@@ -11231,14 +11295,15 @@
           <a:bodyPr wrap="square" lIns="0" tIns="0" rIns="0" bIns="0" rtlCol="0" anchor="t"/>
           <a:lstStyle/>
           <a:p>
-            <a:pPr algn="l" indent="0" marL="0">
-              <a:lnSpc>
-                <a:spcPct val="125000"/>
-              </a:lnSpc>
-              <a:buNone/>
-            </a:pPr>
-            <a:r>
-              <a:rPr lang="en-US" sz="1300" b="1" dirty="0">
+            <a:pPr marL="342900" indent="-342900">
+              <a:spcAft>
+                <a:spcPts val="600"/>
+              </a:spcAft>
+              <a:buSzPct val="100000"/>
+              <a:buChar char="•"/>
+            </a:pPr>
+            <a:r>
+              <a:rPr lang="en-US" sz="1200" dirty="0">
                 <a:solidFill>
                   <a:srgbClr val="4A5568"/>
                 </a:solidFill>
@@ -11246,16 +11311,20 @@
                 <a:ea typeface="Optimist Sans" pitchFamily="34" charset="-122"/>
                 <a:cs typeface="Optimist Sans" pitchFamily="34" charset="-120"/>
               </a:rPr>
-              <a:t>Open question: </a:t>
-            </a:r>
-            <a:pPr algn="l" indent="0" marL="0">
-              <a:lnSpc>
-                <a:spcPct val="125000"/>
-              </a:lnSpc>
-              <a:buNone/>
-            </a:pPr>
-            <a:r>
-              <a:rPr lang="en-US" sz="1300" dirty="0">
+              <a:t>Review and challenge agent output</a:t>
+            </a:r>
+            <a:endParaRPr lang="en-US" sz="1200" dirty="0"/>
+          </a:p>
+          <a:p>
+            <a:pPr marL="342900" indent="-342900">
+              <a:spcAft>
+                <a:spcPts val="600"/>
+              </a:spcAft>
+              <a:buSzPct val="100000"/>
+              <a:buChar char="•"/>
+            </a:pPr>
+            <a:r>
+              <a:rPr lang="en-US" sz="1200" dirty="0">
                 <a:solidFill>
                   <a:srgbClr val="4A5568"/>
                 </a:solidFill>
@@ -11263,57 +11332,36 @@
                 <a:ea typeface="Optimist Sans" pitchFamily="34" charset="-122"/>
                 <a:cs typeface="Optimist Sans" pitchFamily="34" charset="-120"/>
               </a:rPr>
-              <a:t>how do juniors build judgment when agents do entry-level work?</a:t>
-            </a:r>
-            <a:endParaRPr lang="en-US" sz="1300" dirty="0"/>
-          </a:p>
-        </p:txBody>
-      </p:sp>
-      <p:sp>
-        <p:nvSpPr>
-          <p:cNvPr id="30" name="Text 28"/>
-          <p:cNvSpPr txBox="1"/>
-          <p:nvPr/>
-        </p:nvSpPr>
-        <p:spPr>
-          <a:xfrm>
-            <a:off x="8229600" y="5016500"/>
-            <a:ext cx="2946400" cy="279400"/>
-          </a:xfrm>
-          <a:prstGeom prst="rect">
-            <a:avLst/>
-          </a:prstGeom>
-          <a:noFill/>
-          <a:ln/>
-        </p:spPr>
-        <p:txBody>
-          <a:bodyPr wrap="square" lIns="0" tIns="0" rIns="0" bIns="0" rtlCol="0" anchor="t"/>
-          <a:lstStyle/>
-          <a:p>
-            <a:pPr algn="l" indent="0" marL="0">
-              <a:lnSpc>
-                <a:spcPct val="115000"/>
-              </a:lnSpc>
-              <a:buNone/>
-            </a:pPr>
-            <a:r>
-              <a:rPr lang="en-US" sz="1300" dirty="0">
-                <a:solidFill>
-                  <a:srgbClr val="A0521A"/>
-                </a:solidFill>
-                <a:latin typeface="Optimist Sans" pitchFamily="34" charset="0"/>
-                <a:ea typeface="Optimist Sans" pitchFamily="34" charset="-122"/>
-                <a:cs typeface="Optimist Sans" pitchFamily="34" charset="-120"/>
-              </a:rPr>
-              <a:t>→ [Junior pipeline approach]</a:t>
-            </a:r>
-            <a:endParaRPr lang="en-US" sz="1300" dirty="0"/>
-          </a:p>
-        </p:txBody>
-      </p:sp>
-      <p:sp>
-        <p:nvSpPr>
-          <p:cNvPr id="31" name="Text 29"/>
+              <a:t>Hand-build some work end to end</a:t>
+            </a:r>
+            <a:endParaRPr lang="en-US" sz="1200" dirty="0"/>
+          </a:p>
+          <a:p>
+            <a:pPr marL="342900" indent="-342900">
+              <a:spcAft>
+                <a:spcPts val="600"/>
+              </a:spcAft>
+              <a:buSzPct val="100000"/>
+              <a:buChar char="•"/>
+            </a:pPr>
+            <a:r>
+              <a:rPr lang="en-US" sz="1200" dirty="0">
+                <a:solidFill>
+                  <a:srgbClr val="4A5568"/>
+                </a:solidFill>
+                <a:latin typeface="Optimist Sans" pitchFamily="34" charset="0"/>
+                <a:ea typeface="Optimist Sans" pitchFamily="34" charset="-122"/>
+                <a:cs typeface="Optimist Sans" pitchFamily="34" charset="-120"/>
+              </a:rPr>
+              <a:t>Pair with senior ICs on real decisions</a:t>
+            </a:r>
+            <a:endParaRPr lang="en-US" sz="1200" dirty="0"/>
+          </a:p>
+        </p:txBody>
+      </p:sp>
+      <p:sp>
+        <p:nvSpPr>
+          <p:cNvPr id="32" name="Text 30"/>
           <p:cNvSpPr txBox="1"/>
           <p:nvPr/>
         </p:nvSpPr>

</xml_diff>

<commit_message>
Show IC-first career progression on career paths slide
Co-Authored-By: Claude Opus 5.5 <noreply@anthropic.com>
Claude-Session: https://claude.ai/code/session_01JXKaD9UU8MgeRWUr7sq4Za
</commit_message>
<xml_diff>
--- a/Unified Team Strategy.pptx
+++ b/Unified Team Strategy.pptx
@@ -115,27 +115,27 @@
   <p:extLst>
     <p:ext uri="{521415D9-36F7-43E2-AB2F-B90AF26B5E84}">
       <p14:sectionLst xmlns:p14="http://schemas.microsoft.com/office/powerpoint/2010/main">
-        <p14:section name="Why combine" id="{c00ee715-e501-fe74-2395-cfdca3b0038a}">
+        <p14:section name="Why combine" id="{3cc246bd-0282-7c9a-44bc-158a3f1d0c62}">
           <p14:sldIdLst>
             <p14:sldId id="256"/>
             <p14:sldId id="257"/>
           </p14:sldIdLst>
         </p14:section>
-        <p14:section name="How we organize" id="{82be4e55-7fe7-1522-d963-c753cc5c2a06}">
+        <p14:section name="How we organize" id="{6a01e301-4436-d1c2-6d4e-a286e7a6538e}">
           <p14:sldIdLst>
             <p14:sldId id="258"/>
             <p14:sldId id="259"/>
             <p14:sldId id="260"/>
           </p14:sldIdLst>
         </p14:section>
-        <p14:section name="What we do and how we grow" id="{9a62c8f1-1fee-5fcf-d49f-5ccfd47c4861}">
+        <p14:section name="What we do and how we grow" id="{60ddff7e-aa7d-abe8-035c-a0649be7f9c3}">
           <p14:sldIdLst>
             <p14:sldId id="261"/>
             <p14:sldId id="262"/>
             <p14:sldId id="263"/>
           </p14:sldIdLst>
         </p14:section>
-        <p14:section name="Asks" id="{80b59eba-9efa-a11b-b36f-4aab0af745bb}">
+        <p14:section name="Asks" id="{1b62705f-84fd-c610-e7b3-63608a9b7fa5}">
           <p14:sldIdLst>
             <p14:sldId id="264"/>
           </p14:sldIdLst>
@@ -1072,7 +1072,7 @@
           <a:p>
             <a:r>
               <a:rPr lang="en-US" dirty="0"/>
-              <a:t>Start with the people: junior associates need to see where they can go. Both paths are equally valued, with an equal chance of success, and both lead to senior levels. We expect more associates than in the past to choose the IC path, so it must be a real destination, not a consolation prize. The IC path is about personal efficiency and leverage with AI; the manager path is about people, strategy and connecting teams. On performance: as everyone gets better with AI, fitting a distribution gets harder, so benchmarks must stay reasonable. The fix is not a new scoring method; it is a clear, fair development path on both the IC and manager tracks, so people feel fairly treated. With that in place, performance management stays consistent even as it becomes more dynamic. Transition: if many associates take the senior IC path and managers carry wider spans, the org naturally flattens — next slide.</a:t>
+              <a:t>Start with the people: junior associates need to see where they can go. Everyone starts as an individual contributor; juniors are not yet in a position to manage. As they grow more senior, they test their interests and choose the IC or the people-manager path. Both paths are equally valued, with an equal chance of success, and both lead to senior levels. We expect more associates than in the past to choose the IC path, so it must be a real destination, not a consolation prize. The IC path is about personal efficiency and leverage with AI; the manager path is about people, strategy and connecting teams. On performance: as everyone gets better with AI, fitting a distribution gets harder, so benchmarks must stay reasonable. The fix is not a new scoring method; it is a clear, fair development path on both the IC and manager tracks, so people feel fairly treated. With that in place, performance management stays consistent even as it becomes more dynamic. Transition: if many associates take the senior IC path and managers carry wider spans, the org naturally flattens — next slide.</a:t>
             </a:r>
             <a:endParaRPr lang="en-US" dirty="0"/>
           </a:p>
@@ -9166,7 +9166,7 @@
                 <a:ea typeface="Optimist Display" pitchFamily="34" charset="-122"/>
                 <a:cs typeface="Optimist Display" pitchFamily="34" charset="-120"/>
               </a:rPr>
-              <a:t>Two equally valued career paths give every associate a clear way to grow</a:t>
+              <a:t>Everyone starts as an IC, then chooses between two equally valued paths</a:t>
             </a:r>
             <a:endParaRPr lang="en-US" sz="3200" dirty="0"/>
           </a:p>
@@ -9180,8 +9180,8 @@
         </p:nvSpPr>
         <p:spPr>
           <a:xfrm>
-            <a:off x="3225800" y="2286000"/>
-            <a:ext cx="1905000" cy="355600"/>
+            <a:off x="2654300" y="2286000"/>
+            <a:ext cx="3048000" cy="355600"/>
           </a:xfrm>
           <a:prstGeom prst="roundRect">
             <a:avLst>
@@ -9202,8 +9202,8 @@
         </p:nvSpPr>
         <p:spPr>
           <a:xfrm>
-            <a:off x="3225800" y="2286000"/>
-            <a:ext cx="1905000" cy="355600"/>
+            <a:off x="2654300" y="2286000"/>
+            <a:ext cx="3048000" cy="355600"/>
           </a:xfrm>
           <a:prstGeom prst="rect">
             <a:avLst/>
@@ -9230,7 +9230,7 @@
                 <a:ea typeface="Optimist Sans" pitchFamily="34" charset="-122"/>
                 <a:cs typeface="Optimist Sans" pitchFamily="34" charset="-120"/>
               </a:rPr>
-              <a:t>Associate</a:t>
+              <a:t>Junior IC: everyone starts here</a:t>
             </a:r>
             <a:endParaRPr lang="en-US" sz="1300" dirty="0"/>
           </a:p>
@@ -9238,14 +9238,56 @@
       </p:sp>
       <p:sp>
         <p:nvSpPr>
-          <p:cNvPr id="6" name="Shape 4"/>
+          <p:cNvPr id="6" name="Text 4"/>
+          <p:cNvSpPr txBox="1"/>
+          <p:nvPr/>
+        </p:nvSpPr>
+        <p:spPr>
+          <a:xfrm>
+            <a:off x="4279900" y="2628900"/>
+            <a:ext cx="2032000" cy="215900"/>
+          </a:xfrm>
+          <a:prstGeom prst="rect">
+            <a:avLst/>
+          </a:prstGeom>
+          <a:noFill/>
+          <a:ln/>
+        </p:spPr>
+        <p:txBody>
+          <a:bodyPr wrap="square" lIns="0" tIns="0" rIns="0" bIns="0" rtlCol="0" anchor="t"/>
+          <a:lstStyle/>
+          <a:p>
+            <a:pPr algn="l" indent="0" marL="0">
+              <a:lnSpc>
+                <a:spcPct val="115000"/>
+              </a:lnSpc>
+              <a:buNone/>
+            </a:pPr>
+            <a:r>
+              <a:rPr lang="en-US" sz="1200" i="1" dirty="0">
+                <a:solidFill>
+                  <a:srgbClr val="6B7280"/>
+                </a:solidFill>
+                <a:latin typeface="Optimist Sans" pitchFamily="34" charset="0"/>
+                <a:ea typeface="Optimist Sans" pitchFamily="34" charset="-122"/>
+                <a:cs typeface="Optimist Sans" pitchFamily="34" charset="-120"/>
+              </a:rPr>
+              <a:t>Choose at senior level</a:t>
+            </a:r>
+            <a:endParaRPr lang="en-US" sz="1200" dirty="0"/>
+          </a:p>
+        </p:txBody>
+      </p:sp>
+      <p:sp>
+        <p:nvSpPr>
+          <p:cNvPr id="7" name="Shape 5"/>
           <p:cNvSpPr/>
           <p:nvPr/>
         </p:nvSpPr>
         <p:spPr>
           <a:xfrm>
             <a:off x="4178300" y="2641600"/>
-            <a:ext cx="914" cy="152400"/>
+            <a:ext cx="914" cy="228600"/>
           </a:xfrm>
           <a:prstGeom prst="line">
             <a:avLst/>
@@ -9261,13 +9303,13 @@
       </p:sp>
       <p:sp>
         <p:nvSpPr>
-          <p:cNvPr id="7" name="Shape 5"/>
+          <p:cNvPr id="8" name="Shape 6"/>
           <p:cNvSpPr/>
           <p:nvPr/>
         </p:nvSpPr>
         <p:spPr>
           <a:xfrm>
-            <a:off x="2432050" y="2794000"/>
+            <a:off x="2432050" y="2870200"/>
             <a:ext cx="3492500" cy="914"/>
           </a:xfrm>
           <a:prstGeom prst="line">
@@ -9284,14 +9326,14 @@
       </p:sp>
       <p:sp>
         <p:nvSpPr>
-          <p:cNvPr id="8" name="Shape 6"/>
+          <p:cNvPr id="9" name="Shape 7"/>
           <p:cNvSpPr/>
           <p:nvPr/>
         </p:nvSpPr>
         <p:spPr>
           <a:xfrm>
-            <a:off x="2432050" y="2794000"/>
-            <a:ext cx="914" cy="190500"/>
+            <a:off x="2432050" y="2870200"/>
+            <a:ext cx="914" cy="114300"/>
           </a:xfrm>
           <a:prstGeom prst="line">
             <a:avLst/>
@@ -9308,14 +9350,14 @@
       </p:sp>
       <p:sp>
         <p:nvSpPr>
-          <p:cNvPr id="9" name="Shape 7"/>
+          <p:cNvPr id="10" name="Shape 8"/>
           <p:cNvSpPr/>
           <p:nvPr/>
         </p:nvSpPr>
         <p:spPr>
           <a:xfrm>
-            <a:off x="5924550" y="2794000"/>
-            <a:ext cx="914" cy="190500"/>
+            <a:off x="5924550" y="2870200"/>
+            <a:ext cx="914" cy="114300"/>
           </a:xfrm>
           <a:prstGeom prst="line">
             <a:avLst/>
@@ -9332,7 +9374,7 @@
       </p:sp>
       <p:sp>
         <p:nvSpPr>
-          <p:cNvPr id="10" name="Shape 8"/>
+          <p:cNvPr id="11" name="Shape 9"/>
           <p:cNvSpPr/>
           <p:nvPr/>
         </p:nvSpPr>
@@ -9359,7 +9401,7 @@
       </p:sp>
       <p:sp>
         <p:nvSpPr>
-          <p:cNvPr id="11" name="Text 9"/>
+          <p:cNvPr id="12" name="Text 10"/>
           <p:cNvSpPr txBox="1"/>
           <p:nvPr/>
         </p:nvSpPr>
@@ -9401,7 +9443,7 @@
       </p:sp>
       <p:sp>
         <p:nvSpPr>
-          <p:cNvPr id="12" name="Text 10"/>
+          <p:cNvPr id="13" name="Text 11"/>
           <p:cNvSpPr txBox="1"/>
           <p:nvPr/>
         </p:nvSpPr>
@@ -9443,7 +9485,7 @@
       </p:sp>
       <p:sp>
         <p:nvSpPr>
-          <p:cNvPr id="13" name="Text 11"/>
+          <p:cNvPr id="14" name="Text 12"/>
           <p:cNvSpPr txBox="1"/>
           <p:nvPr/>
         </p:nvSpPr>
@@ -9502,7 +9544,7 @@
       </p:sp>
       <p:sp>
         <p:nvSpPr>
-          <p:cNvPr id="14" name="Text 12"/>
+          <p:cNvPr id="15" name="Text 13"/>
           <p:cNvSpPr txBox="1"/>
           <p:nvPr/>
         </p:nvSpPr>
@@ -9561,7 +9603,7 @@
       </p:sp>
       <p:sp>
         <p:nvSpPr>
-          <p:cNvPr id="15" name="Shape 13"/>
+          <p:cNvPr id="16" name="Shape 14"/>
           <p:cNvSpPr/>
           <p:nvPr/>
         </p:nvSpPr>
@@ -9588,7 +9630,7 @@
       </p:sp>
       <p:sp>
         <p:nvSpPr>
-          <p:cNvPr id="16" name="Text 14"/>
+          <p:cNvPr id="17" name="Text 15"/>
           <p:cNvSpPr txBox="1"/>
           <p:nvPr/>
         </p:nvSpPr>
@@ -9630,7 +9672,7 @@
       </p:sp>
       <p:sp>
         <p:nvSpPr>
-          <p:cNvPr id="17" name="Text 15"/>
+          <p:cNvPr id="18" name="Text 16"/>
           <p:cNvSpPr txBox="1"/>
           <p:nvPr/>
         </p:nvSpPr>
@@ -9672,7 +9714,7 @@
       </p:sp>
       <p:sp>
         <p:nvSpPr>
-          <p:cNvPr id="18" name="Text 16"/>
+          <p:cNvPr id="19" name="Text 17"/>
           <p:cNvSpPr txBox="1"/>
           <p:nvPr/>
         </p:nvSpPr>
@@ -9731,7 +9773,7 @@
       </p:sp>
       <p:sp>
         <p:nvSpPr>
-          <p:cNvPr id="19" name="Text 17"/>
+          <p:cNvPr id="20" name="Text 18"/>
           <p:cNvSpPr txBox="1"/>
           <p:nvPr/>
         </p:nvSpPr>
@@ -9790,7 +9832,7 @@
       </p:sp>
       <p:sp>
         <p:nvSpPr>
-          <p:cNvPr id="20" name="Shape 18"/>
+          <p:cNvPr id="21" name="Shape 19"/>
           <p:cNvSpPr/>
           <p:nvPr/>
         </p:nvSpPr>
@@ -9815,7 +9857,7 @@
       </p:sp>
       <p:sp>
         <p:nvSpPr>
-          <p:cNvPr id="21" name="Text 19"/>
+          <p:cNvPr id="22" name="Text 20"/>
           <p:cNvSpPr txBox="1"/>
           <p:nvPr/>
         </p:nvSpPr>
@@ -9857,7 +9899,7 @@
       </p:sp>
       <p:sp>
         <p:nvSpPr>
-          <p:cNvPr id="22" name="Text 20"/>
+          <p:cNvPr id="23" name="Text 21"/>
           <p:cNvSpPr txBox="1"/>
           <p:nvPr/>
         </p:nvSpPr>
@@ -9891,7 +9933,7 @@
                 <a:ea typeface="Optimist Sans" pitchFamily="34" charset="-122"/>
                 <a:cs typeface="Optimist Sans" pitchFamily="34" charset="-120"/>
               </a:rPr>
-              <a:t>Equal chance of success on both paths. </a:t>
+              <a:t>Everyone builds skills as an IC first and chooses once senior. </a:t>
             </a:r>
             <a:pPr algn="l" indent="0" marL="0">
               <a:lnSpc>
@@ -9908,7 +9950,7 @@
                 <a:ea typeface="Optimist Sans" pitchFamily="34" charset="-122"/>
                 <a:cs typeface="Optimist Sans" pitchFamily="34" charset="-120"/>
               </a:rPr>
-              <a:t>We expect more associates to choose the IC path than in the past.</a:t>
+              <a:t>Both paths offer an equal chance of success; we expect more people to stay on the IC path than in the past.</a:t>
             </a:r>
             <a:endParaRPr lang="en-US" sz="1200" dirty="0"/>
           </a:p>
@@ -9916,7 +9958,7 @@
       </p:sp>
       <p:sp>
         <p:nvSpPr>
-          <p:cNvPr id="23" name="Shape 21"/>
+          <p:cNvPr id="24" name="Shape 22"/>
           <p:cNvSpPr/>
           <p:nvPr/>
         </p:nvSpPr>
@@ -9938,7 +9980,7 @@
       </p:sp>
       <p:pic>
         <p:nvPicPr>
-          <p:cNvPr id="24" name="Image 0" descr="preencoded.png">    </p:cNvPr>
+          <p:cNvPr id="25" name="Image 0" descr="preencoded.png">    </p:cNvPr>
           <p:cNvPicPr>
             <a:picLocks noChangeAspect="1"/>
           </p:cNvPicPr>
@@ -9962,7 +10004,7 @@
       </p:pic>
       <p:sp>
         <p:nvSpPr>
-          <p:cNvPr id="25" name="Text 22"/>
+          <p:cNvPr id="26" name="Text 23"/>
           <p:cNvSpPr txBox="1"/>
           <p:nvPr/>
         </p:nvSpPr>
@@ -10004,7 +10046,7 @@
       </p:sp>
       <p:sp>
         <p:nvSpPr>
-          <p:cNvPr id="26" name="Text 23"/>
+          <p:cNvPr id="27" name="Text 24"/>
           <p:cNvSpPr txBox="1"/>
           <p:nvPr/>
         </p:nvSpPr>
@@ -10046,7 +10088,7 @@
       </p:sp>
       <p:sp>
         <p:nvSpPr>
-          <p:cNvPr id="27" name="Shape 24"/>
+          <p:cNvPr id="28" name="Shape 25"/>
           <p:cNvSpPr/>
           <p:nvPr/>
         </p:nvSpPr>
@@ -10068,7 +10110,7 @@
       </p:sp>
       <p:sp>
         <p:nvSpPr>
-          <p:cNvPr id="28" name="Text 25"/>
+          <p:cNvPr id="29" name="Text 26"/>
           <p:cNvSpPr txBox="1"/>
           <p:nvPr/>
         </p:nvSpPr>
@@ -10127,7 +10169,7 @@
       </p:sp>
       <p:sp>
         <p:nvSpPr>
-          <p:cNvPr id="29" name="Text 26"/>
+          <p:cNvPr id="30" name="Text 27"/>
           <p:cNvSpPr txBox="1"/>
           <p:nvPr/>
         </p:nvSpPr>

</xml_diff>

<commit_message>
Merge overlapping costs, add BAU delivery risk, reframe rework as morale risk
Co-Authored-By: Claude Opus 5.5 <noreply@anthropic.com>
Claude-Session: https://claude.ai/code/session_01JXKaD9UU8MgeRWUr7sq4Za
</commit_message>
<xml_diff>
--- a/Unified Team Strategy.pptx
+++ b/Unified Team Strategy.pptx
@@ -115,27 +115,27 @@
   <p:extLst>
     <p:ext uri="{521415D9-36F7-43E2-AB2F-B90AF26B5E84}">
       <p14:sectionLst xmlns:p14="http://schemas.microsoft.com/office/powerpoint/2010/main">
-        <p14:section name="Why combine" id="{3cc246bd-0282-7c9a-44bc-158a3f1d0c62}">
+        <p14:section name="Why combine" id="{72a98bbb-f8dc-7a06-3342-0d78bf7e936c}">
           <p14:sldIdLst>
             <p14:sldId id="256"/>
             <p14:sldId id="257"/>
           </p14:sldIdLst>
         </p14:section>
-        <p14:section name="How we organize" id="{6a01e301-4436-d1c2-6d4e-a286e7a6538e}">
+        <p14:section name="How we organize" id="{ff6de905-8132-0dba-7121-5a051584d2e2}">
           <p14:sldIdLst>
             <p14:sldId id="258"/>
             <p14:sldId id="259"/>
             <p14:sldId id="260"/>
           </p14:sldIdLst>
         </p14:section>
-        <p14:section name="What we do and how we grow" id="{60ddff7e-aa7d-abe8-035c-a0649be7f9c3}">
+        <p14:section name="What we do and how we grow" id="{eef132fa-3793-43d6-2b5e-bb2f712ac103}">
           <p14:sldIdLst>
             <p14:sldId id="261"/>
             <p14:sldId id="262"/>
             <p14:sldId id="263"/>
           </p14:sldIdLst>
         </p14:section>
-        <p14:section name="Asks" id="{1b62705f-84fd-c610-e7b3-63608a9b7fa5}">
+        <p14:section name="Asks" id="{dd8d2d76-ba18-0b6f-cf83-dfed7d5b7553}">
           <p14:sldIdLst>
             <p14:sldId id="264"/>
           </p14:sldIdLst>
@@ -632,7 +632,7 @@
           <a:p>
             <a:r>
               <a:rPr lang="en-US" dirty="0"/>
-              <a:t>Benefit 1 is the biggest. Today the modeling team is led from the business side and model developers work closely with several business analysts. Real-time customer feedback is valuable, but decisions lean toward the business view and can miss technical risks only data scientists see. A leader with a technical background balances the two, so we build analytical products that meet business needs and technical standards, with less technical debt later. Benefit 2: hand-offs and support sit under one leader and one vision. Instead of the infrastructure team pushing modelers to adopt AI or data initiatives, the leader drives them and the whole team takes part. Benefit 3: a bigger talent pool means more internal mobility, aligned performance management, and the flexibility to concentrate people on a priority project at short notice. Costs: (1) With mid-level managers gone, the people stepping up, including the team lead, cover a broader scope; how we support them is still open. (2) Every lead takes on unfamiliar areas, for example Dual Risk Rating modeling and its business stakeholders. This is expected reorg pain; we lean on business analysts and former team members who know the area. (3) The new vision revisits some earlier decisions, such as tooling development and model consolidation, which can cause rework and frustration. This is a smaller concern than it looks: the vision now comes from the team’s own lead rather than from a partner team, so buy-in follows more naturally. We still share the vision openly with the whole team from day one and are clear about what each person is doing and why.</a:t>
+              <a:t>Benefit 1 is the biggest. Today the modeling team is led from the business side and model developers work closely with several business analysts. Real-time customer feedback is valuable, but decisions lean toward the business view and can miss technical risks only data scientists see. A leader with a technical background balances the two, so we build analytical products that meet business needs and technical standards, with less technical debt later. Benefit 2: hand-offs and support sit under one leader and one vision. Instead of the infrastructure team pushing modelers to adopt AI or data initiatives, the leader drives them and the whole team takes part. Benefit 3: a bigger talent pool means more internal mobility, aligned performance management, and the flexibility to concentrate people on a priority project at short notice. Costs: (1) Stretched leads in new areas. With mid-level managers gone, the people stepping up, including the team lead, cover a broader scope that includes unfamiliar areas such as Dual Risk Rating modeling and its business stakeholders. We lean on business analysts and former team members who know the area; the wider support model is still to be decided. (2) BAU delivery at risk. While attention goes to the reorg and the new AI work, in-flight model deliverables must not slip; we name owners and backups for each critical deliverable through the transition. (3) Rework hurts morale. The new vision revisits some earlier decisions, such as tooling development and model consolidation, and the rework that follows can hurt team morale. We share the vision openly with the whole team from day one and are clear about what each person is doing and why; because the vision now comes from the team’s own lead rather than a partner team, buy-in follows more naturally.</a:t>
             </a:r>
             <a:endParaRPr lang="en-US" dirty="0"/>
           </a:p>
@@ -2752,7 +2752,7 @@
                 <a:ea typeface="Optimist Sans" pitchFamily="34" charset="-122"/>
                 <a:cs typeface="Optimist Sans" pitchFamily="34" charset="-120"/>
               </a:rPr>
-              <a:t>Stretched leadership</a:t>
+              <a:t>Stretched leads, new areas</a:t>
             </a:r>
             <a:endParaRPr lang="en-US" sz="1400" dirty="0"/>
           </a:p>
@@ -2794,7 +2794,7 @@
                 <a:ea typeface="Optimist Sans" pitchFamily="34" charset="-122"/>
                 <a:cs typeface="Optimist Sans" pitchFamily="34" charset="-120"/>
               </a:rPr>
-              <a:t>Mid-level managers left; leads cover more</a:t>
+              <a:t>Fewer managers; leads cover more, incl. unfamiliar DRR work</a:t>
             </a:r>
             <a:endParaRPr lang="en-US" sz="1200" dirty="0"/>
           </a:p>
@@ -2837,13 +2837,13 @@
             </a:avLst>
           </a:prstGeom>
           <a:solidFill>
-            <a:srgbClr val="FDFCF9"/>
+            <a:srgbClr val="E1EEF0"/>
           </a:solidFill>
           <a:ln w="19050">
             <a:solidFill>
               <a:srgbClr val="1F6F7E"/>
             </a:solidFill>
-            <a:prstDash val="dash"/>
+            <a:prstDash val="solid"/>
           </a:ln>
         </p:spPr>
       </p:sp>
@@ -2877,13 +2877,13 @@
             <a:r>
               <a:rPr lang="en-US" sz="1200" dirty="0">
                 <a:solidFill>
-                  <a:srgbClr val="155563"/>
-                </a:solidFill>
-                <a:latin typeface="Optimist Sans" pitchFamily="34" charset="0"/>
-                <a:ea typeface="Optimist Sans" pitchFamily="34" charset="-122"/>
-                <a:cs typeface="Optimist Sans" pitchFamily="34" charset="-120"/>
-              </a:rPr>
-              <a:t>[TBD: support model for stretched leads]</a:t>
+                  <a:srgbClr val="14213D"/>
+                </a:solidFill>
+                <a:latin typeface="Optimist Sans" pitchFamily="34" charset="0"/>
+                <a:ea typeface="Optimist Sans" pitchFamily="34" charset="-122"/>
+                <a:cs typeface="Optimist Sans" pitchFamily="34" charset="-120"/>
+              </a:rPr>
+              <a:t>Lean on experts: business analysts, prior team members. Wider support: [TBD]</a:t>
             </a:r>
             <a:endParaRPr lang="en-US" sz="1200" dirty="0"/>
           </a:p>
@@ -2952,7 +2952,7 @@
                 <a:ea typeface="Optimist Sans" pitchFamily="34" charset="-122"/>
                 <a:cs typeface="Optimist Sans" pitchFamily="34" charset="-120"/>
               </a:rPr>
-              <a:t>New areas for leads</a:t>
+              <a:t>BAU delivery at risk</a:t>
             </a:r>
             <a:endParaRPr lang="en-US" sz="1400" dirty="0"/>
           </a:p>
@@ -2994,7 +2994,7 @@
                 <a:ea typeface="Optimist Sans" pitchFamily="34" charset="-122"/>
                 <a:cs typeface="Optimist Sans" pitchFamily="34" charset="-120"/>
               </a:rPr>
-              <a:t>e.g., DRR modeling and its business stakeholders</a:t>
+              <a:t>Transition pulls focus from in-flight model deliverables</a:t>
             </a:r>
             <a:endParaRPr lang="en-US" sz="1200" dirty="0"/>
           </a:p>
@@ -3083,7 +3083,7 @@
                 <a:ea typeface="Optimist Sans" pitchFamily="34" charset="-122"/>
                 <a:cs typeface="Optimist Sans" pitchFamily="34" charset="-120"/>
               </a:rPr>
-              <a:t>Lean on experts: business analysts and prior team members</a:t>
+              <a:t>Name owners and backups for critical deliverables through the transition</a:t>
             </a:r>
             <a:endParaRPr lang="en-US" sz="1200" dirty="0"/>
           </a:p>
@@ -3152,7 +3152,7 @@
                 <a:ea typeface="Optimist Sans" pitchFamily="34" charset="-122"/>
                 <a:cs typeface="Optimist Sans" pitchFamily="34" charset="-120"/>
               </a:rPr>
-              <a:t>Rework and frustration</a:t>
+              <a:t>Rework hurts morale</a:t>
             </a:r>
             <a:endParaRPr lang="en-US" sz="1400" dirty="0"/>
           </a:p>
@@ -3194,7 +3194,7 @@
                 <a:ea typeface="Optimist Sans" pitchFamily="34" charset="-122"/>
                 <a:cs typeface="Optimist Sans" pitchFamily="34" charset="-120"/>
               </a:rPr>
-              <a:t>Revisits past tooling and consolidation choices</a:t>
+              <a:t>New vision revisits past decisions, forcing rework</a:t>
             </a:r>
             <a:endParaRPr lang="en-US" sz="1200" dirty="0"/>
           </a:p>
@@ -3325,7 +3325,7 @@
                 <a:ea typeface="Optimist Sans" pitchFamily="34" charset="-122"/>
                 <a:cs typeface="Optimist Sans" pitchFamily="34" charset="-120"/>
               </a:rPr>
-              <a:t>Draft for discussion · Dashed box is still to be decided</a:t>
+              <a:t>Draft for discussion · Bracketed text is still to be decided</a:t>
             </a:r>
             <a:endParaRPr lang="en-US" sz="1200" dirty="0"/>
           </a:p>

</xml_diff>

<commit_message>
Update AI-era team and Rethink-with-AI priorities
Co-Authored-By: Claude Opus 5.5 <noreply@anthropic.com>
Claude-Session: https://claude.ai/code/session_01JXKaD9UU8MgeRWUr7sq4Za
</commit_message>
<xml_diff>
--- a/Unified Team Strategy.pptx
+++ b/Unified Team Strategy.pptx
@@ -115,27 +115,27 @@
   <p:extLst>
     <p:ext uri="{521415D9-36F7-43E2-AB2F-B90AF26B5E84}">
       <p14:sectionLst xmlns:p14="http://schemas.microsoft.com/office/powerpoint/2010/main">
-        <p14:section name="Why combine" id="{72a98bbb-f8dc-7a06-3342-0d78bf7e936c}">
+        <p14:section name="Why combine" id="{89f7a3d4-f5dd-6119-a155-4be313884047}">
           <p14:sldIdLst>
             <p14:sldId id="256"/>
             <p14:sldId id="257"/>
           </p14:sldIdLst>
         </p14:section>
-        <p14:section name="How we organize" id="{ff6de905-8132-0dba-7121-5a051584d2e2}">
+        <p14:section name="How we organize" id="{2d02081c-6221-6fbd-2a8b-d6689956ae9a}">
           <p14:sldIdLst>
             <p14:sldId id="258"/>
             <p14:sldId id="259"/>
             <p14:sldId id="260"/>
           </p14:sldIdLst>
         </p14:section>
-        <p14:section name="What we do and how we grow" id="{eef132fa-3793-43d6-2b5e-bb2f712ac103}">
+        <p14:section name="What we do and how we grow" id="{98c60417-57db-af97-a549-a5fd91e909e4}">
           <p14:sldIdLst>
             <p14:sldId id="261"/>
             <p14:sldId id="262"/>
             <p14:sldId id="263"/>
           </p14:sldIdLst>
         </p14:section>
-        <p14:section name="Asks" id="{dd8d2d76-ba18-0b6f-cf83-dfed7d5b7553}">
+        <p14:section name="Asks" id="{c16ab74e-5561-f8be-4a20-19090e6afd52}">
           <p14:sldIdLst>
             <p14:sldId id="264"/>
           </p14:sldIdLst>
@@ -984,7 +984,7 @@
           <a:p>
             <a:r>
               <a:rPr lang="en-US" dirty="0"/>
-              <a:t>The first two priorities improve how we work today; the third is deliberately disruptive — an outside-in view of what the team would look like if designed from scratch with AI. The fourth is covered on the next two slides.</a:t>
+              <a:t>The first two priorities improve how we work today; the third is deliberately disruptive — an outside-in view of what the team would look like if designed from scratch with AI. One opportunity already identified: turn the team’s unwritten procedures and best practices into explicit, shared documentation that both people and AI agents can read and follow. The fourth sets up the next two slides: a flatter structure that fits talent empowered by AI; a pipeline of next-generation leaders who can manage mixed teams of ICs and agents with wider spans; and a talent bar that stays consistent while it keeps rising, backed by a development program that helps ICs grow.</a:t>
             </a:r>
             <a:endParaRPr lang="en-US" dirty="0"/>
           </a:p>
@@ -8103,7 +8103,7 @@
         <p:spPr>
           <a:xfrm>
             <a:off x="812800" y="2717800"/>
-            <a:ext cx="2489200" cy="3175000"/>
+            <a:ext cx="2489200" cy="3124200"/>
           </a:xfrm>
           <a:prstGeom prst="roundRect">
             <a:avLst>
@@ -8137,8 +8137,8 @@
         </p:blipFill>
         <p:spPr>
           <a:xfrm>
-            <a:off x="1016000" y="2921000"/>
-            <a:ext cx="304800" cy="304800"/>
+            <a:off x="1016000" y="2870200"/>
+            <a:ext cx="279400" cy="279400"/>
           </a:xfrm>
           <a:prstGeom prst="rect">
             <a:avLst/>
@@ -8153,8 +8153,8 @@
         </p:nvSpPr>
         <p:spPr>
           <a:xfrm>
-            <a:off x="1016000" y="3327400"/>
-            <a:ext cx="2082800" cy="279400"/>
+            <a:off x="1016000" y="3213100"/>
+            <a:ext cx="2082800" cy="508000"/>
           </a:xfrm>
           <a:prstGeom prst="rect">
             <a:avLst/>
@@ -8168,53 +8168,53 @@
           <a:p>
             <a:pPr algn="l" indent="0" marL="0">
               <a:lnSpc>
+                <a:spcPct val="105000"/>
+              </a:lnSpc>
+              <a:buNone/>
+            </a:pPr>
+            <a:r>
+              <a:rPr lang="en-US" sz="1600" b="1" dirty="0">
+                <a:solidFill>
+                  <a:srgbClr val="14213D"/>
+                </a:solidFill>
+                <a:latin typeface="Optimist Sans" pitchFamily="34" charset="0"/>
+                <a:ea typeface="Optimist Sans" pitchFamily="34" charset="-122"/>
+                <a:cs typeface="Optimist Sans" pitchFamily="34" charset="-120"/>
+              </a:rPr>
+              <a:t>Sharpen model strategy</a:t>
+            </a:r>
+            <a:endParaRPr lang="en-US" sz="1600" dirty="0"/>
+          </a:p>
+        </p:txBody>
+      </p:sp>
+      <p:sp>
+        <p:nvSpPr>
+          <p:cNvPr id="13" name="Text 10"/>
+          <p:cNvSpPr txBox="1"/>
+          <p:nvPr/>
+        </p:nvSpPr>
+        <p:spPr>
+          <a:xfrm>
+            <a:off x="1016000" y="3771900"/>
+            <a:ext cx="2082800" cy="444500"/>
+          </a:xfrm>
+          <a:prstGeom prst="rect">
+            <a:avLst/>
+          </a:prstGeom>
+          <a:noFill/>
+          <a:ln/>
+        </p:spPr>
+        <p:txBody>
+          <a:bodyPr wrap="square" lIns="0" tIns="0" rIns="0" bIns="0" rtlCol="0" anchor="t"/>
+          <a:lstStyle/>
+          <a:p>
+            <a:pPr algn="l" indent="0" marL="0">
+              <a:lnSpc>
                 <a:spcPct val="115000"/>
               </a:lnSpc>
               <a:buNone/>
             </a:pPr>
             <a:r>
-              <a:rPr lang="en-US" sz="1600" b="1" dirty="0">
-                <a:solidFill>
-                  <a:srgbClr val="14213D"/>
-                </a:solidFill>
-                <a:latin typeface="Optimist Sans" pitchFamily="34" charset="0"/>
-                <a:ea typeface="Optimist Sans" pitchFamily="34" charset="-122"/>
-                <a:cs typeface="Optimist Sans" pitchFamily="34" charset="-120"/>
-              </a:rPr>
-              <a:t>Sharpen model strategy</a:t>
-            </a:r>
-            <a:endParaRPr lang="en-US" sz="1600" dirty="0"/>
-          </a:p>
-        </p:txBody>
-      </p:sp>
-      <p:sp>
-        <p:nvSpPr>
-          <p:cNvPr id="13" name="Text 10"/>
-          <p:cNvSpPr txBox="1"/>
-          <p:nvPr/>
-        </p:nvSpPr>
-        <p:spPr>
-          <a:xfrm>
-            <a:off x="1016000" y="3657600"/>
-            <a:ext cx="2082800" cy="508000"/>
-          </a:xfrm>
-          <a:prstGeom prst="rect">
-            <a:avLst/>
-          </a:prstGeom>
-          <a:noFill/>
-          <a:ln/>
-        </p:spPr>
-        <p:txBody>
-          <a:bodyPr wrap="square" lIns="0" tIns="0" rIns="0" bIns="0" rtlCol="0" anchor="t"/>
-          <a:lstStyle/>
-          <a:p>
-            <a:pPr algn="l" indent="0" marL="0">
-              <a:lnSpc>
-                <a:spcPct val="115000"/>
-              </a:lnSpc>
-              <a:buNone/>
-            </a:pPr>
-            <a:r>
               <a:rPr lang="en-US" sz="1300" dirty="0">
                 <a:solidFill>
                   <a:srgbClr val="4A5568"/>
@@ -8237,8 +8237,8 @@
         </p:nvSpPr>
         <p:spPr>
           <a:xfrm>
-            <a:off x="1016000" y="4318000"/>
-            <a:ext cx="2082800" cy="1397000"/>
+            <a:off x="1016000" y="4394200"/>
+            <a:ext cx="2082800" cy="1371600"/>
           </a:xfrm>
           <a:prstGeom prst="rect">
             <a:avLst/>
@@ -8323,7 +8323,7 @@
         <p:spPr>
           <a:xfrm>
             <a:off x="3505200" y="2717800"/>
-            <a:ext cx="2489200" cy="3175000"/>
+            <a:ext cx="2489200" cy="3124200"/>
           </a:xfrm>
           <a:prstGeom prst="roundRect">
             <a:avLst>
@@ -8357,8 +8357,8 @@
         </p:blipFill>
         <p:spPr>
           <a:xfrm>
-            <a:off x="3708400" y="2921000"/>
-            <a:ext cx="304800" cy="304800"/>
+            <a:off x="3708400" y="2870200"/>
+            <a:ext cx="279400" cy="279400"/>
           </a:xfrm>
           <a:prstGeom prst="rect">
             <a:avLst/>
@@ -8373,8 +8373,8 @@
         </p:nvSpPr>
         <p:spPr>
           <a:xfrm>
-            <a:off x="3708400" y="3327400"/>
-            <a:ext cx="2082800" cy="279400"/>
+            <a:off x="3708400" y="3213100"/>
+            <a:ext cx="2082800" cy="508000"/>
           </a:xfrm>
           <a:prstGeom prst="rect">
             <a:avLst/>
@@ -8388,53 +8388,53 @@
           <a:p>
             <a:pPr algn="l" indent="0" marL="0">
               <a:lnSpc>
+                <a:spcPct val="105000"/>
+              </a:lnSpc>
+              <a:buNone/>
+            </a:pPr>
+            <a:r>
+              <a:rPr lang="en-US" sz="1600" b="1" dirty="0">
+                <a:solidFill>
+                  <a:srgbClr val="14213D"/>
+                </a:solidFill>
+                <a:latin typeface="Optimist Sans" pitchFamily="34" charset="0"/>
+                <a:ea typeface="Optimist Sans" pitchFamily="34" charset="-122"/>
+                <a:cs typeface="Optimist Sans" pitchFamily="34" charset="-120"/>
+              </a:rPr>
+              <a:t>Clean our house</a:t>
+            </a:r>
+            <a:endParaRPr lang="en-US" sz="1600" dirty="0"/>
+          </a:p>
+        </p:txBody>
+      </p:sp>
+      <p:sp>
+        <p:nvSpPr>
+          <p:cNvPr id="18" name="Text 14"/>
+          <p:cNvSpPr txBox="1"/>
+          <p:nvPr/>
+        </p:nvSpPr>
+        <p:spPr>
+          <a:xfrm>
+            <a:off x="3708400" y="3771900"/>
+            <a:ext cx="2082800" cy="444500"/>
+          </a:xfrm>
+          <a:prstGeom prst="rect">
+            <a:avLst/>
+          </a:prstGeom>
+          <a:noFill/>
+          <a:ln/>
+        </p:spPr>
+        <p:txBody>
+          <a:bodyPr wrap="square" lIns="0" tIns="0" rIns="0" bIns="0" rtlCol="0" anchor="t"/>
+          <a:lstStyle/>
+          <a:p>
+            <a:pPr algn="l" indent="0" marL="0">
+              <a:lnSpc>
                 <a:spcPct val="115000"/>
               </a:lnSpc>
               <a:buNone/>
             </a:pPr>
             <a:r>
-              <a:rPr lang="en-US" sz="1600" b="1" dirty="0">
-                <a:solidFill>
-                  <a:srgbClr val="14213D"/>
-                </a:solidFill>
-                <a:latin typeface="Optimist Sans" pitchFamily="34" charset="0"/>
-                <a:ea typeface="Optimist Sans" pitchFamily="34" charset="-122"/>
-                <a:cs typeface="Optimist Sans" pitchFamily="34" charset="-120"/>
-              </a:rPr>
-              <a:t>Clean our house</a:t>
-            </a:r>
-            <a:endParaRPr lang="en-US" sz="1600" dirty="0"/>
-          </a:p>
-        </p:txBody>
-      </p:sp>
-      <p:sp>
-        <p:nvSpPr>
-          <p:cNvPr id="18" name="Text 14"/>
-          <p:cNvSpPr txBox="1"/>
-          <p:nvPr/>
-        </p:nvSpPr>
-        <p:spPr>
-          <a:xfrm>
-            <a:off x="3708400" y="3657600"/>
-            <a:ext cx="2082800" cy="508000"/>
-          </a:xfrm>
-          <a:prstGeom prst="rect">
-            <a:avLst/>
-          </a:prstGeom>
-          <a:noFill/>
-          <a:ln/>
-        </p:spPr>
-        <p:txBody>
-          <a:bodyPr wrap="square" lIns="0" tIns="0" rIns="0" bIns="0" rtlCol="0" anchor="t"/>
-          <a:lstStyle/>
-          <a:p>
-            <a:pPr algn="l" indent="0" marL="0">
-              <a:lnSpc>
-                <a:spcPct val="115000"/>
-              </a:lnSpc>
-              <a:buNone/>
-            </a:pPr>
-            <a:r>
               <a:rPr lang="en-US" sz="1300" dirty="0">
                 <a:solidFill>
                   <a:srgbClr val="4A5568"/>
@@ -8457,8 +8457,8 @@
         </p:nvSpPr>
         <p:spPr>
           <a:xfrm>
-            <a:off x="3708400" y="4318000"/>
-            <a:ext cx="2082800" cy="1397000"/>
+            <a:off x="3708400" y="4394200"/>
+            <a:ext cx="2082800" cy="1371600"/>
           </a:xfrm>
           <a:prstGeom prst="rect">
             <a:avLst/>
@@ -8543,7 +8543,7 @@
         <p:spPr>
           <a:xfrm>
             <a:off x="6197600" y="2717800"/>
-            <a:ext cx="2489200" cy="3175000"/>
+            <a:ext cx="2489200" cy="3124200"/>
           </a:xfrm>
           <a:prstGeom prst="roundRect">
             <a:avLst>
@@ -8577,8 +8577,8 @@
         </p:blipFill>
         <p:spPr>
           <a:xfrm>
-            <a:off x="6400800" y="2921000"/>
-            <a:ext cx="304800" cy="304800"/>
+            <a:off x="6400800" y="2870200"/>
+            <a:ext cx="279400" cy="279400"/>
           </a:xfrm>
           <a:prstGeom prst="rect">
             <a:avLst/>
@@ -8593,8 +8593,8 @@
         </p:nvSpPr>
         <p:spPr>
           <a:xfrm>
-            <a:off x="6400800" y="3327400"/>
-            <a:ext cx="2082800" cy="279400"/>
+            <a:off x="6400800" y="3213100"/>
+            <a:ext cx="2082800" cy="508000"/>
           </a:xfrm>
           <a:prstGeom prst="rect">
             <a:avLst/>
@@ -8608,53 +8608,53 @@
           <a:p>
             <a:pPr algn="l" indent="0" marL="0">
               <a:lnSpc>
+                <a:spcPct val="105000"/>
+              </a:lnSpc>
+              <a:buNone/>
+            </a:pPr>
+            <a:r>
+              <a:rPr lang="en-US" sz="1600" b="1" dirty="0">
+                <a:solidFill>
+                  <a:srgbClr val="14213D"/>
+                </a:solidFill>
+                <a:latin typeface="Optimist Sans" pitchFamily="34" charset="0"/>
+                <a:ea typeface="Optimist Sans" pitchFamily="34" charset="-122"/>
+                <a:cs typeface="Optimist Sans" pitchFamily="34" charset="-120"/>
+              </a:rPr>
+              <a:t>Rethink with AI</a:t>
+            </a:r>
+            <a:endParaRPr lang="en-US" sz="1600" dirty="0"/>
+          </a:p>
+        </p:txBody>
+      </p:sp>
+      <p:sp>
+        <p:nvSpPr>
+          <p:cNvPr id="23" name="Text 18"/>
+          <p:cNvSpPr txBox="1"/>
+          <p:nvPr/>
+        </p:nvSpPr>
+        <p:spPr>
+          <a:xfrm>
+            <a:off x="6400800" y="3771900"/>
+            <a:ext cx="2082800" cy="444500"/>
+          </a:xfrm>
+          <a:prstGeom prst="rect">
+            <a:avLst/>
+          </a:prstGeom>
+          <a:noFill/>
+          <a:ln/>
+        </p:spPr>
+        <p:txBody>
+          <a:bodyPr wrap="square" lIns="0" tIns="0" rIns="0" bIns="0" rtlCol="0" anchor="t"/>
+          <a:lstStyle/>
+          <a:p>
+            <a:pPr algn="l" indent="0" marL="0">
+              <a:lnSpc>
                 <a:spcPct val="115000"/>
               </a:lnSpc>
               <a:buNone/>
             </a:pPr>
             <a:r>
-              <a:rPr lang="en-US" sz="1600" b="1" dirty="0">
-                <a:solidFill>
-                  <a:srgbClr val="14213D"/>
-                </a:solidFill>
-                <a:latin typeface="Optimist Sans" pitchFamily="34" charset="0"/>
-                <a:ea typeface="Optimist Sans" pitchFamily="34" charset="-122"/>
-                <a:cs typeface="Optimist Sans" pitchFamily="34" charset="-120"/>
-              </a:rPr>
-              <a:t>Rethink with AI</a:t>
-            </a:r>
-            <a:endParaRPr lang="en-US" sz="1600" dirty="0"/>
-          </a:p>
-        </p:txBody>
-      </p:sp>
-      <p:sp>
-        <p:nvSpPr>
-          <p:cNvPr id="23" name="Text 18"/>
-          <p:cNvSpPr txBox="1"/>
-          <p:nvPr/>
-        </p:nvSpPr>
-        <p:spPr>
-          <a:xfrm>
-            <a:off x="6400800" y="3657600"/>
-            <a:ext cx="2082800" cy="508000"/>
-          </a:xfrm>
-          <a:prstGeom prst="rect">
-            <a:avLst/>
-          </a:prstGeom>
-          <a:noFill/>
-          <a:ln/>
-        </p:spPr>
-        <p:txBody>
-          <a:bodyPr wrap="square" lIns="0" tIns="0" rIns="0" bIns="0" rtlCol="0" anchor="t"/>
-          <a:lstStyle/>
-          <a:p>
-            <a:pPr algn="l" indent="0" marL="0">
-              <a:lnSpc>
-                <a:spcPct val="115000"/>
-              </a:lnSpc>
-              <a:buNone/>
-            </a:pPr>
-            <a:r>
               <a:rPr lang="en-US" sz="1300" dirty="0">
                 <a:solidFill>
                   <a:srgbClr val="4A5568"/>
@@ -8677,8 +8677,8 @@
         </p:nvSpPr>
         <p:spPr>
           <a:xfrm>
-            <a:off x="6400800" y="4318000"/>
-            <a:ext cx="2082800" cy="1397000"/>
+            <a:off x="6400800" y="4394200"/>
+            <a:ext cx="2082800" cy="1371600"/>
           </a:xfrm>
           <a:prstGeom prst="rect">
             <a:avLst/>
@@ -8706,7 +8706,7 @@
                 <a:ea typeface="Optimist Sans" pitchFamily="34" charset="-122"/>
                 <a:cs typeface="Optimist Sans" pitchFamily="34" charset="-120"/>
               </a:rPr>
-              <a:t>[Opportunity 1]</a:t>
+              <a:t>Codify unwritten know-how for humans and AI</a:t>
             </a:r>
             <a:endParaRPr lang="en-US" sz="1200" dirty="0"/>
           </a:p>
@@ -8763,7 +8763,7 @@
         <p:spPr>
           <a:xfrm>
             <a:off x="8890000" y="2717800"/>
-            <a:ext cx="2489200" cy="3175000"/>
+            <a:ext cx="2489200" cy="3124200"/>
           </a:xfrm>
           <a:prstGeom prst="roundRect">
             <a:avLst>
@@ -8797,8 +8797,8 @@
         </p:blipFill>
         <p:spPr>
           <a:xfrm>
-            <a:off x="9093200" y="2921000"/>
-            <a:ext cx="304800" cy="304800"/>
+            <a:off x="9093200" y="2870200"/>
+            <a:ext cx="279400" cy="279400"/>
           </a:xfrm>
           <a:prstGeom prst="rect">
             <a:avLst/>
@@ -8813,8 +8813,8 @@
         </p:nvSpPr>
         <p:spPr>
           <a:xfrm>
-            <a:off x="9093200" y="3327400"/>
-            <a:ext cx="2082800" cy="279400"/>
+            <a:off x="9093200" y="3213100"/>
+            <a:ext cx="2082800" cy="508000"/>
           </a:xfrm>
           <a:prstGeom prst="rect">
             <a:avLst/>
@@ -8828,53 +8828,53 @@
           <a:p>
             <a:pPr algn="l" indent="0" marL="0">
               <a:lnSpc>
+                <a:spcPct val="105000"/>
+              </a:lnSpc>
+              <a:buNone/>
+            </a:pPr>
+            <a:r>
+              <a:rPr lang="en-US" sz="1600" b="1" dirty="0">
+                <a:solidFill>
+                  <a:srgbClr val="14213D"/>
+                </a:solidFill>
+                <a:latin typeface="Optimist Sans" pitchFamily="34" charset="0"/>
+                <a:ea typeface="Optimist Sans" pitchFamily="34" charset="-122"/>
+                <a:cs typeface="Optimist Sans" pitchFamily="34" charset="-120"/>
+              </a:rPr>
+              <a:t>Build an AI-era team</a:t>
+            </a:r>
+            <a:endParaRPr lang="en-US" sz="1600" dirty="0"/>
+          </a:p>
+        </p:txBody>
+      </p:sp>
+      <p:sp>
+        <p:nvSpPr>
+          <p:cNvPr id="28" name="Text 22"/>
+          <p:cNvSpPr txBox="1"/>
+          <p:nvPr/>
+        </p:nvSpPr>
+        <p:spPr>
+          <a:xfrm>
+            <a:off x="9093200" y="3771900"/>
+            <a:ext cx="2082800" cy="444500"/>
+          </a:xfrm>
+          <a:prstGeom prst="rect">
+            <a:avLst/>
+          </a:prstGeom>
+          <a:noFill/>
+          <a:ln/>
+        </p:spPr>
+        <p:txBody>
+          <a:bodyPr wrap="square" lIns="0" tIns="0" rIns="0" bIns="0" rtlCol="0" anchor="t"/>
+          <a:lstStyle/>
+          <a:p>
+            <a:pPr algn="l" indent="0" marL="0">
+              <a:lnSpc>
                 <a:spcPct val="115000"/>
               </a:lnSpc>
               <a:buNone/>
             </a:pPr>
             <a:r>
-              <a:rPr lang="en-US" sz="1600" b="1" dirty="0">
-                <a:solidFill>
-                  <a:srgbClr val="14213D"/>
-                </a:solidFill>
-                <a:latin typeface="Optimist Sans" pitchFamily="34" charset="0"/>
-                <a:ea typeface="Optimist Sans" pitchFamily="34" charset="-122"/>
-                <a:cs typeface="Optimist Sans" pitchFamily="34" charset="-120"/>
-              </a:rPr>
-              <a:t>Build an AI-era team</a:t>
-            </a:r>
-            <a:endParaRPr lang="en-US" sz="1600" dirty="0"/>
-          </a:p>
-        </p:txBody>
-      </p:sp>
-      <p:sp>
-        <p:nvSpPr>
-          <p:cNvPr id="28" name="Text 22"/>
-          <p:cNvSpPr txBox="1"/>
-          <p:nvPr/>
-        </p:nvSpPr>
-        <p:spPr>
-          <a:xfrm>
-            <a:off x="9093200" y="3657600"/>
-            <a:ext cx="2082800" cy="508000"/>
-          </a:xfrm>
-          <a:prstGeom prst="rect">
-            <a:avLst/>
-          </a:prstGeom>
-          <a:noFill/>
-          <a:ln/>
-        </p:spPr>
-        <p:txBody>
-          <a:bodyPr wrap="square" lIns="0" tIns="0" rIns="0" bIns="0" rtlCol="0" anchor="t"/>
-          <a:lstStyle/>
-          <a:p>
-            <a:pPr algn="l" indent="0" marL="0">
-              <a:lnSpc>
-                <a:spcPct val="115000"/>
-              </a:lnSpc>
-              <a:buNone/>
-            </a:pPr>
-            <a:r>
               <a:rPr lang="en-US" sz="1300" dirty="0">
                 <a:solidFill>
                   <a:srgbClr val="4A5568"/>
@@ -8897,8 +8897,8 @@
         </p:nvSpPr>
         <p:spPr>
           <a:xfrm>
-            <a:off x="9093200" y="4318000"/>
-            <a:ext cx="2082800" cy="1397000"/>
+            <a:off x="9093200" y="4394200"/>
+            <a:ext cx="2082800" cy="1371600"/>
           </a:xfrm>
           <a:prstGeom prst="rect">
             <a:avLst/>
@@ -8926,7 +8926,7 @@
                 <a:ea typeface="Optimist Sans" pitchFamily="34" charset="-122"/>
                 <a:cs typeface="Optimist Sans" pitchFamily="34" charset="-120"/>
               </a:rPr>
-              <a:t>Flatter structure</a:t>
+              <a:t>Flatter structure for AI-empowered talent</a:t>
             </a:r>
             <a:endParaRPr lang="en-US" sz="1200" dirty="0"/>
           </a:p>
@@ -8947,7 +8947,7 @@
                 <a:ea typeface="Optimist Sans" pitchFamily="34" charset="-122"/>
                 <a:cs typeface="Optimist Sans" pitchFamily="34" charset="-120"/>
               </a:rPr>
-              <a:t>Next-gen leader pipeline</a:t>
+              <a:t>Leaders for mixed IC + agent teams, wider spans</a:t>
             </a:r>
             <a:endParaRPr lang="en-US" sz="1200" dirty="0"/>
           </a:p>
@@ -8968,7 +8968,7 @@
                 <a:ea typeface="Optimist Sans" pitchFamily="34" charset="-122"/>
                 <a:cs typeface="Optimist Sans" pitchFamily="34" charset="-120"/>
               </a:rPr>
-              <a:t>[Item]</a:t>
+              <a:t>Consistent, rising talent bar; IC development</a:t>
             </a:r>
             <a:endParaRPr lang="en-US" sz="1200" dirty="0"/>
           </a:p>

</xml_diff>

<commit_message>
Simplify org detail slide: shorter title, year-end headcount instead of bars
Co-Authored-By: Claude Opus 5.5 <noreply@anthropic.com>
Claude-Session: https://claude.ai/code/session_01JXKaD9UU8MgeRWUr7sq4Za
</commit_message>
<xml_diff>
--- a/Unified Team Strategy.pptx
+++ b/Unified Team Strategy.pptx
@@ -116,13 +116,13 @@
   <p:extLst>
     <p:ext uri="{521415D9-36F7-43E2-AB2F-B90AF26B5E84}">
       <p14:sectionLst xmlns:p14="http://schemas.microsoft.com/office/powerpoint/2010/main">
-        <p14:section name="Why combine" id="{b23fefe0-b801-9041-fbdb-408b88c38ece}">
+        <p14:section name="Why combine" id="{5cd9def0-031c-07e9-e2cd-894518d77e06}">
           <p14:sldIdLst>
             <p14:sldId id="256"/>
             <p14:sldId id="257"/>
           </p14:sldIdLst>
         </p14:section>
-        <p14:section name="How we organize" id="{39e36cba-121b-eca9-4dae-0a5310b7126d}">
+        <p14:section name="How we organize" id="{0c7e561f-c58b-6a0d-e143-fcdc241b7120}">
           <p14:sldIdLst>
             <p14:sldId id="258"/>
             <p14:sldId id="259"/>
@@ -130,14 +130,14 @@
             <p14:sldId id="261"/>
           </p14:sldIdLst>
         </p14:section>
-        <p14:section name="What we do and how we grow" id="{e2de683f-bb16-1503-4a3f-f05199388f49}">
+        <p14:section name="What we do and how we grow" id="{b9c3c889-d034-c044-a716-d58821b5c1d0}">
           <p14:sldIdLst>
             <p14:sldId id="262"/>
             <p14:sldId id="263"/>
             <p14:sldId id="264"/>
           </p14:sldIdLst>
         </p14:section>
-        <p14:section name="Asks" id="{2812ca24-3edd-6315-f041-30c94de14f34}">
+        <p14:section name="Asks" id="{a681bac5-2d66-2f38-fe2b-83122850330a}">
           <p14:sldIdLst>
             <p14:sldId id="265"/>
           </p14:sldIdLst>
@@ -898,7 +898,7 @@
           <a:p>
             <a:r>
               <a:rPr lang="en-US" dirty="0"/>
-              <a:t>This slide turns the four-function structure into the actual team: one team lead, four sub-team heads, and three sub-teams under Modeling, each with its own lead. Each box shows the current headcount, who is on the team, and open roles to backfill. The bars show the planned size of each team at the end of this year, next year and the year after. Modeling, Data Foundation and Platform &amp; Deployment get smaller over time as AI takes on BAU work; AI Enablement grows. The next slide rolls these team-level numbers up into the overall picture.</a:t>
+              <a:t>This slide turns the four-function structure into the actual team: one team lead, four sub-team heads, and three sub-teams under Modeling, each with its own lead and level. Each box lists who is on the team, then year-end headcount: this year’s total with open roles to backfill in parentheses, and the planned size at the end of next year and the year after. Modeling, Data Foundation and Platform &amp; Deployment get smaller over time as AI takes on BAU work; AI Enablement grows. The next slide rolls these team-level numbers up into the overall picture.</a:t>
             </a:r>
             <a:endParaRPr lang="en-US" dirty="0"/>
           </a:p>
@@ -6668,7 +6668,7 @@
                 <a:ea typeface="Optimist Display" pitchFamily="34" charset="-122"/>
                 <a:cs typeface="Optimist Display" pitchFamily="34" charset="-120"/>
               </a:rPr>
-              <a:t>Each sub-team has a named lead and a size path: BAU-heavy teams shrink as AI Enablement grows</a:t>
+              <a:t>BAU-heavy teams shrink as AI Enablement grows</a:t>
             </a:r>
             <a:endParaRPr lang="en-US" sz="3200" dirty="0"/>
           </a:p>
@@ -7123,7 +7123,7 @@
                 <a:ea typeface="Optimist Sans" pitchFamily="34" charset="-122"/>
                 <a:cs typeface="Optimist Sans" pitchFamily="34" charset="-120"/>
               </a:rPr>
-              <a:t>[Name] · Team lead ([Level])</a:t>
+              <a:t>[Name] · Team lead [SD]</a:t>
             </a:r>
             <a:endParaRPr lang="en-US" sz="1300" dirty="0"/>
           </a:p>
@@ -7212,7 +7212,7 @@
                 <a:ea typeface="Optimist Sans" pitchFamily="34" charset="-122"/>
                 <a:cs typeface="Optimist Sans" pitchFamily="34" charset="-120"/>
               </a:rPr>
-              <a:t>[Name] ([Level])</a:t>
+              <a:t>[XX] [D]</a:t>
             </a:r>
             <a:endParaRPr lang="en-US" sz="1200" dirty="0"/>
           </a:p>
@@ -7301,7 +7301,7 @@
                 <a:ea typeface="Optimist Sans" pitchFamily="34" charset="-122"/>
                 <a:cs typeface="Optimist Sans" pitchFamily="34" charset="-120"/>
               </a:rPr>
-              <a:t>[Name] ([Level])</a:t>
+              <a:t>[Name] ([SM])</a:t>
             </a:r>
             <a:endParaRPr lang="en-US" sz="1200" dirty="0"/>
           </a:p>
@@ -7390,7 +7390,7 @@
                 <a:ea typeface="Optimist Sans" pitchFamily="34" charset="-122"/>
                 <a:cs typeface="Optimist Sans" pitchFamily="34" charset="-120"/>
               </a:rPr>
-              <a:t>[Name] ([Level])</a:t>
+              <a:t>[Name] ([SM])</a:t>
             </a:r>
             <a:endParaRPr lang="en-US" sz="1200" dirty="0"/>
           </a:p>
@@ -7479,7 +7479,7 @@
                 <a:ea typeface="Optimist Sans" pitchFamily="34" charset="-122"/>
                 <a:cs typeface="Optimist Sans" pitchFamily="34" charset="-120"/>
               </a:rPr>
-              <a:t>[Name] ([Level])</a:t>
+              <a:t>[Name] ([D/SM])</a:t>
             </a:r>
             <a:endParaRPr lang="en-US" sz="1200" dirty="0"/>
           </a:p>
@@ -7568,7 +7568,7 @@
                 <a:ea typeface="Optimist Sans" pitchFamily="34" charset="-122"/>
                 <a:cs typeface="Optimist Sans" pitchFamily="34" charset="-120"/>
               </a:rPr>
-              <a:t>[Name] ([Level])</a:t>
+              <a:t>[Name] ([SM])</a:t>
             </a:r>
             <a:endParaRPr lang="en-US" sz="1200" dirty="0"/>
           </a:p>
@@ -7657,7 +7657,7 @@
                 <a:ea typeface="Optimist Sans" pitchFamily="34" charset="-122"/>
                 <a:cs typeface="Optimist Sans" pitchFamily="34" charset="-120"/>
               </a:rPr>
-              <a:t>[Name] ([Level])</a:t>
+              <a:t>[Name] ([M])</a:t>
             </a:r>
             <a:endParaRPr lang="en-US" sz="1200" dirty="0"/>
           </a:p>
@@ -7746,7 +7746,7 @@
                 <a:ea typeface="Optimist Sans" pitchFamily="34" charset="-122"/>
                 <a:cs typeface="Optimist Sans" pitchFamily="34" charset="-120"/>
               </a:rPr>
-              <a:t>[Name] ([Level])</a:t>
+              <a:t>[Name] ([M])</a:t>
             </a:r>
             <a:endParaRPr lang="en-US" sz="1200" dirty="0"/>
           </a:p>
@@ -7787,8 +7787,92 @@
         </p:nvSpPr>
         <p:spPr>
           <a:xfrm>
-            <a:off x="901700" y="4521200"/>
-            <a:ext cx="1346200" cy="190500"/>
+            <a:off x="914400" y="4521200"/>
+            <a:ext cx="1320800" cy="406400"/>
+          </a:xfrm>
+          <a:prstGeom prst="rect">
+            <a:avLst/>
+          </a:prstGeom>
+          <a:noFill/>
+          <a:ln/>
+        </p:spPr>
+        <p:txBody>
+          <a:bodyPr wrap="square" lIns="0" tIns="0" rIns="0" bIns="0" rtlCol="0" anchor="t"/>
+          <a:lstStyle/>
+          <a:p>
+            <a:pPr algn="l" indent="0" marL="0">
+              <a:lnSpc>
+                <a:spcPct val="115000"/>
+              </a:lnSpc>
+              <a:buNone/>
+            </a:pPr>
+            <a:r>
+              <a:rPr lang="en-US" sz="1200" dirty="0">
+                <a:solidFill>
+                  <a:srgbClr val="4A5568"/>
+                </a:solidFill>
+                <a:latin typeface="Optimist Sans" pitchFamily="34" charset="0"/>
+                <a:ea typeface="Optimist Sans" pitchFamily="34" charset="-122"/>
+                <a:cs typeface="Optimist Sans" pitchFamily="34" charset="-120"/>
+              </a:rPr>
+              <a:t>[Name], [Name], [Name], …</a:t>
+            </a:r>
+            <a:endParaRPr lang="en-US" sz="1200" dirty="0"/>
+          </a:p>
+        </p:txBody>
+      </p:sp>
+      <p:sp>
+        <p:nvSpPr>
+          <p:cNvPr id="39" name="Text 37"/>
+          <p:cNvSpPr txBox="1"/>
+          <p:nvPr/>
+        </p:nvSpPr>
+        <p:spPr>
+          <a:xfrm>
+            <a:off x="914400" y="5067300"/>
+            <a:ext cx="304800" cy="215900"/>
+          </a:xfrm>
+          <a:prstGeom prst="rect">
+            <a:avLst/>
+          </a:prstGeom>
+          <a:noFill/>
+          <a:ln/>
+        </p:spPr>
+        <p:txBody>
+          <a:bodyPr wrap="square" lIns="0" tIns="0" rIns="0" bIns="0" rtlCol="0" anchor="t"/>
+          <a:lstStyle/>
+          <a:p>
+            <a:pPr algn="l" indent="0" marL="0">
+              <a:lnSpc>
+                <a:spcPct val="115000"/>
+              </a:lnSpc>
+              <a:buNone/>
+            </a:pPr>
+            <a:r>
+              <a:rPr lang="en-US" sz="1200" dirty="0">
+                <a:solidFill>
+                  <a:srgbClr val="6B7280"/>
+                </a:solidFill>
+                <a:latin typeface="Optimist Sans" pitchFamily="34" charset="0"/>
+                <a:ea typeface="Optimist Sans" pitchFamily="34" charset="-122"/>
+                <a:cs typeface="Optimist Sans" pitchFamily="34" charset="-120"/>
+              </a:rPr>
+              <a:t>’26</a:t>
+            </a:r>
+            <a:endParaRPr lang="en-US" sz="1200" dirty="0"/>
+          </a:p>
+        </p:txBody>
+      </p:sp>
+      <p:sp>
+        <p:nvSpPr>
+          <p:cNvPr id="40" name="Text 38"/>
+          <p:cNvSpPr txBox="1"/>
+          <p:nvPr/>
+        </p:nvSpPr>
+        <p:spPr>
+          <a:xfrm>
+            <a:off x="1295400" y="5067300"/>
+            <a:ext cx="939800" cy="215900"/>
           </a:xfrm>
           <a:prstGeom prst="rect">
             <a:avLst/>
@@ -7815,7 +7899,24 @@
                 <a:ea typeface="Optimist Sans" pitchFamily="34" charset="-122"/>
                 <a:cs typeface="Optimist Sans" pitchFamily="34" charset="-120"/>
               </a:rPr>
-              <a:t>[n] associates</a:t>
+              <a:t>[n] </a:t>
+            </a:r>
+            <a:pPr algn="l" indent="0" marL="0">
+              <a:lnSpc>
+                <a:spcPct val="115000"/>
+              </a:lnSpc>
+              <a:buNone/>
+            </a:pPr>
+            <a:r>
+              <a:rPr lang="en-US" sz="1200" dirty="0">
+                <a:solidFill>
+                  <a:srgbClr val="6B7280"/>
+                </a:solidFill>
+                <a:latin typeface="Optimist Sans" pitchFamily="34" charset="0"/>
+                <a:ea typeface="Optimist Sans" pitchFamily="34" charset="-122"/>
+                <a:cs typeface="Optimist Sans" pitchFamily="34" charset="-120"/>
+              </a:rPr>
+              <a:t>([n])</a:t>
             </a:r>
             <a:endParaRPr lang="en-US" sz="1200" dirty="0"/>
           </a:p>
@@ -7823,41 +7924,41 @@
       </p:sp>
       <p:sp>
         <p:nvSpPr>
-          <p:cNvPr id="39" name="Text 37"/>
-          <p:cNvSpPr txBox="1"/>
-          <p:nvPr/>
-        </p:nvSpPr>
-        <p:spPr>
-          <a:xfrm>
-            <a:off x="901700" y="4724400"/>
-            <a:ext cx="1346200" cy="406400"/>
-          </a:xfrm>
-          <a:prstGeom prst="rect">
-            <a:avLst/>
-          </a:prstGeom>
-          <a:noFill/>
-          <a:ln/>
-        </p:spPr>
-        <p:txBody>
-          <a:bodyPr wrap="square" lIns="0" tIns="0" rIns="0" bIns="0" rtlCol="0" anchor="t"/>
-          <a:lstStyle/>
-          <a:p>
-            <a:pPr algn="l" indent="0" marL="0">
-              <a:lnSpc>
-                <a:spcPct val="110000"/>
+          <p:cNvPr id="41" name="Text 39"/>
+          <p:cNvSpPr txBox="1"/>
+          <p:nvPr/>
+        </p:nvSpPr>
+        <p:spPr>
+          <a:xfrm>
+            <a:off x="914400" y="5295900"/>
+            <a:ext cx="304800" cy="215900"/>
+          </a:xfrm>
+          <a:prstGeom prst="rect">
+            <a:avLst/>
+          </a:prstGeom>
+          <a:noFill/>
+          <a:ln/>
+        </p:spPr>
+        <p:txBody>
+          <a:bodyPr wrap="square" lIns="0" tIns="0" rIns="0" bIns="0" rtlCol="0" anchor="t"/>
+          <a:lstStyle/>
+          <a:p>
+            <a:pPr algn="l" indent="0" marL="0">
+              <a:lnSpc>
+                <a:spcPct val="115000"/>
               </a:lnSpc>
               <a:buNone/>
             </a:pPr>
             <a:r>
               <a:rPr lang="en-US" sz="1200" dirty="0">
                 <a:solidFill>
-                  <a:srgbClr val="4A5568"/>
-                </a:solidFill>
-                <a:latin typeface="Optimist Sans" pitchFamily="34" charset="0"/>
-                <a:ea typeface="Optimist Sans" pitchFamily="34" charset="-122"/>
-                <a:cs typeface="Optimist Sans" pitchFamily="34" charset="-120"/>
-              </a:rPr>
-              <a:t>[Name], [Name], [Name] + [n] open</a:t>
+                  <a:srgbClr val="6B7280"/>
+                </a:solidFill>
+                <a:latin typeface="Optimist Sans" pitchFamily="34" charset="0"/>
+                <a:ea typeface="Optimist Sans" pitchFamily="34" charset="-122"/>
+                <a:cs typeface="Optimist Sans" pitchFamily="34" charset="-120"/>
+              </a:rPr>
+              <a:t>’27</a:t>
             </a:r>
             <a:endParaRPr lang="en-US" sz="1200" dirty="0"/>
           </a:p>
@@ -7865,54 +7966,118 @@
       </p:sp>
       <p:sp>
         <p:nvSpPr>
-          <p:cNvPr id="40" name="Shape 38"/>
-          <p:cNvSpPr/>
-          <p:nvPr/>
-        </p:nvSpPr>
-        <p:spPr>
-          <a:xfrm>
-            <a:off x="990600" y="5359400"/>
-            <a:ext cx="254000" cy="215900"/>
-          </a:xfrm>
-          <a:prstGeom prst="rect">
-            <a:avLst/>
-          </a:prstGeom>
-          <a:solidFill>
-            <a:srgbClr val="1F6F7E"/>
-          </a:solidFill>
-          <a:ln/>
-        </p:spPr>
-      </p:sp>
-      <p:sp>
-        <p:nvSpPr>
-          <p:cNvPr id="41" name="Text 39"/>
-          <p:cNvSpPr txBox="1"/>
-          <p:nvPr/>
-        </p:nvSpPr>
-        <p:spPr>
-          <a:xfrm>
-            <a:off x="914400" y="5181600"/>
-            <a:ext cx="406400" cy="165100"/>
-          </a:xfrm>
-          <a:prstGeom prst="rect">
-            <a:avLst/>
-          </a:prstGeom>
-          <a:noFill/>
-          <a:ln/>
-        </p:spPr>
-        <p:txBody>
-          <a:bodyPr wrap="square" lIns="0" tIns="0" rIns="0" bIns="0" rtlCol="0" anchor="t"/>
-          <a:lstStyle/>
-          <a:p>
-            <a:pPr algn="ctr" indent="0" marL="0">
-              <a:lnSpc>
-                <a:spcPct val="100000"/>
+          <p:cNvPr id="42" name="Text 40"/>
+          <p:cNvSpPr txBox="1"/>
+          <p:nvPr/>
+        </p:nvSpPr>
+        <p:spPr>
+          <a:xfrm>
+            <a:off x="1295400" y="5295900"/>
+            <a:ext cx="939800" cy="215900"/>
+          </a:xfrm>
+          <a:prstGeom prst="rect">
+            <a:avLst/>
+          </a:prstGeom>
+          <a:noFill/>
+          <a:ln/>
+        </p:spPr>
+        <p:txBody>
+          <a:bodyPr wrap="square" lIns="0" tIns="0" rIns="0" bIns="0" rtlCol="0" anchor="t"/>
+          <a:lstStyle/>
+          <a:p>
+            <a:pPr algn="l" indent="0" marL="0">
+              <a:lnSpc>
+                <a:spcPct val="115000"/>
+              </a:lnSpc>
+              <a:buNone/>
+            </a:pPr>
+            <a:r>
+              <a:rPr lang="en-US" sz="1200" b="1" dirty="0">
+                <a:solidFill>
+                  <a:srgbClr val="14213D"/>
+                </a:solidFill>
+                <a:latin typeface="Optimist Sans" pitchFamily="34" charset="0"/>
+                <a:ea typeface="Optimist Sans" pitchFamily="34" charset="-122"/>
+                <a:cs typeface="Optimist Sans" pitchFamily="34" charset="-120"/>
+              </a:rPr>
+              <a:t>[n]</a:t>
+            </a:r>
+            <a:endParaRPr lang="en-US" sz="1200" dirty="0"/>
+          </a:p>
+        </p:txBody>
+      </p:sp>
+      <p:sp>
+        <p:nvSpPr>
+          <p:cNvPr id="43" name="Text 41"/>
+          <p:cNvSpPr txBox="1"/>
+          <p:nvPr/>
+        </p:nvSpPr>
+        <p:spPr>
+          <a:xfrm>
+            <a:off x="914400" y="5524500"/>
+            <a:ext cx="304800" cy="215900"/>
+          </a:xfrm>
+          <a:prstGeom prst="rect">
+            <a:avLst/>
+          </a:prstGeom>
+          <a:noFill/>
+          <a:ln/>
+        </p:spPr>
+        <p:txBody>
+          <a:bodyPr wrap="square" lIns="0" tIns="0" rIns="0" bIns="0" rtlCol="0" anchor="t"/>
+          <a:lstStyle/>
+          <a:p>
+            <a:pPr algn="l" indent="0" marL="0">
+              <a:lnSpc>
+                <a:spcPct val="115000"/>
               </a:lnSpc>
               <a:buNone/>
             </a:pPr>
             <a:r>
               <a:rPr lang="en-US" sz="1200" dirty="0">
                 <a:solidFill>
+                  <a:srgbClr val="6B7280"/>
+                </a:solidFill>
+                <a:latin typeface="Optimist Sans" pitchFamily="34" charset="0"/>
+                <a:ea typeface="Optimist Sans" pitchFamily="34" charset="-122"/>
+                <a:cs typeface="Optimist Sans" pitchFamily="34" charset="-120"/>
+              </a:rPr>
+              <a:t>’28</a:t>
+            </a:r>
+            <a:endParaRPr lang="en-US" sz="1200" dirty="0"/>
+          </a:p>
+        </p:txBody>
+      </p:sp>
+      <p:sp>
+        <p:nvSpPr>
+          <p:cNvPr id="44" name="Text 42"/>
+          <p:cNvSpPr txBox="1"/>
+          <p:nvPr/>
+        </p:nvSpPr>
+        <p:spPr>
+          <a:xfrm>
+            <a:off x="1295400" y="5524500"/>
+            <a:ext cx="939800" cy="215900"/>
+          </a:xfrm>
+          <a:prstGeom prst="rect">
+            <a:avLst/>
+          </a:prstGeom>
+          <a:noFill/>
+          <a:ln/>
+        </p:spPr>
+        <p:txBody>
+          <a:bodyPr wrap="square" lIns="0" tIns="0" rIns="0" bIns="0" rtlCol="0" anchor="t"/>
+          <a:lstStyle/>
+          <a:p>
+            <a:pPr algn="l" indent="0" marL="0">
+              <a:lnSpc>
+                <a:spcPct val="115000"/>
+              </a:lnSpc>
+              <a:buNone/>
+            </a:pPr>
+            <a:r>
+              <a:rPr lang="en-US" sz="1200" b="1" dirty="0">
+                <a:solidFill>
                   <a:srgbClr val="14213D"/>
                 </a:solidFill>
                 <a:latin typeface="Optimist Sans" pitchFamily="34" charset="0"/>
@@ -7927,257 +8092,7 @@
       </p:sp>
       <p:sp>
         <p:nvSpPr>
-          <p:cNvPr id="42" name="Text 40"/>
-          <p:cNvSpPr txBox="1"/>
-          <p:nvPr/>
-        </p:nvSpPr>
-        <p:spPr>
-          <a:xfrm>
-            <a:off x="914400" y="5588000"/>
-            <a:ext cx="406400" cy="165100"/>
-          </a:xfrm>
-          <a:prstGeom prst="rect">
-            <a:avLst/>
-          </a:prstGeom>
-          <a:noFill/>
-          <a:ln/>
-        </p:spPr>
-        <p:txBody>
-          <a:bodyPr wrap="square" lIns="0" tIns="0" rIns="0" bIns="0" rtlCol="0" anchor="t"/>
-          <a:lstStyle/>
-          <a:p>
-            <a:pPr algn="ctr" indent="0" marL="0">
-              <a:lnSpc>
-                <a:spcPct val="100000"/>
-              </a:lnSpc>
-              <a:buNone/>
-            </a:pPr>
-            <a:r>
-              <a:rPr lang="en-US" sz="1200" dirty="0">
-                <a:solidFill>
-                  <a:srgbClr val="6B7280"/>
-                </a:solidFill>
-                <a:latin typeface="Optimist Sans" pitchFamily="34" charset="0"/>
-                <a:ea typeface="Optimist Sans" pitchFamily="34" charset="-122"/>
-                <a:cs typeface="Optimist Sans" pitchFamily="34" charset="-120"/>
-              </a:rPr>
-              <a:t>’26</a:t>
-            </a:r>
-            <a:endParaRPr lang="en-US" sz="1200" dirty="0"/>
-          </a:p>
-        </p:txBody>
-      </p:sp>
-      <p:sp>
-        <p:nvSpPr>
-          <p:cNvPr id="43" name="Shape 41"/>
-          <p:cNvSpPr/>
-          <p:nvPr/>
-        </p:nvSpPr>
-        <p:spPr>
-          <a:xfrm>
-            <a:off x="1447800" y="5410200"/>
-            <a:ext cx="254000" cy="165100"/>
-          </a:xfrm>
-          <a:prstGeom prst="rect">
-            <a:avLst/>
-          </a:prstGeom>
-          <a:solidFill>
-            <a:srgbClr val="1F6F7E"/>
-          </a:solidFill>
-          <a:ln/>
-        </p:spPr>
-      </p:sp>
-      <p:sp>
-        <p:nvSpPr>
-          <p:cNvPr id="44" name="Text 42"/>
-          <p:cNvSpPr txBox="1"/>
-          <p:nvPr/>
-        </p:nvSpPr>
-        <p:spPr>
-          <a:xfrm>
-            <a:off x="1371600" y="5232400"/>
-            <a:ext cx="406400" cy="165100"/>
-          </a:xfrm>
-          <a:prstGeom prst="rect">
-            <a:avLst/>
-          </a:prstGeom>
-          <a:noFill/>
-          <a:ln/>
-        </p:spPr>
-        <p:txBody>
-          <a:bodyPr wrap="square" lIns="0" tIns="0" rIns="0" bIns="0" rtlCol="0" anchor="t"/>
-          <a:lstStyle/>
-          <a:p>
-            <a:pPr algn="ctr" indent="0" marL="0">
-              <a:lnSpc>
-                <a:spcPct val="100000"/>
-              </a:lnSpc>
-              <a:buNone/>
-            </a:pPr>
-            <a:r>
-              <a:rPr lang="en-US" sz="1200" dirty="0">
-                <a:solidFill>
-                  <a:srgbClr val="14213D"/>
-                </a:solidFill>
-                <a:latin typeface="Optimist Sans" pitchFamily="34" charset="0"/>
-                <a:ea typeface="Optimist Sans" pitchFamily="34" charset="-122"/>
-                <a:cs typeface="Optimist Sans" pitchFamily="34" charset="-120"/>
-              </a:rPr>
-              <a:t>[n]</a:t>
-            </a:r>
-            <a:endParaRPr lang="en-US" sz="1200" dirty="0"/>
-          </a:p>
-        </p:txBody>
-      </p:sp>
-      <p:sp>
-        <p:nvSpPr>
-          <p:cNvPr id="45" name="Text 43"/>
-          <p:cNvSpPr txBox="1"/>
-          <p:nvPr/>
-        </p:nvSpPr>
-        <p:spPr>
-          <a:xfrm>
-            <a:off x="1371600" y="5588000"/>
-            <a:ext cx="406400" cy="165100"/>
-          </a:xfrm>
-          <a:prstGeom prst="rect">
-            <a:avLst/>
-          </a:prstGeom>
-          <a:noFill/>
-          <a:ln/>
-        </p:spPr>
-        <p:txBody>
-          <a:bodyPr wrap="square" lIns="0" tIns="0" rIns="0" bIns="0" rtlCol="0" anchor="t"/>
-          <a:lstStyle/>
-          <a:p>
-            <a:pPr algn="ctr" indent="0" marL="0">
-              <a:lnSpc>
-                <a:spcPct val="100000"/>
-              </a:lnSpc>
-              <a:buNone/>
-            </a:pPr>
-            <a:r>
-              <a:rPr lang="en-US" sz="1200" dirty="0">
-                <a:solidFill>
-                  <a:srgbClr val="6B7280"/>
-                </a:solidFill>
-                <a:latin typeface="Optimist Sans" pitchFamily="34" charset="0"/>
-                <a:ea typeface="Optimist Sans" pitchFamily="34" charset="-122"/>
-                <a:cs typeface="Optimist Sans" pitchFamily="34" charset="-120"/>
-              </a:rPr>
-              <a:t>’27</a:t>
-            </a:r>
-            <a:endParaRPr lang="en-US" sz="1200" dirty="0"/>
-          </a:p>
-        </p:txBody>
-      </p:sp>
-      <p:sp>
-        <p:nvSpPr>
-          <p:cNvPr id="46" name="Shape 44"/>
-          <p:cNvSpPr/>
-          <p:nvPr/>
-        </p:nvSpPr>
-        <p:spPr>
-          <a:xfrm>
-            <a:off x="1905000" y="5461000"/>
-            <a:ext cx="254000" cy="114300"/>
-          </a:xfrm>
-          <a:prstGeom prst="rect">
-            <a:avLst/>
-          </a:prstGeom>
-          <a:solidFill>
-            <a:srgbClr val="1F6F7E"/>
-          </a:solidFill>
-          <a:ln/>
-        </p:spPr>
-      </p:sp>
-      <p:sp>
-        <p:nvSpPr>
-          <p:cNvPr id="47" name="Text 45"/>
-          <p:cNvSpPr txBox="1"/>
-          <p:nvPr/>
-        </p:nvSpPr>
-        <p:spPr>
-          <a:xfrm>
-            <a:off x="1828800" y="5283200"/>
-            <a:ext cx="406400" cy="165100"/>
-          </a:xfrm>
-          <a:prstGeom prst="rect">
-            <a:avLst/>
-          </a:prstGeom>
-          <a:noFill/>
-          <a:ln/>
-        </p:spPr>
-        <p:txBody>
-          <a:bodyPr wrap="square" lIns="0" tIns="0" rIns="0" bIns="0" rtlCol="0" anchor="t"/>
-          <a:lstStyle/>
-          <a:p>
-            <a:pPr algn="ctr" indent="0" marL="0">
-              <a:lnSpc>
-                <a:spcPct val="100000"/>
-              </a:lnSpc>
-              <a:buNone/>
-            </a:pPr>
-            <a:r>
-              <a:rPr lang="en-US" sz="1200" dirty="0">
-                <a:solidFill>
-                  <a:srgbClr val="14213D"/>
-                </a:solidFill>
-                <a:latin typeface="Optimist Sans" pitchFamily="34" charset="0"/>
-                <a:ea typeface="Optimist Sans" pitchFamily="34" charset="-122"/>
-                <a:cs typeface="Optimist Sans" pitchFamily="34" charset="-120"/>
-              </a:rPr>
-              <a:t>[n]</a:t>
-            </a:r>
-            <a:endParaRPr lang="en-US" sz="1200" dirty="0"/>
-          </a:p>
-        </p:txBody>
-      </p:sp>
-      <p:sp>
-        <p:nvSpPr>
-          <p:cNvPr id="48" name="Text 46"/>
-          <p:cNvSpPr txBox="1"/>
-          <p:nvPr/>
-        </p:nvSpPr>
-        <p:spPr>
-          <a:xfrm>
-            <a:off x="1828800" y="5588000"/>
-            <a:ext cx="406400" cy="165100"/>
-          </a:xfrm>
-          <a:prstGeom prst="rect">
-            <a:avLst/>
-          </a:prstGeom>
-          <a:noFill/>
-          <a:ln/>
-        </p:spPr>
-        <p:txBody>
-          <a:bodyPr wrap="square" lIns="0" tIns="0" rIns="0" bIns="0" rtlCol="0" anchor="t"/>
-          <a:lstStyle/>
-          <a:p>
-            <a:pPr algn="ctr" indent="0" marL="0">
-              <a:lnSpc>
-                <a:spcPct val="100000"/>
-              </a:lnSpc>
-              <a:buNone/>
-            </a:pPr>
-            <a:r>
-              <a:rPr lang="en-US" sz="1200" dirty="0">
-                <a:solidFill>
-                  <a:srgbClr val="6B7280"/>
-                </a:solidFill>
-                <a:latin typeface="Optimist Sans" pitchFamily="34" charset="0"/>
-                <a:ea typeface="Optimist Sans" pitchFamily="34" charset="-122"/>
-                <a:cs typeface="Optimist Sans" pitchFamily="34" charset="-120"/>
-              </a:rPr>
-              <a:t>’28</a:t>
-            </a:r>
-            <a:endParaRPr lang="en-US" sz="1200" dirty="0"/>
-          </a:p>
-        </p:txBody>
-      </p:sp>
-      <p:sp>
-        <p:nvSpPr>
-          <p:cNvPr id="49" name="Shape 47"/>
+          <p:cNvPr id="45" name="Shape 43"/>
           <p:cNvSpPr/>
           <p:nvPr/>
         </p:nvSpPr>
@@ -8204,14 +8119,199 @@
       </p:sp>
       <p:sp>
         <p:nvSpPr>
+          <p:cNvPr id="46" name="Text 44"/>
+          <p:cNvSpPr txBox="1"/>
+          <p:nvPr/>
+        </p:nvSpPr>
+        <p:spPr>
+          <a:xfrm>
+            <a:off x="2540000" y="4521200"/>
+            <a:ext cx="1320800" cy="406400"/>
+          </a:xfrm>
+          <a:prstGeom prst="rect">
+            <a:avLst/>
+          </a:prstGeom>
+          <a:noFill/>
+          <a:ln/>
+        </p:spPr>
+        <p:txBody>
+          <a:bodyPr wrap="square" lIns="0" tIns="0" rIns="0" bIns="0" rtlCol="0" anchor="t"/>
+          <a:lstStyle/>
+          <a:p>
+            <a:pPr algn="l" indent="0" marL="0">
+              <a:lnSpc>
+                <a:spcPct val="115000"/>
+              </a:lnSpc>
+              <a:buNone/>
+            </a:pPr>
+            <a:r>
+              <a:rPr lang="en-US" sz="1200" dirty="0">
+                <a:solidFill>
+                  <a:srgbClr val="4A5568"/>
+                </a:solidFill>
+                <a:latin typeface="Optimist Sans" pitchFamily="34" charset="0"/>
+                <a:ea typeface="Optimist Sans" pitchFamily="34" charset="-122"/>
+                <a:cs typeface="Optimist Sans" pitchFamily="34" charset="-120"/>
+              </a:rPr>
+              <a:t>[Name], [Name], [Name], …</a:t>
+            </a:r>
+            <a:endParaRPr lang="en-US" sz="1200" dirty="0"/>
+          </a:p>
+        </p:txBody>
+      </p:sp>
+      <p:sp>
+        <p:nvSpPr>
+          <p:cNvPr id="47" name="Text 45"/>
+          <p:cNvSpPr txBox="1"/>
+          <p:nvPr/>
+        </p:nvSpPr>
+        <p:spPr>
+          <a:xfrm>
+            <a:off x="2540000" y="5067300"/>
+            <a:ext cx="304800" cy="215900"/>
+          </a:xfrm>
+          <a:prstGeom prst="rect">
+            <a:avLst/>
+          </a:prstGeom>
+          <a:noFill/>
+          <a:ln/>
+        </p:spPr>
+        <p:txBody>
+          <a:bodyPr wrap="square" lIns="0" tIns="0" rIns="0" bIns="0" rtlCol="0" anchor="t"/>
+          <a:lstStyle/>
+          <a:p>
+            <a:pPr algn="l" indent="0" marL="0">
+              <a:lnSpc>
+                <a:spcPct val="115000"/>
+              </a:lnSpc>
+              <a:buNone/>
+            </a:pPr>
+            <a:r>
+              <a:rPr lang="en-US" sz="1200" dirty="0">
+                <a:solidFill>
+                  <a:srgbClr val="6B7280"/>
+                </a:solidFill>
+                <a:latin typeface="Optimist Sans" pitchFamily="34" charset="0"/>
+                <a:ea typeface="Optimist Sans" pitchFamily="34" charset="-122"/>
+                <a:cs typeface="Optimist Sans" pitchFamily="34" charset="-120"/>
+              </a:rPr>
+              <a:t>’26</a:t>
+            </a:r>
+            <a:endParaRPr lang="en-US" sz="1200" dirty="0"/>
+          </a:p>
+        </p:txBody>
+      </p:sp>
+      <p:sp>
+        <p:nvSpPr>
+          <p:cNvPr id="48" name="Text 46"/>
+          <p:cNvSpPr txBox="1"/>
+          <p:nvPr/>
+        </p:nvSpPr>
+        <p:spPr>
+          <a:xfrm>
+            <a:off x="2921000" y="5067300"/>
+            <a:ext cx="939800" cy="215900"/>
+          </a:xfrm>
+          <a:prstGeom prst="rect">
+            <a:avLst/>
+          </a:prstGeom>
+          <a:noFill/>
+          <a:ln/>
+        </p:spPr>
+        <p:txBody>
+          <a:bodyPr wrap="square" lIns="0" tIns="0" rIns="0" bIns="0" rtlCol="0" anchor="t"/>
+          <a:lstStyle/>
+          <a:p>
+            <a:pPr algn="l" indent="0" marL="0">
+              <a:lnSpc>
+                <a:spcPct val="115000"/>
+              </a:lnSpc>
+              <a:buNone/>
+            </a:pPr>
+            <a:r>
+              <a:rPr lang="en-US" sz="1200" b="1" dirty="0">
+                <a:solidFill>
+                  <a:srgbClr val="14213D"/>
+                </a:solidFill>
+                <a:latin typeface="Optimist Sans" pitchFamily="34" charset="0"/>
+                <a:ea typeface="Optimist Sans" pitchFamily="34" charset="-122"/>
+                <a:cs typeface="Optimist Sans" pitchFamily="34" charset="-120"/>
+              </a:rPr>
+              <a:t>[n] </a:t>
+            </a:r>
+            <a:pPr algn="l" indent="0" marL="0">
+              <a:lnSpc>
+                <a:spcPct val="115000"/>
+              </a:lnSpc>
+              <a:buNone/>
+            </a:pPr>
+            <a:r>
+              <a:rPr lang="en-US" sz="1200" dirty="0">
+                <a:solidFill>
+                  <a:srgbClr val="6B7280"/>
+                </a:solidFill>
+                <a:latin typeface="Optimist Sans" pitchFamily="34" charset="0"/>
+                <a:ea typeface="Optimist Sans" pitchFamily="34" charset="-122"/>
+                <a:cs typeface="Optimist Sans" pitchFamily="34" charset="-120"/>
+              </a:rPr>
+              <a:t>([n])</a:t>
+            </a:r>
+            <a:endParaRPr lang="en-US" sz="1200" dirty="0"/>
+          </a:p>
+        </p:txBody>
+      </p:sp>
+      <p:sp>
+        <p:nvSpPr>
+          <p:cNvPr id="49" name="Text 47"/>
+          <p:cNvSpPr txBox="1"/>
+          <p:nvPr/>
+        </p:nvSpPr>
+        <p:spPr>
+          <a:xfrm>
+            <a:off x="2540000" y="5295900"/>
+            <a:ext cx="304800" cy="215900"/>
+          </a:xfrm>
+          <a:prstGeom prst="rect">
+            <a:avLst/>
+          </a:prstGeom>
+          <a:noFill/>
+          <a:ln/>
+        </p:spPr>
+        <p:txBody>
+          <a:bodyPr wrap="square" lIns="0" tIns="0" rIns="0" bIns="0" rtlCol="0" anchor="t"/>
+          <a:lstStyle/>
+          <a:p>
+            <a:pPr algn="l" indent="0" marL="0">
+              <a:lnSpc>
+                <a:spcPct val="115000"/>
+              </a:lnSpc>
+              <a:buNone/>
+            </a:pPr>
+            <a:r>
+              <a:rPr lang="en-US" sz="1200" dirty="0">
+                <a:solidFill>
+                  <a:srgbClr val="6B7280"/>
+                </a:solidFill>
+                <a:latin typeface="Optimist Sans" pitchFamily="34" charset="0"/>
+                <a:ea typeface="Optimist Sans" pitchFamily="34" charset="-122"/>
+                <a:cs typeface="Optimist Sans" pitchFamily="34" charset="-120"/>
+              </a:rPr>
+              <a:t>’27</a:t>
+            </a:r>
+            <a:endParaRPr lang="en-US" sz="1200" dirty="0"/>
+          </a:p>
+        </p:txBody>
+      </p:sp>
+      <p:sp>
+        <p:nvSpPr>
           <p:cNvPr id="50" name="Text 48"/>
           <p:cNvSpPr txBox="1"/>
           <p:nvPr/>
         </p:nvSpPr>
         <p:spPr>
           <a:xfrm>
-            <a:off x="2527300" y="4521200"/>
-            <a:ext cx="1346200" cy="190500"/>
+            <a:off x="2921000" y="5295900"/>
+            <a:ext cx="939800" cy="215900"/>
           </a:xfrm>
           <a:prstGeom prst="rect">
             <a:avLst/>
@@ -8238,7 +8338,7 @@
                 <a:ea typeface="Optimist Sans" pitchFamily="34" charset="-122"/>
                 <a:cs typeface="Optimist Sans" pitchFamily="34" charset="-120"/>
               </a:rPr>
-              <a:t>[n] associates</a:t>
+              <a:t>[n]</a:t>
             </a:r>
             <a:endParaRPr lang="en-US" sz="1200" dirty="0"/>
           </a:p>
@@ -8252,35 +8352,35 @@
         </p:nvSpPr>
         <p:spPr>
           <a:xfrm>
-            <a:off x="2527300" y="4724400"/>
-            <a:ext cx="1346200" cy="406400"/>
-          </a:xfrm>
-          <a:prstGeom prst="rect">
-            <a:avLst/>
-          </a:prstGeom>
-          <a:noFill/>
-          <a:ln/>
-        </p:spPr>
-        <p:txBody>
-          <a:bodyPr wrap="square" lIns="0" tIns="0" rIns="0" bIns="0" rtlCol="0" anchor="t"/>
-          <a:lstStyle/>
-          <a:p>
-            <a:pPr algn="l" indent="0" marL="0">
-              <a:lnSpc>
-                <a:spcPct val="110000"/>
+            <a:off x="2540000" y="5524500"/>
+            <a:ext cx="304800" cy="215900"/>
+          </a:xfrm>
+          <a:prstGeom prst="rect">
+            <a:avLst/>
+          </a:prstGeom>
+          <a:noFill/>
+          <a:ln/>
+        </p:spPr>
+        <p:txBody>
+          <a:bodyPr wrap="square" lIns="0" tIns="0" rIns="0" bIns="0" rtlCol="0" anchor="t"/>
+          <a:lstStyle/>
+          <a:p>
+            <a:pPr algn="l" indent="0" marL="0">
+              <a:lnSpc>
+                <a:spcPct val="115000"/>
               </a:lnSpc>
               <a:buNone/>
             </a:pPr>
             <a:r>
               <a:rPr lang="en-US" sz="1200" dirty="0">
                 <a:solidFill>
-                  <a:srgbClr val="4A5568"/>
-                </a:solidFill>
-                <a:latin typeface="Optimist Sans" pitchFamily="34" charset="0"/>
-                <a:ea typeface="Optimist Sans" pitchFamily="34" charset="-122"/>
-                <a:cs typeface="Optimist Sans" pitchFamily="34" charset="-120"/>
-              </a:rPr>
-              <a:t>[Name], [Name], [Name] + [n] open</a:t>
+                  <a:srgbClr val="6B7280"/>
+                </a:solidFill>
+                <a:latin typeface="Optimist Sans" pitchFamily="34" charset="0"/>
+                <a:ea typeface="Optimist Sans" pitchFamily="34" charset="-122"/>
+                <a:cs typeface="Optimist Sans" pitchFamily="34" charset="-120"/>
+              </a:rPr>
+              <a:t>’28</a:t>
             </a:r>
             <a:endParaRPr lang="en-US" sz="1200" dirty="0"/>
           </a:p>
@@ -8288,53 +8388,33 @@
       </p:sp>
       <p:sp>
         <p:nvSpPr>
-          <p:cNvPr id="52" name="Shape 50"/>
-          <p:cNvSpPr/>
-          <p:nvPr/>
-        </p:nvSpPr>
-        <p:spPr>
-          <a:xfrm>
-            <a:off x="2616200" y="5359400"/>
-            <a:ext cx="254000" cy="215900"/>
-          </a:xfrm>
-          <a:prstGeom prst="rect">
-            <a:avLst/>
-          </a:prstGeom>
-          <a:solidFill>
-            <a:srgbClr val="1F6F7E"/>
-          </a:solidFill>
-          <a:ln/>
-        </p:spPr>
-      </p:sp>
-      <p:sp>
-        <p:nvSpPr>
-          <p:cNvPr id="53" name="Text 51"/>
-          <p:cNvSpPr txBox="1"/>
-          <p:nvPr/>
-        </p:nvSpPr>
-        <p:spPr>
-          <a:xfrm>
-            <a:off x="2540000" y="5181600"/>
-            <a:ext cx="406400" cy="165100"/>
-          </a:xfrm>
-          <a:prstGeom prst="rect">
-            <a:avLst/>
-          </a:prstGeom>
-          <a:noFill/>
-          <a:ln/>
-        </p:spPr>
-        <p:txBody>
-          <a:bodyPr wrap="square" lIns="0" tIns="0" rIns="0" bIns="0" rtlCol="0" anchor="t"/>
-          <a:lstStyle/>
-          <a:p>
-            <a:pPr algn="ctr" indent="0" marL="0">
-              <a:lnSpc>
-                <a:spcPct val="100000"/>
-              </a:lnSpc>
-              <a:buNone/>
-            </a:pPr>
-            <a:r>
-              <a:rPr lang="en-US" sz="1200" dirty="0">
+          <p:cNvPr id="52" name="Text 50"/>
+          <p:cNvSpPr txBox="1"/>
+          <p:nvPr/>
+        </p:nvSpPr>
+        <p:spPr>
+          <a:xfrm>
+            <a:off x="2921000" y="5524500"/>
+            <a:ext cx="939800" cy="215900"/>
+          </a:xfrm>
+          <a:prstGeom prst="rect">
+            <a:avLst/>
+          </a:prstGeom>
+          <a:noFill/>
+          <a:ln/>
+        </p:spPr>
+        <p:txBody>
+          <a:bodyPr wrap="square" lIns="0" tIns="0" rIns="0" bIns="0" rtlCol="0" anchor="t"/>
+          <a:lstStyle/>
+          <a:p>
+            <a:pPr algn="l" indent="0" marL="0">
+              <a:lnSpc>
+                <a:spcPct val="115000"/>
+              </a:lnSpc>
+              <a:buNone/>
+            </a:pPr>
+            <a:r>
+              <a:rPr lang="en-US" sz="1200" b="1" dirty="0">
                 <a:solidFill>
                   <a:srgbClr val="14213D"/>
                 </a:solidFill>
@@ -8350,257 +8430,7 @@
       </p:sp>
       <p:sp>
         <p:nvSpPr>
-          <p:cNvPr id="54" name="Text 52"/>
-          <p:cNvSpPr txBox="1"/>
-          <p:nvPr/>
-        </p:nvSpPr>
-        <p:spPr>
-          <a:xfrm>
-            <a:off x="2540000" y="5588000"/>
-            <a:ext cx="406400" cy="165100"/>
-          </a:xfrm>
-          <a:prstGeom prst="rect">
-            <a:avLst/>
-          </a:prstGeom>
-          <a:noFill/>
-          <a:ln/>
-        </p:spPr>
-        <p:txBody>
-          <a:bodyPr wrap="square" lIns="0" tIns="0" rIns="0" bIns="0" rtlCol="0" anchor="t"/>
-          <a:lstStyle/>
-          <a:p>
-            <a:pPr algn="ctr" indent="0" marL="0">
-              <a:lnSpc>
-                <a:spcPct val="100000"/>
-              </a:lnSpc>
-              <a:buNone/>
-            </a:pPr>
-            <a:r>
-              <a:rPr lang="en-US" sz="1200" dirty="0">
-                <a:solidFill>
-                  <a:srgbClr val="6B7280"/>
-                </a:solidFill>
-                <a:latin typeface="Optimist Sans" pitchFamily="34" charset="0"/>
-                <a:ea typeface="Optimist Sans" pitchFamily="34" charset="-122"/>
-                <a:cs typeface="Optimist Sans" pitchFamily="34" charset="-120"/>
-              </a:rPr>
-              <a:t>’26</a:t>
-            </a:r>
-            <a:endParaRPr lang="en-US" sz="1200" dirty="0"/>
-          </a:p>
-        </p:txBody>
-      </p:sp>
-      <p:sp>
-        <p:nvSpPr>
-          <p:cNvPr id="55" name="Shape 53"/>
-          <p:cNvSpPr/>
-          <p:nvPr/>
-        </p:nvSpPr>
-        <p:spPr>
-          <a:xfrm>
-            <a:off x="3073400" y="5410200"/>
-            <a:ext cx="254000" cy="165100"/>
-          </a:xfrm>
-          <a:prstGeom prst="rect">
-            <a:avLst/>
-          </a:prstGeom>
-          <a:solidFill>
-            <a:srgbClr val="1F6F7E"/>
-          </a:solidFill>
-          <a:ln/>
-        </p:spPr>
-      </p:sp>
-      <p:sp>
-        <p:nvSpPr>
-          <p:cNvPr id="56" name="Text 54"/>
-          <p:cNvSpPr txBox="1"/>
-          <p:nvPr/>
-        </p:nvSpPr>
-        <p:spPr>
-          <a:xfrm>
-            <a:off x="2997200" y="5232400"/>
-            <a:ext cx="406400" cy="165100"/>
-          </a:xfrm>
-          <a:prstGeom prst="rect">
-            <a:avLst/>
-          </a:prstGeom>
-          <a:noFill/>
-          <a:ln/>
-        </p:spPr>
-        <p:txBody>
-          <a:bodyPr wrap="square" lIns="0" tIns="0" rIns="0" bIns="0" rtlCol="0" anchor="t"/>
-          <a:lstStyle/>
-          <a:p>
-            <a:pPr algn="ctr" indent="0" marL="0">
-              <a:lnSpc>
-                <a:spcPct val="100000"/>
-              </a:lnSpc>
-              <a:buNone/>
-            </a:pPr>
-            <a:r>
-              <a:rPr lang="en-US" sz="1200" dirty="0">
-                <a:solidFill>
-                  <a:srgbClr val="14213D"/>
-                </a:solidFill>
-                <a:latin typeface="Optimist Sans" pitchFamily="34" charset="0"/>
-                <a:ea typeface="Optimist Sans" pitchFamily="34" charset="-122"/>
-                <a:cs typeface="Optimist Sans" pitchFamily="34" charset="-120"/>
-              </a:rPr>
-              <a:t>[n]</a:t>
-            </a:r>
-            <a:endParaRPr lang="en-US" sz="1200" dirty="0"/>
-          </a:p>
-        </p:txBody>
-      </p:sp>
-      <p:sp>
-        <p:nvSpPr>
-          <p:cNvPr id="57" name="Text 55"/>
-          <p:cNvSpPr txBox="1"/>
-          <p:nvPr/>
-        </p:nvSpPr>
-        <p:spPr>
-          <a:xfrm>
-            <a:off x="2997200" y="5588000"/>
-            <a:ext cx="406400" cy="165100"/>
-          </a:xfrm>
-          <a:prstGeom prst="rect">
-            <a:avLst/>
-          </a:prstGeom>
-          <a:noFill/>
-          <a:ln/>
-        </p:spPr>
-        <p:txBody>
-          <a:bodyPr wrap="square" lIns="0" tIns="0" rIns="0" bIns="0" rtlCol="0" anchor="t"/>
-          <a:lstStyle/>
-          <a:p>
-            <a:pPr algn="ctr" indent="0" marL="0">
-              <a:lnSpc>
-                <a:spcPct val="100000"/>
-              </a:lnSpc>
-              <a:buNone/>
-            </a:pPr>
-            <a:r>
-              <a:rPr lang="en-US" sz="1200" dirty="0">
-                <a:solidFill>
-                  <a:srgbClr val="6B7280"/>
-                </a:solidFill>
-                <a:latin typeface="Optimist Sans" pitchFamily="34" charset="0"/>
-                <a:ea typeface="Optimist Sans" pitchFamily="34" charset="-122"/>
-                <a:cs typeface="Optimist Sans" pitchFamily="34" charset="-120"/>
-              </a:rPr>
-              <a:t>’27</a:t>
-            </a:r>
-            <a:endParaRPr lang="en-US" sz="1200" dirty="0"/>
-          </a:p>
-        </p:txBody>
-      </p:sp>
-      <p:sp>
-        <p:nvSpPr>
-          <p:cNvPr id="58" name="Shape 56"/>
-          <p:cNvSpPr/>
-          <p:nvPr/>
-        </p:nvSpPr>
-        <p:spPr>
-          <a:xfrm>
-            <a:off x="3530600" y="5461000"/>
-            <a:ext cx="254000" cy="114300"/>
-          </a:xfrm>
-          <a:prstGeom prst="rect">
-            <a:avLst/>
-          </a:prstGeom>
-          <a:solidFill>
-            <a:srgbClr val="1F6F7E"/>
-          </a:solidFill>
-          <a:ln/>
-        </p:spPr>
-      </p:sp>
-      <p:sp>
-        <p:nvSpPr>
-          <p:cNvPr id="59" name="Text 57"/>
-          <p:cNvSpPr txBox="1"/>
-          <p:nvPr/>
-        </p:nvSpPr>
-        <p:spPr>
-          <a:xfrm>
-            <a:off x="3454400" y="5283200"/>
-            <a:ext cx="406400" cy="165100"/>
-          </a:xfrm>
-          <a:prstGeom prst="rect">
-            <a:avLst/>
-          </a:prstGeom>
-          <a:noFill/>
-          <a:ln/>
-        </p:spPr>
-        <p:txBody>
-          <a:bodyPr wrap="square" lIns="0" tIns="0" rIns="0" bIns="0" rtlCol="0" anchor="t"/>
-          <a:lstStyle/>
-          <a:p>
-            <a:pPr algn="ctr" indent="0" marL="0">
-              <a:lnSpc>
-                <a:spcPct val="100000"/>
-              </a:lnSpc>
-              <a:buNone/>
-            </a:pPr>
-            <a:r>
-              <a:rPr lang="en-US" sz="1200" dirty="0">
-                <a:solidFill>
-                  <a:srgbClr val="14213D"/>
-                </a:solidFill>
-                <a:latin typeface="Optimist Sans" pitchFamily="34" charset="0"/>
-                <a:ea typeface="Optimist Sans" pitchFamily="34" charset="-122"/>
-                <a:cs typeface="Optimist Sans" pitchFamily="34" charset="-120"/>
-              </a:rPr>
-              <a:t>[n]</a:t>
-            </a:r>
-            <a:endParaRPr lang="en-US" sz="1200" dirty="0"/>
-          </a:p>
-        </p:txBody>
-      </p:sp>
-      <p:sp>
-        <p:nvSpPr>
-          <p:cNvPr id="60" name="Text 58"/>
-          <p:cNvSpPr txBox="1"/>
-          <p:nvPr/>
-        </p:nvSpPr>
-        <p:spPr>
-          <a:xfrm>
-            <a:off x="3454400" y="5588000"/>
-            <a:ext cx="406400" cy="165100"/>
-          </a:xfrm>
-          <a:prstGeom prst="rect">
-            <a:avLst/>
-          </a:prstGeom>
-          <a:noFill/>
-          <a:ln/>
-        </p:spPr>
-        <p:txBody>
-          <a:bodyPr wrap="square" lIns="0" tIns="0" rIns="0" bIns="0" rtlCol="0" anchor="t"/>
-          <a:lstStyle/>
-          <a:p>
-            <a:pPr algn="ctr" indent="0" marL="0">
-              <a:lnSpc>
-                <a:spcPct val="100000"/>
-              </a:lnSpc>
-              <a:buNone/>
-            </a:pPr>
-            <a:r>
-              <a:rPr lang="en-US" sz="1200" dirty="0">
-                <a:solidFill>
-                  <a:srgbClr val="6B7280"/>
-                </a:solidFill>
-                <a:latin typeface="Optimist Sans" pitchFamily="34" charset="0"/>
-                <a:ea typeface="Optimist Sans" pitchFamily="34" charset="-122"/>
-                <a:cs typeface="Optimist Sans" pitchFamily="34" charset="-120"/>
-              </a:rPr>
-              <a:t>’28</a:t>
-            </a:r>
-            <a:endParaRPr lang="en-US" sz="1200" dirty="0"/>
-          </a:p>
-        </p:txBody>
-      </p:sp>
-      <p:sp>
-        <p:nvSpPr>
-          <p:cNvPr id="61" name="Shape 59"/>
+          <p:cNvPr id="53" name="Shape 51"/>
           <p:cNvSpPr/>
           <p:nvPr/>
         </p:nvSpPr>
@@ -8627,14 +8457,98 @@
       </p:sp>
       <p:sp>
         <p:nvSpPr>
-          <p:cNvPr id="62" name="Text 60"/>
-          <p:cNvSpPr txBox="1"/>
-          <p:nvPr/>
-        </p:nvSpPr>
-        <p:spPr>
-          <a:xfrm>
-            <a:off x="4152900" y="4521200"/>
-            <a:ext cx="1346200" cy="190500"/>
+          <p:cNvPr id="54" name="Text 52"/>
+          <p:cNvSpPr txBox="1"/>
+          <p:nvPr/>
+        </p:nvSpPr>
+        <p:spPr>
+          <a:xfrm>
+            <a:off x="4165600" y="4521200"/>
+            <a:ext cx="1320800" cy="406400"/>
+          </a:xfrm>
+          <a:prstGeom prst="rect">
+            <a:avLst/>
+          </a:prstGeom>
+          <a:noFill/>
+          <a:ln/>
+        </p:spPr>
+        <p:txBody>
+          <a:bodyPr wrap="square" lIns="0" tIns="0" rIns="0" bIns="0" rtlCol="0" anchor="t"/>
+          <a:lstStyle/>
+          <a:p>
+            <a:pPr algn="l" indent="0" marL="0">
+              <a:lnSpc>
+                <a:spcPct val="115000"/>
+              </a:lnSpc>
+              <a:buNone/>
+            </a:pPr>
+            <a:r>
+              <a:rPr lang="en-US" sz="1200" dirty="0">
+                <a:solidFill>
+                  <a:srgbClr val="4A5568"/>
+                </a:solidFill>
+                <a:latin typeface="Optimist Sans" pitchFamily="34" charset="0"/>
+                <a:ea typeface="Optimist Sans" pitchFamily="34" charset="-122"/>
+                <a:cs typeface="Optimist Sans" pitchFamily="34" charset="-120"/>
+              </a:rPr>
+              <a:t>[Name], [Name], [Name], …</a:t>
+            </a:r>
+            <a:endParaRPr lang="en-US" sz="1200" dirty="0"/>
+          </a:p>
+        </p:txBody>
+      </p:sp>
+      <p:sp>
+        <p:nvSpPr>
+          <p:cNvPr id="55" name="Text 53"/>
+          <p:cNvSpPr txBox="1"/>
+          <p:nvPr/>
+        </p:nvSpPr>
+        <p:spPr>
+          <a:xfrm>
+            <a:off x="4165600" y="5067300"/>
+            <a:ext cx="304800" cy="215900"/>
+          </a:xfrm>
+          <a:prstGeom prst="rect">
+            <a:avLst/>
+          </a:prstGeom>
+          <a:noFill/>
+          <a:ln/>
+        </p:spPr>
+        <p:txBody>
+          <a:bodyPr wrap="square" lIns="0" tIns="0" rIns="0" bIns="0" rtlCol="0" anchor="t"/>
+          <a:lstStyle/>
+          <a:p>
+            <a:pPr algn="l" indent="0" marL="0">
+              <a:lnSpc>
+                <a:spcPct val="115000"/>
+              </a:lnSpc>
+              <a:buNone/>
+            </a:pPr>
+            <a:r>
+              <a:rPr lang="en-US" sz="1200" dirty="0">
+                <a:solidFill>
+                  <a:srgbClr val="6B7280"/>
+                </a:solidFill>
+                <a:latin typeface="Optimist Sans" pitchFamily="34" charset="0"/>
+                <a:ea typeface="Optimist Sans" pitchFamily="34" charset="-122"/>
+                <a:cs typeface="Optimist Sans" pitchFamily="34" charset="-120"/>
+              </a:rPr>
+              <a:t>’26</a:t>
+            </a:r>
+            <a:endParaRPr lang="en-US" sz="1200" dirty="0"/>
+          </a:p>
+        </p:txBody>
+      </p:sp>
+      <p:sp>
+        <p:nvSpPr>
+          <p:cNvPr id="56" name="Text 54"/>
+          <p:cNvSpPr txBox="1"/>
+          <p:nvPr/>
+        </p:nvSpPr>
+        <p:spPr>
+          <a:xfrm>
+            <a:off x="4546600" y="5067300"/>
+            <a:ext cx="939800" cy="215900"/>
           </a:xfrm>
           <a:prstGeom prst="rect">
             <a:avLst/>
@@ -8661,7 +8575,24 @@
                 <a:ea typeface="Optimist Sans" pitchFamily="34" charset="-122"/>
                 <a:cs typeface="Optimist Sans" pitchFamily="34" charset="-120"/>
               </a:rPr>
-              <a:t>[n] associates</a:t>
+              <a:t>[n] </a:t>
+            </a:r>
+            <a:pPr algn="l" indent="0" marL="0">
+              <a:lnSpc>
+                <a:spcPct val="115000"/>
+              </a:lnSpc>
+              <a:buNone/>
+            </a:pPr>
+            <a:r>
+              <a:rPr lang="en-US" sz="1200" dirty="0">
+                <a:solidFill>
+                  <a:srgbClr val="6B7280"/>
+                </a:solidFill>
+                <a:latin typeface="Optimist Sans" pitchFamily="34" charset="0"/>
+                <a:ea typeface="Optimist Sans" pitchFamily="34" charset="-122"/>
+                <a:cs typeface="Optimist Sans" pitchFamily="34" charset="-120"/>
+              </a:rPr>
+              <a:t>([n])</a:t>
             </a:r>
             <a:endParaRPr lang="en-US" sz="1200" dirty="0"/>
           </a:p>
@@ -8669,41 +8600,41 @@
       </p:sp>
       <p:sp>
         <p:nvSpPr>
-          <p:cNvPr id="63" name="Text 61"/>
-          <p:cNvSpPr txBox="1"/>
-          <p:nvPr/>
-        </p:nvSpPr>
-        <p:spPr>
-          <a:xfrm>
-            <a:off x="4152900" y="4724400"/>
-            <a:ext cx="1346200" cy="406400"/>
-          </a:xfrm>
-          <a:prstGeom prst="rect">
-            <a:avLst/>
-          </a:prstGeom>
-          <a:noFill/>
-          <a:ln/>
-        </p:spPr>
-        <p:txBody>
-          <a:bodyPr wrap="square" lIns="0" tIns="0" rIns="0" bIns="0" rtlCol="0" anchor="t"/>
-          <a:lstStyle/>
-          <a:p>
-            <a:pPr algn="l" indent="0" marL="0">
-              <a:lnSpc>
-                <a:spcPct val="110000"/>
+          <p:cNvPr id="57" name="Text 55"/>
+          <p:cNvSpPr txBox="1"/>
+          <p:nvPr/>
+        </p:nvSpPr>
+        <p:spPr>
+          <a:xfrm>
+            <a:off x="4165600" y="5295900"/>
+            <a:ext cx="304800" cy="215900"/>
+          </a:xfrm>
+          <a:prstGeom prst="rect">
+            <a:avLst/>
+          </a:prstGeom>
+          <a:noFill/>
+          <a:ln/>
+        </p:spPr>
+        <p:txBody>
+          <a:bodyPr wrap="square" lIns="0" tIns="0" rIns="0" bIns="0" rtlCol="0" anchor="t"/>
+          <a:lstStyle/>
+          <a:p>
+            <a:pPr algn="l" indent="0" marL="0">
+              <a:lnSpc>
+                <a:spcPct val="115000"/>
               </a:lnSpc>
               <a:buNone/>
             </a:pPr>
             <a:r>
               <a:rPr lang="en-US" sz="1200" dirty="0">
                 <a:solidFill>
-                  <a:srgbClr val="4A5568"/>
-                </a:solidFill>
-                <a:latin typeface="Optimist Sans" pitchFamily="34" charset="0"/>
-                <a:ea typeface="Optimist Sans" pitchFamily="34" charset="-122"/>
-                <a:cs typeface="Optimist Sans" pitchFamily="34" charset="-120"/>
-              </a:rPr>
-              <a:t>[Name], [Name], [Name] + [n] open</a:t>
+                  <a:srgbClr val="6B7280"/>
+                </a:solidFill>
+                <a:latin typeface="Optimist Sans" pitchFamily="34" charset="0"/>
+                <a:ea typeface="Optimist Sans" pitchFamily="34" charset="-122"/>
+                <a:cs typeface="Optimist Sans" pitchFamily="34" charset="-120"/>
+              </a:rPr>
+              <a:t>’27</a:t>
             </a:r>
             <a:endParaRPr lang="en-US" sz="1200" dirty="0"/>
           </a:p>
@@ -8711,54 +8642,118 @@
       </p:sp>
       <p:sp>
         <p:nvSpPr>
-          <p:cNvPr id="64" name="Shape 62"/>
-          <p:cNvSpPr/>
-          <p:nvPr/>
-        </p:nvSpPr>
-        <p:spPr>
-          <a:xfrm>
-            <a:off x="4241800" y="5359400"/>
-            <a:ext cx="254000" cy="215900"/>
-          </a:xfrm>
-          <a:prstGeom prst="rect">
-            <a:avLst/>
-          </a:prstGeom>
-          <a:solidFill>
-            <a:srgbClr val="1F6F7E"/>
-          </a:solidFill>
-          <a:ln/>
-        </p:spPr>
-      </p:sp>
-      <p:sp>
-        <p:nvSpPr>
-          <p:cNvPr id="65" name="Text 63"/>
-          <p:cNvSpPr txBox="1"/>
-          <p:nvPr/>
-        </p:nvSpPr>
-        <p:spPr>
-          <a:xfrm>
-            <a:off x="4165600" y="5181600"/>
-            <a:ext cx="406400" cy="165100"/>
-          </a:xfrm>
-          <a:prstGeom prst="rect">
-            <a:avLst/>
-          </a:prstGeom>
-          <a:noFill/>
-          <a:ln/>
-        </p:spPr>
-        <p:txBody>
-          <a:bodyPr wrap="square" lIns="0" tIns="0" rIns="0" bIns="0" rtlCol="0" anchor="t"/>
-          <a:lstStyle/>
-          <a:p>
-            <a:pPr algn="ctr" indent="0" marL="0">
-              <a:lnSpc>
-                <a:spcPct val="100000"/>
+          <p:cNvPr id="58" name="Text 56"/>
+          <p:cNvSpPr txBox="1"/>
+          <p:nvPr/>
+        </p:nvSpPr>
+        <p:spPr>
+          <a:xfrm>
+            <a:off x="4546600" y="5295900"/>
+            <a:ext cx="939800" cy="215900"/>
+          </a:xfrm>
+          <a:prstGeom prst="rect">
+            <a:avLst/>
+          </a:prstGeom>
+          <a:noFill/>
+          <a:ln/>
+        </p:spPr>
+        <p:txBody>
+          <a:bodyPr wrap="square" lIns="0" tIns="0" rIns="0" bIns="0" rtlCol="0" anchor="t"/>
+          <a:lstStyle/>
+          <a:p>
+            <a:pPr algn="l" indent="0" marL="0">
+              <a:lnSpc>
+                <a:spcPct val="115000"/>
+              </a:lnSpc>
+              <a:buNone/>
+            </a:pPr>
+            <a:r>
+              <a:rPr lang="en-US" sz="1200" b="1" dirty="0">
+                <a:solidFill>
+                  <a:srgbClr val="14213D"/>
+                </a:solidFill>
+                <a:latin typeface="Optimist Sans" pitchFamily="34" charset="0"/>
+                <a:ea typeface="Optimist Sans" pitchFamily="34" charset="-122"/>
+                <a:cs typeface="Optimist Sans" pitchFamily="34" charset="-120"/>
+              </a:rPr>
+              <a:t>[n]</a:t>
+            </a:r>
+            <a:endParaRPr lang="en-US" sz="1200" dirty="0"/>
+          </a:p>
+        </p:txBody>
+      </p:sp>
+      <p:sp>
+        <p:nvSpPr>
+          <p:cNvPr id="59" name="Text 57"/>
+          <p:cNvSpPr txBox="1"/>
+          <p:nvPr/>
+        </p:nvSpPr>
+        <p:spPr>
+          <a:xfrm>
+            <a:off x="4165600" y="5524500"/>
+            <a:ext cx="304800" cy="215900"/>
+          </a:xfrm>
+          <a:prstGeom prst="rect">
+            <a:avLst/>
+          </a:prstGeom>
+          <a:noFill/>
+          <a:ln/>
+        </p:spPr>
+        <p:txBody>
+          <a:bodyPr wrap="square" lIns="0" tIns="0" rIns="0" bIns="0" rtlCol="0" anchor="t"/>
+          <a:lstStyle/>
+          <a:p>
+            <a:pPr algn="l" indent="0" marL="0">
+              <a:lnSpc>
+                <a:spcPct val="115000"/>
               </a:lnSpc>
               <a:buNone/>
             </a:pPr>
             <a:r>
               <a:rPr lang="en-US" sz="1200" dirty="0">
                 <a:solidFill>
+                  <a:srgbClr val="6B7280"/>
+                </a:solidFill>
+                <a:latin typeface="Optimist Sans" pitchFamily="34" charset="0"/>
+                <a:ea typeface="Optimist Sans" pitchFamily="34" charset="-122"/>
+                <a:cs typeface="Optimist Sans" pitchFamily="34" charset="-120"/>
+              </a:rPr>
+              <a:t>’28</a:t>
+            </a:r>
+            <a:endParaRPr lang="en-US" sz="1200" dirty="0"/>
+          </a:p>
+        </p:txBody>
+      </p:sp>
+      <p:sp>
+        <p:nvSpPr>
+          <p:cNvPr id="60" name="Text 58"/>
+          <p:cNvSpPr txBox="1"/>
+          <p:nvPr/>
+        </p:nvSpPr>
+        <p:spPr>
+          <a:xfrm>
+            <a:off x="4546600" y="5524500"/>
+            <a:ext cx="939800" cy="215900"/>
+          </a:xfrm>
+          <a:prstGeom prst="rect">
+            <a:avLst/>
+          </a:prstGeom>
+          <a:noFill/>
+          <a:ln/>
+        </p:spPr>
+        <p:txBody>
+          <a:bodyPr wrap="square" lIns="0" tIns="0" rIns="0" bIns="0" rtlCol="0" anchor="t"/>
+          <a:lstStyle/>
+          <a:p>
+            <a:pPr algn="l" indent="0" marL="0">
+              <a:lnSpc>
+                <a:spcPct val="115000"/>
+              </a:lnSpc>
+              <a:buNone/>
+            </a:pPr>
+            <a:r>
+              <a:rPr lang="en-US" sz="1200" b="1" dirty="0">
+                <a:solidFill>
                   <a:srgbClr val="14213D"/>
                 </a:solidFill>
                 <a:latin typeface="Optimist Sans" pitchFamily="34" charset="0"/>
@@ -8773,257 +8768,7 @@
       </p:sp>
       <p:sp>
         <p:nvSpPr>
-          <p:cNvPr id="66" name="Text 64"/>
-          <p:cNvSpPr txBox="1"/>
-          <p:nvPr/>
-        </p:nvSpPr>
-        <p:spPr>
-          <a:xfrm>
-            <a:off x="4165600" y="5588000"/>
-            <a:ext cx="406400" cy="165100"/>
-          </a:xfrm>
-          <a:prstGeom prst="rect">
-            <a:avLst/>
-          </a:prstGeom>
-          <a:noFill/>
-          <a:ln/>
-        </p:spPr>
-        <p:txBody>
-          <a:bodyPr wrap="square" lIns="0" tIns="0" rIns="0" bIns="0" rtlCol="0" anchor="t"/>
-          <a:lstStyle/>
-          <a:p>
-            <a:pPr algn="ctr" indent="0" marL="0">
-              <a:lnSpc>
-                <a:spcPct val="100000"/>
-              </a:lnSpc>
-              <a:buNone/>
-            </a:pPr>
-            <a:r>
-              <a:rPr lang="en-US" sz="1200" dirty="0">
-                <a:solidFill>
-                  <a:srgbClr val="6B7280"/>
-                </a:solidFill>
-                <a:latin typeface="Optimist Sans" pitchFamily="34" charset="0"/>
-                <a:ea typeface="Optimist Sans" pitchFamily="34" charset="-122"/>
-                <a:cs typeface="Optimist Sans" pitchFamily="34" charset="-120"/>
-              </a:rPr>
-              <a:t>’26</a:t>
-            </a:r>
-            <a:endParaRPr lang="en-US" sz="1200" dirty="0"/>
-          </a:p>
-        </p:txBody>
-      </p:sp>
-      <p:sp>
-        <p:nvSpPr>
-          <p:cNvPr id="67" name="Shape 65"/>
-          <p:cNvSpPr/>
-          <p:nvPr/>
-        </p:nvSpPr>
-        <p:spPr>
-          <a:xfrm>
-            <a:off x="4699000" y="5410200"/>
-            <a:ext cx="254000" cy="165100"/>
-          </a:xfrm>
-          <a:prstGeom prst="rect">
-            <a:avLst/>
-          </a:prstGeom>
-          <a:solidFill>
-            <a:srgbClr val="1F6F7E"/>
-          </a:solidFill>
-          <a:ln/>
-        </p:spPr>
-      </p:sp>
-      <p:sp>
-        <p:nvSpPr>
-          <p:cNvPr id="68" name="Text 66"/>
-          <p:cNvSpPr txBox="1"/>
-          <p:nvPr/>
-        </p:nvSpPr>
-        <p:spPr>
-          <a:xfrm>
-            <a:off x="4622800" y="5232400"/>
-            <a:ext cx="406400" cy="165100"/>
-          </a:xfrm>
-          <a:prstGeom prst="rect">
-            <a:avLst/>
-          </a:prstGeom>
-          <a:noFill/>
-          <a:ln/>
-        </p:spPr>
-        <p:txBody>
-          <a:bodyPr wrap="square" lIns="0" tIns="0" rIns="0" bIns="0" rtlCol="0" anchor="t"/>
-          <a:lstStyle/>
-          <a:p>
-            <a:pPr algn="ctr" indent="0" marL="0">
-              <a:lnSpc>
-                <a:spcPct val="100000"/>
-              </a:lnSpc>
-              <a:buNone/>
-            </a:pPr>
-            <a:r>
-              <a:rPr lang="en-US" sz="1200" dirty="0">
-                <a:solidFill>
-                  <a:srgbClr val="14213D"/>
-                </a:solidFill>
-                <a:latin typeface="Optimist Sans" pitchFamily="34" charset="0"/>
-                <a:ea typeface="Optimist Sans" pitchFamily="34" charset="-122"/>
-                <a:cs typeface="Optimist Sans" pitchFamily="34" charset="-120"/>
-              </a:rPr>
-              <a:t>[n]</a:t>
-            </a:r>
-            <a:endParaRPr lang="en-US" sz="1200" dirty="0"/>
-          </a:p>
-        </p:txBody>
-      </p:sp>
-      <p:sp>
-        <p:nvSpPr>
-          <p:cNvPr id="69" name="Text 67"/>
-          <p:cNvSpPr txBox="1"/>
-          <p:nvPr/>
-        </p:nvSpPr>
-        <p:spPr>
-          <a:xfrm>
-            <a:off x="4622800" y="5588000"/>
-            <a:ext cx="406400" cy="165100"/>
-          </a:xfrm>
-          <a:prstGeom prst="rect">
-            <a:avLst/>
-          </a:prstGeom>
-          <a:noFill/>
-          <a:ln/>
-        </p:spPr>
-        <p:txBody>
-          <a:bodyPr wrap="square" lIns="0" tIns="0" rIns="0" bIns="0" rtlCol="0" anchor="t"/>
-          <a:lstStyle/>
-          <a:p>
-            <a:pPr algn="ctr" indent="0" marL="0">
-              <a:lnSpc>
-                <a:spcPct val="100000"/>
-              </a:lnSpc>
-              <a:buNone/>
-            </a:pPr>
-            <a:r>
-              <a:rPr lang="en-US" sz="1200" dirty="0">
-                <a:solidFill>
-                  <a:srgbClr val="6B7280"/>
-                </a:solidFill>
-                <a:latin typeface="Optimist Sans" pitchFamily="34" charset="0"/>
-                <a:ea typeface="Optimist Sans" pitchFamily="34" charset="-122"/>
-                <a:cs typeface="Optimist Sans" pitchFamily="34" charset="-120"/>
-              </a:rPr>
-              <a:t>’27</a:t>
-            </a:r>
-            <a:endParaRPr lang="en-US" sz="1200" dirty="0"/>
-          </a:p>
-        </p:txBody>
-      </p:sp>
-      <p:sp>
-        <p:nvSpPr>
-          <p:cNvPr id="70" name="Shape 68"/>
-          <p:cNvSpPr/>
-          <p:nvPr/>
-        </p:nvSpPr>
-        <p:spPr>
-          <a:xfrm>
-            <a:off x="5156200" y="5461000"/>
-            <a:ext cx="254000" cy="114300"/>
-          </a:xfrm>
-          <a:prstGeom prst="rect">
-            <a:avLst/>
-          </a:prstGeom>
-          <a:solidFill>
-            <a:srgbClr val="1F6F7E"/>
-          </a:solidFill>
-          <a:ln/>
-        </p:spPr>
-      </p:sp>
-      <p:sp>
-        <p:nvSpPr>
-          <p:cNvPr id="71" name="Text 69"/>
-          <p:cNvSpPr txBox="1"/>
-          <p:nvPr/>
-        </p:nvSpPr>
-        <p:spPr>
-          <a:xfrm>
-            <a:off x="5080000" y="5283200"/>
-            <a:ext cx="406400" cy="165100"/>
-          </a:xfrm>
-          <a:prstGeom prst="rect">
-            <a:avLst/>
-          </a:prstGeom>
-          <a:noFill/>
-          <a:ln/>
-        </p:spPr>
-        <p:txBody>
-          <a:bodyPr wrap="square" lIns="0" tIns="0" rIns="0" bIns="0" rtlCol="0" anchor="t"/>
-          <a:lstStyle/>
-          <a:p>
-            <a:pPr algn="ctr" indent="0" marL="0">
-              <a:lnSpc>
-                <a:spcPct val="100000"/>
-              </a:lnSpc>
-              <a:buNone/>
-            </a:pPr>
-            <a:r>
-              <a:rPr lang="en-US" sz="1200" dirty="0">
-                <a:solidFill>
-                  <a:srgbClr val="14213D"/>
-                </a:solidFill>
-                <a:latin typeface="Optimist Sans" pitchFamily="34" charset="0"/>
-                <a:ea typeface="Optimist Sans" pitchFamily="34" charset="-122"/>
-                <a:cs typeface="Optimist Sans" pitchFamily="34" charset="-120"/>
-              </a:rPr>
-              <a:t>[n]</a:t>
-            </a:r>
-            <a:endParaRPr lang="en-US" sz="1200" dirty="0"/>
-          </a:p>
-        </p:txBody>
-      </p:sp>
-      <p:sp>
-        <p:nvSpPr>
-          <p:cNvPr id="72" name="Text 70"/>
-          <p:cNvSpPr txBox="1"/>
-          <p:nvPr/>
-        </p:nvSpPr>
-        <p:spPr>
-          <a:xfrm>
-            <a:off x="5080000" y="5588000"/>
-            <a:ext cx="406400" cy="165100"/>
-          </a:xfrm>
-          <a:prstGeom prst="rect">
-            <a:avLst/>
-          </a:prstGeom>
-          <a:noFill/>
-          <a:ln/>
-        </p:spPr>
-        <p:txBody>
-          <a:bodyPr wrap="square" lIns="0" tIns="0" rIns="0" bIns="0" rtlCol="0" anchor="t"/>
-          <a:lstStyle/>
-          <a:p>
-            <a:pPr algn="ctr" indent="0" marL="0">
-              <a:lnSpc>
-                <a:spcPct val="100000"/>
-              </a:lnSpc>
-              <a:buNone/>
-            </a:pPr>
-            <a:r>
-              <a:rPr lang="en-US" sz="1200" dirty="0">
-                <a:solidFill>
-                  <a:srgbClr val="6B7280"/>
-                </a:solidFill>
-                <a:latin typeface="Optimist Sans" pitchFamily="34" charset="0"/>
-                <a:ea typeface="Optimist Sans" pitchFamily="34" charset="-122"/>
-                <a:cs typeface="Optimist Sans" pitchFamily="34" charset="-120"/>
-              </a:rPr>
-              <a:t>’28</a:t>
-            </a:r>
-            <a:endParaRPr lang="en-US" sz="1200" dirty="0"/>
-          </a:p>
-        </p:txBody>
-      </p:sp>
-      <p:sp>
-        <p:nvSpPr>
-          <p:cNvPr id="73" name="Shape 71"/>
+          <p:cNvPr id="61" name="Shape 59"/>
           <p:cNvSpPr/>
           <p:nvPr/>
         </p:nvSpPr>
@@ -9050,14 +8795,98 @@
       </p:sp>
       <p:sp>
         <p:nvSpPr>
-          <p:cNvPr id="74" name="Text 72"/>
-          <p:cNvSpPr txBox="1"/>
-          <p:nvPr/>
-        </p:nvSpPr>
-        <p:spPr>
-          <a:xfrm>
-            <a:off x="5829300" y="3911600"/>
-            <a:ext cx="1600200" cy="190500"/>
+          <p:cNvPr id="62" name="Text 60"/>
+          <p:cNvSpPr txBox="1"/>
+          <p:nvPr/>
+        </p:nvSpPr>
+        <p:spPr>
+          <a:xfrm>
+            <a:off x="5842000" y="3911600"/>
+            <a:ext cx="1574800" cy="406400"/>
+          </a:xfrm>
+          <a:prstGeom prst="rect">
+            <a:avLst/>
+          </a:prstGeom>
+          <a:noFill/>
+          <a:ln/>
+        </p:spPr>
+        <p:txBody>
+          <a:bodyPr wrap="square" lIns="0" tIns="0" rIns="0" bIns="0" rtlCol="0" anchor="t"/>
+          <a:lstStyle/>
+          <a:p>
+            <a:pPr algn="l" indent="0" marL="0">
+              <a:lnSpc>
+                <a:spcPct val="115000"/>
+              </a:lnSpc>
+              <a:buNone/>
+            </a:pPr>
+            <a:r>
+              <a:rPr lang="en-US" sz="1200" dirty="0">
+                <a:solidFill>
+                  <a:srgbClr val="4A5568"/>
+                </a:solidFill>
+                <a:latin typeface="Optimist Sans" pitchFamily="34" charset="0"/>
+                <a:ea typeface="Optimist Sans" pitchFamily="34" charset="-122"/>
+                <a:cs typeface="Optimist Sans" pitchFamily="34" charset="-120"/>
+              </a:rPr>
+              <a:t>[Name], [Name], [Name], …</a:t>
+            </a:r>
+            <a:endParaRPr lang="en-US" sz="1200" dirty="0"/>
+          </a:p>
+        </p:txBody>
+      </p:sp>
+      <p:sp>
+        <p:nvSpPr>
+          <p:cNvPr id="63" name="Text 61"/>
+          <p:cNvSpPr txBox="1"/>
+          <p:nvPr/>
+        </p:nvSpPr>
+        <p:spPr>
+          <a:xfrm>
+            <a:off x="5842000" y="5067300"/>
+            <a:ext cx="304800" cy="215900"/>
+          </a:xfrm>
+          <a:prstGeom prst="rect">
+            <a:avLst/>
+          </a:prstGeom>
+          <a:noFill/>
+          <a:ln/>
+        </p:spPr>
+        <p:txBody>
+          <a:bodyPr wrap="square" lIns="0" tIns="0" rIns="0" bIns="0" rtlCol="0" anchor="t"/>
+          <a:lstStyle/>
+          <a:p>
+            <a:pPr algn="l" indent="0" marL="0">
+              <a:lnSpc>
+                <a:spcPct val="115000"/>
+              </a:lnSpc>
+              <a:buNone/>
+            </a:pPr>
+            <a:r>
+              <a:rPr lang="en-US" sz="1200" dirty="0">
+                <a:solidFill>
+                  <a:srgbClr val="6B7280"/>
+                </a:solidFill>
+                <a:latin typeface="Optimist Sans" pitchFamily="34" charset="0"/>
+                <a:ea typeface="Optimist Sans" pitchFamily="34" charset="-122"/>
+                <a:cs typeface="Optimist Sans" pitchFamily="34" charset="-120"/>
+              </a:rPr>
+              <a:t>’26</a:t>
+            </a:r>
+            <a:endParaRPr lang="en-US" sz="1200" dirty="0"/>
+          </a:p>
+        </p:txBody>
+      </p:sp>
+      <p:sp>
+        <p:nvSpPr>
+          <p:cNvPr id="64" name="Text 62"/>
+          <p:cNvSpPr txBox="1"/>
+          <p:nvPr/>
+        </p:nvSpPr>
+        <p:spPr>
+          <a:xfrm>
+            <a:off x="6223000" y="5067300"/>
+            <a:ext cx="1193800" cy="215900"/>
           </a:xfrm>
           <a:prstGeom prst="rect">
             <a:avLst/>
@@ -9084,7 +8913,24 @@
                 <a:ea typeface="Optimist Sans" pitchFamily="34" charset="-122"/>
                 <a:cs typeface="Optimist Sans" pitchFamily="34" charset="-120"/>
               </a:rPr>
-              <a:t>[n] associates</a:t>
+              <a:t>[n] </a:t>
+            </a:r>
+            <a:pPr algn="l" indent="0" marL="0">
+              <a:lnSpc>
+                <a:spcPct val="115000"/>
+              </a:lnSpc>
+              <a:buNone/>
+            </a:pPr>
+            <a:r>
+              <a:rPr lang="en-US" sz="1200" dirty="0">
+                <a:solidFill>
+                  <a:srgbClr val="6B7280"/>
+                </a:solidFill>
+                <a:latin typeface="Optimist Sans" pitchFamily="34" charset="0"/>
+                <a:ea typeface="Optimist Sans" pitchFamily="34" charset="-122"/>
+                <a:cs typeface="Optimist Sans" pitchFamily="34" charset="-120"/>
+              </a:rPr>
+              <a:t>([n])</a:t>
             </a:r>
             <a:endParaRPr lang="en-US" sz="1200" dirty="0"/>
           </a:p>
@@ -9092,41 +8938,41 @@
       </p:sp>
       <p:sp>
         <p:nvSpPr>
-          <p:cNvPr id="75" name="Text 73"/>
-          <p:cNvSpPr txBox="1"/>
-          <p:nvPr/>
-        </p:nvSpPr>
-        <p:spPr>
-          <a:xfrm>
-            <a:off x="5829300" y="4114800"/>
-            <a:ext cx="1600200" cy="406400"/>
-          </a:xfrm>
-          <a:prstGeom prst="rect">
-            <a:avLst/>
-          </a:prstGeom>
-          <a:noFill/>
-          <a:ln/>
-        </p:spPr>
-        <p:txBody>
-          <a:bodyPr wrap="square" lIns="0" tIns="0" rIns="0" bIns="0" rtlCol="0" anchor="t"/>
-          <a:lstStyle/>
-          <a:p>
-            <a:pPr algn="l" indent="0" marL="0">
-              <a:lnSpc>
-                <a:spcPct val="110000"/>
+          <p:cNvPr id="65" name="Text 63"/>
+          <p:cNvSpPr txBox="1"/>
+          <p:nvPr/>
+        </p:nvSpPr>
+        <p:spPr>
+          <a:xfrm>
+            <a:off x="5842000" y="5295900"/>
+            <a:ext cx="304800" cy="215900"/>
+          </a:xfrm>
+          <a:prstGeom prst="rect">
+            <a:avLst/>
+          </a:prstGeom>
+          <a:noFill/>
+          <a:ln/>
+        </p:spPr>
+        <p:txBody>
+          <a:bodyPr wrap="square" lIns="0" tIns="0" rIns="0" bIns="0" rtlCol="0" anchor="t"/>
+          <a:lstStyle/>
+          <a:p>
+            <a:pPr algn="l" indent="0" marL="0">
+              <a:lnSpc>
+                <a:spcPct val="115000"/>
               </a:lnSpc>
               <a:buNone/>
             </a:pPr>
             <a:r>
               <a:rPr lang="en-US" sz="1200" dirty="0">
                 <a:solidFill>
-                  <a:srgbClr val="4A5568"/>
-                </a:solidFill>
-                <a:latin typeface="Optimist Sans" pitchFamily="34" charset="0"/>
-                <a:ea typeface="Optimist Sans" pitchFamily="34" charset="-122"/>
-                <a:cs typeface="Optimist Sans" pitchFamily="34" charset="-120"/>
-              </a:rPr>
-              <a:t>[Name], [Name], [Name] + [n] open</a:t>
+                  <a:srgbClr val="6B7280"/>
+                </a:solidFill>
+                <a:latin typeface="Optimist Sans" pitchFamily="34" charset="0"/>
+                <a:ea typeface="Optimist Sans" pitchFamily="34" charset="-122"/>
+                <a:cs typeface="Optimist Sans" pitchFamily="34" charset="-120"/>
+              </a:rPr>
+              <a:t>’27</a:t>
             </a:r>
             <a:endParaRPr lang="en-US" sz="1200" dirty="0"/>
           </a:p>
@@ -9134,54 +8980,118 @@
       </p:sp>
       <p:sp>
         <p:nvSpPr>
-          <p:cNvPr id="76" name="Shape 74"/>
-          <p:cNvSpPr/>
-          <p:nvPr/>
-        </p:nvSpPr>
-        <p:spPr>
-          <a:xfrm>
-            <a:off x="6045200" y="5295900"/>
-            <a:ext cx="254000" cy="279400"/>
-          </a:xfrm>
-          <a:prstGeom prst="rect">
-            <a:avLst/>
-          </a:prstGeom>
-          <a:solidFill>
-            <a:srgbClr val="1F6F7E"/>
-          </a:solidFill>
-          <a:ln/>
-        </p:spPr>
-      </p:sp>
-      <p:sp>
-        <p:nvSpPr>
-          <p:cNvPr id="77" name="Text 75"/>
-          <p:cNvSpPr txBox="1"/>
-          <p:nvPr/>
-        </p:nvSpPr>
-        <p:spPr>
-          <a:xfrm>
-            <a:off x="5969000" y="5118100"/>
-            <a:ext cx="406400" cy="165100"/>
-          </a:xfrm>
-          <a:prstGeom prst="rect">
-            <a:avLst/>
-          </a:prstGeom>
-          <a:noFill/>
-          <a:ln/>
-        </p:spPr>
-        <p:txBody>
-          <a:bodyPr wrap="square" lIns="0" tIns="0" rIns="0" bIns="0" rtlCol="0" anchor="t"/>
-          <a:lstStyle/>
-          <a:p>
-            <a:pPr algn="ctr" indent="0" marL="0">
-              <a:lnSpc>
-                <a:spcPct val="100000"/>
+          <p:cNvPr id="66" name="Text 64"/>
+          <p:cNvSpPr txBox="1"/>
+          <p:nvPr/>
+        </p:nvSpPr>
+        <p:spPr>
+          <a:xfrm>
+            <a:off x="6223000" y="5295900"/>
+            <a:ext cx="1193800" cy="215900"/>
+          </a:xfrm>
+          <a:prstGeom prst="rect">
+            <a:avLst/>
+          </a:prstGeom>
+          <a:noFill/>
+          <a:ln/>
+        </p:spPr>
+        <p:txBody>
+          <a:bodyPr wrap="square" lIns="0" tIns="0" rIns="0" bIns="0" rtlCol="0" anchor="t"/>
+          <a:lstStyle/>
+          <a:p>
+            <a:pPr algn="l" indent="0" marL="0">
+              <a:lnSpc>
+                <a:spcPct val="115000"/>
+              </a:lnSpc>
+              <a:buNone/>
+            </a:pPr>
+            <a:r>
+              <a:rPr lang="en-US" sz="1200" b="1" dirty="0">
+                <a:solidFill>
+                  <a:srgbClr val="14213D"/>
+                </a:solidFill>
+                <a:latin typeface="Optimist Sans" pitchFamily="34" charset="0"/>
+                <a:ea typeface="Optimist Sans" pitchFamily="34" charset="-122"/>
+                <a:cs typeface="Optimist Sans" pitchFamily="34" charset="-120"/>
+              </a:rPr>
+              <a:t>[n]</a:t>
+            </a:r>
+            <a:endParaRPr lang="en-US" sz="1200" dirty="0"/>
+          </a:p>
+        </p:txBody>
+      </p:sp>
+      <p:sp>
+        <p:nvSpPr>
+          <p:cNvPr id="67" name="Text 65"/>
+          <p:cNvSpPr txBox="1"/>
+          <p:nvPr/>
+        </p:nvSpPr>
+        <p:spPr>
+          <a:xfrm>
+            <a:off x="5842000" y="5524500"/>
+            <a:ext cx="304800" cy="215900"/>
+          </a:xfrm>
+          <a:prstGeom prst="rect">
+            <a:avLst/>
+          </a:prstGeom>
+          <a:noFill/>
+          <a:ln/>
+        </p:spPr>
+        <p:txBody>
+          <a:bodyPr wrap="square" lIns="0" tIns="0" rIns="0" bIns="0" rtlCol="0" anchor="t"/>
+          <a:lstStyle/>
+          <a:p>
+            <a:pPr algn="l" indent="0" marL="0">
+              <a:lnSpc>
+                <a:spcPct val="115000"/>
               </a:lnSpc>
               <a:buNone/>
             </a:pPr>
             <a:r>
               <a:rPr lang="en-US" sz="1200" dirty="0">
                 <a:solidFill>
+                  <a:srgbClr val="6B7280"/>
+                </a:solidFill>
+                <a:latin typeface="Optimist Sans" pitchFamily="34" charset="0"/>
+                <a:ea typeface="Optimist Sans" pitchFamily="34" charset="-122"/>
+                <a:cs typeface="Optimist Sans" pitchFamily="34" charset="-120"/>
+              </a:rPr>
+              <a:t>’28</a:t>
+            </a:r>
+            <a:endParaRPr lang="en-US" sz="1200" dirty="0"/>
+          </a:p>
+        </p:txBody>
+      </p:sp>
+      <p:sp>
+        <p:nvSpPr>
+          <p:cNvPr id="68" name="Text 66"/>
+          <p:cNvSpPr txBox="1"/>
+          <p:nvPr/>
+        </p:nvSpPr>
+        <p:spPr>
+          <a:xfrm>
+            <a:off x="6223000" y="5524500"/>
+            <a:ext cx="1193800" cy="215900"/>
+          </a:xfrm>
+          <a:prstGeom prst="rect">
+            <a:avLst/>
+          </a:prstGeom>
+          <a:noFill/>
+          <a:ln/>
+        </p:spPr>
+        <p:txBody>
+          <a:bodyPr wrap="square" lIns="0" tIns="0" rIns="0" bIns="0" rtlCol="0" anchor="t"/>
+          <a:lstStyle/>
+          <a:p>
+            <a:pPr algn="l" indent="0" marL="0">
+              <a:lnSpc>
+                <a:spcPct val="115000"/>
+              </a:lnSpc>
+              <a:buNone/>
+            </a:pPr>
+            <a:r>
+              <a:rPr lang="en-US" sz="1200" b="1" dirty="0">
+                <a:solidFill>
                   <a:srgbClr val="14213D"/>
                 </a:solidFill>
                 <a:latin typeface="Optimist Sans" pitchFamily="34" charset="0"/>
@@ -9196,257 +9106,7 @@
       </p:sp>
       <p:sp>
         <p:nvSpPr>
-          <p:cNvPr id="78" name="Text 76"/>
-          <p:cNvSpPr txBox="1"/>
-          <p:nvPr/>
-        </p:nvSpPr>
-        <p:spPr>
-          <a:xfrm>
-            <a:off x="5969000" y="5588000"/>
-            <a:ext cx="406400" cy="165100"/>
-          </a:xfrm>
-          <a:prstGeom prst="rect">
-            <a:avLst/>
-          </a:prstGeom>
-          <a:noFill/>
-          <a:ln/>
-        </p:spPr>
-        <p:txBody>
-          <a:bodyPr wrap="square" lIns="0" tIns="0" rIns="0" bIns="0" rtlCol="0" anchor="t"/>
-          <a:lstStyle/>
-          <a:p>
-            <a:pPr algn="ctr" indent="0" marL="0">
-              <a:lnSpc>
-                <a:spcPct val="100000"/>
-              </a:lnSpc>
-              <a:buNone/>
-            </a:pPr>
-            <a:r>
-              <a:rPr lang="en-US" sz="1200" dirty="0">
-                <a:solidFill>
-                  <a:srgbClr val="6B7280"/>
-                </a:solidFill>
-                <a:latin typeface="Optimist Sans" pitchFamily="34" charset="0"/>
-                <a:ea typeface="Optimist Sans" pitchFamily="34" charset="-122"/>
-                <a:cs typeface="Optimist Sans" pitchFamily="34" charset="-120"/>
-              </a:rPr>
-              <a:t>’26</a:t>
-            </a:r>
-            <a:endParaRPr lang="en-US" sz="1200" dirty="0"/>
-          </a:p>
-        </p:txBody>
-      </p:sp>
-      <p:sp>
-        <p:nvSpPr>
-          <p:cNvPr id="79" name="Shape 77"/>
-          <p:cNvSpPr/>
-          <p:nvPr/>
-        </p:nvSpPr>
-        <p:spPr>
-          <a:xfrm>
-            <a:off x="6502400" y="5359400"/>
-            <a:ext cx="254000" cy="215900"/>
-          </a:xfrm>
-          <a:prstGeom prst="rect">
-            <a:avLst/>
-          </a:prstGeom>
-          <a:solidFill>
-            <a:srgbClr val="1F6F7E"/>
-          </a:solidFill>
-          <a:ln/>
-        </p:spPr>
-      </p:sp>
-      <p:sp>
-        <p:nvSpPr>
-          <p:cNvPr id="80" name="Text 78"/>
-          <p:cNvSpPr txBox="1"/>
-          <p:nvPr/>
-        </p:nvSpPr>
-        <p:spPr>
-          <a:xfrm>
-            <a:off x="6426200" y="5181600"/>
-            <a:ext cx="406400" cy="165100"/>
-          </a:xfrm>
-          <a:prstGeom prst="rect">
-            <a:avLst/>
-          </a:prstGeom>
-          <a:noFill/>
-          <a:ln/>
-        </p:spPr>
-        <p:txBody>
-          <a:bodyPr wrap="square" lIns="0" tIns="0" rIns="0" bIns="0" rtlCol="0" anchor="t"/>
-          <a:lstStyle/>
-          <a:p>
-            <a:pPr algn="ctr" indent="0" marL="0">
-              <a:lnSpc>
-                <a:spcPct val="100000"/>
-              </a:lnSpc>
-              <a:buNone/>
-            </a:pPr>
-            <a:r>
-              <a:rPr lang="en-US" sz="1200" dirty="0">
-                <a:solidFill>
-                  <a:srgbClr val="14213D"/>
-                </a:solidFill>
-                <a:latin typeface="Optimist Sans" pitchFamily="34" charset="0"/>
-                <a:ea typeface="Optimist Sans" pitchFamily="34" charset="-122"/>
-                <a:cs typeface="Optimist Sans" pitchFamily="34" charset="-120"/>
-              </a:rPr>
-              <a:t>[n]</a:t>
-            </a:r>
-            <a:endParaRPr lang="en-US" sz="1200" dirty="0"/>
-          </a:p>
-        </p:txBody>
-      </p:sp>
-      <p:sp>
-        <p:nvSpPr>
-          <p:cNvPr id="81" name="Text 79"/>
-          <p:cNvSpPr txBox="1"/>
-          <p:nvPr/>
-        </p:nvSpPr>
-        <p:spPr>
-          <a:xfrm>
-            <a:off x="6426200" y="5588000"/>
-            <a:ext cx="406400" cy="165100"/>
-          </a:xfrm>
-          <a:prstGeom prst="rect">
-            <a:avLst/>
-          </a:prstGeom>
-          <a:noFill/>
-          <a:ln/>
-        </p:spPr>
-        <p:txBody>
-          <a:bodyPr wrap="square" lIns="0" tIns="0" rIns="0" bIns="0" rtlCol="0" anchor="t"/>
-          <a:lstStyle/>
-          <a:p>
-            <a:pPr algn="ctr" indent="0" marL="0">
-              <a:lnSpc>
-                <a:spcPct val="100000"/>
-              </a:lnSpc>
-              <a:buNone/>
-            </a:pPr>
-            <a:r>
-              <a:rPr lang="en-US" sz="1200" dirty="0">
-                <a:solidFill>
-                  <a:srgbClr val="6B7280"/>
-                </a:solidFill>
-                <a:latin typeface="Optimist Sans" pitchFamily="34" charset="0"/>
-                <a:ea typeface="Optimist Sans" pitchFamily="34" charset="-122"/>
-                <a:cs typeface="Optimist Sans" pitchFamily="34" charset="-120"/>
-              </a:rPr>
-              <a:t>’27</a:t>
-            </a:r>
-            <a:endParaRPr lang="en-US" sz="1200" dirty="0"/>
-          </a:p>
-        </p:txBody>
-      </p:sp>
-      <p:sp>
-        <p:nvSpPr>
-          <p:cNvPr id="82" name="Shape 80"/>
-          <p:cNvSpPr/>
-          <p:nvPr/>
-        </p:nvSpPr>
-        <p:spPr>
-          <a:xfrm>
-            <a:off x="6959600" y="5422900"/>
-            <a:ext cx="254000" cy="152400"/>
-          </a:xfrm>
-          <a:prstGeom prst="rect">
-            <a:avLst/>
-          </a:prstGeom>
-          <a:solidFill>
-            <a:srgbClr val="1F6F7E"/>
-          </a:solidFill>
-          <a:ln/>
-        </p:spPr>
-      </p:sp>
-      <p:sp>
-        <p:nvSpPr>
-          <p:cNvPr id="83" name="Text 81"/>
-          <p:cNvSpPr txBox="1"/>
-          <p:nvPr/>
-        </p:nvSpPr>
-        <p:spPr>
-          <a:xfrm>
-            <a:off x="6883400" y="5245100"/>
-            <a:ext cx="406400" cy="165100"/>
-          </a:xfrm>
-          <a:prstGeom prst="rect">
-            <a:avLst/>
-          </a:prstGeom>
-          <a:noFill/>
-          <a:ln/>
-        </p:spPr>
-        <p:txBody>
-          <a:bodyPr wrap="square" lIns="0" tIns="0" rIns="0" bIns="0" rtlCol="0" anchor="t"/>
-          <a:lstStyle/>
-          <a:p>
-            <a:pPr algn="ctr" indent="0" marL="0">
-              <a:lnSpc>
-                <a:spcPct val="100000"/>
-              </a:lnSpc>
-              <a:buNone/>
-            </a:pPr>
-            <a:r>
-              <a:rPr lang="en-US" sz="1200" dirty="0">
-                <a:solidFill>
-                  <a:srgbClr val="14213D"/>
-                </a:solidFill>
-                <a:latin typeface="Optimist Sans" pitchFamily="34" charset="0"/>
-                <a:ea typeface="Optimist Sans" pitchFamily="34" charset="-122"/>
-                <a:cs typeface="Optimist Sans" pitchFamily="34" charset="-120"/>
-              </a:rPr>
-              <a:t>[n]</a:t>
-            </a:r>
-            <a:endParaRPr lang="en-US" sz="1200" dirty="0"/>
-          </a:p>
-        </p:txBody>
-      </p:sp>
-      <p:sp>
-        <p:nvSpPr>
-          <p:cNvPr id="84" name="Text 82"/>
-          <p:cNvSpPr txBox="1"/>
-          <p:nvPr/>
-        </p:nvSpPr>
-        <p:spPr>
-          <a:xfrm>
-            <a:off x="6883400" y="5588000"/>
-            <a:ext cx="406400" cy="165100"/>
-          </a:xfrm>
-          <a:prstGeom prst="rect">
-            <a:avLst/>
-          </a:prstGeom>
-          <a:noFill/>
-          <a:ln/>
-        </p:spPr>
-        <p:txBody>
-          <a:bodyPr wrap="square" lIns="0" tIns="0" rIns="0" bIns="0" rtlCol="0" anchor="t"/>
-          <a:lstStyle/>
-          <a:p>
-            <a:pPr algn="ctr" indent="0" marL="0">
-              <a:lnSpc>
-                <a:spcPct val="100000"/>
-              </a:lnSpc>
-              <a:buNone/>
-            </a:pPr>
-            <a:r>
-              <a:rPr lang="en-US" sz="1200" dirty="0">
-                <a:solidFill>
-                  <a:srgbClr val="6B7280"/>
-                </a:solidFill>
-                <a:latin typeface="Optimist Sans" pitchFamily="34" charset="0"/>
-                <a:ea typeface="Optimist Sans" pitchFamily="34" charset="-122"/>
-                <a:cs typeface="Optimist Sans" pitchFamily="34" charset="-120"/>
-              </a:rPr>
-              <a:t>’28</a:t>
-            </a:r>
-            <a:endParaRPr lang="en-US" sz="1200" dirty="0"/>
-          </a:p>
-        </p:txBody>
-      </p:sp>
-      <p:sp>
-        <p:nvSpPr>
-          <p:cNvPr id="85" name="Shape 83"/>
+          <p:cNvPr id="69" name="Shape 67"/>
           <p:cNvSpPr/>
           <p:nvPr/>
         </p:nvSpPr>
@@ -9473,14 +9133,98 @@
       </p:sp>
       <p:sp>
         <p:nvSpPr>
-          <p:cNvPr id="86" name="Text 84"/>
-          <p:cNvSpPr txBox="1"/>
-          <p:nvPr/>
-        </p:nvSpPr>
-        <p:spPr>
-          <a:xfrm>
-            <a:off x="7759700" y="3911600"/>
-            <a:ext cx="1600200" cy="190500"/>
+          <p:cNvPr id="70" name="Text 68"/>
+          <p:cNvSpPr txBox="1"/>
+          <p:nvPr/>
+        </p:nvSpPr>
+        <p:spPr>
+          <a:xfrm>
+            <a:off x="7772400" y="3911600"/>
+            <a:ext cx="1574800" cy="406400"/>
+          </a:xfrm>
+          <a:prstGeom prst="rect">
+            <a:avLst/>
+          </a:prstGeom>
+          <a:noFill/>
+          <a:ln/>
+        </p:spPr>
+        <p:txBody>
+          <a:bodyPr wrap="square" lIns="0" tIns="0" rIns="0" bIns="0" rtlCol="0" anchor="t"/>
+          <a:lstStyle/>
+          <a:p>
+            <a:pPr algn="l" indent="0" marL="0">
+              <a:lnSpc>
+                <a:spcPct val="115000"/>
+              </a:lnSpc>
+              <a:buNone/>
+            </a:pPr>
+            <a:r>
+              <a:rPr lang="en-US" sz="1200" dirty="0">
+                <a:solidFill>
+                  <a:srgbClr val="4A5568"/>
+                </a:solidFill>
+                <a:latin typeface="Optimist Sans" pitchFamily="34" charset="0"/>
+                <a:ea typeface="Optimist Sans" pitchFamily="34" charset="-122"/>
+                <a:cs typeface="Optimist Sans" pitchFamily="34" charset="-120"/>
+              </a:rPr>
+              <a:t>[Name], [Name], [Name], …</a:t>
+            </a:r>
+            <a:endParaRPr lang="en-US" sz="1200" dirty="0"/>
+          </a:p>
+        </p:txBody>
+      </p:sp>
+      <p:sp>
+        <p:nvSpPr>
+          <p:cNvPr id="71" name="Text 69"/>
+          <p:cNvSpPr txBox="1"/>
+          <p:nvPr/>
+        </p:nvSpPr>
+        <p:spPr>
+          <a:xfrm>
+            <a:off x="7772400" y="5067300"/>
+            <a:ext cx="304800" cy="215900"/>
+          </a:xfrm>
+          <a:prstGeom prst="rect">
+            <a:avLst/>
+          </a:prstGeom>
+          <a:noFill/>
+          <a:ln/>
+        </p:spPr>
+        <p:txBody>
+          <a:bodyPr wrap="square" lIns="0" tIns="0" rIns="0" bIns="0" rtlCol="0" anchor="t"/>
+          <a:lstStyle/>
+          <a:p>
+            <a:pPr algn="l" indent="0" marL="0">
+              <a:lnSpc>
+                <a:spcPct val="115000"/>
+              </a:lnSpc>
+              <a:buNone/>
+            </a:pPr>
+            <a:r>
+              <a:rPr lang="en-US" sz="1200" dirty="0">
+                <a:solidFill>
+                  <a:srgbClr val="6B7280"/>
+                </a:solidFill>
+                <a:latin typeface="Optimist Sans" pitchFamily="34" charset="0"/>
+                <a:ea typeface="Optimist Sans" pitchFamily="34" charset="-122"/>
+                <a:cs typeface="Optimist Sans" pitchFamily="34" charset="-120"/>
+              </a:rPr>
+              <a:t>’26</a:t>
+            </a:r>
+            <a:endParaRPr lang="en-US" sz="1200" dirty="0"/>
+          </a:p>
+        </p:txBody>
+      </p:sp>
+      <p:sp>
+        <p:nvSpPr>
+          <p:cNvPr id="72" name="Text 70"/>
+          <p:cNvSpPr txBox="1"/>
+          <p:nvPr/>
+        </p:nvSpPr>
+        <p:spPr>
+          <a:xfrm>
+            <a:off x="8153400" y="5067300"/>
+            <a:ext cx="1193800" cy="215900"/>
           </a:xfrm>
           <a:prstGeom prst="rect">
             <a:avLst/>
@@ -9507,7 +9251,24 @@
                 <a:ea typeface="Optimist Sans" pitchFamily="34" charset="-122"/>
                 <a:cs typeface="Optimist Sans" pitchFamily="34" charset="-120"/>
               </a:rPr>
-              <a:t>[n] associates</a:t>
+              <a:t>[n] </a:t>
+            </a:r>
+            <a:pPr algn="l" indent="0" marL="0">
+              <a:lnSpc>
+                <a:spcPct val="115000"/>
+              </a:lnSpc>
+              <a:buNone/>
+            </a:pPr>
+            <a:r>
+              <a:rPr lang="en-US" sz="1200" dirty="0">
+                <a:solidFill>
+                  <a:srgbClr val="6B7280"/>
+                </a:solidFill>
+                <a:latin typeface="Optimist Sans" pitchFamily="34" charset="0"/>
+                <a:ea typeface="Optimist Sans" pitchFamily="34" charset="-122"/>
+                <a:cs typeface="Optimist Sans" pitchFamily="34" charset="-120"/>
+              </a:rPr>
+              <a:t>([n])</a:t>
             </a:r>
             <a:endParaRPr lang="en-US" sz="1200" dirty="0"/>
           </a:p>
@@ -9515,41 +9276,41 @@
       </p:sp>
       <p:sp>
         <p:nvSpPr>
-          <p:cNvPr id="87" name="Text 85"/>
-          <p:cNvSpPr txBox="1"/>
-          <p:nvPr/>
-        </p:nvSpPr>
-        <p:spPr>
-          <a:xfrm>
-            <a:off x="7759700" y="4114800"/>
-            <a:ext cx="1600200" cy="406400"/>
-          </a:xfrm>
-          <a:prstGeom prst="rect">
-            <a:avLst/>
-          </a:prstGeom>
-          <a:noFill/>
-          <a:ln/>
-        </p:spPr>
-        <p:txBody>
-          <a:bodyPr wrap="square" lIns="0" tIns="0" rIns="0" bIns="0" rtlCol="0" anchor="t"/>
-          <a:lstStyle/>
-          <a:p>
-            <a:pPr algn="l" indent="0" marL="0">
-              <a:lnSpc>
-                <a:spcPct val="110000"/>
+          <p:cNvPr id="73" name="Text 71"/>
+          <p:cNvSpPr txBox="1"/>
+          <p:nvPr/>
+        </p:nvSpPr>
+        <p:spPr>
+          <a:xfrm>
+            <a:off x="7772400" y="5295900"/>
+            <a:ext cx="304800" cy="215900"/>
+          </a:xfrm>
+          <a:prstGeom prst="rect">
+            <a:avLst/>
+          </a:prstGeom>
+          <a:noFill/>
+          <a:ln/>
+        </p:spPr>
+        <p:txBody>
+          <a:bodyPr wrap="square" lIns="0" tIns="0" rIns="0" bIns="0" rtlCol="0" anchor="t"/>
+          <a:lstStyle/>
+          <a:p>
+            <a:pPr algn="l" indent="0" marL="0">
+              <a:lnSpc>
+                <a:spcPct val="115000"/>
               </a:lnSpc>
               <a:buNone/>
             </a:pPr>
             <a:r>
               <a:rPr lang="en-US" sz="1200" dirty="0">
                 <a:solidFill>
-                  <a:srgbClr val="4A5568"/>
-                </a:solidFill>
-                <a:latin typeface="Optimist Sans" pitchFamily="34" charset="0"/>
-                <a:ea typeface="Optimist Sans" pitchFamily="34" charset="-122"/>
-                <a:cs typeface="Optimist Sans" pitchFamily="34" charset="-120"/>
-              </a:rPr>
-              <a:t>[Name], [Name], [Name] + [n] open</a:t>
+                  <a:srgbClr val="6B7280"/>
+                </a:solidFill>
+                <a:latin typeface="Optimist Sans" pitchFamily="34" charset="0"/>
+                <a:ea typeface="Optimist Sans" pitchFamily="34" charset="-122"/>
+                <a:cs typeface="Optimist Sans" pitchFamily="34" charset="-120"/>
+              </a:rPr>
+              <a:t>’27</a:t>
             </a:r>
             <a:endParaRPr lang="en-US" sz="1200" dirty="0"/>
           </a:p>
@@ -9557,54 +9318,118 @@
       </p:sp>
       <p:sp>
         <p:nvSpPr>
-          <p:cNvPr id="88" name="Shape 86"/>
-          <p:cNvSpPr/>
-          <p:nvPr/>
-        </p:nvSpPr>
-        <p:spPr>
-          <a:xfrm>
-            <a:off x="7975600" y="5295900"/>
-            <a:ext cx="254000" cy="279400"/>
-          </a:xfrm>
-          <a:prstGeom prst="rect">
-            <a:avLst/>
-          </a:prstGeom>
-          <a:solidFill>
-            <a:srgbClr val="1F6F7E"/>
-          </a:solidFill>
-          <a:ln/>
-        </p:spPr>
-      </p:sp>
-      <p:sp>
-        <p:nvSpPr>
-          <p:cNvPr id="89" name="Text 87"/>
-          <p:cNvSpPr txBox="1"/>
-          <p:nvPr/>
-        </p:nvSpPr>
-        <p:spPr>
-          <a:xfrm>
-            <a:off x="7899400" y="5118100"/>
-            <a:ext cx="406400" cy="165100"/>
-          </a:xfrm>
-          <a:prstGeom prst="rect">
-            <a:avLst/>
-          </a:prstGeom>
-          <a:noFill/>
-          <a:ln/>
-        </p:spPr>
-        <p:txBody>
-          <a:bodyPr wrap="square" lIns="0" tIns="0" rIns="0" bIns="0" rtlCol="0" anchor="t"/>
-          <a:lstStyle/>
-          <a:p>
-            <a:pPr algn="ctr" indent="0" marL="0">
-              <a:lnSpc>
-                <a:spcPct val="100000"/>
+          <p:cNvPr id="74" name="Text 72"/>
+          <p:cNvSpPr txBox="1"/>
+          <p:nvPr/>
+        </p:nvSpPr>
+        <p:spPr>
+          <a:xfrm>
+            <a:off x="8153400" y="5295900"/>
+            <a:ext cx="1193800" cy="215900"/>
+          </a:xfrm>
+          <a:prstGeom prst="rect">
+            <a:avLst/>
+          </a:prstGeom>
+          <a:noFill/>
+          <a:ln/>
+        </p:spPr>
+        <p:txBody>
+          <a:bodyPr wrap="square" lIns="0" tIns="0" rIns="0" bIns="0" rtlCol="0" anchor="t"/>
+          <a:lstStyle/>
+          <a:p>
+            <a:pPr algn="l" indent="0" marL="0">
+              <a:lnSpc>
+                <a:spcPct val="115000"/>
+              </a:lnSpc>
+              <a:buNone/>
+            </a:pPr>
+            <a:r>
+              <a:rPr lang="en-US" sz="1200" b="1" dirty="0">
+                <a:solidFill>
+                  <a:srgbClr val="14213D"/>
+                </a:solidFill>
+                <a:latin typeface="Optimist Sans" pitchFamily="34" charset="0"/>
+                <a:ea typeface="Optimist Sans" pitchFamily="34" charset="-122"/>
+                <a:cs typeface="Optimist Sans" pitchFamily="34" charset="-120"/>
+              </a:rPr>
+              <a:t>[n]</a:t>
+            </a:r>
+            <a:endParaRPr lang="en-US" sz="1200" dirty="0"/>
+          </a:p>
+        </p:txBody>
+      </p:sp>
+      <p:sp>
+        <p:nvSpPr>
+          <p:cNvPr id="75" name="Text 73"/>
+          <p:cNvSpPr txBox="1"/>
+          <p:nvPr/>
+        </p:nvSpPr>
+        <p:spPr>
+          <a:xfrm>
+            <a:off x="7772400" y="5524500"/>
+            <a:ext cx="304800" cy="215900"/>
+          </a:xfrm>
+          <a:prstGeom prst="rect">
+            <a:avLst/>
+          </a:prstGeom>
+          <a:noFill/>
+          <a:ln/>
+        </p:spPr>
+        <p:txBody>
+          <a:bodyPr wrap="square" lIns="0" tIns="0" rIns="0" bIns="0" rtlCol="0" anchor="t"/>
+          <a:lstStyle/>
+          <a:p>
+            <a:pPr algn="l" indent="0" marL="0">
+              <a:lnSpc>
+                <a:spcPct val="115000"/>
               </a:lnSpc>
               <a:buNone/>
             </a:pPr>
             <a:r>
               <a:rPr lang="en-US" sz="1200" dirty="0">
                 <a:solidFill>
+                  <a:srgbClr val="6B7280"/>
+                </a:solidFill>
+                <a:latin typeface="Optimist Sans" pitchFamily="34" charset="0"/>
+                <a:ea typeface="Optimist Sans" pitchFamily="34" charset="-122"/>
+                <a:cs typeface="Optimist Sans" pitchFamily="34" charset="-120"/>
+              </a:rPr>
+              <a:t>’28</a:t>
+            </a:r>
+            <a:endParaRPr lang="en-US" sz="1200" dirty="0"/>
+          </a:p>
+        </p:txBody>
+      </p:sp>
+      <p:sp>
+        <p:nvSpPr>
+          <p:cNvPr id="76" name="Text 74"/>
+          <p:cNvSpPr txBox="1"/>
+          <p:nvPr/>
+        </p:nvSpPr>
+        <p:spPr>
+          <a:xfrm>
+            <a:off x="8153400" y="5524500"/>
+            <a:ext cx="1193800" cy="215900"/>
+          </a:xfrm>
+          <a:prstGeom prst="rect">
+            <a:avLst/>
+          </a:prstGeom>
+          <a:noFill/>
+          <a:ln/>
+        </p:spPr>
+        <p:txBody>
+          <a:bodyPr wrap="square" lIns="0" tIns="0" rIns="0" bIns="0" rtlCol="0" anchor="t"/>
+          <a:lstStyle/>
+          <a:p>
+            <a:pPr algn="l" indent="0" marL="0">
+              <a:lnSpc>
+                <a:spcPct val="115000"/>
+              </a:lnSpc>
+              <a:buNone/>
+            </a:pPr>
+            <a:r>
+              <a:rPr lang="en-US" sz="1200" b="1" dirty="0">
+                <a:solidFill>
                   <a:srgbClr val="14213D"/>
                 </a:solidFill>
                 <a:latin typeface="Optimist Sans" pitchFamily="34" charset="0"/>
@@ -9619,257 +9444,7 @@
       </p:sp>
       <p:sp>
         <p:nvSpPr>
-          <p:cNvPr id="90" name="Text 88"/>
-          <p:cNvSpPr txBox="1"/>
-          <p:nvPr/>
-        </p:nvSpPr>
-        <p:spPr>
-          <a:xfrm>
-            <a:off x="7899400" y="5588000"/>
-            <a:ext cx="406400" cy="165100"/>
-          </a:xfrm>
-          <a:prstGeom prst="rect">
-            <a:avLst/>
-          </a:prstGeom>
-          <a:noFill/>
-          <a:ln/>
-        </p:spPr>
-        <p:txBody>
-          <a:bodyPr wrap="square" lIns="0" tIns="0" rIns="0" bIns="0" rtlCol="0" anchor="t"/>
-          <a:lstStyle/>
-          <a:p>
-            <a:pPr algn="ctr" indent="0" marL="0">
-              <a:lnSpc>
-                <a:spcPct val="100000"/>
-              </a:lnSpc>
-              <a:buNone/>
-            </a:pPr>
-            <a:r>
-              <a:rPr lang="en-US" sz="1200" dirty="0">
-                <a:solidFill>
-                  <a:srgbClr val="6B7280"/>
-                </a:solidFill>
-                <a:latin typeface="Optimist Sans" pitchFamily="34" charset="0"/>
-                <a:ea typeface="Optimist Sans" pitchFamily="34" charset="-122"/>
-                <a:cs typeface="Optimist Sans" pitchFamily="34" charset="-120"/>
-              </a:rPr>
-              <a:t>’26</a:t>
-            </a:r>
-            <a:endParaRPr lang="en-US" sz="1200" dirty="0"/>
-          </a:p>
-        </p:txBody>
-      </p:sp>
-      <p:sp>
-        <p:nvSpPr>
-          <p:cNvPr id="91" name="Shape 89"/>
-          <p:cNvSpPr/>
-          <p:nvPr/>
-        </p:nvSpPr>
-        <p:spPr>
-          <a:xfrm>
-            <a:off x="8432800" y="5359400"/>
-            <a:ext cx="254000" cy="215900"/>
-          </a:xfrm>
-          <a:prstGeom prst="rect">
-            <a:avLst/>
-          </a:prstGeom>
-          <a:solidFill>
-            <a:srgbClr val="1F6F7E"/>
-          </a:solidFill>
-          <a:ln/>
-        </p:spPr>
-      </p:sp>
-      <p:sp>
-        <p:nvSpPr>
-          <p:cNvPr id="92" name="Text 90"/>
-          <p:cNvSpPr txBox="1"/>
-          <p:nvPr/>
-        </p:nvSpPr>
-        <p:spPr>
-          <a:xfrm>
-            <a:off x="8356600" y="5181600"/>
-            <a:ext cx="406400" cy="165100"/>
-          </a:xfrm>
-          <a:prstGeom prst="rect">
-            <a:avLst/>
-          </a:prstGeom>
-          <a:noFill/>
-          <a:ln/>
-        </p:spPr>
-        <p:txBody>
-          <a:bodyPr wrap="square" lIns="0" tIns="0" rIns="0" bIns="0" rtlCol="0" anchor="t"/>
-          <a:lstStyle/>
-          <a:p>
-            <a:pPr algn="ctr" indent="0" marL="0">
-              <a:lnSpc>
-                <a:spcPct val="100000"/>
-              </a:lnSpc>
-              <a:buNone/>
-            </a:pPr>
-            <a:r>
-              <a:rPr lang="en-US" sz="1200" dirty="0">
-                <a:solidFill>
-                  <a:srgbClr val="14213D"/>
-                </a:solidFill>
-                <a:latin typeface="Optimist Sans" pitchFamily="34" charset="0"/>
-                <a:ea typeface="Optimist Sans" pitchFamily="34" charset="-122"/>
-                <a:cs typeface="Optimist Sans" pitchFamily="34" charset="-120"/>
-              </a:rPr>
-              <a:t>[n]</a:t>
-            </a:r>
-            <a:endParaRPr lang="en-US" sz="1200" dirty="0"/>
-          </a:p>
-        </p:txBody>
-      </p:sp>
-      <p:sp>
-        <p:nvSpPr>
-          <p:cNvPr id="93" name="Text 91"/>
-          <p:cNvSpPr txBox="1"/>
-          <p:nvPr/>
-        </p:nvSpPr>
-        <p:spPr>
-          <a:xfrm>
-            <a:off x="8356600" y="5588000"/>
-            <a:ext cx="406400" cy="165100"/>
-          </a:xfrm>
-          <a:prstGeom prst="rect">
-            <a:avLst/>
-          </a:prstGeom>
-          <a:noFill/>
-          <a:ln/>
-        </p:spPr>
-        <p:txBody>
-          <a:bodyPr wrap="square" lIns="0" tIns="0" rIns="0" bIns="0" rtlCol="0" anchor="t"/>
-          <a:lstStyle/>
-          <a:p>
-            <a:pPr algn="ctr" indent="0" marL="0">
-              <a:lnSpc>
-                <a:spcPct val="100000"/>
-              </a:lnSpc>
-              <a:buNone/>
-            </a:pPr>
-            <a:r>
-              <a:rPr lang="en-US" sz="1200" dirty="0">
-                <a:solidFill>
-                  <a:srgbClr val="6B7280"/>
-                </a:solidFill>
-                <a:latin typeface="Optimist Sans" pitchFamily="34" charset="0"/>
-                <a:ea typeface="Optimist Sans" pitchFamily="34" charset="-122"/>
-                <a:cs typeface="Optimist Sans" pitchFamily="34" charset="-120"/>
-              </a:rPr>
-              <a:t>’27</a:t>
-            </a:r>
-            <a:endParaRPr lang="en-US" sz="1200" dirty="0"/>
-          </a:p>
-        </p:txBody>
-      </p:sp>
-      <p:sp>
-        <p:nvSpPr>
-          <p:cNvPr id="94" name="Shape 92"/>
-          <p:cNvSpPr/>
-          <p:nvPr/>
-        </p:nvSpPr>
-        <p:spPr>
-          <a:xfrm>
-            <a:off x="8890000" y="5422900"/>
-            <a:ext cx="254000" cy="152400"/>
-          </a:xfrm>
-          <a:prstGeom prst="rect">
-            <a:avLst/>
-          </a:prstGeom>
-          <a:solidFill>
-            <a:srgbClr val="1F6F7E"/>
-          </a:solidFill>
-          <a:ln/>
-        </p:spPr>
-      </p:sp>
-      <p:sp>
-        <p:nvSpPr>
-          <p:cNvPr id="95" name="Text 93"/>
-          <p:cNvSpPr txBox="1"/>
-          <p:nvPr/>
-        </p:nvSpPr>
-        <p:spPr>
-          <a:xfrm>
-            <a:off x="8813800" y="5245100"/>
-            <a:ext cx="406400" cy="165100"/>
-          </a:xfrm>
-          <a:prstGeom prst="rect">
-            <a:avLst/>
-          </a:prstGeom>
-          <a:noFill/>
-          <a:ln/>
-        </p:spPr>
-        <p:txBody>
-          <a:bodyPr wrap="square" lIns="0" tIns="0" rIns="0" bIns="0" rtlCol="0" anchor="t"/>
-          <a:lstStyle/>
-          <a:p>
-            <a:pPr algn="ctr" indent="0" marL="0">
-              <a:lnSpc>
-                <a:spcPct val="100000"/>
-              </a:lnSpc>
-              <a:buNone/>
-            </a:pPr>
-            <a:r>
-              <a:rPr lang="en-US" sz="1200" dirty="0">
-                <a:solidFill>
-                  <a:srgbClr val="14213D"/>
-                </a:solidFill>
-                <a:latin typeface="Optimist Sans" pitchFamily="34" charset="0"/>
-                <a:ea typeface="Optimist Sans" pitchFamily="34" charset="-122"/>
-                <a:cs typeface="Optimist Sans" pitchFamily="34" charset="-120"/>
-              </a:rPr>
-              <a:t>[n]</a:t>
-            </a:r>
-            <a:endParaRPr lang="en-US" sz="1200" dirty="0"/>
-          </a:p>
-        </p:txBody>
-      </p:sp>
-      <p:sp>
-        <p:nvSpPr>
-          <p:cNvPr id="96" name="Text 94"/>
-          <p:cNvSpPr txBox="1"/>
-          <p:nvPr/>
-        </p:nvSpPr>
-        <p:spPr>
-          <a:xfrm>
-            <a:off x="8813800" y="5588000"/>
-            <a:ext cx="406400" cy="165100"/>
-          </a:xfrm>
-          <a:prstGeom prst="rect">
-            <a:avLst/>
-          </a:prstGeom>
-          <a:noFill/>
-          <a:ln/>
-        </p:spPr>
-        <p:txBody>
-          <a:bodyPr wrap="square" lIns="0" tIns="0" rIns="0" bIns="0" rtlCol="0" anchor="t"/>
-          <a:lstStyle/>
-          <a:p>
-            <a:pPr algn="ctr" indent="0" marL="0">
-              <a:lnSpc>
-                <a:spcPct val="100000"/>
-              </a:lnSpc>
-              <a:buNone/>
-            </a:pPr>
-            <a:r>
-              <a:rPr lang="en-US" sz="1200" dirty="0">
-                <a:solidFill>
-                  <a:srgbClr val="6B7280"/>
-                </a:solidFill>
-                <a:latin typeface="Optimist Sans" pitchFamily="34" charset="0"/>
-                <a:ea typeface="Optimist Sans" pitchFamily="34" charset="-122"/>
-                <a:cs typeface="Optimist Sans" pitchFamily="34" charset="-120"/>
-              </a:rPr>
-              <a:t>’28</a:t>
-            </a:r>
-            <a:endParaRPr lang="en-US" sz="1200" dirty="0"/>
-          </a:p>
-        </p:txBody>
-      </p:sp>
-      <p:sp>
-        <p:nvSpPr>
-          <p:cNvPr id="97" name="Shape 95"/>
+          <p:cNvPr id="77" name="Shape 75"/>
           <p:cNvSpPr/>
           <p:nvPr/>
         </p:nvSpPr>
@@ -9896,14 +9471,98 @@
       </p:sp>
       <p:sp>
         <p:nvSpPr>
-          <p:cNvPr id="98" name="Text 96"/>
-          <p:cNvSpPr txBox="1"/>
-          <p:nvPr/>
-        </p:nvSpPr>
-        <p:spPr>
-          <a:xfrm>
-            <a:off x="9690100" y="3911600"/>
-            <a:ext cx="1600200" cy="190500"/>
+          <p:cNvPr id="78" name="Text 76"/>
+          <p:cNvSpPr txBox="1"/>
+          <p:nvPr/>
+        </p:nvSpPr>
+        <p:spPr>
+          <a:xfrm>
+            <a:off x="9702800" y="3911600"/>
+            <a:ext cx="1574800" cy="406400"/>
+          </a:xfrm>
+          <a:prstGeom prst="rect">
+            <a:avLst/>
+          </a:prstGeom>
+          <a:noFill/>
+          <a:ln/>
+        </p:spPr>
+        <p:txBody>
+          <a:bodyPr wrap="square" lIns="0" tIns="0" rIns="0" bIns="0" rtlCol="0" anchor="t"/>
+          <a:lstStyle/>
+          <a:p>
+            <a:pPr algn="l" indent="0" marL="0">
+              <a:lnSpc>
+                <a:spcPct val="115000"/>
+              </a:lnSpc>
+              <a:buNone/>
+            </a:pPr>
+            <a:r>
+              <a:rPr lang="en-US" sz="1200" dirty="0">
+                <a:solidFill>
+                  <a:srgbClr val="4A5568"/>
+                </a:solidFill>
+                <a:latin typeface="Optimist Sans" pitchFamily="34" charset="0"/>
+                <a:ea typeface="Optimist Sans" pitchFamily="34" charset="-122"/>
+                <a:cs typeface="Optimist Sans" pitchFamily="34" charset="-120"/>
+              </a:rPr>
+              <a:t>[Name], [Name], [Name], …</a:t>
+            </a:r>
+            <a:endParaRPr lang="en-US" sz="1200" dirty="0"/>
+          </a:p>
+        </p:txBody>
+      </p:sp>
+      <p:sp>
+        <p:nvSpPr>
+          <p:cNvPr id="79" name="Text 77"/>
+          <p:cNvSpPr txBox="1"/>
+          <p:nvPr/>
+        </p:nvSpPr>
+        <p:spPr>
+          <a:xfrm>
+            <a:off x="9702800" y="5067300"/>
+            <a:ext cx="304800" cy="215900"/>
+          </a:xfrm>
+          <a:prstGeom prst="rect">
+            <a:avLst/>
+          </a:prstGeom>
+          <a:noFill/>
+          <a:ln/>
+        </p:spPr>
+        <p:txBody>
+          <a:bodyPr wrap="square" lIns="0" tIns="0" rIns="0" bIns="0" rtlCol="0" anchor="t"/>
+          <a:lstStyle/>
+          <a:p>
+            <a:pPr algn="l" indent="0" marL="0">
+              <a:lnSpc>
+                <a:spcPct val="115000"/>
+              </a:lnSpc>
+              <a:buNone/>
+            </a:pPr>
+            <a:r>
+              <a:rPr lang="en-US" sz="1200" dirty="0">
+                <a:solidFill>
+                  <a:srgbClr val="6B7280"/>
+                </a:solidFill>
+                <a:latin typeface="Optimist Sans" pitchFamily="34" charset="0"/>
+                <a:ea typeface="Optimist Sans" pitchFamily="34" charset="-122"/>
+                <a:cs typeface="Optimist Sans" pitchFamily="34" charset="-120"/>
+              </a:rPr>
+              <a:t>’26</a:t>
+            </a:r>
+            <a:endParaRPr lang="en-US" sz="1200" dirty="0"/>
+          </a:p>
+        </p:txBody>
+      </p:sp>
+      <p:sp>
+        <p:nvSpPr>
+          <p:cNvPr id="80" name="Text 78"/>
+          <p:cNvSpPr txBox="1"/>
+          <p:nvPr/>
+        </p:nvSpPr>
+        <p:spPr>
+          <a:xfrm>
+            <a:off x="10083800" y="5067300"/>
+            <a:ext cx="1193800" cy="215900"/>
           </a:xfrm>
           <a:prstGeom prst="rect">
             <a:avLst/>
@@ -9924,13 +9583,30 @@
             <a:r>
               <a:rPr lang="en-US" sz="1200" b="1" dirty="0">
                 <a:solidFill>
-                  <a:srgbClr val="14213D"/>
-                </a:solidFill>
-                <a:latin typeface="Optimist Sans" pitchFamily="34" charset="0"/>
-                <a:ea typeface="Optimist Sans" pitchFamily="34" charset="-122"/>
-                <a:cs typeface="Optimist Sans" pitchFamily="34" charset="-120"/>
-              </a:rPr>
-              <a:t>[n] associates</a:t>
+                  <a:srgbClr val="8A4514"/>
+                </a:solidFill>
+                <a:latin typeface="Optimist Sans" pitchFamily="34" charset="0"/>
+                <a:ea typeface="Optimist Sans" pitchFamily="34" charset="-122"/>
+                <a:cs typeface="Optimist Sans" pitchFamily="34" charset="-120"/>
+              </a:rPr>
+              <a:t>[n] </a:t>
+            </a:r>
+            <a:pPr algn="l" indent="0" marL="0">
+              <a:lnSpc>
+                <a:spcPct val="115000"/>
+              </a:lnSpc>
+              <a:buNone/>
+            </a:pPr>
+            <a:r>
+              <a:rPr lang="en-US" sz="1200" dirty="0">
+                <a:solidFill>
+                  <a:srgbClr val="6B7280"/>
+                </a:solidFill>
+                <a:latin typeface="Optimist Sans" pitchFamily="34" charset="0"/>
+                <a:ea typeface="Optimist Sans" pitchFamily="34" charset="-122"/>
+                <a:cs typeface="Optimist Sans" pitchFamily="34" charset="-120"/>
+              </a:rPr>
+              <a:t>([n])</a:t>
             </a:r>
             <a:endParaRPr lang="en-US" sz="1200" dirty="0"/>
           </a:p>
@@ -9938,41 +9614,41 @@
       </p:sp>
       <p:sp>
         <p:nvSpPr>
-          <p:cNvPr id="99" name="Text 97"/>
-          <p:cNvSpPr txBox="1"/>
-          <p:nvPr/>
-        </p:nvSpPr>
-        <p:spPr>
-          <a:xfrm>
-            <a:off x="9690100" y="4114800"/>
-            <a:ext cx="1600200" cy="406400"/>
-          </a:xfrm>
-          <a:prstGeom prst="rect">
-            <a:avLst/>
-          </a:prstGeom>
-          <a:noFill/>
-          <a:ln/>
-        </p:spPr>
-        <p:txBody>
-          <a:bodyPr wrap="square" lIns="0" tIns="0" rIns="0" bIns="0" rtlCol="0" anchor="t"/>
-          <a:lstStyle/>
-          <a:p>
-            <a:pPr algn="l" indent="0" marL="0">
-              <a:lnSpc>
-                <a:spcPct val="110000"/>
+          <p:cNvPr id="81" name="Text 79"/>
+          <p:cNvSpPr txBox="1"/>
+          <p:nvPr/>
+        </p:nvSpPr>
+        <p:spPr>
+          <a:xfrm>
+            <a:off x="9702800" y="5295900"/>
+            <a:ext cx="304800" cy="215900"/>
+          </a:xfrm>
+          <a:prstGeom prst="rect">
+            <a:avLst/>
+          </a:prstGeom>
+          <a:noFill/>
+          <a:ln/>
+        </p:spPr>
+        <p:txBody>
+          <a:bodyPr wrap="square" lIns="0" tIns="0" rIns="0" bIns="0" rtlCol="0" anchor="t"/>
+          <a:lstStyle/>
+          <a:p>
+            <a:pPr algn="l" indent="0" marL="0">
+              <a:lnSpc>
+                <a:spcPct val="115000"/>
               </a:lnSpc>
               <a:buNone/>
             </a:pPr>
             <a:r>
               <a:rPr lang="en-US" sz="1200" dirty="0">
                 <a:solidFill>
-                  <a:srgbClr val="4A5568"/>
-                </a:solidFill>
-                <a:latin typeface="Optimist Sans" pitchFamily="34" charset="0"/>
-                <a:ea typeface="Optimist Sans" pitchFamily="34" charset="-122"/>
-                <a:cs typeface="Optimist Sans" pitchFamily="34" charset="-120"/>
-              </a:rPr>
-              <a:t>[Name], [Name], [Name] + [n] open</a:t>
+                  <a:srgbClr val="6B7280"/>
+                </a:solidFill>
+                <a:latin typeface="Optimist Sans" pitchFamily="34" charset="0"/>
+                <a:ea typeface="Optimist Sans" pitchFamily="34" charset="-122"/>
+                <a:cs typeface="Optimist Sans" pitchFamily="34" charset="-120"/>
+              </a:rPr>
+              <a:t>’27</a:t>
             </a:r>
             <a:endParaRPr lang="en-US" sz="1200" dirty="0"/>
           </a:p>
@@ -9980,55 +9656,119 @@
       </p:sp>
       <p:sp>
         <p:nvSpPr>
-          <p:cNvPr id="100" name="Shape 98"/>
-          <p:cNvSpPr/>
-          <p:nvPr/>
-        </p:nvSpPr>
-        <p:spPr>
-          <a:xfrm>
-            <a:off x="9906000" y="5448300"/>
-            <a:ext cx="254000" cy="127000"/>
-          </a:xfrm>
-          <a:prstGeom prst="rect">
-            <a:avLst/>
-          </a:prstGeom>
-          <a:solidFill>
-            <a:srgbClr val="E3A86B"/>
-          </a:solidFill>
-          <a:ln/>
-        </p:spPr>
-      </p:sp>
-      <p:sp>
-        <p:nvSpPr>
-          <p:cNvPr id="101" name="Text 99"/>
-          <p:cNvSpPr txBox="1"/>
-          <p:nvPr/>
-        </p:nvSpPr>
-        <p:spPr>
-          <a:xfrm>
-            <a:off x="9829800" y="5270500"/>
-            <a:ext cx="406400" cy="165100"/>
-          </a:xfrm>
-          <a:prstGeom prst="rect">
-            <a:avLst/>
-          </a:prstGeom>
-          <a:noFill/>
-          <a:ln/>
-        </p:spPr>
-        <p:txBody>
-          <a:bodyPr wrap="square" lIns="0" tIns="0" rIns="0" bIns="0" rtlCol="0" anchor="t"/>
-          <a:lstStyle/>
-          <a:p>
-            <a:pPr algn="ctr" indent="0" marL="0">
-              <a:lnSpc>
-                <a:spcPct val="100000"/>
+          <p:cNvPr id="82" name="Text 80"/>
+          <p:cNvSpPr txBox="1"/>
+          <p:nvPr/>
+        </p:nvSpPr>
+        <p:spPr>
+          <a:xfrm>
+            <a:off x="10083800" y="5295900"/>
+            <a:ext cx="1193800" cy="215900"/>
+          </a:xfrm>
+          <a:prstGeom prst="rect">
+            <a:avLst/>
+          </a:prstGeom>
+          <a:noFill/>
+          <a:ln/>
+        </p:spPr>
+        <p:txBody>
+          <a:bodyPr wrap="square" lIns="0" tIns="0" rIns="0" bIns="0" rtlCol="0" anchor="t"/>
+          <a:lstStyle/>
+          <a:p>
+            <a:pPr algn="l" indent="0" marL="0">
+              <a:lnSpc>
+                <a:spcPct val="115000"/>
+              </a:lnSpc>
+              <a:buNone/>
+            </a:pPr>
+            <a:r>
+              <a:rPr lang="en-US" sz="1200" b="1" dirty="0">
+                <a:solidFill>
+                  <a:srgbClr val="8A4514"/>
+                </a:solidFill>
+                <a:latin typeface="Optimist Sans" pitchFamily="34" charset="0"/>
+                <a:ea typeface="Optimist Sans" pitchFamily="34" charset="-122"/>
+                <a:cs typeface="Optimist Sans" pitchFamily="34" charset="-120"/>
+              </a:rPr>
+              <a:t>[n]</a:t>
+            </a:r>
+            <a:endParaRPr lang="en-US" sz="1200" dirty="0"/>
+          </a:p>
+        </p:txBody>
+      </p:sp>
+      <p:sp>
+        <p:nvSpPr>
+          <p:cNvPr id="83" name="Text 81"/>
+          <p:cNvSpPr txBox="1"/>
+          <p:nvPr/>
+        </p:nvSpPr>
+        <p:spPr>
+          <a:xfrm>
+            <a:off x="9702800" y="5524500"/>
+            <a:ext cx="304800" cy="215900"/>
+          </a:xfrm>
+          <a:prstGeom prst="rect">
+            <a:avLst/>
+          </a:prstGeom>
+          <a:noFill/>
+          <a:ln/>
+        </p:spPr>
+        <p:txBody>
+          <a:bodyPr wrap="square" lIns="0" tIns="0" rIns="0" bIns="0" rtlCol="0" anchor="t"/>
+          <a:lstStyle/>
+          <a:p>
+            <a:pPr algn="l" indent="0" marL="0">
+              <a:lnSpc>
+                <a:spcPct val="115000"/>
               </a:lnSpc>
               <a:buNone/>
             </a:pPr>
             <a:r>
               <a:rPr lang="en-US" sz="1200" dirty="0">
                 <a:solidFill>
-                  <a:srgbClr val="14213D"/>
+                  <a:srgbClr val="6B7280"/>
+                </a:solidFill>
+                <a:latin typeface="Optimist Sans" pitchFamily="34" charset="0"/>
+                <a:ea typeface="Optimist Sans" pitchFamily="34" charset="-122"/>
+                <a:cs typeface="Optimist Sans" pitchFamily="34" charset="-120"/>
+              </a:rPr>
+              <a:t>’28</a:t>
+            </a:r>
+            <a:endParaRPr lang="en-US" sz="1200" dirty="0"/>
+          </a:p>
+        </p:txBody>
+      </p:sp>
+      <p:sp>
+        <p:nvSpPr>
+          <p:cNvPr id="84" name="Text 82"/>
+          <p:cNvSpPr txBox="1"/>
+          <p:nvPr/>
+        </p:nvSpPr>
+        <p:spPr>
+          <a:xfrm>
+            <a:off x="10083800" y="5524500"/>
+            <a:ext cx="1193800" cy="215900"/>
+          </a:xfrm>
+          <a:prstGeom prst="rect">
+            <a:avLst/>
+          </a:prstGeom>
+          <a:noFill/>
+          <a:ln/>
+        </p:spPr>
+        <p:txBody>
+          <a:bodyPr wrap="square" lIns="0" tIns="0" rIns="0" bIns="0" rtlCol="0" anchor="t"/>
+          <a:lstStyle/>
+          <a:p>
+            <a:pPr algn="l" indent="0" marL="0">
+              <a:lnSpc>
+                <a:spcPct val="115000"/>
+              </a:lnSpc>
+              <a:buNone/>
+            </a:pPr>
+            <a:r>
+              <a:rPr lang="en-US" sz="1200" b="1" dirty="0">
+                <a:solidFill>
+                  <a:srgbClr val="8A4514"/>
                 </a:solidFill>
                 <a:latin typeface="Optimist Sans" pitchFamily="34" charset="0"/>
                 <a:ea typeface="Optimist Sans" pitchFamily="34" charset="-122"/>
@@ -10042,257 +9782,7 @@
       </p:sp>
       <p:sp>
         <p:nvSpPr>
-          <p:cNvPr id="102" name="Text 100"/>
-          <p:cNvSpPr txBox="1"/>
-          <p:nvPr/>
-        </p:nvSpPr>
-        <p:spPr>
-          <a:xfrm>
-            <a:off x="9829800" y="5588000"/>
-            <a:ext cx="406400" cy="165100"/>
-          </a:xfrm>
-          <a:prstGeom prst="rect">
-            <a:avLst/>
-          </a:prstGeom>
-          <a:noFill/>
-          <a:ln/>
-        </p:spPr>
-        <p:txBody>
-          <a:bodyPr wrap="square" lIns="0" tIns="0" rIns="0" bIns="0" rtlCol="0" anchor="t"/>
-          <a:lstStyle/>
-          <a:p>
-            <a:pPr algn="ctr" indent="0" marL="0">
-              <a:lnSpc>
-                <a:spcPct val="100000"/>
-              </a:lnSpc>
-              <a:buNone/>
-            </a:pPr>
-            <a:r>
-              <a:rPr lang="en-US" sz="1200" dirty="0">
-                <a:solidFill>
-                  <a:srgbClr val="6B7280"/>
-                </a:solidFill>
-                <a:latin typeface="Optimist Sans" pitchFamily="34" charset="0"/>
-                <a:ea typeface="Optimist Sans" pitchFamily="34" charset="-122"/>
-                <a:cs typeface="Optimist Sans" pitchFamily="34" charset="-120"/>
-              </a:rPr>
-              <a:t>’26</a:t>
-            </a:r>
-            <a:endParaRPr lang="en-US" sz="1200" dirty="0"/>
-          </a:p>
-        </p:txBody>
-      </p:sp>
-      <p:sp>
-        <p:nvSpPr>
-          <p:cNvPr id="103" name="Shape 101"/>
-          <p:cNvSpPr/>
-          <p:nvPr/>
-        </p:nvSpPr>
-        <p:spPr>
-          <a:xfrm>
-            <a:off x="10363200" y="5372100"/>
-            <a:ext cx="254000" cy="203200"/>
-          </a:xfrm>
-          <a:prstGeom prst="rect">
-            <a:avLst/>
-          </a:prstGeom>
-          <a:solidFill>
-            <a:srgbClr val="E3A86B"/>
-          </a:solidFill>
-          <a:ln/>
-        </p:spPr>
-      </p:sp>
-      <p:sp>
-        <p:nvSpPr>
-          <p:cNvPr id="104" name="Text 102"/>
-          <p:cNvSpPr txBox="1"/>
-          <p:nvPr/>
-        </p:nvSpPr>
-        <p:spPr>
-          <a:xfrm>
-            <a:off x="10287000" y="5194300"/>
-            <a:ext cx="406400" cy="165100"/>
-          </a:xfrm>
-          <a:prstGeom prst="rect">
-            <a:avLst/>
-          </a:prstGeom>
-          <a:noFill/>
-          <a:ln/>
-        </p:spPr>
-        <p:txBody>
-          <a:bodyPr wrap="square" lIns="0" tIns="0" rIns="0" bIns="0" rtlCol="0" anchor="t"/>
-          <a:lstStyle/>
-          <a:p>
-            <a:pPr algn="ctr" indent="0" marL="0">
-              <a:lnSpc>
-                <a:spcPct val="100000"/>
-              </a:lnSpc>
-              <a:buNone/>
-            </a:pPr>
-            <a:r>
-              <a:rPr lang="en-US" sz="1200" dirty="0">
-                <a:solidFill>
-                  <a:srgbClr val="14213D"/>
-                </a:solidFill>
-                <a:latin typeface="Optimist Sans" pitchFamily="34" charset="0"/>
-                <a:ea typeface="Optimist Sans" pitchFamily="34" charset="-122"/>
-                <a:cs typeface="Optimist Sans" pitchFamily="34" charset="-120"/>
-              </a:rPr>
-              <a:t>[n]</a:t>
-            </a:r>
-            <a:endParaRPr lang="en-US" sz="1200" dirty="0"/>
-          </a:p>
-        </p:txBody>
-      </p:sp>
-      <p:sp>
-        <p:nvSpPr>
-          <p:cNvPr id="105" name="Text 103"/>
-          <p:cNvSpPr txBox="1"/>
-          <p:nvPr/>
-        </p:nvSpPr>
-        <p:spPr>
-          <a:xfrm>
-            <a:off x="10287000" y="5588000"/>
-            <a:ext cx="406400" cy="165100"/>
-          </a:xfrm>
-          <a:prstGeom prst="rect">
-            <a:avLst/>
-          </a:prstGeom>
-          <a:noFill/>
-          <a:ln/>
-        </p:spPr>
-        <p:txBody>
-          <a:bodyPr wrap="square" lIns="0" tIns="0" rIns="0" bIns="0" rtlCol="0" anchor="t"/>
-          <a:lstStyle/>
-          <a:p>
-            <a:pPr algn="ctr" indent="0" marL="0">
-              <a:lnSpc>
-                <a:spcPct val="100000"/>
-              </a:lnSpc>
-              <a:buNone/>
-            </a:pPr>
-            <a:r>
-              <a:rPr lang="en-US" sz="1200" dirty="0">
-                <a:solidFill>
-                  <a:srgbClr val="6B7280"/>
-                </a:solidFill>
-                <a:latin typeface="Optimist Sans" pitchFamily="34" charset="0"/>
-                <a:ea typeface="Optimist Sans" pitchFamily="34" charset="-122"/>
-                <a:cs typeface="Optimist Sans" pitchFamily="34" charset="-120"/>
-              </a:rPr>
-              <a:t>’27</a:t>
-            </a:r>
-            <a:endParaRPr lang="en-US" sz="1200" dirty="0"/>
-          </a:p>
-        </p:txBody>
-      </p:sp>
-      <p:sp>
-        <p:nvSpPr>
-          <p:cNvPr id="106" name="Shape 104"/>
-          <p:cNvSpPr/>
-          <p:nvPr/>
-        </p:nvSpPr>
-        <p:spPr>
-          <a:xfrm>
-            <a:off x="10820400" y="5295900"/>
-            <a:ext cx="254000" cy="279400"/>
-          </a:xfrm>
-          <a:prstGeom prst="rect">
-            <a:avLst/>
-          </a:prstGeom>
-          <a:solidFill>
-            <a:srgbClr val="E3A86B"/>
-          </a:solidFill>
-          <a:ln/>
-        </p:spPr>
-      </p:sp>
-      <p:sp>
-        <p:nvSpPr>
-          <p:cNvPr id="107" name="Text 105"/>
-          <p:cNvSpPr txBox="1"/>
-          <p:nvPr/>
-        </p:nvSpPr>
-        <p:spPr>
-          <a:xfrm>
-            <a:off x="10744200" y="5118100"/>
-            <a:ext cx="406400" cy="165100"/>
-          </a:xfrm>
-          <a:prstGeom prst="rect">
-            <a:avLst/>
-          </a:prstGeom>
-          <a:noFill/>
-          <a:ln/>
-        </p:spPr>
-        <p:txBody>
-          <a:bodyPr wrap="square" lIns="0" tIns="0" rIns="0" bIns="0" rtlCol="0" anchor="t"/>
-          <a:lstStyle/>
-          <a:p>
-            <a:pPr algn="ctr" indent="0" marL="0">
-              <a:lnSpc>
-                <a:spcPct val="100000"/>
-              </a:lnSpc>
-              <a:buNone/>
-            </a:pPr>
-            <a:r>
-              <a:rPr lang="en-US" sz="1200" dirty="0">
-                <a:solidFill>
-                  <a:srgbClr val="14213D"/>
-                </a:solidFill>
-                <a:latin typeface="Optimist Sans" pitchFamily="34" charset="0"/>
-                <a:ea typeface="Optimist Sans" pitchFamily="34" charset="-122"/>
-                <a:cs typeface="Optimist Sans" pitchFamily="34" charset="-120"/>
-              </a:rPr>
-              <a:t>[n]</a:t>
-            </a:r>
-            <a:endParaRPr lang="en-US" sz="1200" dirty="0"/>
-          </a:p>
-        </p:txBody>
-      </p:sp>
-      <p:sp>
-        <p:nvSpPr>
-          <p:cNvPr id="108" name="Text 106"/>
-          <p:cNvSpPr txBox="1"/>
-          <p:nvPr/>
-        </p:nvSpPr>
-        <p:spPr>
-          <a:xfrm>
-            <a:off x="10744200" y="5588000"/>
-            <a:ext cx="406400" cy="165100"/>
-          </a:xfrm>
-          <a:prstGeom prst="rect">
-            <a:avLst/>
-          </a:prstGeom>
-          <a:noFill/>
-          <a:ln/>
-        </p:spPr>
-        <p:txBody>
-          <a:bodyPr wrap="square" lIns="0" tIns="0" rIns="0" bIns="0" rtlCol="0" anchor="t"/>
-          <a:lstStyle/>
-          <a:p>
-            <a:pPr algn="ctr" indent="0" marL="0">
-              <a:lnSpc>
-                <a:spcPct val="100000"/>
-              </a:lnSpc>
-              <a:buNone/>
-            </a:pPr>
-            <a:r>
-              <a:rPr lang="en-US" sz="1200" dirty="0">
-                <a:solidFill>
-                  <a:srgbClr val="6B7280"/>
-                </a:solidFill>
-                <a:latin typeface="Optimist Sans" pitchFamily="34" charset="0"/>
-                <a:ea typeface="Optimist Sans" pitchFamily="34" charset="-122"/>
-                <a:cs typeface="Optimist Sans" pitchFamily="34" charset="-120"/>
-              </a:rPr>
-              <a:t>’28</a:t>
-            </a:r>
-            <a:endParaRPr lang="en-US" sz="1200" dirty="0"/>
-          </a:p>
-        </p:txBody>
-      </p:sp>
-      <p:sp>
-        <p:nvSpPr>
-          <p:cNvPr id="109" name="Text 107"/>
+          <p:cNvPr id="85" name="Text 83"/>
           <p:cNvSpPr txBox="1"/>
           <p:nvPr/>
         </p:nvSpPr>
@@ -10326,7 +9816,7 @@
                 <a:ea typeface="Optimist Sans" pitchFamily="34" charset="-122"/>
                 <a:cs typeface="Optimist Sans" pitchFamily="34" charset="-120"/>
               </a:rPr>
-              <a:t>Draft for discussion · Bars show planned team size at year-end ’26, ’27, ’28 (illustrative)</a:t>
+              <a:t>Draft for discussion · Year-end headcount; open roles in parentheses</a:t>
             </a:r>
             <a:endParaRPr lang="en-US" sz="1200" dirty="0"/>
           </a:p>

</xml_diff>

<commit_message>
Org detail: list members by level, compact year-end headcount strip
Co-Authored-By: Claude Opus 5.5 <noreply@anthropic.com>
Claude-Session: https://claude.ai/code/session_01JXKaD9UU8MgeRWUr7sq4Za
</commit_message>
<xml_diff>
--- a/Unified Team Strategy.pptx
+++ b/Unified Team Strategy.pptx
@@ -116,13 +116,13 @@
   <p:extLst>
     <p:ext uri="{521415D9-36F7-43E2-AB2F-B90AF26B5E84}">
       <p14:sectionLst xmlns:p14="http://schemas.microsoft.com/office/powerpoint/2010/main">
-        <p14:section name="Why combine" id="{5cd9def0-031c-07e9-e2cd-894518d77e06}">
+        <p14:section name="Why combine" id="{938cc258-6560-3efd-8c07-a25870967155}">
           <p14:sldIdLst>
             <p14:sldId id="256"/>
             <p14:sldId id="257"/>
           </p14:sldIdLst>
         </p14:section>
-        <p14:section name="How we organize" id="{0c7e561f-c58b-6a0d-e143-fcdc241b7120}">
+        <p14:section name="How we organize" id="{eaaba427-264d-9d14-daaa-4086c0e3ddea}">
           <p14:sldIdLst>
             <p14:sldId id="258"/>
             <p14:sldId id="259"/>
@@ -130,14 +130,14 @@
             <p14:sldId id="261"/>
           </p14:sldIdLst>
         </p14:section>
-        <p14:section name="What we do and how we grow" id="{b9c3c889-d034-c044-a716-d58821b5c1d0}">
+        <p14:section name="What we do and how we grow" id="{393b95de-0777-e44f-4343-396f7d9ba639}">
           <p14:sldIdLst>
             <p14:sldId id="262"/>
             <p14:sldId id="263"/>
             <p14:sldId id="264"/>
           </p14:sldIdLst>
         </p14:section>
-        <p14:section name="Asks" id="{a681bac5-2d66-2f38-fe2b-83122850330a}">
+        <p14:section name="Asks" id="{992e1d88-655b-a0eb-b1ee-26486d20bc59}">
           <p14:sldIdLst>
             <p14:sldId id="265"/>
           </p14:sldIdLst>
@@ -898,7 +898,7 @@
           <a:p>
             <a:r>
               <a:rPr lang="en-US" dirty="0"/>
-              <a:t>This slide turns the four-function structure into the actual team: one team lead, four sub-team heads, and three sub-teams under Modeling, each with its own lead and level. Each box lists who is on the team, then year-end headcount: this year’s total with open roles to backfill in parentheses, and the planned size at the end of next year and the year after. Modeling, Data Foundation and Platform &amp; Deployment get smaller over time as AI takes on BAU work; AI Enablement grows. The next slide rolls these team-level numbers up into the overall picture.</a:t>
+              <a:t>This slide turns the four-function structure into the actual team: one team lead, four sub-team heads, and three sub-teams under Modeling, each with its own lead and level. Each box lists every member with their level, including open roles to backfill, then a small bar strip with year-end headcount for this year, next year and the year after. Modeling, Data Foundation and Platform &amp; Deployment get smaller over time as AI takes on BAU work; AI Enablement grows. The next slide rolls these team-level numbers up into the overall picture.</a:t>
             </a:r>
             <a:endParaRPr lang="en-US" dirty="0"/>
           </a:p>
@@ -7301,7 +7301,7 @@
                 <a:ea typeface="Optimist Sans" pitchFamily="34" charset="-122"/>
                 <a:cs typeface="Optimist Sans" pitchFamily="34" charset="-120"/>
               </a:rPr>
-              <a:t>[Name] ([SM])</a:t>
+              <a:t>Name [SM]</a:t>
             </a:r>
             <a:endParaRPr lang="en-US" sz="1200" dirty="0"/>
           </a:p>
@@ -7390,7 +7390,7 @@
                 <a:ea typeface="Optimist Sans" pitchFamily="34" charset="-122"/>
                 <a:cs typeface="Optimist Sans" pitchFamily="34" charset="-120"/>
               </a:rPr>
-              <a:t>[Name] ([SM])</a:t>
+              <a:t>[Name] [SM]</a:t>
             </a:r>
             <a:endParaRPr lang="en-US" sz="1200" dirty="0"/>
           </a:p>
@@ -7479,7 +7479,7 @@
                 <a:ea typeface="Optimist Sans" pitchFamily="34" charset="-122"/>
                 <a:cs typeface="Optimist Sans" pitchFamily="34" charset="-120"/>
               </a:rPr>
-              <a:t>[Name] ([D/SM])</a:t>
+              <a:t>[Name] [D/SM]</a:t>
             </a:r>
             <a:endParaRPr lang="en-US" sz="1200" dirty="0"/>
           </a:p>
@@ -7568,7 +7568,7 @@
                 <a:ea typeface="Optimist Sans" pitchFamily="34" charset="-122"/>
                 <a:cs typeface="Optimist Sans" pitchFamily="34" charset="-120"/>
               </a:rPr>
-              <a:t>[Name] ([SM])</a:t>
+              <a:t>[Name] [SM]</a:t>
             </a:r>
             <a:endParaRPr lang="en-US" sz="1200" dirty="0"/>
           </a:p>
@@ -7657,7 +7657,7 @@
                 <a:ea typeface="Optimist Sans" pitchFamily="34" charset="-122"/>
                 <a:cs typeface="Optimist Sans" pitchFamily="34" charset="-120"/>
               </a:rPr>
-              <a:t>[Name] ([M])</a:t>
+              <a:t>[Name] [M]</a:t>
             </a:r>
             <a:endParaRPr lang="en-US" sz="1200" dirty="0"/>
           </a:p>
@@ -7746,7 +7746,7 @@
                 <a:ea typeface="Optimist Sans" pitchFamily="34" charset="-122"/>
                 <a:cs typeface="Optimist Sans" pitchFamily="34" charset="-120"/>
               </a:rPr>
-              <a:t>[Name] ([M])</a:t>
+              <a:t>[Name] [M]</a:t>
             </a:r>
             <a:endParaRPr lang="en-US" sz="1200" dirty="0"/>
           </a:p>
@@ -7788,21 +7788,21 @@
         <p:spPr>
           <a:xfrm>
             <a:off x="914400" y="4521200"/>
-            <a:ext cx="1320800" cy="406400"/>
-          </a:xfrm>
-          <a:prstGeom prst="rect">
-            <a:avLst/>
-          </a:prstGeom>
-          <a:noFill/>
-          <a:ln/>
-        </p:spPr>
-        <p:txBody>
-          <a:bodyPr wrap="square" lIns="0" tIns="0" rIns="0" bIns="0" rtlCol="0" anchor="t"/>
-          <a:lstStyle/>
-          <a:p>
-            <a:pPr algn="l" indent="0" marL="0">
-              <a:lnSpc>
-                <a:spcPct val="115000"/>
+            <a:ext cx="1320800" cy="590550"/>
+          </a:xfrm>
+          <a:prstGeom prst="rect">
+            <a:avLst/>
+          </a:prstGeom>
+          <a:noFill/>
+          <a:ln/>
+        </p:spPr>
+        <p:txBody>
+          <a:bodyPr wrap="square" lIns="0" tIns="0" rIns="0" bIns="0" rtlCol="0" anchor="t"/>
+          <a:lstStyle/>
+          <a:p>
+            <a:pPr algn="l" indent="0" marL="0">
+              <a:lnSpc>
+                <a:spcPct val="105000"/>
               </a:lnSpc>
               <a:buNone/>
             </a:pPr>
@@ -7815,42 +7815,167 @@
                 <a:ea typeface="Optimist Sans" pitchFamily="34" charset="-122"/>
                 <a:cs typeface="Optimist Sans" pitchFamily="34" charset="-120"/>
               </a:rPr>
-              <a:t>[Name], [Name], [Name], …</a:t>
-            </a:r>
-            <a:endParaRPr lang="en-US" sz="1200" dirty="0"/>
-          </a:p>
-        </p:txBody>
-      </p:sp>
-      <p:sp>
-        <p:nvSpPr>
-          <p:cNvPr id="39" name="Text 37"/>
-          <p:cNvSpPr txBox="1"/>
-          <p:nvPr/>
-        </p:nvSpPr>
-        <p:spPr>
-          <a:xfrm>
-            <a:off x="914400" y="5067300"/>
-            <a:ext cx="304800" cy="215900"/>
-          </a:xfrm>
-          <a:prstGeom prst="rect">
-            <a:avLst/>
-          </a:prstGeom>
-          <a:noFill/>
-          <a:ln/>
-        </p:spPr>
-        <p:txBody>
-          <a:bodyPr wrap="square" lIns="0" tIns="0" rIns="0" bIns="0" rtlCol="0" anchor="t"/>
-          <a:lstStyle/>
-          <a:p>
-            <a:pPr algn="l" indent="0" marL="0">
-              <a:lnSpc>
-                <a:spcPct val="115000"/>
+              <a:t>[Name] [Lvl]</a:t>
+            </a:r>
+            <a:endParaRPr lang="en-US" sz="1200" dirty="0"/>
+          </a:p>
+          <a:p>
+            <a:pPr algn="l" indent="0" marL="0">
+              <a:lnSpc>
+                <a:spcPct val="105000"/>
               </a:lnSpc>
               <a:buNone/>
             </a:pPr>
             <a:r>
               <a:rPr lang="en-US" sz="1200" dirty="0">
                 <a:solidFill>
+                  <a:srgbClr val="4A5568"/>
+                </a:solidFill>
+                <a:latin typeface="Optimist Sans" pitchFamily="34" charset="0"/>
+                <a:ea typeface="Optimist Sans" pitchFamily="34" charset="-122"/>
+                <a:cs typeface="Optimist Sans" pitchFamily="34" charset="-120"/>
+              </a:rPr>
+              <a:t>[Name] [Lvl]</a:t>
+            </a:r>
+            <a:endParaRPr lang="en-US" sz="1200" dirty="0"/>
+          </a:p>
+          <a:p>
+            <a:pPr algn="l" indent="0" marL="0">
+              <a:lnSpc>
+                <a:spcPct val="105000"/>
+              </a:lnSpc>
+              <a:buNone/>
+            </a:pPr>
+            <a:r>
+              <a:rPr lang="en-US" sz="1200" dirty="0">
+                <a:solidFill>
+                  <a:srgbClr val="4A5568"/>
+                </a:solidFill>
+                <a:latin typeface="Optimist Sans" pitchFamily="34" charset="0"/>
+                <a:ea typeface="Optimist Sans" pitchFamily="34" charset="-122"/>
+                <a:cs typeface="Optimist Sans" pitchFamily="34" charset="-120"/>
+              </a:rPr>
+              <a:t>[Opening] [Lvl]</a:t>
+            </a:r>
+            <a:endParaRPr lang="en-US" sz="1200" dirty="0"/>
+          </a:p>
+        </p:txBody>
+      </p:sp>
+      <p:sp>
+        <p:nvSpPr>
+          <p:cNvPr id="39" name="Shape 37"/>
+          <p:cNvSpPr/>
+          <p:nvPr/>
+        </p:nvSpPr>
+        <p:spPr>
+          <a:xfrm>
+            <a:off x="914400" y="5213350"/>
+            <a:ext cx="1320800" cy="914"/>
+          </a:xfrm>
+          <a:prstGeom prst="line">
+            <a:avLst/>
+          </a:prstGeom>
+          <a:noFill/>
+          <a:ln w="12700">
+            <a:solidFill>
+              <a:srgbClr val="E3DED2"/>
+            </a:solidFill>
+            <a:prstDash val="solid"/>
+          </a:ln>
+        </p:spPr>
+      </p:sp>
+      <p:sp>
+        <p:nvSpPr>
+          <p:cNvPr id="40" name="Shape 38"/>
+          <p:cNvSpPr/>
+          <p:nvPr/>
+        </p:nvSpPr>
+        <p:spPr>
+          <a:xfrm>
+            <a:off x="1066800" y="5264150"/>
+            <a:ext cx="203200" cy="152400"/>
+          </a:xfrm>
+          <a:prstGeom prst="rect">
+            <a:avLst/>
+          </a:prstGeom>
+          <a:solidFill>
+            <a:srgbClr val="1F6F7E"/>
+          </a:solidFill>
+          <a:ln/>
+        </p:spPr>
+      </p:sp>
+      <p:sp>
+        <p:nvSpPr>
+          <p:cNvPr id="41" name="Text 39"/>
+          <p:cNvSpPr txBox="1"/>
+          <p:nvPr/>
+        </p:nvSpPr>
+        <p:spPr>
+          <a:xfrm>
+            <a:off x="990600" y="5429250"/>
+            <a:ext cx="355600" cy="165100"/>
+          </a:xfrm>
+          <a:prstGeom prst="rect">
+            <a:avLst/>
+          </a:prstGeom>
+          <a:noFill/>
+          <a:ln/>
+        </p:spPr>
+        <p:txBody>
+          <a:bodyPr wrap="square" lIns="0" tIns="0" rIns="0" bIns="0" rtlCol="0" anchor="t"/>
+          <a:lstStyle/>
+          <a:p>
+            <a:pPr algn="ctr" indent="0" marL="0">
+              <a:lnSpc>
+                <a:spcPct val="100000"/>
+              </a:lnSpc>
+              <a:buNone/>
+            </a:pPr>
+            <a:r>
+              <a:rPr lang="en-US" sz="1200" b="1" dirty="0">
+                <a:solidFill>
+                  <a:srgbClr val="14213D"/>
+                </a:solidFill>
+                <a:latin typeface="Optimist Sans" pitchFamily="34" charset="0"/>
+                <a:ea typeface="Optimist Sans" pitchFamily="34" charset="-122"/>
+                <a:cs typeface="Optimist Sans" pitchFamily="34" charset="-120"/>
+              </a:rPr>
+              <a:t>[n]</a:t>
+            </a:r>
+            <a:endParaRPr lang="en-US" sz="1200" dirty="0"/>
+          </a:p>
+        </p:txBody>
+      </p:sp>
+      <p:sp>
+        <p:nvSpPr>
+          <p:cNvPr id="42" name="Text 40"/>
+          <p:cNvSpPr txBox="1"/>
+          <p:nvPr/>
+        </p:nvSpPr>
+        <p:spPr>
+          <a:xfrm>
+            <a:off x="990600" y="5600700"/>
+            <a:ext cx="355600" cy="165100"/>
+          </a:xfrm>
+          <a:prstGeom prst="rect">
+            <a:avLst/>
+          </a:prstGeom>
+          <a:noFill/>
+          <a:ln/>
+        </p:spPr>
+        <p:txBody>
+          <a:bodyPr wrap="square" lIns="0" tIns="0" rIns="0" bIns="0" rtlCol="0" anchor="t"/>
+          <a:lstStyle/>
+          <a:p>
+            <a:pPr algn="ctr" indent="0" marL="0">
+              <a:lnSpc>
+                <a:spcPct val="100000"/>
+              </a:lnSpc>
+              <a:buNone/>
+            </a:pPr>
+            <a:r>
+              <a:rPr lang="en-US" sz="1200" dirty="0">
+                <a:solidFill>
                   <a:srgbClr val="6B7280"/>
                 </a:solidFill>
                 <a:latin typeface="Optimist Sans" pitchFamily="34" charset="0"/>
@@ -7865,28 +7990,48 @@
       </p:sp>
       <p:sp>
         <p:nvSpPr>
-          <p:cNvPr id="40" name="Text 38"/>
-          <p:cNvSpPr txBox="1"/>
-          <p:nvPr/>
-        </p:nvSpPr>
-        <p:spPr>
-          <a:xfrm>
-            <a:off x="1295400" y="5067300"/>
-            <a:ext cx="939800" cy="215900"/>
-          </a:xfrm>
-          <a:prstGeom prst="rect">
-            <a:avLst/>
-          </a:prstGeom>
-          <a:noFill/>
-          <a:ln/>
-        </p:spPr>
-        <p:txBody>
-          <a:bodyPr wrap="square" lIns="0" tIns="0" rIns="0" bIns="0" rtlCol="0" anchor="t"/>
-          <a:lstStyle/>
-          <a:p>
-            <a:pPr algn="l" indent="0" marL="0">
-              <a:lnSpc>
-                <a:spcPct val="115000"/>
+          <p:cNvPr id="43" name="Shape 41"/>
+          <p:cNvSpPr/>
+          <p:nvPr/>
+        </p:nvSpPr>
+        <p:spPr>
+          <a:xfrm>
+            <a:off x="1473200" y="5302250"/>
+            <a:ext cx="203200" cy="114300"/>
+          </a:xfrm>
+          <a:prstGeom prst="rect">
+            <a:avLst/>
+          </a:prstGeom>
+          <a:solidFill>
+            <a:srgbClr val="1F6F7E"/>
+          </a:solidFill>
+          <a:ln/>
+        </p:spPr>
+      </p:sp>
+      <p:sp>
+        <p:nvSpPr>
+          <p:cNvPr id="44" name="Text 42"/>
+          <p:cNvSpPr txBox="1"/>
+          <p:nvPr/>
+        </p:nvSpPr>
+        <p:spPr>
+          <a:xfrm>
+            <a:off x="1397000" y="5429250"/>
+            <a:ext cx="355600" cy="165100"/>
+          </a:xfrm>
+          <a:prstGeom prst="rect">
+            <a:avLst/>
+          </a:prstGeom>
+          <a:noFill/>
+          <a:ln/>
+        </p:spPr>
+        <p:txBody>
+          <a:bodyPr wrap="square" lIns="0" tIns="0" rIns="0" bIns="0" rtlCol="0" anchor="t"/>
+          <a:lstStyle/>
+          <a:p>
+            <a:pPr algn="ctr" indent="0" marL="0">
+              <a:lnSpc>
+                <a:spcPct val="100000"/>
               </a:lnSpc>
               <a:buNone/>
             </a:pPr>
@@ -7899,11 +8044,36 @@
                 <a:ea typeface="Optimist Sans" pitchFamily="34" charset="-122"/>
                 <a:cs typeface="Optimist Sans" pitchFamily="34" charset="-120"/>
               </a:rPr>
-              <a:t>[n] </a:t>
-            </a:r>
-            <a:pPr algn="l" indent="0" marL="0">
-              <a:lnSpc>
-                <a:spcPct val="115000"/>
+              <a:t>[n]</a:t>
+            </a:r>
+            <a:endParaRPr lang="en-US" sz="1200" dirty="0"/>
+          </a:p>
+        </p:txBody>
+      </p:sp>
+      <p:sp>
+        <p:nvSpPr>
+          <p:cNvPr id="45" name="Text 43"/>
+          <p:cNvSpPr txBox="1"/>
+          <p:nvPr/>
+        </p:nvSpPr>
+        <p:spPr>
+          <a:xfrm>
+            <a:off x="1397000" y="5600700"/>
+            <a:ext cx="355600" cy="165100"/>
+          </a:xfrm>
+          <a:prstGeom prst="rect">
+            <a:avLst/>
+          </a:prstGeom>
+          <a:noFill/>
+          <a:ln/>
+        </p:spPr>
+        <p:txBody>
+          <a:bodyPr wrap="square" lIns="0" tIns="0" rIns="0" bIns="0" rtlCol="0" anchor="t"/>
+          <a:lstStyle/>
+          <a:p>
+            <a:pPr algn="ctr" indent="0" marL="0">
+              <a:lnSpc>
+                <a:spcPct val="100000"/>
               </a:lnSpc>
               <a:buNone/>
             </a:pPr>
@@ -7916,36 +8086,98 @@
                 <a:ea typeface="Optimist Sans" pitchFamily="34" charset="-122"/>
                 <a:cs typeface="Optimist Sans" pitchFamily="34" charset="-120"/>
               </a:rPr>
-              <a:t>([n])</a:t>
-            </a:r>
-            <a:endParaRPr lang="en-US" sz="1200" dirty="0"/>
-          </a:p>
-        </p:txBody>
-      </p:sp>
-      <p:sp>
-        <p:nvSpPr>
-          <p:cNvPr id="41" name="Text 39"/>
-          <p:cNvSpPr txBox="1"/>
-          <p:nvPr/>
-        </p:nvSpPr>
-        <p:spPr>
-          <a:xfrm>
-            <a:off x="914400" y="5295900"/>
-            <a:ext cx="304800" cy="215900"/>
-          </a:xfrm>
-          <a:prstGeom prst="rect">
-            <a:avLst/>
-          </a:prstGeom>
-          <a:noFill/>
-          <a:ln/>
-        </p:spPr>
-        <p:txBody>
-          <a:bodyPr wrap="square" lIns="0" tIns="0" rIns="0" bIns="0" rtlCol="0" anchor="t"/>
-          <a:lstStyle/>
-          <a:p>
-            <a:pPr algn="l" indent="0" marL="0">
-              <a:lnSpc>
-                <a:spcPct val="115000"/>
+              <a:t>’27</a:t>
+            </a:r>
+            <a:endParaRPr lang="en-US" sz="1200" dirty="0"/>
+          </a:p>
+        </p:txBody>
+      </p:sp>
+      <p:sp>
+        <p:nvSpPr>
+          <p:cNvPr id="46" name="Shape 44"/>
+          <p:cNvSpPr/>
+          <p:nvPr/>
+        </p:nvSpPr>
+        <p:spPr>
+          <a:xfrm>
+            <a:off x="1879600" y="5340350"/>
+            <a:ext cx="203200" cy="76200"/>
+          </a:xfrm>
+          <a:prstGeom prst="rect">
+            <a:avLst/>
+          </a:prstGeom>
+          <a:solidFill>
+            <a:srgbClr val="1F6F7E"/>
+          </a:solidFill>
+          <a:ln/>
+        </p:spPr>
+      </p:sp>
+      <p:sp>
+        <p:nvSpPr>
+          <p:cNvPr id="47" name="Text 45"/>
+          <p:cNvSpPr txBox="1"/>
+          <p:nvPr/>
+        </p:nvSpPr>
+        <p:spPr>
+          <a:xfrm>
+            <a:off x="1803400" y="5429250"/>
+            <a:ext cx="355600" cy="165100"/>
+          </a:xfrm>
+          <a:prstGeom prst="rect">
+            <a:avLst/>
+          </a:prstGeom>
+          <a:noFill/>
+          <a:ln/>
+        </p:spPr>
+        <p:txBody>
+          <a:bodyPr wrap="square" lIns="0" tIns="0" rIns="0" bIns="0" rtlCol="0" anchor="t"/>
+          <a:lstStyle/>
+          <a:p>
+            <a:pPr algn="ctr" indent="0" marL="0">
+              <a:lnSpc>
+                <a:spcPct val="100000"/>
+              </a:lnSpc>
+              <a:buNone/>
+            </a:pPr>
+            <a:r>
+              <a:rPr lang="en-US" sz="1200" b="1" dirty="0">
+                <a:solidFill>
+                  <a:srgbClr val="14213D"/>
+                </a:solidFill>
+                <a:latin typeface="Optimist Sans" pitchFamily="34" charset="0"/>
+                <a:ea typeface="Optimist Sans" pitchFamily="34" charset="-122"/>
+                <a:cs typeface="Optimist Sans" pitchFamily="34" charset="-120"/>
+              </a:rPr>
+              <a:t>[n]</a:t>
+            </a:r>
+            <a:endParaRPr lang="en-US" sz="1200" dirty="0"/>
+          </a:p>
+        </p:txBody>
+      </p:sp>
+      <p:sp>
+        <p:nvSpPr>
+          <p:cNvPr id="48" name="Text 46"/>
+          <p:cNvSpPr txBox="1"/>
+          <p:nvPr/>
+        </p:nvSpPr>
+        <p:spPr>
+          <a:xfrm>
+            <a:off x="1803400" y="5600700"/>
+            <a:ext cx="355600" cy="165100"/>
+          </a:xfrm>
+          <a:prstGeom prst="rect">
+            <a:avLst/>
+          </a:prstGeom>
+          <a:noFill/>
+          <a:ln/>
+        </p:spPr>
+        <p:txBody>
+          <a:bodyPr wrap="square" lIns="0" tIns="0" rIns="0" bIns="0" rtlCol="0" anchor="t"/>
+          <a:lstStyle/>
+          <a:p>
+            <a:pPr algn="ctr" indent="0" marL="0">
+              <a:lnSpc>
+                <a:spcPct val="100000"/>
               </a:lnSpc>
               <a:buNone/>
             </a:pPr>
@@ -7958,90 +8190,6 @@
                 <a:ea typeface="Optimist Sans" pitchFamily="34" charset="-122"/>
                 <a:cs typeface="Optimist Sans" pitchFamily="34" charset="-120"/>
               </a:rPr>
-              <a:t>’27</a:t>
-            </a:r>
-            <a:endParaRPr lang="en-US" sz="1200" dirty="0"/>
-          </a:p>
-        </p:txBody>
-      </p:sp>
-      <p:sp>
-        <p:nvSpPr>
-          <p:cNvPr id="42" name="Text 40"/>
-          <p:cNvSpPr txBox="1"/>
-          <p:nvPr/>
-        </p:nvSpPr>
-        <p:spPr>
-          <a:xfrm>
-            <a:off x="1295400" y="5295900"/>
-            <a:ext cx="939800" cy="215900"/>
-          </a:xfrm>
-          <a:prstGeom prst="rect">
-            <a:avLst/>
-          </a:prstGeom>
-          <a:noFill/>
-          <a:ln/>
-        </p:spPr>
-        <p:txBody>
-          <a:bodyPr wrap="square" lIns="0" tIns="0" rIns="0" bIns="0" rtlCol="0" anchor="t"/>
-          <a:lstStyle/>
-          <a:p>
-            <a:pPr algn="l" indent="0" marL="0">
-              <a:lnSpc>
-                <a:spcPct val="115000"/>
-              </a:lnSpc>
-              <a:buNone/>
-            </a:pPr>
-            <a:r>
-              <a:rPr lang="en-US" sz="1200" b="1" dirty="0">
-                <a:solidFill>
-                  <a:srgbClr val="14213D"/>
-                </a:solidFill>
-                <a:latin typeface="Optimist Sans" pitchFamily="34" charset="0"/>
-                <a:ea typeface="Optimist Sans" pitchFamily="34" charset="-122"/>
-                <a:cs typeface="Optimist Sans" pitchFamily="34" charset="-120"/>
-              </a:rPr>
-              <a:t>[n]</a:t>
-            </a:r>
-            <a:endParaRPr lang="en-US" sz="1200" dirty="0"/>
-          </a:p>
-        </p:txBody>
-      </p:sp>
-      <p:sp>
-        <p:nvSpPr>
-          <p:cNvPr id="43" name="Text 41"/>
-          <p:cNvSpPr txBox="1"/>
-          <p:nvPr/>
-        </p:nvSpPr>
-        <p:spPr>
-          <a:xfrm>
-            <a:off x="914400" y="5524500"/>
-            <a:ext cx="304800" cy="215900"/>
-          </a:xfrm>
-          <a:prstGeom prst="rect">
-            <a:avLst/>
-          </a:prstGeom>
-          <a:noFill/>
-          <a:ln/>
-        </p:spPr>
-        <p:txBody>
-          <a:bodyPr wrap="square" lIns="0" tIns="0" rIns="0" bIns="0" rtlCol="0" anchor="t"/>
-          <a:lstStyle/>
-          <a:p>
-            <a:pPr algn="l" indent="0" marL="0">
-              <a:lnSpc>
-                <a:spcPct val="115000"/>
-              </a:lnSpc>
-              <a:buNone/>
-            </a:pPr>
-            <a:r>
-              <a:rPr lang="en-US" sz="1200" dirty="0">
-                <a:solidFill>
-                  <a:srgbClr val="6B7280"/>
-                </a:solidFill>
-                <a:latin typeface="Optimist Sans" pitchFamily="34" charset="0"/>
-                <a:ea typeface="Optimist Sans" pitchFamily="34" charset="-122"/>
-                <a:cs typeface="Optimist Sans" pitchFamily="34" charset="-120"/>
-              </a:rPr>
               <a:t>’28</a:t>
             </a:r>
             <a:endParaRPr lang="en-US" sz="1200" dirty="0"/>
@@ -8050,49 +8198,7 @@
       </p:sp>
       <p:sp>
         <p:nvSpPr>
-          <p:cNvPr id="44" name="Text 42"/>
-          <p:cNvSpPr txBox="1"/>
-          <p:nvPr/>
-        </p:nvSpPr>
-        <p:spPr>
-          <a:xfrm>
-            <a:off x="1295400" y="5524500"/>
-            <a:ext cx="939800" cy="215900"/>
-          </a:xfrm>
-          <a:prstGeom prst="rect">
-            <a:avLst/>
-          </a:prstGeom>
-          <a:noFill/>
-          <a:ln/>
-        </p:spPr>
-        <p:txBody>
-          <a:bodyPr wrap="square" lIns="0" tIns="0" rIns="0" bIns="0" rtlCol="0" anchor="t"/>
-          <a:lstStyle/>
-          <a:p>
-            <a:pPr algn="l" indent="0" marL="0">
-              <a:lnSpc>
-                <a:spcPct val="115000"/>
-              </a:lnSpc>
-              <a:buNone/>
-            </a:pPr>
-            <a:r>
-              <a:rPr lang="en-US" sz="1200" b="1" dirty="0">
-                <a:solidFill>
-                  <a:srgbClr val="14213D"/>
-                </a:solidFill>
-                <a:latin typeface="Optimist Sans" pitchFamily="34" charset="0"/>
-                <a:ea typeface="Optimist Sans" pitchFamily="34" charset="-122"/>
-                <a:cs typeface="Optimist Sans" pitchFamily="34" charset="-120"/>
-              </a:rPr>
-              <a:t>[n]</a:t>
-            </a:r>
-            <a:endParaRPr lang="en-US" sz="1200" dirty="0"/>
-          </a:p>
-        </p:txBody>
-      </p:sp>
-      <p:sp>
-        <p:nvSpPr>
-          <p:cNvPr id="45" name="Shape 43"/>
+          <p:cNvPr id="49" name="Shape 47"/>
           <p:cNvSpPr/>
           <p:nvPr/>
         </p:nvSpPr>
@@ -8119,28 +8225,28 @@
       </p:sp>
       <p:sp>
         <p:nvSpPr>
-          <p:cNvPr id="46" name="Text 44"/>
+          <p:cNvPr id="50" name="Text 48"/>
           <p:cNvSpPr txBox="1"/>
           <p:nvPr/>
         </p:nvSpPr>
         <p:spPr>
           <a:xfrm>
             <a:off x="2540000" y="4521200"/>
-            <a:ext cx="1320800" cy="406400"/>
-          </a:xfrm>
-          <a:prstGeom prst="rect">
-            <a:avLst/>
-          </a:prstGeom>
-          <a:noFill/>
-          <a:ln/>
-        </p:spPr>
-        <p:txBody>
-          <a:bodyPr wrap="square" lIns="0" tIns="0" rIns="0" bIns="0" rtlCol="0" anchor="t"/>
-          <a:lstStyle/>
-          <a:p>
-            <a:pPr algn="l" indent="0" marL="0">
-              <a:lnSpc>
-                <a:spcPct val="115000"/>
+            <a:ext cx="1320800" cy="590550"/>
+          </a:xfrm>
+          <a:prstGeom prst="rect">
+            <a:avLst/>
+          </a:prstGeom>
+          <a:noFill/>
+          <a:ln/>
+        </p:spPr>
+        <p:txBody>
+          <a:bodyPr wrap="square" lIns="0" tIns="0" rIns="0" bIns="0" rtlCol="0" anchor="t"/>
+          <a:lstStyle/>
+          <a:p>
+            <a:pPr algn="l" indent="0" marL="0">
+              <a:lnSpc>
+                <a:spcPct val="105000"/>
               </a:lnSpc>
               <a:buNone/>
             </a:pPr>
@@ -8153,42 +8259,167 @@
                 <a:ea typeface="Optimist Sans" pitchFamily="34" charset="-122"/>
                 <a:cs typeface="Optimist Sans" pitchFamily="34" charset="-120"/>
               </a:rPr>
-              <a:t>[Name], [Name], [Name], …</a:t>
-            </a:r>
-            <a:endParaRPr lang="en-US" sz="1200" dirty="0"/>
-          </a:p>
-        </p:txBody>
-      </p:sp>
-      <p:sp>
-        <p:nvSpPr>
-          <p:cNvPr id="47" name="Text 45"/>
-          <p:cNvSpPr txBox="1"/>
-          <p:nvPr/>
-        </p:nvSpPr>
-        <p:spPr>
-          <a:xfrm>
-            <a:off x="2540000" y="5067300"/>
-            <a:ext cx="304800" cy="215900"/>
-          </a:xfrm>
-          <a:prstGeom prst="rect">
-            <a:avLst/>
-          </a:prstGeom>
-          <a:noFill/>
-          <a:ln/>
-        </p:spPr>
-        <p:txBody>
-          <a:bodyPr wrap="square" lIns="0" tIns="0" rIns="0" bIns="0" rtlCol="0" anchor="t"/>
-          <a:lstStyle/>
-          <a:p>
-            <a:pPr algn="l" indent="0" marL="0">
-              <a:lnSpc>
-                <a:spcPct val="115000"/>
+              <a:t>[Name] [Lvl]</a:t>
+            </a:r>
+            <a:endParaRPr lang="en-US" sz="1200" dirty="0"/>
+          </a:p>
+          <a:p>
+            <a:pPr algn="l" indent="0" marL="0">
+              <a:lnSpc>
+                <a:spcPct val="105000"/>
               </a:lnSpc>
               <a:buNone/>
             </a:pPr>
             <a:r>
               <a:rPr lang="en-US" sz="1200" dirty="0">
                 <a:solidFill>
+                  <a:srgbClr val="4A5568"/>
+                </a:solidFill>
+                <a:latin typeface="Optimist Sans" pitchFamily="34" charset="0"/>
+                <a:ea typeface="Optimist Sans" pitchFamily="34" charset="-122"/>
+                <a:cs typeface="Optimist Sans" pitchFamily="34" charset="-120"/>
+              </a:rPr>
+              <a:t>[Name] [Lvl]</a:t>
+            </a:r>
+            <a:endParaRPr lang="en-US" sz="1200" dirty="0"/>
+          </a:p>
+          <a:p>
+            <a:pPr algn="l" indent="0" marL="0">
+              <a:lnSpc>
+                <a:spcPct val="105000"/>
+              </a:lnSpc>
+              <a:buNone/>
+            </a:pPr>
+            <a:r>
+              <a:rPr lang="en-US" sz="1200" dirty="0">
+                <a:solidFill>
+                  <a:srgbClr val="4A5568"/>
+                </a:solidFill>
+                <a:latin typeface="Optimist Sans" pitchFamily="34" charset="0"/>
+                <a:ea typeface="Optimist Sans" pitchFamily="34" charset="-122"/>
+                <a:cs typeface="Optimist Sans" pitchFamily="34" charset="-120"/>
+              </a:rPr>
+              <a:t>[Opening] [Lvl]</a:t>
+            </a:r>
+            <a:endParaRPr lang="en-US" sz="1200" dirty="0"/>
+          </a:p>
+        </p:txBody>
+      </p:sp>
+      <p:sp>
+        <p:nvSpPr>
+          <p:cNvPr id="51" name="Shape 49"/>
+          <p:cNvSpPr/>
+          <p:nvPr/>
+        </p:nvSpPr>
+        <p:spPr>
+          <a:xfrm>
+            <a:off x="2540000" y="5213350"/>
+            <a:ext cx="1320800" cy="914"/>
+          </a:xfrm>
+          <a:prstGeom prst="line">
+            <a:avLst/>
+          </a:prstGeom>
+          <a:noFill/>
+          <a:ln w="12700">
+            <a:solidFill>
+              <a:srgbClr val="E3DED2"/>
+            </a:solidFill>
+            <a:prstDash val="solid"/>
+          </a:ln>
+        </p:spPr>
+      </p:sp>
+      <p:sp>
+        <p:nvSpPr>
+          <p:cNvPr id="52" name="Shape 50"/>
+          <p:cNvSpPr/>
+          <p:nvPr/>
+        </p:nvSpPr>
+        <p:spPr>
+          <a:xfrm>
+            <a:off x="2692400" y="5264150"/>
+            <a:ext cx="203200" cy="152400"/>
+          </a:xfrm>
+          <a:prstGeom prst="rect">
+            <a:avLst/>
+          </a:prstGeom>
+          <a:solidFill>
+            <a:srgbClr val="1F6F7E"/>
+          </a:solidFill>
+          <a:ln/>
+        </p:spPr>
+      </p:sp>
+      <p:sp>
+        <p:nvSpPr>
+          <p:cNvPr id="53" name="Text 51"/>
+          <p:cNvSpPr txBox="1"/>
+          <p:nvPr/>
+        </p:nvSpPr>
+        <p:spPr>
+          <a:xfrm>
+            <a:off x="2616200" y="5429250"/>
+            <a:ext cx="355600" cy="165100"/>
+          </a:xfrm>
+          <a:prstGeom prst="rect">
+            <a:avLst/>
+          </a:prstGeom>
+          <a:noFill/>
+          <a:ln/>
+        </p:spPr>
+        <p:txBody>
+          <a:bodyPr wrap="square" lIns="0" tIns="0" rIns="0" bIns="0" rtlCol="0" anchor="t"/>
+          <a:lstStyle/>
+          <a:p>
+            <a:pPr algn="ctr" indent="0" marL="0">
+              <a:lnSpc>
+                <a:spcPct val="100000"/>
+              </a:lnSpc>
+              <a:buNone/>
+            </a:pPr>
+            <a:r>
+              <a:rPr lang="en-US" sz="1200" b="1" dirty="0">
+                <a:solidFill>
+                  <a:srgbClr val="14213D"/>
+                </a:solidFill>
+                <a:latin typeface="Optimist Sans" pitchFamily="34" charset="0"/>
+                <a:ea typeface="Optimist Sans" pitchFamily="34" charset="-122"/>
+                <a:cs typeface="Optimist Sans" pitchFamily="34" charset="-120"/>
+              </a:rPr>
+              <a:t>[n]</a:t>
+            </a:r>
+            <a:endParaRPr lang="en-US" sz="1200" dirty="0"/>
+          </a:p>
+        </p:txBody>
+      </p:sp>
+      <p:sp>
+        <p:nvSpPr>
+          <p:cNvPr id="54" name="Text 52"/>
+          <p:cNvSpPr txBox="1"/>
+          <p:nvPr/>
+        </p:nvSpPr>
+        <p:spPr>
+          <a:xfrm>
+            <a:off x="2616200" y="5600700"/>
+            <a:ext cx="355600" cy="165100"/>
+          </a:xfrm>
+          <a:prstGeom prst="rect">
+            <a:avLst/>
+          </a:prstGeom>
+          <a:noFill/>
+          <a:ln/>
+        </p:spPr>
+        <p:txBody>
+          <a:bodyPr wrap="square" lIns="0" tIns="0" rIns="0" bIns="0" rtlCol="0" anchor="t"/>
+          <a:lstStyle/>
+          <a:p>
+            <a:pPr algn="ctr" indent="0" marL="0">
+              <a:lnSpc>
+                <a:spcPct val="100000"/>
+              </a:lnSpc>
+              <a:buNone/>
+            </a:pPr>
+            <a:r>
+              <a:rPr lang="en-US" sz="1200" dirty="0">
+                <a:solidFill>
                   <a:srgbClr val="6B7280"/>
                 </a:solidFill>
                 <a:latin typeface="Optimist Sans" pitchFamily="34" charset="0"/>
@@ -8203,28 +8434,48 @@
       </p:sp>
       <p:sp>
         <p:nvSpPr>
-          <p:cNvPr id="48" name="Text 46"/>
-          <p:cNvSpPr txBox="1"/>
-          <p:nvPr/>
-        </p:nvSpPr>
-        <p:spPr>
-          <a:xfrm>
-            <a:off x="2921000" y="5067300"/>
-            <a:ext cx="939800" cy="215900"/>
-          </a:xfrm>
-          <a:prstGeom prst="rect">
-            <a:avLst/>
-          </a:prstGeom>
-          <a:noFill/>
-          <a:ln/>
-        </p:spPr>
-        <p:txBody>
-          <a:bodyPr wrap="square" lIns="0" tIns="0" rIns="0" bIns="0" rtlCol="0" anchor="t"/>
-          <a:lstStyle/>
-          <a:p>
-            <a:pPr algn="l" indent="0" marL="0">
-              <a:lnSpc>
-                <a:spcPct val="115000"/>
+          <p:cNvPr id="55" name="Shape 53"/>
+          <p:cNvSpPr/>
+          <p:nvPr/>
+        </p:nvSpPr>
+        <p:spPr>
+          <a:xfrm>
+            <a:off x="3098800" y="5302250"/>
+            <a:ext cx="203200" cy="114300"/>
+          </a:xfrm>
+          <a:prstGeom prst="rect">
+            <a:avLst/>
+          </a:prstGeom>
+          <a:solidFill>
+            <a:srgbClr val="1F6F7E"/>
+          </a:solidFill>
+          <a:ln/>
+        </p:spPr>
+      </p:sp>
+      <p:sp>
+        <p:nvSpPr>
+          <p:cNvPr id="56" name="Text 54"/>
+          <p:cNvSpPr txBox="1"/>
+          <p:nvPr/>
+        </p:nvSpPr>
+        <p:spPr>
+          <a:xfrm>
+            <a:off x="3022600" y="5429250"/>
+            <a:ext cx="355600" cy="165100"/>
+          </a:xfrm>
+          <a:prstGeom prst="rect">
+            <a:avLst/>
+          </a:prstGeom>
+          <a:noFill/>
+          <a:ln/>
+        </p:spPr>
+        <p:txBody>
+          <a:bodyPr wrap="square" lIns="0" tIns="0" rIns="0" bIns="0" rtlCol="0" anchor="t"/>
+          <a:lstStyle/>
+          <a:p>
+            <a:pPr algn="ctr" indent="0" marL="0">
+              <a:lnSpc>
+                <a:spcPct val="100000"/>
               </a:lnSpc>
               <a:buNone/>
             </a:pPr>
@@ -8237,11 +8488,36 @@
                 <a:ea typeface="Optimist Sans" pitchFamily="34" charset="-122"/>
                 <a:cs typeface="Optimist Sans" pitchFamily="34" charset="-120"/>
               </a:rPr>
-              <a:t>[n] </a:t>
-            </a:r>
-            <a:pPr algn="l" indent="0" marL="0">
-              <a:lnSpc>
-                <a:spcPct val="115000"/>
+              <a:t>[n]</a:t>
+            </a:r>
+            <a:endParaRPr lang="en-US" sz="1200" dirty="0"/>
+          </a:p>
+        </p:txBody>
+      </p:sp>
+      <p:sp>
+        <p:nvSpPr>
+          <p:cNvPr id="57" name="Text 55"/>
+          <p:cNvSpPr txBox="1"/>
+          <p:nvPr/>
+        </p:nvSpPr>
+        <p:spPr>
+          <a:xfrm>
+            <a:off x="3022600" y="5600700"/>
+            <a:ext cx="355600" cy="165100"/>
+          </a:xfrm>
+          <a:prstGeom prst="rect">
+            <a:avLst/>
+          </a:prstGeom>
+          <a:noFill/>
+          <a:ln/>
+        </p:spPr>
+        <p:txBody>
+          <a:bodyPr wrap="square" lIns="0" tIns="0" rIns="0" bIns="0" rtlCol="0" anchor="t"/>
+          <a:lstStyle/>
+          <a:p>
+            <a:pPr algn="ctr" indent="0" marL="0">
+              <a:lnSpc>
+                <a:spcPct val="100000"/>
               </a:lnSpc>
               <a:buNone/>
             </a:pPr>
@@ -8254,36 +8530,98 @@
                 <a:ea typeface="Optimist Sans" pitchFamily="34" charset="-122"/>
                 <a:cs typeface="Optimist Sans" pitchFamily="34" charset="-120"/>
               </a:rPr>
-              <a:t>([n])</a:t>
-            </a:r>
-            <a:endParaRPr lang="en-US" sz="1200" dirty="0"/>
-          </a:p>
-        </p:txBody>
-      </p:sp>
-      <p:sp>
-        <p:nvSpPr>
-          <p:cNvPr id="49" name="Text 47"/>
-          <p:cNvSpPr txBox="1"/>
-          <p:nvPr/>
-        </p:nvSpPr>
-        <p:spPr>
-          <a:xfrm>
-            <a:off x="2540000" y="5295900"/>
-            <a:ext cx="304800" cy="215900"/>
-          </a:xfrm>
-          <a:prstGeom prst="rect">
-            <a:avLst/>
-          </a:prstGeom>
-          <a:noFill/>
-          <a:ln/>
-        </p:spPr>
-        <p:txBody>
-          <a:bodyPr wrap="square" lIns="0" tIns="0" rIns="0" bIns="0" rtlCol="0" anchor="t"/>
-          <a:lstStyle/>
-          <a:p>
-            <a:pPr algn="l" indent="0" marL="0">
-              <a:lnSpc>
-                <a:spcPct val="115000"/>
+              <a:t>’27</a:t>
+            </a:r>
+            <a:endParaRPr lang="en-US" sz="1200" dirty="0"/>
+          </a:p>
+        </p:txBody>
+      </p:sp>
+      <p:sp>
+        <p:nvSpPr>
+          <p:cNvPr id="58" name="Shape 56"/>
+          <p:cNvSpPr/>
+          <p:nvPr/>
+        </p:nvSpPr>
+        <p:spPr>
+          <a:xfrm>
+            <a:off x="3505200" y="5340350"/>
+            <a:ext cx="203200" cy="76200"/>
+          </a:xfrm>
+          <a:prstGeom prst="rect">
+            <a:avLst/>
+          </a:prstGeom>
+          <a:solidFill>
+            <a:srgbClr val="1F6F7E"/>
+          </a:solidFill>
+          <a:ln/>
+        </p:spPr>
+      </p:sp>
+      <p:sp>
+        <p:nvSpPr>
+          <p:cNvPr id="59" name="Text 57"/>
+          <p:cNvSpPr txBox="1"/>
+          <p:nvPr/>
+        </p:nvSpPr>
+        <p:spPr>
+          <a:xfrm>
+            <a:off x="3429000" y="5429250"/>
+            <a:ext cx="355600" cy="165100"/>
+          </a:xfrm>
+          <a:prstGeom prst="rect">
+            <a:avLst/>
+          </a:prstGeom>
+          <a:noFill/>
+          <a:ln/>
+        </p:spPr>
+        <p:txBody>
+          <a:bodyPr wrap="square" lIns="0" tIns="0" rIns="0" bIns="0" rtlCol="0" anchor="t"/>
+          <a:lstStyle/>
+          <a:p>
+            <a:pPr algn="ctr" indent="0" marL="0">
+              <a:lnSpc>
+                <a:spcPct val="100000"/>
+              </a:lnSpc>
+              <a:buNone/>
+            </a:pPr>
+            <a:r>
+              <a:rPr lang="en-US" sz="1200" b="1" dirty="0">
+                <a:solidFill>
+                  <a:srgbClr val="14213D"/>
+                </a:solidFill>
+                <a:latin typeface="Optimist Sans" pitchFamily="34" charset="0"/>
+                <a:ea typeface="Optimist Sans" pitchFamily="34" charset="-122"/>
+                <a:cs typeface="Optimist Sans" pitchFamily="34" charset="-120"/>
+              </a:rPr>
+              <a:t>[n]</a:t>
+            </a:r>
+            <a:endParaRPr lang="en-US" sz="1200" dirty="0"/>
+          </a:p>
+        </p:txBody>
+      </p:sp>
+      <p:sp>
+        <p:nvSpPr>
+          <p:cNvPr id="60" name="Text 58"/>
+          <p:cNvSpPr txBox="1"/>
+          <p:nvPr/>
+        </p:nvSpPr>
+        <p:spPr>
+          <a:xfrm>
+            <a:off x="3429000" y="5600700"/>
+            <a:ext cx="355600" cy="165100"/>
+          </a:xfrm>
+          <a:prstGeom prst="rect">
+            <a:avLst/>
+          </a:prstGeom>
+          <a:noFill/>
+          <a:ln/>
+        </p:spPr>
+        <p:txBody>
+          <a:bodyPr wrap="square" lIns="0" tIns="0" rIns="0" bIns="0" rtlCol="0" anchor="t"/>
+          <a:lstStyle/>
+          <a:p>
+            <a:pPr algn="ctr" indent="0" marL="0">
+              <a:lnSpc>
+                <a:spcPct val="100000"/>
               </a:lnSpc>
               <a:buNone/>
             </a:pPr>
@@ -8296,90 +8634,6 @@
                 <a:ea typeface="Optimist Sans" pitchFamily="34" charset="-122"/>
                 <a:cs typeface="Optimist Sans" pitchFamily="34" charset="-120"/>
               </a:rPr>
-              <a:t>’27</a:t>
-            </a:r>
-            <a:endParaRPr lang="en-US" sz="1200" dirty="0"/>
-          </a:p>
-        </p:txBody>
-      </p:sp>
-      <p:sp>
-        <p:nvSpPr>
-          <p:cNvPr id="50" name="Text 48"/>
-          <p:cNvSpPr txBox="1"/>
-          <p:nvPr/>
-        </p:nvSpPr>
-        <p:spPr>
-          <a:xfrm>
-            <a:off x="2921000" y="5295900"/>
-            <a:ext cx="939800" cy="215900"/>
-          </a:xfrm>
-          <a:prstGeom prst="rect">
-            <a:avLst/>
-          </a:prstGeom>
-          <a:noFill/>
-          <a:ln/>
-        </p:spPr>
-        <p:txBody>
-          <a:bodyPr wrap="square" lIns="0" tIns="0" rIns="0" bIns="0" rtlCol="0" anchor="t"/>
-          <a:lstStyle/>
-          <a:p>
-            <a:pPr algn="l" indent="0" marL="0">
-              <a:lnSpc>
-                <a:spcPct val="115000"/>
-              </a:lnSpc>
-              <a:buNone/>
-            </a:pPr>
-            <a:r>
-              <a:rPr lang="en-US" sz="1200" b="1" dirty="0">
-                <a:solidFill>
-                  <a:srgbClr val="14213D"/>
-                </a:solidFill>
-                <a:latin typeface="Optimist Sans" pitchFamily="34" charset="0"/>
-                <a:ea typeface="Optimist Sans" pitchFamily="34" charset="-122"/>
-                <a:cs typeface="Optimist Sans" pitchFamily="34" charset="-120"/>
-              </a:rPr>
-              <a:t>[n]</a:t>
-            </a:r>
-            <a:endParaRPr lang="en-US" sz="1200" dirty="0"/>
-          </a:p>
-        </p:txBody>
-      </p:sp>
-      <p:sp>
-        <p:nvSpPr>
-          <p:cNvPr id="51" name="Text 49"/>
-          <p:cNvSpPr txBox="1"/>
-          <p:nvPr/>
-        </p:nvSpPr>
-        <p:spPr>
-          <a:xfrm>
-            <a:off x="2540000" y="5524500"/>
-            <a:ext cx="304800" cy="215900"/>
-          </a:xfrm>
-          <a:prstGeom prst="rect">
-            <a:avLst/>
-          </a:prstGeom>
-          <a:noFill/>
-          <a:ln/>
-        </p:spPr>
-        <p:txBody>
-          <a:bodyPr wrap="square" lIns="0" tIns="0" rIns="0" bIns="0" rtlCol="0" anchor="t"/>
-          <a:lstStyle/>
-          <a:p>
-            <a:pPr algn="l" indent="0" marL="0">
-              <a:lnSpc>
-                <a:spcPct val="115000"/>
-              </a:lnSpc>
-              <a:buNone/>
-            </a:pPr>
-            <a:r>
-              <a:rPr lang="en-US" sz="1200" dirty="0">
-                <a:solidFill>
-                  <a:srgbClr val="6B7280"/>
-                </a:solidFill>
-                <a:latin typeface="Optimist Sans" pitchFamily="34" charset="0"/>
-                <a:ea typeface="Optimist Sans" pitchFamily="34" charset="-122"/>
-                <a:cs typeface="Optimist Sans" pitchFamily="34" charset="-120"/>
-              </a:rPr>
               <a:t>’28</a:t>
             </a:r>
             <a:endParaRPr lang="en-US" sz="1200" dirty="0"/>
@@ -8388,49 +8642,7 @@
       </p:sp>
       <p:sp>
         <p:nvSpPr>
-          <p:cNvPr id="52" name="Text 50"/>
-          <p:cNvSpPr txBox="1"/>
-          <p:nvPr/>
-        </p:nvSpPr>
-        <p:spPr>
-          <a:xfrm>
-            <a:off x="2921000" y="5524500"/>
-            <a:ext cx="939800" cy="215900"/>
-          </a:xfrm>
-          <a:prstGeom prst="rect">
-            <a:avLst/>
-          </a:prstGeom>
-          <a:noFill/>
-          <a:ln/>
-        </p:spPr>
-        <p:txBody>
-          <a:bodyPr wrap="square" lIns="0" tIns="0" rIns="0" bIns="0" rtlCol="0" anchor="t"/>
-          <a:lstStyle/>
-          <a:p>
-            <a:pPr algn="l" indent="0" marL="0">
-              <a:lnSpc>
-                <a:spcPct val="115000"/>
-              </a:lnSpc>
-              <a:buNone/>
-            </a:pPr>
-            <a:r>
-              <a:rPr lang="en-US" sz="1200" b="1" dirty="0">
-                <a:solidFill>
-                  <a:srgbClr val="14213D"/>
-                </a:solidFill>
-                <a:latin typeface="Optimist Sans" pitchFamily="34" charset="0"/>
-                <a:ea typeface="Optimist Sans" pitchFamily="34" charset="-122"/>
-                <a:cs typeface="Optimist Sans" pitchFamily="34" charset="-120"/>
-              </a:rPr>
-              <a:t>[n]</a:t>
-            </a:r>
-            <a:endParaRPr lang="en-US" sz="1200" dirty="0"/>
-          </a:p>
-        </p:txBody>
-      </p:sp>
-      <p:sp>
-        <p:nvSpPr>
-          <p:cNvPr id="53" name="Shape 51"/>
+          <p:cNvPr id="61" name="Shape 59"/>
           <p:cNvSpPr/>
           <p:nvPr/>
         </p:nvSpPr>
@@ -8457,28 +8669,28 @@
       </p:sp>
       <p:sp>
         <p:nvSpPr>
-          <p:cNvPr id="54" name="Text 52"/>
+          <p:cNvPr id="62" name="Text 60"/>
           <p:cNvSpPr txBox="1"/>
           <p:nvPr/>
         </p:nvSpPr>
         <p:spPr>
           <a:xfrm>
             <a:off x="4165600" y="4521200"/>
-            <a:ext cx="1320800" cy="406400"/>
-          </a:xfrm>
-          <a:prstGeom prst="rect">
-            <a:avLst/>
-          </a:prstGeom>
-          <a:noFill/>
-          <a:ln/>
-        </p:spPr>
-        <p:txBody>
-          <a:bodyPr wrap="square" lIns="0" tIns="0" rIns="0" bIns="0" rtlCol="0" anchor="t"/>
-          <a:lstStyle/>
-          <a:p>
-            <a:pPr algn="l" indent="0" marL="0">
-              <a:lnSpc>
-                <a:spcPct val="115000"/>
+            <a:ext cx="1320800" cy="590550"/>
+          </a:xfrm>
+          <a:prstGeom prst="rect">
+            <a:avLst/>
+          </a:prstGeom>
+          <a:noFill/>
+          <a:ln/>
+        </p:spPr>
+        <p:txBody>
+          <a:bodyPr wrap="square" lIns="0" tIns="0" rIns="0" bIns="0" rtlCol="0" anchor="t"/>
+          <a:lstStyle/>
+          <a:p>
+            <a:pPr algn="l" indent="0" marL="0">
+              <a:lnSpc>
+                <a:spcPct val="105000"/>
               </a:lnSpc>
               <a:buNone/>
             </a:pPr>
@@ -8491,42 +8703,167 @@
                 <a:ea typeface="Optimist Sans" pitchFamily="34" charset="-122"/>
                 <a:cs typeface="Optimist Sans" pitchFamily="34" charset="-120"/>
               </a:rPr>
-              <a:t>[Name], [Name], [Name], …</a:t>
-            </a:r>
-            <a:endParaRPr lang="en-US" sz="1200" dirty="0"/>
-          </a:p>
-        </p:txBody>
-      </p:sp>
-      <p:sp>
-        <p:nvSpPr>
-          <p:cNvPr id="55" name="Text 53"/>
-          <p:cNvSpPr txBox="1"/>
-          <p:nvPr/>
-        </p:nvSpPr>
-        <p:spPr>
-          <a:xfrm>
-            <a:off x="4165600" y="5067300"/>
-            <a:ext cx="304800" cy="215900"/>
-          </a:xfrm>
-          <a:prstGeom prst="rect">
-            <a:avLst/>
-          </a:prstGeom>
-          <a:noFill/>
-          <a:ln/>
-        </p:spPr>
-        <p:txBody>
-          <a:bodyPr wrap="square" lIns="0" tIns="0" rIns="0" bIns="0" rtlCol="0" anchor="t"/>
-          <a:lstStyle/>
-          <a:p>
-            <a:pPr algn="l" indent="0" marL="0">
-              <a:lnSpc>
-                <a:spcPct val="115000"/>
+              <a:t>[Name] [Lvl]</a:t>
+            </a:r>
+            <a:endParaRPr lang="en-US" sz="1200" dirty="0"/>
+          </a:p>
+          <a:p>
+            <a:pPr algn="l" indent="0" marL="0">
+              <a:lnSpc>
+                <a:spcPct val="105000"/>
               </a:lnSpc>
               <a:buNone/>
             </a:pPr>
             <a:r>
               <a:rPr lang="en-US" sz="1200" dirty="0">
                 <a:solidFill>
+                  <a:srgbClr val="4A5568"/>
+                </a:solidFill>
+                <a:latin typeface="Optimist Sans" pitchFamily="34" charset="0"/>
+                <a:ea typeface="Optimist Sans" pitchFamily="34" charset="-122"/>
+                <a:cs typeface="Optimist Sans" pitchFamily="34" charset="-120"/>
+              </a:rPr>
+              <a:t>[Name] [Lvl]</a:t>
+            </a:r>
+            <a:endParaRPr lang="en-US" sz="1200" dirty="0"/>
+          </a:p>
+          <a:p>
+            <a:pPr algn="l" indent="0" marL="0">
+              <a:lnSpc>
+                <a:spcPct val="105000"/>
+              </a:lnSpc>
+              <a:buNone/>
+            </a:pPr>
+            <a:r>
+              <a:rPr lang="en-US" sz="1200" dirty="0">
+                <a:solidFill>
+                  <a:srgbClr val="4A5568"/>
+                </a:solidFill>
+                <a:latin typeface="Optimist Sans" pitchFamily="34" charset="0"/>
+                <a:ea typeface="Optimist Sans" pitchFamily="34" charset="-122"/>
+                <a:cs typeface="Optimist Sans" pitchFamily="34" charset="-120"/>
+              </a:rPr>
+              <a:t>[Opening] [Lvl]</a:t>
+            </a:r>
+            <a:endParaRPr lang="en-US" sz="1200" dirty="0"/>
+          </a:p>
+        </p:txBody>
+      </p:sp>
+      <p:sp>
+        <p:nvSpPr>
+          <p:cNvPr id="63" name="Shape 61"/>
+          <p:cNvSpPr/>
+          <p:nvPr/>
+        </p:nvSpPr>
+        <p:spPr>
+          <a:xfrm>
+            <a:off x="4165600" y="5213350"/>
+            <a:ext cx="1320800" cy="914"/>
+          </a:xfrm>
+          <a:prstGeom prst="line">
+            <a:avLst/>
+          </a:prstGeom>
+          <a:noFill/>
+          <a:ln w="12700">
+            <a:solidFill>
+              <a:srgbClr val="E3DED2"/>
+            </a:solidFill>
+            <a:prstDash val="solid"/>
+          </a:ln>
+        </p:spPr>
+      </p:sp>
+      <p:sp>
+        <p:nvSpPr>
+          <p:cNvPr id="64" name="Shape 62"/>
+          <p:cNvSpPr/>
+          <p:nvPr/>
+        </p:nvSpPr>
+        <p:spPr>
+          <a:xfrm>
+            <a:off x="4318000" y="5264150"/>
+            <a:ext cx="203200" cy="152400"/>
+          </a:xfrm>
+          <a:prstGeom prst="rect">
+            <a:avLst/>
+          </a:prstGeom>
+          <a:solidFill>
+            <a:srgbClr val="1F6F7E"/>
+          </a:solidFill>
+          <a:ln/>
+        </p:spPr>
+      </p:sp>
+      <p:sp>
+        <p:nvSpPr>
+          <p:cNvPr id="65" name="Text 63"/>
+          <p:cNvSpPr txBox="1"/>
+          <p:nvPr/>
+        </p:nvSpPr>
+        <p:spPr>
+          <a:xfrm>
+            <a:off x="4241800" y="5429250"/>
+            <a:ext cx="355600" cy="165100"/>
+          </a:xfrm>
+          <a:prstGeom prst="rect">
+            <a:avLst/>
+          </a:prstGeom>
+          <a:noFill/>
+          <a:ln/>
+        </p:spPr>
+        <p:txBody>
+          <a:bodyPr wrap="square" lIns="0" tIns="0" rIns="0" bIns="0" rtlCol="0" anchor="t"/>
+          <a:lstStyle/>
+          <a:p>
+            <a:pPr algn="ctr" indent="0" marL="0">
+              <a:lnSpc>
+                <a:spcPct val="100000"/>
+              </a:lnSpc>
+              <a:buNone/>
+            </a:pPr>
+            <a:r>
+              <a:rPr lang="en-US" sz="1200" b="1" dirty="0">
+                <a:solidFill>
+                  <a:srgbClr val="14213D"/>
+                </a:solidFill>
+                <a:latin typeface="Optimist Sans" pitchFamily="34" charset="0"/>
+                <a:ea typeface="Optimist Sans" pitchFamily="34" charset="-122"/>
+                <a:cs typeface="Optimist Sans" pitchFamily="34" charset="-120"/>
+              </a:rPr>
+              <a:t>[n]</a:t>
+            </a:r>
+            <a:endParaRPr lang="en-US" sz="1200" dirty="0"/>
+          </a:p>
+        </p:txBody>
+      </p:sp>
+      <p:sp>
+        <p:nvSpPr>
+          <p:cNvPr id="66" name="Text 64"/>
+          <p:cNvSpPr txBox="1"/>
+          <p:nvPr/>
+        </p:nvSpPr>
+        <p:spPr>
+          <a:xfrm>
+            <a:off x="4241800" y="5600700"/>
+            <a:ext cx="355600" cy="165100"/>
+          </a:xfrm>
+          <a:prstGeom prst="rect">
+            <a:avLst/>
+          </a:prstGeom>
+          <a:noFill/>
+          <a:ln/>
+        </p:spPr>
+        <p:txBody>
+          <a:bodyPr wrap="square" lIns="0" tIns="0" rIns="0" bIns="0" rtlCol="0" anchor="t"/>
+          <a:lstStyle/>
+          <a:p>
+            <a:pPr algn="ctr" indent="0" marL="0">
+              <a:lnSpc>
+                <a:spcPct val="100000"/>
+              </a:lnSpc>
+              <a:buNone/>
+            </a:pPr>
+            <a:r>
+              <a:rPr lang="en-US" sz="1200" dirty="0">
+                <a:solidFill>
                   <a:srgbClr val="6B7280"/>
                 </a:solidFill>
                 <a:latin typeface="Optimist Sans" pitchFamily="34" charset="0"/>
@@ -8541,28 +8878,48 @@
       </p:sp>
       <p:sp>
         <p:nvSpPr>
-          <p:cNvPr id="56" name="Text 54"/>
-          <p:cNvSpPr txBox="1"/>
-          <p:nvPr/>
-        </p:nvSpPr>
-        <p:spPr>
-          <a:xfrm>
-            <a:off x="4546600" y="5067300"/>
-            <a:ext cx="939800" cy="215900"/>
-          </a:xfrm>
-          <a:prstGeom prst="rect">
-            <a:avLst/>
-          </a:prstGeom>
-          <a:noFill/>
-          <a:ln/>
-        </p:spPr>
-        <p:txBody>
-          <a:bodyPr wrap="square" lIns="0" tIns="0" rIns="0" bIns="0" rtlCol="0" anchor="t"/>
-          <a:lstStyle/>
-          <a:p>
-            <a:pPr algn="l" indent="0" marL="0">
-              <a:lnSpc>
-                <a:spcPct val="115000"/>
+          <p:cNvPr id="67" name="Shape 65"/>
+          <p:cNvSpPr/>
+          <p:nvPr/>
+        </p:nvSpPr>
+        <p:spPr>
+          <a:xfrm>
+            <a:off x="4724400" y="5302250"/>
+            <a:ext cx="203200" cy="114300"/>
+          </a:xfrm>
+          <a:prstGeom prst="rect">
+            <a:avLst/>
+          </a:prstGeom>
+          <a:solidFill>
+            <a:srgbClr val="1F6F7E"/>
+          </a:solidFill>
+          <a:ln/>
+        </p:spPr>
+      </p:sp>
+      <p:sp>
+        <p:nvSpPr>
+          <p:cNvPr id="68" name="Text 66"/>
+          <p:cNvSpPr txBox="1"/>
+          <p:nvPr/>
+        </p:nvSpPr>
+        <p:spPr>
+          <a:xfrm>
+            <a:off x="4648200" y="5429250"/>
+            <a:ext cx="355600" cy="165100"/>
+          </a:xfrm>
+          <a:prstGeom prst="rect">
+            <a:avLst/>
+          </a:prstGeom>
+          <a:noFill/>
+          <a:ln/>
+        </p:spPr>
+        <p:txBody>
+          <a:bodyPr wrap="square" lIns="0" tIns="0" rIns="0" bIns="0" rtlCol="0" anchor="t"/>
+          <a:lstStyle/>
+          <a:p>
+            <a:pPr algn="ctr" indent="0" marL="0">
+              <a:lnSpc>
+                <a:spcPct val="100000"/>
               </a:lnSpc>
               <a:buNone/>
             </a:pPr>
@@ -8575,11 +8932,36 @@
                 <a:ea typeface="Optimist Sans" pitchFamily="34" charset="-122"/>
                 <a:cs typeface="Optimist Sans" pitchFamily="34" charset="-120"/>
               </a:rPr>
-              <a:t>[n] </a:t>
-            </a:r>
-            <a:pPr algn="l" indent="0" marL="0">
-              <a:lnSpc>
-                <a:spcPct val="115000"/>
+              <a:t>[n]</a:t>
+            </a:r>
+            <a:endParaRPr lang="en-US" sz="1200" dirty="0"/>
+          </a:p>
+        </p:txBody>
+      </p:sp>
+      <p:sp>
+        <p:nvSpPr>
+          <p:cNvPr id="69" name="Text 67"/>
+          <p:cNvSpPr txBox="1"/>
+          <p:nvPr/>
+        </p:nvSpPr>
+        <p:spPr>
+          <a:xfrm>
+            <a:off x="4648200" y="5600700"/>
+            <a:ext cx="355600" cy="165100"/>
+          </a:xfrm>
+          <a:prstGeom prst="rect">
+            <a:avLst/>
+          </a:prstGeom>
+          <a:noFill/>
+          <a:ln/>
+        </p:spPr>
+        <p:txBody>
+          <a:bodyPr wrap="square" lIns="0" tIns="0" rIns="0" bIns="0" rtlCol="0" anchor="t"/>
+          <a:lstStyle/>
+          <a:p>
+            <a:pPr algn="ctr" indent="0" marL="0">
+              <a:lnSpc>
+                <a:spcPct val="100000"/>
               </a:lnSpc>
               <a:buNone/>
             </a:pPr>
@@ -8592,36 +8974,98 @@
                 <a:ea typeface="Optimist Sans" pitchFamily="34" charset="-122"/>
                 <a:cs typeface="Optimist Sans" pitchFamily="34" charset="-120"/>
               </a:rPr>
-              <a:t>([n])</a:t>
-            </a:r>
-            <a:endParaRPr lang="en-US" sz="1200" dirty="0"/>
-          </a:p>
-        </p:txBody>
-      </p:sp>
-      <p:sp>
-        <p:nvSpPr>
-          <p:cNvPr id="57" name="Text 55"/>
-          <p:cNvSpPr txBox="1"/>
-          <p:nvPr/>
-        </p:nvSpPr>
-        <p:spPr>
-          <a:xfrm>
-            <a:off x="4165600" y="5295900"/>
-            <a:ext cx="304800" cy="215900"/>
-          </a:xfrm>
-          <a:prstGeom prst="rect">
-            <a:avLst/>
-          </a:prstGeom>
-          <a:noFill/>
-          <a:ln/>
-        </p:spPr>
-        <p:txBody>
-          <a:bodyPr wrap="square" lIns="0" tIns="0" rIns="0" bIns="0" rtlCol="0" anchor="t"/>
-          <a:lstStyle/>
-          <a:p>
-            <a:pPr algn="l" indent="0" marL="0">
-              <a:lnSpc>
-                <a:spcPct val="115000"/>
+              <a:t>’27</a:t>
+            </a:r>
+            <a:endParaRPr lang="en-US" sz="1200" dirty="0"/>
+          </a:p>
+        </p:txBody>
+      </p:sp>
+      <p:sp>
+        <p:nvSpPr>
+          <p:cNvPr id="70" name="Shape 68"/>
+          <p:cNvSpPr/>
+          <p:nvPr/>
+        </p:nvSpPr>
+        <p:spPr>
+          <a:xfrm>
+            <a:off x="5130800" y="5340350"/>
+            <a:ext cx="203200" cy="76200"/>
+          </a:xfrm>
+          <a:prstGeom prst="rect">
+            <a:avLst/>
+          </a:prstGeom>
+          <a:solidFill>
+            <a:srgbClr val="1F6F7E"/>
+          </a:solidFill>
+          <a:ln/>
+        </p:spPr>
+      </p:sp>
+      <p:sp>
+        <p:nvSpPr>
+          <p:cNvPr id="71" name="Text 69"/>
+          <p:cNvSpPr txBox="1"/>
+          <p:nvPr/>
+        </p:nvSpPr>
+        <p:spPr>
+          <a:xfrm>
+            <a:off x="5054600" y="5429250"/>
+            <a:ext cx="355600" cy="165100"/>
+          </a:xfrm>
+          <a:prstGeom prst="rect">
+            <a:avLst/>
+          </a:prstGeom>
+          <a:noFill/>
+          <a:ln/>
+        </p:spPr>
+        <p:txBody>
+          <a:bodyPr wrap="square" lIns="0" tIns="0" rIns="0" bIns="0" rtlCol="0" anchor="t"/>
+          <a:lstStyle/>
+          <a:p>
+            <a:pPr algn="ctr" indent="0" marL="0">
+              <a:lnSpc>
+                <a:spcPct val="100000"/>
+              </a:lnSpc>
+              <a:buNone/>
+            </a:pPr>
+            <a:r>
+              <a:rPr lang="en-US" sz="1200" b="1" dirty="0">
+                <a:solidFill>
+                  <a:srgbClr val="14213D"/>
+                </a:solidFill>
+                <a:latin typeface="Optimist Sans" pitchFamily="34" charset="0"/>
+                <a:ea typeface="Optimist Sans" pitchFamily="34" charset="-122"/>
+                <a:cs typeface="Optimist Sans" pitchFamily="34" charset="-120"/>
+              </a:rPr>
+              <a:t>[n]</a:t>
+            </a:r>
+            <a:endParaRPr lang="en-US" sz="1200" dirty="0"/>
+          </a:p>
+        </p:txBody>
+      </p:sp>
+      <p:sp>
+        <p:nvSpPr>
+          <p:cNvPr id="72" name="Text 70"/>
+          <p:cNvSpPr txBox="1"/>
+          <p:nvPr/>
+        </p:nvSpPr>
+        <p:spPr>
+          <a:xfrm>
+            <a:off x="5054600" y="5600700"/>
+            <a:ext cx="355600" cy="165100"/>
+          </a:xfrm>
+          <a:prstGeom prst="rect">
+            <a:avLst/>
+          </a:prstGeom>
+          <a:noFill/>
+          <a:ln/>
+        </p:spPr>
+        <p:txBody>
+          <a:bodyPr wrap="square" lIns="0" tIns="0" rIns="0" bIns="0" rtlCol="0" anchor="t"/>
+          <a:lstStyle/>
+          <a:p>
+            <a:pPr algn="ctr" indent="0" marL="0">
+              <a:lnSpc>
+                <a:spcPct val="100000"/>
               </a:lnSpc>
               <a:buNone/>
             </a:pPr>
@@ -8634,90 +9078,6 @@
                 <a:ea typeface="Optimist Sans" pitchFamily="34" charset="-122"/>
                 <a:cs typeface="Optimist Sans" pitchFamily="34" charset="-120"/>
               </a:rPr>
-              <a:t>’27</a:t>
-            </a:r>
-            <a:endParaRPr lang="en-US" sz="1200" dirty="0"/>
-          </a:p>
-        </p:txBody>
-      </p:sp>
-      <p:sp>
-        <p:nvSpPr>
-          <p:cNvPr id="58" name="Text 56"/>
-          <p:cNvSpPr txBox="1"/>
-          <p:nvPr/>
-        </p:nvSpPr>
-        <p:spPr>
-          <a:xfrm>
-            <a:off x="4546600" y="5295900"/>
-            <a:ext cx="939800" cy="215900"/>
-          </a:xfrm>
-          <a:prstGeom prst="rect">
-            <a:avLst/>
-          </a:prstGeom>
-          <a:noFill/>
-          <a:ln/>
-        </p:spPr>
-        <p:txBody>
-          <a:bodyPr wrap="square" lIns="0" tIns="0" rIns="0" bIns="0" rtlCol="0" anchor="t"/>
-          <a:lstStyle/>
-          <a:p>
-            <a:pPr algn="l" indent="0" marL="0">
-              <a:lnSpc>
-                <a:spcPct val="115000"/>
-              </a:lnSpc>
-              <a:buNone/>
-            </a:pPr>
-            <a:r>
-              <a:rPr lang="en-US" sz="1200" b="1" dirty="0">
-                <a:solidFill>
-                  <a:srgbClr val="14213D"/>
-                </a:solidFill>
-                <a:latin typeface="Optimist Sans" pitchFamily="34" charset="0"/>
-                <a:ea typeface="Optimist Sans" pitchFamily="34" charset="-122"/>
-                <a:cs typeface="Optimist Sans" pitchFamily="34" charset="-120"/>
-              </a:rPr>
-              <a:t>[n]</a:t>
-            </a:r>
-            <a:endParaRPr lang="en-US" sz="1200" dirty="0"/>
-          </a:p>
-        </p:txBody>
-      </p:sp>
-      <p:sp>
-        <p:nvSpPr>
-          <p:cNvPr id="59" name="Text 57"/>
-          <p:cNvSpPr txBox="1"/>
-          <p:nvPr/>
-        </p:nvSpPr>
-        <p:spPr>
-          <a:xfrm>
-            <a:off x="4165600" y="5524500"/>
-            <a:ext cx="304800" cy="215900"/>
-          </a:xfrm>
-          <a:prstGeom prst="rect">
-            <a:avLst/>
-          </a:prstGeom>
-          <a:noFill/>
-          <a:ln/>
-        </p:spPr>
-        <p:txBody>
-          <a:bodyPr wrap="square" lIns="0" tIns="0" rIns="0" bIns="0" rtlCol="0" anchor="t"/>
-          <a:lstStyle/>
-          <a:p>
-            <a:pPr algn="l" indent="0" marL="0">
-              <a:lnSpc>
-                <a:spcPct val="115000"/>
-              </a:lnSpc>
-              <a:buNone/>
-            </a:pPr>
-            <a:r>
-              <a:rPr lang="en-US" sz="1200" dirty="0">
-                <a:solidFill>
-                  <a:srgbClr val="6B7280"/>
-                </a:solidFill>
-                <a:latin typeface="Optimist Sans" pitchFamily="34" charset="0"/>
-                <a:ea typeface="Optimist Sans" pitchFamily="34" charset="-122"/>
-                <a:cs typeface="Optimist Sans" pitchFamily="34" charset="-120"/>
-              </a:rPr>
               <a:t>’28</a:t>
             </a:r>
             <a:endParaRPr lang="en-US" sz="1200" dirty="0"/>
@@ -8726,49 +9086,7 @@
       </p:sp>
       <p:sp>
         <p:nvSpPr>
-          <p:cNvPr id="60" name="Text 58"/>
-          <p:cNvSpPr txBox="1"/>
-          <p:nvPr/>
-        </p:nvSpPr>
-        <p:spPr>
-          <a:xfrm>
-            <a:off x="4546600" y="5524500"/>
-            <a:ext cx="939800" cy="215900"/>
-          </a:xfrm>
-          <a:prstGeom prst="rect">
-            <a:avLst/>
-          </a:prstGeom>
-          <a:noFill/>
-          <a:ln/>
-        </p:spPr>
-        <p:txBody>
-          <a:bodyPr wrap="square" lIns="0" tIns="0" rIns="0" bIns="0" rtlCol="0" anchor="t"/>
-          <a:lstStyle/>
-          <a:p>
-            <a:pPr algn="l" indent="0" marL="0">
-              <a:lnSpc>
-                <a:spcPct val="115000"/>
-              </a:lnSpc>
-              <a:buNone/>
-            </a:pPr>
-            <a:r>
-              <a:rPr lang="en-US" sz="1200" b="1" dirty="0">
-                <a:solidFill>
-                  <a:srgbClr val="14213D"/>
-                </a:solidFill>
-                <a:latin typeface="Optimist Sans" pitchFamily="34" charset="0"/>
-                <a:ea typeface="Optimist Sans" pitchFamily="34" charset="-122"/>
-                <a:cs typeface="Optimist Sans" pitchFamily="34" charset="-120"/>
-              </a:rPr>
-              <a:t>[n]</a:t>
-            </a:r>
-            <a:endParaRPr lang="en-US" sz="1200" dirty="0"/>
-          </a:p>
-        </p:txBody>
-      </p:sp>
-      <p:sp>
-        <p:nvSpPr>
-          <p:cNvPr id="61" name="Shape 59"/>
+          <p:cNvPr id="73" name="Shape 71"/>
           <p:cNvSpPr/>
           <p:nvPr/>
         </p:nvSpPr>
@@ -8795,28 +9113,28 @@
       </p:sp>
       <p:sp>
         <p:nvSpPr>
-          <p:cNvPr id="62" name="Text 60"/>
+          <p:cNvPr id="74" name="Text 72"/>
           <p:cNvSpPr txBox="1"/>
           <p:nvPr/>
         </p:nvSpPr>
         <p:spPr>
           <a:xfrm>
             <a:off x="5842000" y="3911600"/>
-            <a:ext cx="1574800" cy="406400"/>
-          </a:xfrm>
-          <a:prstGeom prst="rect">
-            <a:avLst/>
-          </a:prstGeom>
-          <a:noFill/>
-          <a:ln/>
-        </p:spPr>
-        <p:txBody>
-          <a:bodyPr wrap="square" lIns="0" tIns="0" rIns="0" bIns="0" rtlCol="0" anchor="t"/>
-          <a:lstStyle/>
-          <a:p>
-            <a:pPr algn="l" indent="0" marL="0">
-              <a:lnSpc>
-                <a:spcPct val="115000"/>
+            <a:ext cx="1574800" cy="984250"/>
+          </a:xfrm>
+          <a:prstGeom prst="rect">
+            <a:avLst/>
+          </a:prstGeom>
+          <a:noFill/>
+          <a:ln/>
+        </p:spPr>
+        <p:txBody>
+          <a:bodyPr wrap="square" lIns="0" tIns="0" rIns="0" bIns="0" rtlCol="0" anchor="t"/>
+          <a:lstStyle/>
+          <a:p>
+            <a:pPr algn="l" indent="0" marL="0">
+              <a:lnSpc>
+                <a:spcPct val="105000"/>
               </a:lnSpc>
               <a:buNone/>
             </a:pPr>
@@ -8829,42 +9147,207 @@
                 <a:ea typeface="Optimist Sans" pitchFamily="34" charset="-122"/>
                 <a:cs typeface="Optimist Sans" pitchFamily="34" charset="-120"/>
               </a:rPr>
-              <a:t>[Name], [Name], [Name], …</a:t>
-            </a:r>
-            <a:endParaRPr lang="en-US" sz="1200" dirty="0"/>
-          </a:p>
-        </p:txBody>
-      </p:sp>
-      <p:sp>
-        <p:nvSpPr>
-          <p:cNvPr id="63" name="Text 61"/>
-          <p:cNvSpPr txBox="1"/>
-          <p:nvPr/>
-        </p:nvSpPr>
-        <p:spPr>
-          <a:xfrm>
-            <a:off x="5842000" y="5067300"/>
-            <a:ext cx="304800" cy="215900"/>
-          </a:xfrm>
-          <a:prstGeom prst="rect">
-            <a:avLst/>
-          </a:prstGeom>
-          <a:noFill/>
-          <a:ln/>
-        </p:spPr>
-        <p:txBody>
-          <a:bodyPr wrap="square" lIns="0" tIns="0" rIns="0" bIns="0" rtlCol="0" anchor="t"/>
-          <a:lstStyle/>
-          <a:p>
-            <a:pPr algn="l" indent="0" marL="0">
-              <a:lnSpc>
-                <a:spcPct val="115000"/>
+              <a:t>Name [SA]</a:t>
+            </a:r>
+            <a:endParaRPr lang="en-US" sz="1200" dirty="0"/>
+          </a:p>
+          <a:p>
+            <a:pPr algn="l" indent="0" marL="0">
+              <a:lnSpc>
+                <a:spcPct val="105000"/>
               </a:lnSpc>
               <a:buNone/>
             </a:pPr>
             <a:r>
               <a:rPr lang="en-US" sz="1200" dirty="0">
                 <a:solidFill>
+                  <a:srgbClr val="4A5568"/>
+                </a:solidFill>
+                <a:latin typeface="Optimist Sans" pitchFamily="34" charset="0"/>
+                <a:ea typeface="Optimist Sans" pitchFamily="34" charset="-122"/>
+                <a:cs typeface="Optimist Sans" pitchFamily="34" charset="-120"/>
+              </a:rPr>
+              <a:t>Name [PA]</a:t>
+            </a:r>
+            <a:endParaRPr lang="en-US" sz="1200" dirty="0"/>
+          </a:p>
+          <a:p>
+            <a:pPr algn="l" indent="0" marL="0">
+              <a:lnSpc>
+                <a:spcPct val="105000"/>
+              </a:lnSpc>
+              <a:buNone/>
+            </a:pPr>
+            <a:r>
+              <a:rPr lang="en-US" sz="1200" dirty="0">
+                <a:solidFill>
+                  <a:srgbClr val="4A5568"/>
+                </a:solidFill>
+                <a:latin typeface="Optimist Sans" pitchFamily="34" charset="0"/>
+                <a:ea typeface="Optimist Sans" pitchFamily="34" charset="-122"/>
+                <a:cs typeface="Optimist Sans" pitchFamily="34" charset="-120"/>
+              </a:rPr>
+              <a:t>Name [Mgr Opening]</a:t>
+            </a:r>
+            <a:endParaRPr lang="en-US" sz="1200" dirty="0"/>
+          </a:p>
+          <a:p>
+            <a:pPr algn="l" indent="0" marL="0">
+              <a:lnSpc>
+                <a:spcPct val="105000"/>
+              </a:lnSpc>
+              <a:buNone/>
+            </a:pPr>
+            <a:r>
+              <a:rPr lang="en-US" sz="1200" dirty="0">
+                <a:solidFill>
+                  <a:srgbClr val="4A5568"/>
+                </a:solidFill>
+                <a:latin typeface="Optimist Sans" pitchFamily="34" charset="0"/>
+                <a:ea typeface="Optimist Sans" pitchFamily="34" charset="-122"/>
+                <a:cs typeface="Optimist Sans" pitchFamily="34" charset="-120"/>
+              </a:rPr>
+              <a:t>[Name] [Lvl]</a:t>
+            </a:r>
+            <a:endParaRPr lang="en-US" sz="1200" dirty="0"/>
+          </a:p>
+          <a:p>
+            <a:pPr algn="l" indent="0" marL="0">
+              <a:lnSpc>
+                <a:spcPct val="105000"/>
+              </a:lnSpc>
+              <a:buNone/>
+            </a:pPr>
+            <a:r>
+              <a:rPr lang="en-US" sz="1200" dirty="0">
+                <a:solidFill>
+                  <a:srgbClr val="4A5568"/>
+                </a:solidFill>
+                <a:latin typeface="Optimist Sans" pitchFamily="34" charset="0"/>
+                <a:ea typeface="Optimist Sans" pitchFamily="34" charset="-122"/>
+                <a:cs typeface="Optimist Sans" pitchFamily="34" charset="-120"/>
+              </a:rPr>
+              <a:t>[Name] [Lvl]</a:t>
+            </a:r>
+            <a:endParaRPr lang="en-US" sz="1200" dirty="0"/>
+          </a:p>
+        </p:txBody>
+      </p:sp>
+      <p:sp>
+        <p:nvSpPr>
+          <p:cNvPr id="75" name="Shape 73"/>
+          <p:cNvSpPr/>
+          <p:nvPr/>
+        </p:nvSpPr>
+        <p:spPr>
+          <a:xfrm>
+            <a:off x="5842000" y="5213350"/>
+            <a:ext cx="1574800" cy="914"/>
+          </a:xfrm>
+          <a:prstGeom prst="line">
+            <a:avLst/>
+          </a:prstGeom>
+          <a:noFill/>
+          <a:ln w="12700">
+            <a:solidFill>
+              <a:srgbClr val="E3DED2"/>
+            </a:solidFill>
+            <a:prstDash val="solid"/>
+          </a:ln>
+        </p:spPr>
+      </p:sp>
+      <p:sp>
+        <p:nvSpPr>
+          <p:cNvPr id="76" name="Shape 74"/>
+          <p:cNvSpPr/>
+          <p:nvPr/>
+        </p:nvSpPr>
+        <p:spPr>
+          <a:xfrm>
+            <a:off x="6121400" y="5264150"/>
+            <a:ext cx="203200" cy="152400"/>
+          </a:xfrm>
+          <a:prstGeom prst="rect">
+            <a:avLst/>
+          </a:prstGeom>
+          <a:solidFill>
+            <a:srgbClr val="1F6F7E"/>
+          </a:solidFill>
+          <a:ln/>
+        </p:spPr>
+      </p:sp>
+      <p:sp>
+        <p:nvSpPr>
+          <p:cNvPr id="77" name="Text 75"/>
+          <p:cNvSpPr txBox="1"/>
+          <p:nvPr/>
+        </p:nvSpPr>
+        <p:spPr>
+          <a:xfrm>
+            <a:off x="6045200" y="5429250"/>
+            <a:ext cx="355600" cy="165100"/>
+          </a:xfrm>
+          <a:prstGeom prst="rect">
+            <a:avLst/>
+          </a:prstGeom>
+          <a:noFill/>
+          <a:ln/>
+        </p:spPr>
+        <p:txBody>
+          <a:bodyPr wrap="square" lIns="0" tIns="0" rIns="0" bIns="0" rtlCol="0" anchor="t"/>
+          <a:lstStyle/>
+          <a:p>
+            <a:pPr algn="ctr" indent="0" marL="0">
+              <a:lnSpc>
+                <a:spcPct val="100000"/>
+              </a:lnSpc>
+              <a:buNone/>
+            </a:pPr>
+            <a:r>
+              <a:rPr lang="en-US" sz="1200" b="1" dirty="0">
+                <a:solidFill>
+                  <a:srgbClr val="14213D"/>
+                </a:solidFill>
+                <a:latin typeface="Optimist Sans" pitchFamily="34" charset="0"/>
+                <a:ea typeface="Optimist Sans" pitchFamily="34" charset="-122"/>
+                <a:cs typeface="Optimist Sans" pitchFamily="34" charset="-120"/>
+              </a:rPr>
+              <a:t>[n]</a:t>
+            </a:r>
+            <a:endParaRPr lang="en-US" sz="1200" dirty="0"/>
+          </a:p>
+        </p:txBody>
+      </p:sp>
+      <p:sp>
+        <p:nvSpPr>
+          <p:cNvPr id="78" name="Text 76"/>
+          <p:cNvSpPr txBox="1"/>
+          <p:nvPr/>
+        </p:nvSpPr>
+        <p:spPr>
+          <a:xfrm>
+            <a:off x="6045200" y="5600700"/>
+            <a:ext cx="355600" cy="165100"/>
+          </a:xfrm>
+          <a:prstGeom prst="rect">
+            <a:avLst/>
+          </a:prstGeom>
+          <a:noFill/>
+          <a:ln/>
+        </p:spPr>
+        <p:txBody>
+          <a:bodyPr wrap="square" lIns="0" tIns="0" rIns="0" bIns="0" rtlCol="0" anchor="t"/>
+          <a:lstStyle/>
+          <a:p>
+            <a:pPr algn="ctr" indent="0" marL="0">
+              <a:lnSpc>
+                <a:spcPct val="100000"/>
+              </a:lnSpc>
+              <a:buNone/>
+            </a:pPr>
+            <a:r>
+              <a:rPr lang="en-US" sz="1200" dirty="0">
+                <a:solidFill>
                   <a:srgbClr val="6B7280"/>
                 </a:solidFill>
                 <a:latin typeface="Optimist Sans" pitchFamily="34" charset="0"/>
@@ -8879,28 +9362,48 @@
       </p:sp>
       <p:sp>
         <p:nvSpPr>
-          <p:cNvPr id="64" name="Text 62"/>
-          <p:cNvSpPr txBox="1"/>
-          <p:nvPr/>
-        </p:nvSpPr>
-        <p:spPr>
-          <a:xfrm>
-            <a:off x="6223000" y="5067300"/>
-            <a:ext cx="1193800" cy="215900"/>
-          </a:xfrm>
-          <a:prstGeom prst="rect">
-            <a:avLst/>
-          </a:prstGeom>
-          <a:noFill/>
-          <a:ln/>
-        </p:spPr>
-        <p:txBody>
-          <a:bodyPr wrap="square" lIns="0" tIns="0" rIns="0" bIns="0" rtlCol="0" anchor="t"/>
-          <a:lstStyle/>
-          <a:p>
-            <a:pPr algn="l" indent="0" marL="0">
-              <a:lnSpc>
-                <a:spcPct val="115000"/>
+          <p:cNvPr id="79" name="Shape 77"/>
+          <p:cNvSpPr/>
+          <p:nvPr/>
+        </p:nvSpPr>
+        <p:spPr>
+          <a:xfrm>
+            <a:off x="6527800" y="5302250"/>
+            <a:ext cx="203200" cy="114300"/>
+          </a:xfrm>
+          <a:prstGeom prst="rect">
+            <a:avLst/>
+          </a:prstGeom>
+          <a:solidFill>
+            <a:srgbClr val="1F6F7E"/>
+          </a:solidFill>
+          <a:ln/>
+        </p:spPr>
+      </p:sp>
+      <p:sp>
+        <p:nvSpPr>
+          <p:cNvPr id="80" name="Text 78"/>
+          <p:cNvSpPr txBox="1"/>
+          <p:nvPr/>
+        </p:nvSpPr>
+        <p:spPr>
+          <a:xfrm>
+            <a:off x="6451600" y="5429250"/>
+            <a:ext cx="355600" cy="165100"/>
+          </a:xfrm>
+          <a:prstGeom prst="rect">
+            <a:avLst/>
+          </a:prstGeom>
+          <a:noFill/>
+          <a:ln/>
+        </p:spPr>
+        <p:txBody>
+          <a:bodyPr wrap="square" lIns="0" tIns="0" rIns="0" bIns="0" rtlCol="0" anchor="t"/>
+          <a:lstStyle/>
+          <a:p>
+            <a:pPr algn="ctr" indent="0" marL="0">
+              <a:lnSpc>
+                <a:spcPct val="100000"/>
               </a:lnSpc>
               <a:buNone/>
             </a:pPr>
@@ -8913,11 +9416,36 @@
                 <a:ea typeface="Optimist Sans" pitchFamily="34" charset="-122"/>
                 <a:cs typeface="Optimist Sans" pitchFamily="34" charset="-120"/>
               </a:rPr>
-              <a:t>[n] </a:t>
-            </a:r>
-            <a:pPr algn="l" indent="0" marL="0">
-              <a:lnSpc>
-                <a:spcPct val="115000"/>
+              <a:t>[n]</a:t>
+            </a:r>
+            <a:endParaRPr lang="en-US" sz="1200" dirty="0"/>
+          </a:p>
+        </p:txBody>
+      </p:sp>
+      <p:sp>
+        <p:nvSpPr>
+          <p:cNvPr id="81" name="Text 79"/>
+          <p:cNvSpPr txBox="1"/>
+          <p:nvPr/>
+        </p:nvSpPr>
+        <p:spPr>
+          <a:xfrm>
+            <a:off x="6451600" y="5600700"/>
+            <a:ext cx="355600" cy="165100"/>
+          </a:xfrm>
+          <a:prstGeom prst="rect">
+            <a:avLst/>
+          </a:prstGeom>
+          <a:noFill/>
+          <a:ln/>
+        </p:spPr>
+        <p:txBody>
+          <a:bodyPr wrap="square" lIns="0" tIns="0" rIns="0" bIns="0" rtlCol="0" anchor="t"/>
+          <a:lstStyle/>
+          <a:p>
+            <a:pPr algn="ctr" indent="0" marL="0">
+              <a:lnSpc>
+                <a:spcPct val="100000"/>
               </a:lnSpc>
               <a:buNone/>
             </a:pPr>
@@ -8930,36 +9458,98 @@
                 <a:ea typeface="Optimist Sans" pitchFamily="34" charset="-122"/>
                 <a:cs typeface="Optimist Sans" pitchFamily="34" charset="-120"/>
               </a:rPr>
-              <a:t>([n])</a:t>
-            </a:r>
-            <a:endParaRPr lang="en-US" sz="1200" dirty="0"/>
-          </a:p>
-        </p:txBody>
-      </p:sp>
-      <p:sp>
-        <p:nvSpPr>
-          <p:cNvPr id="65" name="Text 63"/>
-          <p:cNvSpPr txBox="1"/>
-          <p:nvPr/>
-        </p:nvSpPr>
-        <p:spPr>
-          <a:xfrm>
-            <a:off x="5842000" y="5295900"/>
-            <a:ext cx="304800" cy="215900"/>
-          </a:xfrm>
-          <a:prstGeom prst="rect">
-            <a:avLst/>
-          </a:prstGeom>
-          <a:noFill/>
-          <a:ln/>
-        </p:spPr>
-        <p:txBody>
-          <a:bodyPr wrap="square" lIns="0" tIns="0" rIns="0" bIns="0" rtlCol="0" anchor="t"/>
-          <a:lstStyle/>
-          <a:p>
-            <a:pPr algn="l" indent="0" marL="0">
-              <a:lnSpc>
-                <a:spcPct val="115000"/>
+              <a:t>’27</a:t>
+            </a:r>
+            <a:endParaRPr lang="en-US" sz="1200" dirty="0"/>
+          </a:p>
+        </p:txBody>
+      </p:sp>
+      <p:sp>
+        <p:nvSpPr>
+          <p:cNvPr id="82" name="Shape 80"/>
+          <p:cNvSpPr/>
+          <p:nvPr/>
+        </p:nvSpPr>
+        <p:spPr>
+          <a:xfrm>
+            <a:off x="6934200" y="5340350"/>
+            <a:ext cx="203200" cy="76200"/>
+          </a:xfrm>
+          <a:prstGeom prst="rect">
+            <a:avLst/>
+          </a:prstGeom>
+          <a:solidFill>
+            <a:srgbClr val="1F6F7E"/>
+          </a:solidFill>
+          <a:ln/>
+        </p:spPr>
+      </p:sp>
+      <p:sp>
+        <p:nvSpPr>
+          <p:cNvPr id="83" name="Text 81"/>
+          <p:cNvSpPr txBox="1"/>
+          <p:nvPr/>
+        </p:nvSpPr>
+        <p:spPr>
+          <a:xfrm>
+            <a:off x="6858000" y="5429250"/>
+            <a:ext cx="355600" cy="165100"/>
+          </a:xfrm>
+          <a:prstGeom prst="rect">
+            <a:avLst/>
+          </a:prstGeom>
+          <a:noFill/>
+          <a:ln/>
+        </p:spPr>
+        <p:txBody>
+          <a:bodyPr wrap="square" lIns="0" tIns="0" rIns="0" bIns="0" rtlCol="0" anchor="t"/>
+          <a:lstStyle/>
+          <a:p>
+            <a:pPr algn="ctr" indent="0" marL="0">
+              <a:lnSpc>
+                <a:spcPct val="100000"/>
+              </a:lnSpc>
+              <a:buNone/>
+            </a:pPr>
+            <a:r>
+              <a:rPr lang="en-US" sz="1200" b="1" dirty="0">
+                <a:solidFill>
+                  <a:srgbClr val="14213D"/>
+                </a:solidFill>
+                <a:latin typeface="Optimist Sans" pitchFamily="34" charset="0"/>
+                <a:ea typeface="Optimist Sans" pitchFamily="34" charset="-122"/>
+                <a:cs typeface="Optimist Sans" pitchFamily="34" charset="-120"/>
+              </a:rPr>
+              <a:t>[n]</a:t>
+            </a:r>
+            <a:endParaRPr lang="en-US" sz="1200" dirty="0"/>
+          </a:p>
+        </p:txBody>
+      </p:sp>
+      <p:sp>
+        <p:nvSpPr>
+          <p:cNvPr id="84" name="Text 82"/>
+          <p:cNvSpPr txBox="1"/>
+          <p:nvPr/>
+        </p:nvSpPr>
+        <p:spPr>
+          <a:xfrm>
+            <a:off x="6858000" y="5600700"/>
+            <a:ext cx="355600" cy="165100"/>
+          </a:xfrm>
+          <a:prstGeom prst="rect">
+            <a:avLst/>
+          </a:prstGeom>
+          <a:noFill/>
+          <a:ln/>
+        </p:spPr>
+        <p:txBody>
+          <a:bodyPr wrap="square" lIns="0" tIns="0" rIns="0" bIns="0" rtlCol="0" anchor="t"/>
+          <a:lstStyle/>
+          <a:p>
+            <a:pPr algn="ctr" indent="0" marL="0">
+              <a:lnSpc>
+                <a:spcPct val="100000"/>
               </a:lnSpc>
               <a:buNone/>
             </a:pPr>
@@ -8972,90 +9562,6 @@
                 <a:ea typeface="Optimist Sans" pitchFamily="34" charset="-122"/>
                 <a:cs typeface="Optimist Sans" pitchFamily="34" charset="-120"/>
               </a:rPr>
-              <a:t>’27</a:t>
-            </a:r>
-            <a:endParaRPr lang="en-US" sz="1200" dirty="0"/>
-          </a:p>
-        </p:txBody>
-      </p:sp>
-      <p:sp>
-        <p:nvSpPr>
-          <p:cNvPr id="66" name="Text 64"/>
-          <p:cNvSpPr txBox="1"/>
-          <p:nvPr/>
-        </p:nvSpPr>
-        <p:spPr>
-          <a:xfrm>
-            <a:off x="6223000" y="5295900"/>
-            <a:ext cx="1193800" cy="215900"/>
-          </a:xfrm>
-          <a:prstGeom prst="rect">
-            <a:avLst/>
-          </a:prstGeom>
-          <a:noFill/>
-          <a:ln/>
-        </p:spPr>
-        <p:txBody>
-          <a:bodyPr wrap="square" lIns="0" tIns="0" rIns="0" bIns="0" rtlCol="0" anchor="t"/>
-          <a:lstStyle/>
-          <a:p>
-            <a:pPr algn="l" indent="0" marL="0">
-              <a:lnSpc>
-                <a:spcPct val="115000"/>
-              </a:lnSpc>
-              <a:buNone/>
-            </a:pPr>
-            <a:r>
-              <a:rPr lang="en-US" sz="1200" b="1" dirty="0">
-                <a:solidFill>
-                  <a:srgbClr val="14213D"/>
-                </a:solidFill>
-                <a:latin typeface="Optimist Sans" pitchFamily="34" charset="0"/>
-                <a:ea typeface="Optimist Sans" pitchFamily="34" charset="-122"/>
-                <a:cs typeface="Optimist Sans" pitchFamily="34" charset="-120"/>
-              </a:rPr>
-              <a:t>[n]</a:t>
-            </a:r>
-            <a:endParaRPr lang="en-US" sz="1200" dirty="0"/>
-          </a:p>
-        </p:txBody>
-      </p:sp>
-      <p:sp>
-        <p:nvSpPr>
-          <p:cNvPr id="67" name="Text 65"/>
-          <p:cNvSpPr txBox="1"/>
-          <p:nvPr/>
-        </p:nvSpPr>
-        <p:spPr>
-          <a:xfrm>
-            <a:off x="5842000" y="5524500"/>
-            <a:ext cx="304800" cy="215900"/>
-          </a:xfrm>
-          <a:prstGeom prst="rect">
-            <a:avLst/>
-          </a:prstGeom>
-          <a:noFill/>
-          <a:ln/>
-        </p:spPr>
-        <p:txBody>
-          <a:bodyPr wrap="square" lIns="0" tIns="0" rIns="0" bIns="0" rtlCol="0" anchor="t"/>
-          <a:lstStyle/>
-          <a:p>
-            <a:pPr algn="l" indent="0" marL="0">
-              <a:lnSpc>
-                <a:spcPct val="115000"/>
-              </a:lnSpc>
-              <a:buNone/>
-            </a:pPr>
-            <a:r>
-              <a:rPr lang="en-US" sz="1200" dirty="0">
-                <a:solidFill>
-                  <a:srgbClr val="6B7280"/>
-                </a:solidFill>
-                <a:latin typeface="Optimist Sans" pitchFamily="34" charset="0"/>
-                <a:ea typeface="Optimist Sans" pitchFamily="34" charset="-122"/>
-                <a:cs typeface="Optimist Sans" pitchFamily="34" charset="-120"/>
-              </a:rPr>
               <a:t>’28</a:t>
             </a:r>
             <a:endParaRPr lang="en-US" sz="1200" dirty="0"/>
@@ -9064,49 +9570,7 @@
       </p:sp>
       <p:sp>
         <p:nvSpPr>
-          <p:cNvPr id="68" name="Text 66"/>
-          <p:cNvSpPr txBox="1"/>
-          <p:nvPr/>
-        </p:nvSpPr>
-        <p:spPr>
-          <a:xfrm>
-            <a:off x="6223000" y="5524500"/>
-            <a:ext cx="1193800" cy="215900"/>
-          </a:xfrm>
-          <a:prstGeom prst="rect">
-            <a:avLst/>
-          </a:prstGeom>
-          <a:noFill/>
-          <a:ln/>
-        </p:spPr>
-        <p:txBody>
-          <a:bodyPr wrap="square" lIns="0" tIns="0" rIns="0" bIns="0" rtlCol="0" anchor="t"/>
-          <a:lstStyle/>
-          <a:p>
-            <a:pPr algn="l" indent="0" marL="0">
-              <a:lnSpc>
-                <a:spcPct val="115000"/>
-              </a:lnSpc>
-              <a:buNone/>
-            </a:pPr>
-            <a:r>
-              <a:rPr lang="en-US" sz="1200" b="1" dirty="0">
-                <a:solidFill>
-                  <a:srgbClr val="14213D"/>
-                </a:solidFill>
-                <a:latin typeface="Optimist Sans" pitchFamily="34" charset="0"/>
-                <a:ea typeface="Optimist Sans" pitchFamily="34" charset="-122"/>
-                <a:cs typeface="Optimist Sans" pitchFamily="34" charset="-120"/>
-              </a:rPr>
-              <a:t>[n]</a:t>
-            </a:r>
-            <a:endParaRPr lang="en-US" sz="1200" dirty="0"/>
-          </a:p>
-        </p:txBody>
-      </p:sp>
-      <p:sp>
-        <p:nvSpPr>
-          <p:cNvPr id="69" name="Shape 67"/>
+          <p:cNvPr id="85" name="Shape 83"/>
           <p:cNvSpPr/>
           <p:nvPr/>
         </p:nvSpPr>
@@ -9133,28 +9597,28 @@
       </p:sp>
       <p:sp>
         <p:nvSpPr>
-          <p:cNvPr id="70" name="Text 68"/>
+          <p:cNvPr id="86" name="Text 84"/>
           <p:cNvSpPr txBox="1"/>
           <p:nvPr/>
         </p:nvSpPr>
         <p:spPr>
           <a:xfrm>
             <a:off x="7772400" y="3911600"/>
-            <a:ext cx="1574800" cy="406400"/>
-          </a:xfrm>
-          <a:prstGeom prst="rect">
-            <a:avLst/>
-          </a:prstGeom>
-          <a:noFill/>
-          <a:ln/>
-        </p:spPr>
-        <p:txBody>
-          <a:bodyPr wrap="square" lIns="0" tIns="0" rIns="0" bIns="0" rtlCol="0" anchor="t"/>
-          <a:lstStyle/>
-          <a:p>
-            <a:pPr algn="l" indent="0" marL="0">
-              <a:lnSpc>
-                <a:spcPct val="115000"/>
+            <a:ext cx="1574800" cy="984250"/>
+          </a:xfrm>
+          <a:prstGeom prst="rect">
+            <a:avLst/>
+          </a:prstGeom>
+          <a:noFill/>
+          <a:ln/>
+        </p:spPr>
+        <p:txBody>
+          <a:bodyPr wrap="square" lIns="0" tIns="0" rIns="0" bIns="0" rtlCol="0" anchor="t"/>
+          <a:lstStyle/>
+          <a:p>
+            <a:pPr algn="l" indent="0" marL="0">
+              <a:lnSpc>
+                <a:spcPct val="105000"/>
               </a:lnSpc>
               <a:buNone/>
             </a:pPr>
@@ -9167,42 +9631,207 @@
                 <a:ea typeface="Optimist Sans" pitchFamily="34" charset="-122"/>
                 <a:cs typeface="Optimist Sans" pitchFamily="34" charset="-120"/>
               </a:rPr>
-              <a:t>[Name], [Name], [Name], …</a:t>
-            </a:r>
-            <a:endParaRPr lang="en-US" sz="1200" dirty="0"/>
-          </a:p>
-        </p:txBody>
-      </p:sp>
-      <p:sp>
-        <p:nvSpPr>
-          <p:cNvPr id="71" name="Text 69"/>
-          <p:cNvSpPr txBox="1"/>
-          <p:nvPr/>
-        </p:nvSpPr>
-        <p:spPr>
-          <a:xfrm>
-            <a:off x="7772400" y="5067300"/>
-            <a:ext cx="304800" cy="215900"/>
-          </a:xfrm>
-          <a:prstGeom prst="rect">
-            <a:avLst/>
-          </a:prstGeom>
-          <a:noFill/>
-          <a:ln/>
-        </p:spPr>
-        <p:txBody>
-          <a:bodyPr wrap="square" lIns="0" tIns="0" rIns="0" bIns="0" rtlCol="0" anchor="t"/>
-          <a:lstStyle/>
-          <a:p>
-            <a:pPr algn="l" indent="0" marL="0">
-              <a:lnSpc>
-                <a:spcPct val="115000"/>
+              <a:t>[Name] [Lvl]</a:t>
+            </a:r>
+            <a:endParaRPr lang="en-US" sz="1200" dirty="0"/>
+          </a:p>
+          <a:p>
+            <a:pPr algn="l" indent="0" marL="0">
+              <a:lnSpc>
+                <a:spcPct val="105000"/>
               </a:lnSpc>
               <a:buNone/>
             </a:pPr>
             <a:r>
               <a:rPr lang="en-US" sz="1200" dirty="0">
                 <a:solidFill>
+                  <a:srgbClr val="4A5568"/>
+                </a:solidFill>
+                <a:latin typeface="Optimist Sans" pitchFamily="34" charset="0"/>
+                <a:ea typeface="Optimist Sans" pitchFamily="34" charset="-122"/>
+                <a:cs typeface="Optimist Sans" pitchFamily="34" charset="-120"/>
+              </a:rPr>
+              <a:t>[Name] [Lvl]</a:t>
+            </a:r>
+            <a:endParaRPr lang="en-US" sz="1200" dirty="0"/>
+          </a:p>
+          <a:p>
+            <a:pPr algn="l" indent="0" marL="0">
+              <a:lnSpc>
+                <a:spcPct val="105000"/>
+              </a:lnSpc>
+              <a:buNone/>
+            </a:pPr>
+            <a:r>
+              <a:rPr lang="en-US" sz="1200" dirty="0">
+                <a:solidFill>
+                  <a:srgbClr val="4A5568"/>
+                </a:solidFill>
+                <a:latin typeface="Optimist Sans" pitchFamily="34" charset="0"/>
+                <a:ea typeface="Optimist Sans" pitchFamily="34" charset="-122"/>
+                <a:cs typeface="Optimist Sans" pitchFamily="34" charset="-120"/>
+              </a:rPr>
+              <a:t>[Name] [Lvl]</a:t>
+            </a:r>
+            <a:endParaRPr lang="en-US" sz="1200" dirty="0"/>
+          </a:p>
+          <a:p>
+            <a:pPr algn="l" indent="0" marL="0">
+              <a:lnSpc>
+                <a:spcPct val="105000"/>
+              </a:lnSpc>
+              <a:buNone/>
+            </a:pPr>
+            <a:r>
+              <a:rPr lang="en-US" sz="1200" dirty="0">
+                <a:solidFill>
+                  <a:srgbClr val="4A5568"/>
+                </a:solidFill>
+                <a:latin typeface="Optimist Sans" pitchFamily="34" charset="0"/>
+                <a:ea typeface="Optimist Sans" pitchFamily="34" charset="-122"/>
+                <a:cs typeface="Optimist Sans" pitchFamily="34" charset="-120"/>
+              </a:rPr>
+              <a:t>[Name] [Lvl]</a:t>
+            </a:r>
+            <a:endParaRPr lang="en-US" sz="1200" dirty="0"/>
+          </a:p>
+          <a:p>
+            <a:pPr algn="l" indent="0" marL="0">
+              <a:lnSpc>
+                <a:spcPct val="105000"/>
+              </a:lnSpc>
+              <a:buNone/>
+            </a:pPr>
+            <a:r>
+              <a:rPr lang="en-US" sz="1200" dirty="0">
+                <a:solidFill>
+                  <a:srgbClr val="4A5568"/>
+                </a:solidFill>
+                <a:latin typeface="Optimist Sans" pitchFamily="34" charset="0"/>
+                <a:ea typeface="Optimist Sans" pitchFamily="34" charset="-122"/>
+                <a:cs typeface="Optimist Sans" pitchFamily="34" charset="-120"/>
+              </a:rPr>
+              <a:t>[Opening] [Lvl]</a:t>
+            </a:r>
+            <a:endParaRPr lang="en-US" sz="1200" dirty="0"/>
+          </a:p>
+        </p:txBody>
+      </p:sp>
+      <p:sp>
+        <p:nvSpPr>
+          <p:cNvPr id="87" name="Shape 85"/>
+          <p:cNvSpPr/>
+          <p:nvPr/>
+        </p:nvSpPr>
+        <p:spPr>
+          <a:xfrm>
+            <a:off x="7772400" y="5213350"/>
+            <a:ext cx="1574800" cy="914"/>
+          </a:xfrm>
+          <a:prstGeom prst="line">
+            <a:avLst/>
+          </a:prstGeom>
+          <a:noFill/>
+          <a:ln w="12700">
+            <a:solidFill>
+              <a:srgbClr val="E3DED2"/>
+            </a:solidFill>
+            <a:prstDash val="solid"/>
+          </a:ln>
+        </p:spPr>
+      </p:sp>
+      <p:sp>
+        <p:nvSpPr>
+          <p:cNvPr id="88" name="Shape 86"/>
+          <p:cNvSpPr/>
+          <p:nvPr/>
+        </p:nvSpPr>
+        <p:spPr>
+          <a:xfrm>
+            <a:off x="8051800" y="5264150"/>
+            <a:ext cx="203200" cy="152400"/>
+          </a:xfrm>
+          <a:prstGeom prst="rect">
+            <a:avLst/>
+          </a:prstGeom>
+          <a:solidFill>
+            <a:srgbClr val="1F6F7E"/>
+          </a:solidFill>
+          <a:ln/>
+        </p:spPr>
+      </p:sp>
+      <p:sp>
+        <p:nvSpPr>
+          <p:cNvPr id="89" name="Text 87"/>
+          <p:cNvSpPr txBox="1"/>
+          <p:nvPr/>
+        </p:nvSpPr>
+        <p:spPr>
+          <a:xfrm>
+            <a:off x="7975600" y="5429250"/>
+            <a:ext cx="355600" cy="165100"/>
+          </a:xfrm>
+          <a:prstGeom prst="rect">
+            <a:avLst/>
+          </a:prstGeom>
+          <a:noFill/>
+          <a:ln/>
+        </p:spPr>
+        <p:txBody>
+          <a:bodyPr wrap="square" lIns="0" tIns="0" rIns="0" bIns="0" rtlCol="0" anchor="t"/>
+          <a:lstStyle/>
+          <a:p>
+            <a:pPr algn="ctr" indent="0" marL="0">
+              <a:lnSpc>
+                <a:spcPct val="100000"/>
+              </a:lnSpc>
+              <a:buNone/>
+            </a:pPr>
+            <a:r>
+              <a:rPr lang="en-US" sz="1200" b="1" dirty="0">
+                <a:solidFill>
+                  <a:srgbClr val="14213D"/>
+                </a:solidFill>
+                <a:latin typeface="Optimist Sans" pitchFamily="34" charset="0"/>
+                <a:ea typeface="Optimist Sans" pitchFamily="34" charset="-122"/>
+                <a:cs typeface="Optimist Sans" pitchFamily="34" charset="-120"/>
+              </a:rPr>
+              <a:t>[n]</a:t>
+            </a:r>
+            <a:endParaRPr lang="en-US" sz="1200" dirty="0"/>
+          </a:p>
+        </p:txBody>
+      </p:sp>
+      <p:sp>
+        <p:nvSpPr>
+          <p:cNvPr id="90" name="Text 88"/>
+          <p:cNvSpPr txBox="1"/>
+          <p:nvPr/>
+        </p:nvSpPr>
+        <p:spPr>
+          <a:xfrm>
+            <a:off x="7975600" y="5600700"/>
+            <a:ext cx="355600" cy="165100"/>
+          </a:xfrm>
+          <a:prstGeom prst="rect">
+            <a:avLst/>
+          </a:prstGeom>
+          <a:noFill/>
+          <a:ln/>
+        </p:spPr>
+        <p:txBody>
+          <a:bodyPr wrap="square" lIns="0" tIns="0" rIns="0" bIns="0" rtlCol="0" anchor="t"/>
+          <a:lstStyle/>
+          <a:p>
+            <a:pPr algn="ctr" indent="0" marL="0">
+              <a:lnSpc>
+                <a:spcPct val="100000"/>
+              </a:lnSpc>
+              <a:buNone/>
+            </a:pPr>
+            <a:r>
+              <a:rPr lang="en-US" sz="1200" dirty="0">
+                <a:solidFill>
                   <a:srgbClr val="6B7280"/>
                 </a:solidFill>
                 <a:latin typeface="Optimist Sans" pitchFamily="34" charset="0"/>
@@ -9217,28 +9846,48 @@
       </p:sp>
       <p:sp>
         <p:nvSpPr>
-          <p:cNvPr id="72" name="Text 70"/>
-          <p:cNvSpPr txBox="1"/>
-          <p:nvPr/>
-        </p:nvSpPr>
-        <p:spPr>
-          <a:xfrm>
-            <a:off x="8153400" y="5067300"/>
-            <a:ext cx="1193800" cy="215900"/>
-          </a:xfrm>
-          <a:prstGeom prst="rect">
-            <a:avLst/>
-          </a:prstGeom>
-          <a:noFill/>
-          <a:ln/>
-        </p:spPr>
-        <p:txBody>
-          <a:bodyPr wrap="square" lIns="0" tIns="0" rIns="0" bIns="0" rtlCol="0" anchor="t"/>
-          <a:lstStyle/>
-          <a:p>
-            <a:pPr algn="l" indent="0" marL="0">
-              <a:lnSpc>
-                <a:spcPct val="115000"/>
+          <p:cNvPr id="91" name="Shape 89"/>
+          <p:cNvSpPr/>
+          <p:nvPr/>
+        </p:nvSpPr>
+        <p:spPr>
+          <a:xfrm>
+            <a:off x="8458200" y="5302250"/>
+            <a:ext cx="203200" cy="114300"/>
+          </a:xfrm>
+          <a:prstGeom prst="rect">
+            <a:avLst/>
+          </a:prstGeom>
+          <a:solidFill>
+            <a:srgbClr val="1F6F7E"/>
+          </a:solidFill>
+          <a:ln/>
+        </p:spPr>
+      </p:sp>
+      <p:sp>
+        <p:nvSpPr>
+          <p:cNvPr id="92" name="Text 90"/>
+          <p:cNvSpPr txBox="1"/>
+          <p:nvPr/>
+        </p:nvSpPr>
+        <p:spPr>
+          <a:xfrm>
+            <a:off x="8382000" y="5429250"/>
+            <a:ext cx="355600" cy="165100"/>
+          </a:xfrm>
+          <a:prstGeom prst="rect">
+            <a:avLst/>
+          </a:prstGeom>
+          <a:noFill/>
+          <a:ln/>
+        </p:spPr>
+        <p:txBody>
+          <a:bodyPr wrap="square" lIns="0" tIns="0" rIns="0" bIns="0" rtlCol="0" anchor="t"/>
+          <a:lstStyle/>
+          <a:p>
+            <a:pPr algn="ctr" indent="0" marL="0">
+              <a:lnSpc>
+                <a:spcPct val="100000"/>
               </a:lnSpc>
               <a:buNone/>
             </a:pPr>
@@ -9251,11 +9900,36 @@
                 <a:ea typeface="Optimist Sans" pitchFamily="34" charset="-122"/>
                 <a:cs typeface="Optimist Sans" pitchFamily="34" charset="-120"/>
               </a:rPr>
-              <a:t>[n] </a:t>
-            </a:r>
-            <a:pPr algn="l" indent="0" marL="0">
-              <a:lnSpc>
-                <a:spcPct val="115000"/>
+              <a:t>[n]</a:t>
+            </a:r>
+            <a:endParaRPr lang="en-US" sz="1200" dirty="0"/>
+          </a:p>
+        </p:txBody>
+      </p:sp>
+      <p:sp>
+        <p:nvSpPr>
+          <p:cNvPr id="93" name="Text 91"/>
+          <p:cNvSpPr txBox="1"/>
+          <p:nvPr/>
+        </p:nvSpPr>
+        <p:spPr>
+          <a:xfrm>
+            <a:off x="8382000" y="5600700"/>
+            <a:ext cx="355600" cy="165100"/>
+          </a:xfrm>
+          <a:prstGeom prst="rect">
+            <a:avLst/>
+          </a:prstGeom>
+          <a:noFill/>
+          <a:ln/>
+        </p:spPr>
+        <p:txBody>
+          <a:bodyPr wrap="square" lIns="0" tIns="0" rIns="0" bIns="0" rtlCol="0" anchor="t"/>
+          <a:lstStyle/>
+          <a:p>
+            <a:pPr algn="ctr" indent="0" marL="0">
+              <a:lnSpc>
+                <a:spcPct val="100000"/>
               </a:lnSpc>
               <a:buNone/>
             </a:pPr>
@@ -9268,36 +9942,98 @@
                 <a:ea typeface="Optimist Sans" pitchFamily="34" charset="-122"/>
                 <a:cs typeface="Optimist Sans" pitchFamily="34" charset="-120"/>
               </a:rPr>
-              <a:t>([n])</a:t>
-            </a:r>
-            <a:endParaRPr lang="en-US" sz="1200" dirty="0"/>
-          </a:p>
-        </p:txBody>
-      </p:sp>
-      <p:sp>
-        <p:nvSpPr>
-          <p:cNvPr id="73" name="Text 71"/>
-          <p:cNvSpPr txBox="1"/>
-          <p:nvPr/>
-        </p:nvSpPr>
-        <p:spPr>
-          <a:xfrm>
-            <a:off x="7772400" y="5295900"/>
-            <a:ext cx="304800" cy="215900"/>
-          </a:xfrm>
-          <a:prstGeom prst="rect">
-            <a:avLst/>
-          </a:prstGeom>
-          <a:noFill/>
-          <a:ln/>
-        </p:spPr>
-        <p:txBody>
-          <a:bodyPr wrap="square" lIns="0" tIns="0" rIns="0" bIns="0" rtlCol="0" anchor="t"/>
-          <a:lstStyle/>
-          <a:p>
-            <a:pPr algn="l" indent="0" marL="0">
-              <a:lnSpc>
-                <a:spcPct val="115000"/>
+              <a:t>’27</a:t>
+            </a:r>
+            <a:endParaRPr lang="en-US" sz="1200" dirty="0"/>
+          </a:p>
+        </p:txBody>
+      </p:sp>
+      <p:sp>
+        <p:nvSpPr>
+          <p:cNvPr id="94" name="Shape 92"/>
+          <p:cNvSpPr/>
+          <p:nvPr/>
+        </p:nvSpPr>
+        <p:spPr>
+          <a:xfrm>
+            <a:off x="8864600" y="5340350"/>
+            <a:ext cx="203200" cy="76200"/>
+          </a:xfrm>
+          <a:prstGeom prst="rect">
+            <a:avLst/>
+          </a:prstGeom>
+          <a:solidFill>
+            <a:srgbClr val="1F6F7E"/>
+          </a:solidFill>
+          <a:ln/>
+        </p:spPr>
+      </p:sp>
+      <p:sp>
+        <p:nvSpPr>
+          <p:cNvPr id="95" name="Text 93"/>
+          <p:cNvSpPr txBox="1"/>
+          <p:nvPr/>
+        </p:nvSpPr>
+        <p:spPr>
+          <a:xfrm>
+            <a:off x="8788400" y="5429250"/>
+            <a:ext cx="355600" cy="165100"/>
+          </a:xfrm>
+          <a:prstGeom prst="rect">
+            <a:avLst/>
+          </a:prstGeom>
+          <a:noFill/>
+          <a:ln/>
+        </p:spPr>
+        <p:txBody>
+          <a:bodyPr wrap="square" lIns="0" tIns="0" rIns="0" bIns="0" rtlCol="0" anchor="t"/>
+          <a:lstStyle/>
+          <a:p>
+            <a:pPr algn="ctr" indent="0" marL="0">
+              <a:lnSpc>
+                <a:spcPct val="100000"/>
+              </a:lnSpc>
+              <a:buNone/>
+            </a:pPr>
+            <a:r>
+              <a:rPr lang="en-US" sz="1200" b="1" dirty="0">
+                <a:solidFill>
+                  <a:srgbClr val="14213D"/>
+                </a:solidFill>
+                <a:latin typeface="Optimist Sans" pitchFamily="34" charset="0"/>
+                <a:ea typeface="Optimist Sans" pitchFamily="34" charset="-122"/>
+                <a:cs typeface="Optimist Sans" pitchFamily="34" charset="-120"/>
+              </a:rPr>
+              <a:t>[n]</a:t>
+            </a:r>
+            <a:endParaRPr lang="en-US" sz="1200" dirty="0"/>
+          </a:p>
+        </p:txBody>
+      </p:sp>
+      <p:sp>
+        <p:nvSpPr>
+          <p:cNvPr id="96" name="Text 94"/>
+          <p:cNvSpPr txBox="1"/>
+          <p:nvPr/>
+        </p:nvSpPr>
+        <p:spPr>
+          <a:xfrm>
+            <a:off x="8788400" y="5600700"/>
+            <a:ext cx="355600" cy="165100"/>
+          </a:xfrm>
+          <a:prstGeom prst="rect">
+            <a:avLst/>
+          </a:prstGeom>
+          <a:noFill/>
+          <a:ln/>
+        </p:spPr>
+        <p:txBody>
+          <a:bodyPr wrap="square" lIns="0" tIns="0" rIns="0" bIns="0" rtlCol="0" anchor="t"/>
+          <a:lstStyle/>
+          <a:p>
+            <a:pPr algn="ctr" indent="0" marL="0">
+              <a:lnSpc>
+                <a:spcPct val="100000"/>
               </a:lnSpc>
               <a:buNone/>
             </a:pPr>
@@ -9310,90 +10046,6 @@
                 <a:ea typeface="Optimist Sans" pitchFamily="34" charset="-122"/>
                 <a:cs typeface="Optimist Sans" pitchFamily="34" charset="-120"/>
               </a:rPr>
-              <a:t>’27</a:t>
-            </a:r>
-            <a:endParaRPr lang="en-US" sz="1200" dirty="0"/>
-          </a:p>
-        </p:txBody>
-      </p:sp>
-      <p:sp>
-        <p:nvSpPr>
-          <p:cNvPr id="74" name="Text 72"/>
-          <p:cNvSpPr txBox="1"/>
-          <p:nvPr/>
-        </p:nvSpPr>
-        <p:spPr>
-          <a:xfrm>
-            <a:off x="8153400" y="5295900"/>
-            <a:ext cx="1193800" cy="215900"/>
-          </a:xfrm>
-          <a:prstGeom prst="rect">
-            <a:avLst/>
-          </a:prstGeom>
-          <a:noFill/>
-          <a:ln/>
-        </p:spPr>
-        <p:txBody>
-          <a:bodyPr wrap="square" lIns="0" tIns="0" rIns="0" bIns="0" rtlCol="0" anchor="t"/>
-          <a:lstStyle/>
-          <a:p>
-            <a:pPr algn="l" indent="0" marL="0">
-              <a:lnSpc>
-                <a:spcPct val="115000"/>
-              </a:lnSpc>
-              <a:buNone/>
-            </a:pPr>
-            <a:r>
-              <a:rPr lang="en-US" sz="1200" b="1" dirty="0">
-                <a:solidFill>
-                  <a:srgbClr val="14213D"/>
-                </a:solidFill>
-                <a:latin typeface="Optimist Sans" pitchFamily="34" charset="0"/>
-                <a:ea typeface="Optimist Sans" pitchFamily="34" charset="-122"/>
-                <a:cs typeface="Optimist Sans" pitchFamily="34" charset="-120"/>
-              </a:rPr>
-              <a:t>[n]</a:t>
-            </a:r>
-            <a:endParaRPr lang="en-US" sz="1200" dirty="0"/>
-          </a:p>
-        </p:txBody>
-      </p:sp>
-      <p:sp>
-        <p:nvSpPr>
-          <p:cNvPr id="75" name="Text 73"/>
-          <p:cNvSpPr txBox="1"/>
-          <p:nvPr/>
-        </p:nvSpPr>
-        <p:spPr>
-          <a:xfrm>
-            <a:off x="7772400" y="5524500"/>
-            <a:ext cx="304800" cy="215900"/>
-          </a:xfrm>
-          <a:prstGeom prst="rect">
-            <a:avLst/>
-          </a:prstGeom>
-          <a:noFill/>
-          <a:ln/>
-        </p:spPr>
-        <p:txBody>
-          <a:bodyPr wrap="square" lIns="0" tIns="0" rIns="0" bIns="0" rtlCol="0" anchor="t"/>
-          <a:lstStyle/>
-          <a:p>
-            <a:pPr algn="l" indent="0" marL="0">
-              <a:lnSpc>
-                <a:spcPct val="115000"/>
-              </a:lnSpc>
-              <a:buNone/>
-            </a:pPr>
-            <a:r>
-              <a:rPr lang="en-US" sz="1200" dirty="0">
-                <a:solidFill>
-                  <a:srgbClr val="6B7280"/>
-                </a:solidFill>
-                <a:latin typeface="Optimist Sans" pitchFamily="34" charset="0"/>
-                <a:ea typeface="Optimist Sans" pitchFamily="34" charset="-122"/>
-                <a:cs typeface="Optimist Sans" pitchFamily="34" charset="-120"/>
-              </a:rPr>
               <a:t>’28</a:t>
             </a:r>
             <a:endParaRPr lang="en-US" sz="1200" dirty="0"/>
@@ -9402,49 +10054,7 @@
       </p:sp>
       <p:sp>
         <p:nvSpPr>
-          <p:cNvPr id="76" name="Text 74"/>
-          <p:cNvSpPr txBox="1"/>
-          <p:nvPr/>
-        </p:nvSpPr>
-        <p:spPr>
-          <a:xfrm>
-            <a:off x="8153400" y="5524500"/>
-            <a:ext cx="1193800" cy="215900"/>
-          </a:xfrm>
-          <a:prstGeom prst="rect">
-            <a:avLst/>
-          </a:prstGeom>
-          <a:noFill/>
-          <a:ln/>
-        </p:spPr>
-        <p:txBody>
-          <a:bodyPr wrap="square" lIns="0" tIns="0" rIns="0" bIns="0" rtlCol="0" anchor="t"/>
-          <a:lstStyle/>
-          <a:p>
-            <a:pPr algn="l" indent="0" marL="0">
-              <a:lnSpc>
-                <a:spcPct val="115000"/>
-              </a:lnSpc>
-              <a:buNone/>
-            </a:pPr>
-            <a:r>
-              <a:rPr lang="en-US" sz="1200" b="1" dirty="0">
-                <a:solidFill>
-                  <a:srgbClr val="14213D"/>
-                </a:solidFill>
-                <a:latin typeface="Optimist Sans" pitchFamily="34" charset="0"/>
-                <a:ea typeface="Optimist Sans" pitchFamily="34" charset="-122"/>
-                <a:cs typeface="Optimist Sans" pitchFamily="34" charset="-120"/>
-              </a:rPr>
-              <a:t>[n]</a:t>
-            </a:r>
-            <a:endParaRPr lang="en-US" sz="1200" dirty="0"/>
-          </a:p>
-        </p:txBody>
-      </p:sp>
-      <p:sp>
-        <p:nvSpPr>
-          <p:cNvPr id="77" name="Shape 75"/>
+          <p:cNvPr id="97" name="Shape 95"/>
           <p:cNvSpPr/>
           <p:nvPr/>
         </p:nvSpPr>
@@ -9471,28 +10081,28 @@
       </p:sp>
       <p:sp>
         <p:nvSpPr>
-          <p:cNvPr id="78" name="Text 76"/>
+          <p:cNvPr id="98" name="Text 96"/>
           <p:cNvSpPr txBox="1"/>
           <p:nvPr/>
         </p:nvSpPr>
         <p:spPr>
           <a:xfrm>
             <a:off x="9702800" y="3911600"/>
-            <a:ext cx="1574800" cy="406400"/>
-          </a:xfrm>
-          <a:prstGeom prst="rect">
-            <a:avLst/>
-          </a:prstGeom>
-          <a:noFill/>
-          <a:ln/>
-        </p:spPr>
-        <p:txBody>
-          <a:bodyPr wrap="square" lIns="0" tIns="0" rIns="0" bIns="0" rtlCol="0" anchor="t"/>
-          <a:lstStyle/>
-          <a:p>
-            <a:pPr algn="l" indent="0" marL="0">
-              <a:lnSpc>
-                <a:spcPct val="115000"/>
+            <a:ext cx="1574800" cy="984250"/>
+          </a:xfrm>
+          <a:prstGeom prst="rect">
+            <a:avLst/>
+          </a:prstGeom>
+          <a:noFill/>
+          <a:ln/>
+        </p:spPr>
+        <p:txBody>
+          <a:bodyPr wrap="square" lIns="0" tIns="0" rIns="0" bIns="0" rtlCol="0" anchor="t"/>
+          <a:lstStyle/>
+          <a:p>
+            <a:pPr algn="l" indent="0" marL="0">
+              <a:lnSpc>
+                <a:spcPct val="105000"/>
               </a:lnSpc>
               <a:buNone/>
             </a:pPr>
@@ -9505,42 +10115,207 @@
                 <a:ea typeface="Optimist Sans" pitchFamily="34" charset="-122"/>
                 <a:cs typeface="Optimist Sans" pitchFamily="34" charset="-120"/>
               </a:rPr>
-              <a:t>[Name], [Name], [Name], …</a:t>
-            </a:r>
-            <a:endParaRPr lang="en-US" sz="1200" dirty="0"/>
-          </a:p>
-        </p:txBody>
-      </p:sp>
-      <p:sp>
-        <p:nvSpPr>
-          <p:cNvPr id="79" name="Text 77"/>
-          <p:cNvSpPr txBox="1"/>
-          <p:nvPr/>
-        </p:nvSpPr>
-        <p:spPr>
-          <a:xfrm>
-            <a:off x="9702800" y="5067300"/>
-            <a:ext cx="304800" cy="215900"/>
-          </a:xfrm>
-          <a:prstGeom prst="rect">
-            <a:avLst/>
-          </a:prstGeom>
-          <a:noFill/>
-          <a:ln/>
-        </p:spPr>
-        <p:txBody>
-          <a:bodyPr wrap="square" lIns="0" tIns="0" rIns="0" bIns="0" rtlCol="0" anchor="t"/>
-          <a:lstStyle/>
-          <a:p>
-            <a:pPr algn="l" indent="0" marL="0">
-              <a:lnSpc>
-                <a:spcPct val="115000"/>
+              <a:t>[Name] [Lvl]</a:t>
+            </a:r>
+            <a:endParaRPr lang="en-US" sz="1200" dirty="0"/>
+          </a:p>
+          <a:p>
+            <a:pPr algn="l" indent="0" marL="0">
+              <a:lnSpc>
+                <a:spcPct val="105000"/>
               </a:lnSpc>
               <a:buNone/>
             </a:pPr>
             <a:r>
               <a:rPr lang="en-US" sz="1200" dirty="0">
                 <a:solidFill>
+                  <a:srgbClr val="4A5568"/>
+                </a:solidFill>
+                <a:latin typeface="Optimist Sans" pitchFamily="34" charset="0"/>
+                <a:ea typeface="Optimist Sans" pitchFamily="34" charset="-122"/>
+                <a:cs typeface="Optimist Sans" pitchFamily="34" charset="-120"/>
+              </a:rPr>
+              <a:t>[Name] [Lvl]</a:t>
+            </a:r>
+            <a:endParaRPr lang="en-US" sz="1200" dirty="0"/>
+          </a:p>
+          <a:p>
+            <a:pPr algn="l" indent="0" marL="0">
+              <a:lnSpc>
+                <a:spcPct val="105000"/>
+              </a:lnSpc>
+              <a:buNone/>
+            </a:pPr>
+            <a:r>
+              <a:rPr lang="en-US" sz="1200" dirty="0">
+                <a:solidFill>
+                  <a:srgbClr val="4A5568"/>
+                </a:solidFill>
+                <a:latin typeface="Optimist Sans" pitchFamily="34" charset="0"/>
+                <a:ea typeface="Optimist Sans" pitchFamily="34" charset="-122"/>
+                <a:cs typeface="Optimist Sans" pitchFamily="34" charset="-120"/>
+              </a:rPr>
+              <a:t>[Name] [Lvl]</a:t>
+            </a:r>
+            <a:endParaRPr lang="en-US" sz="1200" dirty="0"/>
+          </a:p>
+          <a:p>
+            <a:pPr algn="l" indent="0" marL="0">
+              <a:lnSpc>
+                <a:spcPct val="105000"/>
+              </a:lnSpc>
+              <a:buNone/>
+            </a:pPr>
+            <a:r>
+              <a:rPr lang="en-US" sz="1200" dirty="0">
+                <a:solidFill>
+                  <a:srgbClr val="4A5568"/>
+                </a:solidFill>
+                <a:latin typeface="Optimist Sans" pitchFamily="34" charset="0"/>
+                <a:ea typeface="Optimist Sans" pitchFamily="34" charset="-122"/>
+                <a:cs typeface="Optimist Sans" pitchFamily="34" charset="-120"/>
+              </a:rPr>
+              <a:t>[Name] [Lvl]</a:t>
+            </a:r>
+            <a:endParaRPr lang="en-US" sz="1200" dirty="0"/>
+          </a:p>
+          <a:p>
+            <a:pPr algn="l" indent="0" marL="0">
+              <a:lnSpc>
+                <a:spcPct val="105000"/>
+              </a:lnSpc>
+              <a:buNone/>
+            </a:pPr>
+            <a:r>
+              <a:rPr lang="en-US" sz="1200" dirty="0">
+                <a:solidFill>
+                  <a:srgbClr val="4A5568"/>
+                </a:solidFill>
+                <a:latin typeface="Optimist Sans" pitchFamily="34" charset="0"/>
+                <a:ea typeface="Optimist Sans" pitchFamily="34" charset="-122"/>
+                <a:cs typeface="Optimist Sans" pitchFamily="34" charset="-120"/>
+              </a:rPr>
+              <a:t>[Opening] [Lvl]</a:t>
+            </a:r>
+            <a:endParaRPr lang="en-US" sz="1200" dirty="0"/>
+          </a:p>
+        </p:txBody>
+      </p:sp>
+      <p:sp>
+        <p:nvSpPr>
+          <p:cNvPr id="99" name="Shape 97"/>
+          <p:cNvSpPr/>
+          <p:nvPr/>
+        </p:nvSpPr>
+        <p:spPr>
+          <a:xfrm>
+            <a:off x="9702800" y="5213350"/>
+            <a:ext cx="1574800" cy="914"/>
+          </a:xfrm>
+          <a:prstGeom prst="line">
+            <a:avLst/>
+          </a:prstGeom>
+          <a:noFill/>
+          <a:ln w="12700">
+            <a:solidFill>
+              <a:srgbClr val="E3DED2"/>
+            </a:solidFill>
+            <a:prstDash val="solid"/>
+          </a:ln>
+        </p:spPr>
+      </p:sp>
+      <p:sp>
+        <p:nvSpPr>
+          <p:cNvPr id="100" name="Shape 98"/>
+          <p:cNvSpPr/>
+          <p:nvPr/>
+        </p:nvSpPr>
+        <p:spPr>
+          <a:xfrm>
+            <a:off x="9982200" y="5353050"/>
+            <a:ext cx="203200" cy="63500"/>
+          </a:xfrm>
+          <a:prstGeom prst="rect">
+            <a:avLst/>
+          </a:prstGeom>
+          <a:solidFill>
+            <a:srgbClr val="E3A86B"/>
+          </a:solidFill>
+          <a:ln/>
+        </p:spPr>
+      </p:sp>
+      <p:sp>
+        <p:nvSpPr>
+          <p:cNvPr id="101" name="Text 99"/>
+          <p:cNvSpPr txBox="1"/>
+          <p:nvPr/>
+        </p:nvSpPr>
+        <p:spPr>
+          <a:xfrm>
+            <a:off x="9906000" y="5429250"/>
+            <a:ext cx="355600" cy="165100"/>
+          </a:xfrm>
+          <a:prstGeom prst="rect">
+            <a:avLst/>
+          </a:prstGeom>
+          <a:noFill/>
+          <a:ln/>
+        </p:spPr>
+        <p:txBody>
+          <a:bodyPr wrap="square" lIns="0" tIns="0" rIns="0" bIns="0" rtlCol="0" anchor="t"/>
+          <a:lstStyle/>
+          <a:p>
+            <a:pPr algn="ctr" indent="0" marL="0">
+              <a:lnSpc>
+                <a:spcPct val="100000"/>
+              </a:lnSpc>
+              <a:buNone/>
+            </a:pPr>
+            <a:r>
+              <a:rPr lang="en-US" sz="1200" b="1" dirty="0">
+                <a:solidFill>
+                  <a:srgbClr val="8A4514"/>
+                </a:solidFill>
+                <a:latin typeface="Optimist Sans" pitchFamily="34" charset="0"/>
+                <a:ea typeface="Optimist Sans" pitchFamily="34" charset="-122"/>
+                <a:cs typeface="Optimist Sans" pitchFamily="34" charset="-120"/>
+              </a:rPr>
+              <a:t>[n]</a:t>
+            </a:r>
+            <a:endParaRPr lang="en-US" sz="1200" dirty="0"/>
+          </a:p>
+        </p:txBody>
+      </p:sp>
+      <p:sp>
+        <p:nvSpPr>
+          <p:cNvPr id="102" name="Text 100"/>
+          <p:cNvSpPr txBox="1"/>
+          <p:nvPr/>
+        </p:nvSpPr>
+        <p:spPr>
+          <a:xfrm>
+            <a:off x="9906000" y="5600700"/>
+            <a:ext cx="355600" cy="165100"/>
+          </a:xfrm>
+          <a:prstGeom prst="rect">
+            <a:avLst/>
+          </a:prstGeom>
+          <a:noFill/>
+          <a:ln/>
+        </p:spPr>
+        <p:txBody>
+          <a:bodyPr wrap="square" lIns="0" tIns="0" rIns="0" bIns="0" rtlCol="0" anchor="t"/>
+          <a:lstStyle/>
+          <a:p>
+            <a:pPr algn="ctr" indent="0" marL="0">
+              <a:lnSpc>
+                <a:spcPct val="100000"/>
+              </a:lnSpc>
+              <a:buNone/>
+            </a:pPr>
+            <a:r>
+              <a:rPr lang="en-US" sz="1200" dirty="0">
+                <a:solidFill>
                   <a:srgbClr val="6B7280"/>
                 </a:solidFill>
                 <a:latin typeface="Optimist Sans" pitchFamily="34" charset="0"/>
@@ -9555,28 +10330,48 @@
       </p:sp>
       <p:sp>
         <p:nvSpPr>
-          <p:cNvPr id="80" name="Text 78"/>
-          <p:cNvSpPr txBox="1"/>
-          <p:nvPr/>
-        </p:nvSpPr>
-        <p:spPr>
-          <a:xfrm>
-            <a:off x="10083800" y="5067300"/>
-            <a:ext cx="1193800" cy="215900"/>
-          </a:xfrm>
-          <a:prstGeom prst="rect">
-            <a:avLst/>
-          </a:prstGeom>
-          <a:noFill/>
-          <a:ln/>
-        </p:spPr>
-        <p:txBody>
-          <a:bodyPr wrap="square" lIns="0" tIns="0" rIns="0" bIns="0" rtlCol="0" anchor="t"/>
-          <a:lstStyle/>
-          <a:p>
-            <a:pPr algn="l" indent="0" marL="0">
-              <a:lnSpc>
-                <a:spcPct val="115000"/>
+          <p:cNvPr id="103" name="Shape 101"/>
+          <p:cNvSpPr/>
+          <p:nvPr/>
+        </p:nvSpPr>
+        <p:spPr>
+          <a:xfrm>
+            <a:off x="10388600" y="5308600"/>
+            <a:ext cx="203200" cy="107950"/>
+          </a:xfrm>
+          <a:prstGeom prst="rect">
+            <a:avLst/>
+          </a:prstGeom>
+          <a:solidFill>
+            <a:srgbClr val="E3A86B"/>
+          </a:solidFill>
+          <a:ln/>
+        </p:spPr>
+      </p:sp>
+      <p:sp>
+        <p:nvSpPr>
+          <p:cNvPr id="104" name="Text 102"/>
+          <p:cNvSpPr txBox="1"/>
+          <p:nvPr/>
+        </p:nvSpPr>
+        <p:spPr>
+          <a:xfrm>
+            <a:off x="10312400" y="5429250"/>
+            <a:ext cx="355600" cy="165100"/>
+          </a:xfrm>
+          <a:prstGeom prst="rect">
+            <a:avLst/>
+          </a:prstGeom>
+          <a:noFill/>
+          <a:ln/>
+        </p:spPr>
+        <p:txBody>
+          <a:bodyPr wrap="square" lIns="0" tIns="0" rIns="0" bIns="0" rtlCol="0" anchor="t"/>
+          <a:lstStyle/>
+          <a:p>
+            <a:pPr algn="ctr" indent="0" marL="0">
+              <a:lnSpc>
+                <a:spcPct val="100000"/>
               </a:lnSpc>
               <a:buNone/>
             </a:pPr>
@@ -9589,11 +10384,36 @@
                 <a:ea typeface="Optimist Sans" pitchFamily="34" charset="-122"/>
                 <a:cs typeface="Optimist Sans" pitchFamily="34" charset="-120"/>
               </a:rPr>
-              <a:t>[n] </a:t>
-            </a:r>
-            <a:pPr algn="l" indent="0" marL="0">
-              <a:lnSpc>
-                <a:spcPct val="115000"/>
+              <a:t>[n]</a:t>
+            </a:r>
+            <a:endParaRPr lang="en-US" sz="1200" dirty="0"/>
+          </a:p>
+        </p:txBody>
+      </p:sp>
+      <p:sp>
+        <p:nvSpPr>
+          <p:cNvPr id="105" name="Text 103"/>
+          <p:cNvSpPr txBox="1"/>
+          <p:nvPr/>
+        </p:nvSpPr>
+        <p:spPr>
+          <a:xfrm>
+            <a:off x="10312400" y="5600700"/>
+            <a:ext cx="355600" cy="165100"/>
+          </a:xfrm>
+          <a:prstGeom prst="rect">
+            <a:avLst/>
+          </a:prstGeom>
+          <a:noFill/>
+          <a:ln/>
+        </p:spPr>
+        <p:txBody>
+          <a:bodyPr wrap="square" lIns="0" tIns="0" rIns="0" bIns="0" rtlCol="0" anchor="t"/>
+          <a:lstStyle/>
+          <a:p>
+            <a:pPr algn="ctr" indent="0" marL="0">
+              <a:lnSpc>
+                <a:spcPct val="100000"/>
               </a:lnSpc>
               <a:buNone/>
             </a:pPr>
@@ -9606,36 +10426,98 @@
                 <a:ea typeface="Optimist Sans" pitchFamily="34" charset="-122"/>
                 <a:cs typeface="Optimist Sans" pitchFamily="34" charset="-120"/>
               </a:rPr>
-              <a:t>([n])</a:t>
-            </a:r>
-            <a:endParaRPr lang="en-US" sz="1200" dirty="0"/>
-          </a:p>
-        </p:txBody>
-      </p:sp>
-      <p:sp>
-        <p:nvSpPr>
-          <p:cNvPr id="81" name="Text 79"/>
-          <p:cNvSpPr txBox="1"/>
-          <p:nvPr/>
-        </p:nvSpPr>
-        <p:spPr>
-          <a:xfrm>
-            <a:off x="9702800" y="5295900"/>
-            <a:ext cx="304800" cy="215900"/>
-          </a:xfrm>
-          <a:prstGeom prst="rect">
-            <a:avLst/>
-          </a:prstGeom>
-          <a:noFill/>
-          <a:ln/>
-        </p:spPr>
-        <p:txBody>
-          <a:bodyPr wrap="square" lIns="0" tIns="0" rIns="0" bIns="0" rtlCol="0" anchor="t"/>
-          <a:lstStyle/>
-          <a:p>
-            <a:pPr algn="l" indent="0" marL="0">
-              <a:lnSpc>
-                <a:spcPct val="115000"/>
+              <a:t>’27</a:t>
+            </a:r>
+            <a:endParaRPr lang="en-US" sz="1200" dirty="0"/>
+          </a:p>
+        </p:txBody>
+      </p:sp>
+      <p:sp>
+        <p:nvSpPr>
+          <p:cNvPr id="106" name="Shape 104"/>
+          <p:cNvSpPr/>
+          <p:nvPr/>
+        </p:nvSpPr>
+        <p:spPr>
+          <a:xfrm>
+            <a:off x="10795000" y="5264150"/>
+            <a:ext cx="203200" cy="152400"/>
+          </a:xfrm>
+          <a:prstGeom prst="rect">
+            <a:avLst/>
+          </a:prstGeom>
+          <a:solidFill>
+            <a:srgbClr val="E3A86B"/>
+          </a:solidFill>
+          <a:ln/>
+        </p:spPr>
+      </p:sp>
+      <p:sp>
+        <p:nvSpPr>
+          <p:cNvPr id="107" name="Text 105"/>
+          <p:cNvSpPr txBox="1"/>
+          <p:nvPr/>
+        </p:nvSpPr>
+        <p:spPr>
+          <a:xfrm>
+            <a:off x="10718800" y="5429250"/>
+            <a:ext cx="355600" cy="165100"/>
+          </a:xfrm>
+          <a:prstGeom prst="rect">
+            <a:avLst/>
+          </a:prstGeom>
+          <a:noFill/>
+          <a:ln/>
+        </p:spPr>
+        <p:txBody>
+          <a:bodyPr wrap="square" lIns="0" tIns="0" rIns="0" bIns="0" rtlCol="0" anchor="t"/>
+          <a:lstStyle/>
+          <a:p>
+            <a:pPr algn="ctr" indent="0" marL="0">
+              <a:lnSpc>
+                <a:spcPct val="100000"/>
+              </a:lnSpc>
+              <a:buNone/>
+            </a:pPr>
+            <a:r>
+              <a:rPr lang="en-US" sz="1200" b="1" dirty="0">
+                <a:solidFill>
+                  <a:srgbClr val="8A4514"/>
+                </a:solidFill>
+                <a:latin typeface="Optimist Sans" pitchFamily="34" charset="0"/>
+                <a:ea typeface="Optimist Sans" pitchFamily="34" charset="-122"/>
+                <a:cs typeface="Optimist Sans" pitchFamily="34" charset="-120"/>
+              </a:rPr>
+              <a:t>[n]</a:t>
+            </a:r>
+            <a:endParaRPr lang="en-US" sz="1200" dirty="0"/>
+          </a:p>
+        </p:txBody>
+      </p:sp>
+      <p:sp>
+        <p:nvSpPr>
+          <p:cNvPr id="108" name="Text 106"/>
+          <p:cNvSpPr txBox="1"/>
+          <p:nvPr/>
+        </p:nvSpPr>
+        <p:spPr>
+          <a:xfrm>
+            <a:off x="10718800" y="5600700"/>
+            <a:ext cx="355600" cy="165100"/>
+          </a:xfrm>
+          <a:prstGeom prst="rect">
+            <a:avLst/>
+          </a:prstGeom>
+          <a:noFill/>
+          <a:ln/>
+        </p:spPr>
+        <p:txBody>
+          <a:bodyPr wrap="square" lIns="0" tIns="0" rIns="0" bIns="0" rtlCol="0" anchor="t"/>
+          <a:lstStyle/>
+          <a:p>
+            <a:pPr algn="ctr" indent="0" marL="0">
+              <a:lnSpc>
+                <a:spcPct val="100000"/>
               </a:lnSpc>
               <a:buNone/>
             </a:pPr>
@@ -9648,90 +10530,6 @@
                 <a:ea typeface="Optimist Sans" pitchFamily="34" charset="-122"/>
                 <a:cs typeface="Optimist Sans" pitchFamily="34" charset="-120"/>
               </a:rPr>
-              <a:t>’27</a:t>
-            </a:r>
-            <a:endParaRPr lang="en-US" sz="1200" dirty="0"/>
-          </a:p>
-        </p:txBody>
-      </p:sp>
-      <p:sp>
-        <p:nvSpPr>
-          <p:cNvPr id="82" name="Text 80"/>
-          <p:cNvSpPr txBox="1"/>
-          <p:nvPr/>
-        </p:nvSpPr>
-        <p:spPr>
-          <a:xfrm>
-            <a:off x="10083800" y="5295900"/>
-            <a:ext cx="1193800" cy="215900"/>
-          </a:xfrm>
-          <a:prstGeom prst="rect">
-            <a:avLst/>
-          </a:prstGeom>
-          <a:noFill/>
-          <a:ln/>
-        </p:spPr>
-        <p:txBody>
-          <a:bodyPr wrap="square" lIns="0" tIns="0" rIns="0" bIns="0" rtlCol="0" anchor="t"/>
-          <a:lstStyle/>
-          <a:p>
-            <a:pPr algn="l" indent="0" marL="0">
-              <a:lnSpc>
-                <a:spcPct val="115000"/>
-              </a:lnSpc>
-              <a:buNone/>
-            </a:pPr>
-            <a:r>
-              <a:rPr lang="en-US" sz="1200" b="1" dirty="0">
-                <a:solidFill>
-                  <a:srgbClr val="8A4514"/>
-                </a:solidFill>
-                <a:latin typeface="Optimist Sans" pitchFamily="34" charset="0"/>
-                <a:ea typeface="Optimist Sans" pitchFamily="34" charset="-122"/>
-                <a:cs typeface="Optimist Sans" pitchFamily="34" charset="-120"/>
-              </a:rPr>
-              <a:t>[n]</a:t>
-            </a:r>
-            <a:endParaRPr lang="en-US" sz="1200" dirty="0"/>
-          </a:p>
-        </p:txBody>
-      </p:sp>
-      <p:sp>
-        <p:nvSpPr>
-          <p:cNvPr id="83" name="Text 81"/>
-          <p:cNvSpPr txBox="1"/>
-          <p:nvPr/>
-        </p:nvSpPr>
-        <p:spPr>
-          <a:xfrm>
-            <a:off x="9702800" y="5524500"/>
-            <a:ext cx="304800" cy="215900"/>
-          </a:xfrm>
-          <a:prstGeom prst="rect">
-            <a:avLst/>
-          </a:prstGeom>
-          <a:noFill/>
-          <a:ln/>
-        </p:spPr>
-        <p:txBody>
-          <a:bodyPr wrap="square" lIns="0" tIns="0" rIns="0" bIns="0" rtlCol="0" anchor="t"/>
-          <a:lstStyle/>
-          <a:p>
-            <a:pPr algn="l" indent="0" marL="0">
-              <a:lnSpc>
-                <a:spcPct val="115000"/>
-              </a:lnSpc>
-              <a:buNone/>
-            </a:pPr>
-            <a:r>
-              <a:rPr lang="en-US" sz="1200" dirty="0">
-                <a:solidFill>
-                  <a:srgbClr val="6B7280"/>
-                </a:solidFill>
-                <a:latin typeface="Optimist Sans" pitchFamily="34" charset="0"/>
-                <a:ea typeface="Optimist Sans" pitchFamily="34" charset="-122"/>
-                <a:cs typeface="Optimist Sans" pitchFamily="34" charset="-120"/>
-              </a:rPr>
               <a:t>’28</a:t>
             </a:r>
             <a:endParaRPr lang="en-US" sz="1200" dirty="0"/>
@@ -9740,49 +10538,7 @@
       </p:sp>
       <p:sp>
         <p:nvSpPr>
-          <p:cNvPr id="84" name="Text 82"/>
-          <p:cNvSpPr txBox="1"/>
-          <p:nvPr/>
-        </p:nvSpPr>
-        <p:spPr>
-          <a:xfrm>
-            <a:off x="10083800" y="5524500"/>
-            <a:ext cx="1193800" cy="215900"/>
-          </a:xfrm>
-          <a:prstGeom prst="rect">
-            <a:avLst/>
-          </a:prstGeom>
-          <a:noFill/>
-          <a:ln/>
-        </p:spPr>
-        <p:txBody>
-          <a:bodyPr wrap="square" lIns="0" tIns="0" rIns="0" bIns="0" rtlCol="0" anchor="t"/>
-          <a:lstStyle/>
-          <a:p>
-            <a:pPr algn="l" indent="0" marL="0">
-              <a:lnSpc>
-                <a:spcPct val="115000"/>
-              </a:lnSpc>
-              <a:buNone/>
-            </a:pPr>
-            <a:r>
-              <a:rPr lang="en-US" sz="1200" b="1" dirty="0">
-                <a:solidFill>
-                  <a:srgbClr val="8A4514"/>
-                </a:solidFill>
-                <a:latin typeface="Optimist Sans" pitchFamily="34" charset="0"/>
-                <a:ea typeface="Optimist Sans" pitchFamily="34" charset="-122"/>
-                <a:cs typeface="Optimist Sans" pitchFamily="34" charset="-120"/>
-              </a:rPr>
-              <a:t>[n]</a:t>
-            </a:r>
-            <a:endParaRPr lang="en-US" sz="1200" dirty="0"/>
-          </a:p>
-        </p:txBody>
-      </p:sp>
-      <p:sp>
-        <p:nvSpPr>
-          <p:cNvPr id="85" name="Text 83"/>
+          <p:cNvPr id="109" name="Text 107"/>
           <p:cNvSpPr txBox="1"/>
           <p:nvPr/>
         </p:nvSpPr>
@@ -9816,7 +10572,7 @@
                 <a:ea typeface="Optimist Sans" pitchFamily="34" charset="-122"/>
                 <a:cs typeface="Optimist Sans" pitchFamily="34" charset="-120"/>
               </a:rPr>
-              <a:t>Draft for discussion · Year-end headcount; open roles in parentheses</a:t>
+              <a:t>Draft for discussion · Each box lists members and openings by level; bars show year-end headcount</a:t>
             </a:r>
             <a:endParaRPr lang="en-US" sz="1200" dirty="0"/>
           </a:p>

</xml_diff>

<commit_message>
Add departures footnote to org detail; add end-2027 row to headcount slide
Co-Authored-By: Claude Opus 5.5 <noreply@anthropic.com>
Claude-Session: https://claude.ai/code/session_01JXKaD9UU8MgeRWUr7sq4Za
</commit_message>
<xml_diff>
--- a/Unified Team Strategy.pptx
+++ b/Unified Team Strategy.pptx
@@ -116,13 +116,13 @@
   <p:extLst>
     <p:ext uri="{521415D9-36F7-43E2-AB2F-B90AF26B5E84}">
       <p14:sectionLst xmlns:p14="http://schemas.microsoft.com/office/powerpoint/2010/main">
-        <p14:section name="Why combine" id="{938cc258-6560-3efd-8c07-a25870967155}">
+        <p14:section name="Why combine" id="{401c2f1d-28db-d781-37b0-bf015290ff83}">
           <p14:sldIdLst>
             <p14:sldId id="256"/>
             <p14:sldId id="257"/>
           </p14:sldIdLst>
         </p14:section>
-        <p14:section name="How we organize" id="{eaaba427-264d-9d14-daaa-4086c0e3ddea}">
+        <p14:section name="How we organize" id="{ac8aac3a-ed9a-20f4-d201-974d99b18566}">
           <p14:sldIdLst>
             <p14:sldId id="258"/>
             <p14:sldId id="259"/>
@@ -130,14 +130,14 @@
             <p14:sldId id="261"/>
           </p14:sldIdLst>
         </p14:section>
-        <p14:section name="What we do and how we grow" id="{393b95de-0777-e44f-4343-396f7d9ba639}">
+        <p14:section name="What we do and how we grow" id="{a149054d-15f9-5212-384a-3cbf507b17f1}">
           <p14:sldIdLst>
             <p14:sldId id="262"/>
             <p14:sldId id="263"/>
             <p14:sldId id="264"/>
           </p14:sldIdLst>
         </p14:section>
-        <p14:section name="Asks" id="{992e1d88-655b-a0eb-b1ee-26486d20bc59}">
+        <p14:section name="Asks" id="{f4815e03-c1f4-7d0d-9581-a89a73efa431}">
           <p14:sldIdLst>
             <p14:sldId id="265"/>
           </p14:sldIdLst>
@@ -898,7 +898,7 @@
           <a:p>
             <a:r>
               <a:rPr lang="en-US" dirty="0"/>
-              <a:t>This slide turns the four-function structure into the actual team: one team lead, four sub-team heads, and three sub-teams under Modeling, each with its own lead and level. Each box lists every member with their level, including open roles to backfill, then a small bar strip with year-end headcount for this year, next year and the year after. Modeling, Data Foundation and Platform &amp; Deployment get smaller over time as AI takes on BAU work; AI Enablement grows. The next slide rolls these team-level numbers up into the overall picture.</a:t>
+              <a:t>This slide turns the four-function structure into the actual team: one team lead, four sub-team heads, and three sub-teams under Modeling, each with its own lead and level. Each box lists every member with their level, including open roles to backfill (expected departures of [XYZ] associates are already counted as openings), then a small bar strip with year-end headcount for this year, next year and the year after. Modeling, Data Foundation and Platform &amp; Deployment get smaller over time as AI takes on BAU work; AI Enablement grows. The next slide rolls these team-level numbers up into the overall picture.</a:t>
             </a:r>
             <a:endParaRPr lang="en-US" dirty="0"/>
           </a:p>
@@ -986,7 +986,7 @@
           <a:p>
             <a:r>
               <a:rPr lang="en-US" dirty="0"/>
-              <a:t>This rolls up the team-by-team plan on the previous slide. The story: today almost all capacity goes to BAU, and dedicated AI work is near zero. AI and new tooling let BAU shrink, but only down to a floor. That floor is the minimum BAU team we need to manage operational risk: critical functions like model deployment must never depend on one person whose departure takes all the knowledge with them. Rotation and cross-functional mixing keep that floor as low as safely possible, but we will not go below it. Everything freed above the floor moves to AI-focused work, the change-the-business end of the structure. Any net headcount reduction is a by-product, shown as the dashed box.</a:t>
+              <a:t>This rolls up the team-by-team plan on the previous slide. The story, from the end of this year to the end of 2028: today almost all capacity goes to BAU, and dedicated AI work is near zero. AI and new tooling let BAU shrink step by step (the end of 2027 shows the midpoint), but only down to a floor. That floor is the minimum BAU team we need to manage operational risk: critical functions like model deployment must never depend on one person whose departure takes all the knowledge with them. Rotation and cross-functional mixing keep that floor as low as safely possible, but we will not go below it. Everything freed above the floor moves to AI-focused work, the change-the-business end of the structure. Any net headcount reduction is a by-product, shown as the dashed box.</a:t>
             </a:r>
             <a:endParaRPr lang="en-US" dirty="0"/>
           </a:p>
@@ -9187,7 +9187,7 @@
                 <a:ea typeface="Optimist Sans" pitchFamily="34" charset="-122"/>
                 <a:cs typeface="Optimist Sans" pitchFamily="34" charset="-120"/>
               </a:rPr>
-              <a:t>Name [Mgr Opening]</a:t>
+              <a:t>Open [Mgr Opening]</a:t>
             </a:r>
             <a:endParaRPr lang="en-US" sz="1200" dirty="0"/>
           </a:p>
@@ -10572,7 +10572,7 @@
                 <a:ea typeface="Optimist Sans" pitchFamily="34" charset="-122"/>
                 <a:cs typeface="Optimist Sans" pitchFamily="34" charset="-120"/>
               </a:rPr>
-              <a:t>Draft for discussion · Each box lists members and openings by level; bars show year-end headcount</a:t>
+              <a:t>Draft for discussion · Bars show year-end headcount · Expected departures of [XYZ] associates are counted as openings</a:t>
             </a:r>
             <a:endParaRPr lang="en-US" sz="1200" dirty="0"/>
           </a:p>
@@ -10743,7 +10743,7 @@
         <p:spPr>
           <a:xfrm>
             <a:off x="812800" y="2400300"/>
-            <a:ext cx="1905000" cy="279400"/>
+            <a:ext cx="1905000" cy="254000"/>
           </a:xfrm>
           <a:prstGeom prst="rect">
             <a:avLst/>
@@ -10770,7 +10770,7 @@
                 <a:ea typeface="Optimist Sans" pitchFamily="34" charset="-122"/>
                 <a:cs typeface="Optimist Sans" pitchFamily="34" charset="-120"/>
               </a:rPr>
-              <a:t>Today</a:t>
+              <a:t>End ’26</a:t>
             </a:r>
             <a:endParaRPr lang="en-US" sz="1600" dirty="0"/>
           </a:p>
@@ -10784,8 +10784,8 @@
         </p:nvSpPr>
         <p:spPr>
           <a:xfrm>
-            <a:off x="812800" y="2679700"/>
-            <a:ext cx="1905000" cy="215900"/>
+            <a:off x="812800" y="2667000"/>
+            <a:ext cx="1905000" cy="203200"/>
           </a:xfrm>
           <a:prstGeom prst="rect">
             <a:avLst/>
@@ -10826,8 +10826,8 @@
         </p:nvSpPr>
         <p:spPr>
           <a:xfrm>
-            <a:off x="2921000" y="2413000"/>
-            <a:ext cx="7366000" cy="508000"/>
+            <a:off x="2921000" y="2438400"/>
+            <a:ext cx="7366000" cy="406400"/>
           </a:xfrm>
           <a:prstGeom prst="rect">
             <a:avLst/>
@@ -10846,8 +10846,8 @@
         </p:nvSpPr>
         <p:spPr>
           <a:xfrm>
-            <a:off x="3073400" y="2413000"/>
-            <a:ext cx="6985000" cy="508000"/>
+            <a:off x="3073400" y="2438400"/>
+            <a:ext cx="7213600" cy="406400"/>
           </a:xfrm>
           <a:prstGeom prst="rect">
             <a:avLst/>
@@ -10888,8 +10888,8 @@
         </p:nvSpPr>
         <p:spPr>
           <a:xfrm>
-            <a:off x="10287000" y="2413000"/>
-            <a:ext cx="127000" cy="508000"/>
+            <a:off x="10287000" y="2438400"/>
+            <a:ext cx="127000" cy="406400"/>
           </a:xfrm>
           <a:prstGeom prst="rect">
             <a:avLst/>
@@ -10908,8 +10908,8 @@
         </p:nvSpPr>
         <p:spPr>
           <a:xfrm>
-            <a:off x="10515600" y="2413000"/>
-            <a:ext cx="863600" cy="508000"/>
+            <a:off x="10515600" y="2438400"/>
+            <a:ext cx="863600" cy="406400"/>
           </a:xfrm>
           <a:prstGeom prst="rect">
             <a:avLst/>
@@ -10950,8 +10950,8 @@
         </p:nvSpPr>
         <p:spPr>
           <a:xfrm>
-            <a:off x="812800" y="3136900"/>
-            <a:ext cx="1905000" cy="279400"/>
+            <a:off x="812800" y="2984500"/>
+            <a:ext cx="1905000" cy="254000"/>
           </a:xfrm>
           <a:prstGeom prst="rect">
             <a:avLst/>
@@ -10978,7 +10978,7 @@
                 <a:ea typeface="Optimist Sans" pitchFamily="34" charset="-122"/>
                 <a:cs typeface="Optimist Sans" pitchFamily="34" charset="-120"/>
               </a:rPr>
-              <a:t>Target</a:t>
+              <a:t>End ’27</a:t>
             </a:r>
             <a:endParaRPr lang="en-US" sz="1600" dirty="0"/>
           </a:p>
@@ -10992,8 +10992,8 @@
         </p:nvSpPr>
         <p:spPr>
           <a:xfrm>
-            <a:off x="812800" y="3416300"/>
-            <a:ext cx="1905000" cy="215900"/>
+            <a:off x="812800" y="3251200"/>
+            <a:ext cx="1905000" cy="203200"/>
           </a:xfrm>
           <a:prstGeom prst="rect">
             <a:avLst/>
@@ -11034,8 +11034,8 @@
         </p:nvSpPr>
         <p:spPr>
           <a:xfrm>
-            <a:off x="2921000" y="3149600"/>
-            <a:ext cx="3556000" cy="508000"/>
+            <a:off x="2921000" y="3022600"/>
+            <a:ext cx="4953000" cy="406400"/>
           </a:xfrm>
           <a:prstGeom prst="rect">
             <a:avLst/>
@@ -11054,8 +11054,8 @@
         </p:nvSpPr>
         <p:spPr>
           <a:xfrm>
-            <a:off x="4953000" y="3149600"/>
-            <a:ext cx="1371600" cy="508000"/>
+            <a:off x="2921000" y="3022600"/>
+            <a:ext cx="4800600" cy="406400"/>
           </a:xfrm>
           <a:prstGeom prst="rect">
             <a:avLst/>
@@ -11096,8 +11096,8 @@
         </p:nvSpPr>
         <p:spPr>
           <a:xfrm>
-            <a:off x="6477000" y="3149600"/>
-            <a:ext cx="3048000" cy="508000"/>
+            <a:off x="7874000" y="3022600"/>
+            <a:ext cx="2159000" cy="406400"/>
           </a:xfrm>
           <a:prstGeom prst="rect">
             <a:avLst/>
@@ -11116,8 +11116,8 @@
         </p:nvSpPr>
         <p:spPr>
           <a:xfrm>
-            <a:off x="6629400" y="3149600"/>
-            <a:ext cx="2794000" cy="508000"/>
+            <a:off x="8026400" y="3022600"/>
+            <a:ext cx="1905000" cy="406400"/>
           </a:xfrm>
           <a:prstGeom prst="rect">
             <a:avLst/>
@@ -11158,8 +11158,8 @@
         </p:nvSpPr>
         <p:spPr>
           <a:xfrm>
-            <a:off x="9525000" y="3149600"/>
-            <a:ext cx="889000" cy="508000"/>
+            <a:off x="10033000" y="3022600"/>
+            <a:ext cx="381000" cy="406400"/>
           </a:xfrm>
           <a:prstGeom prst="rect">
             <a:avLst/>
@@ -11183,8 +11183,112 @@
         </p:nvSpPr>
         <p:spPr>
           <a:xfrm>
-            <a:off x="9525000" y="3149600"/>
-            <a:ext cx="889000" cy="508000"/>
+            <a:off x="812800" y="3568700"/>
+            <a:ext cx="1905000" cy="254000"/>
+          </a:xfrm>
+          <a:prstGeom prst="rect">
+            <a:avLst/>
+          </a:prstGeom>
+          <a:noFill/>
+          <a:ln/>
+        </p:spPr>
+        <p:txBody>
+          <a:bodyPr wrap="square" lIns="0" tIns="0" rIns="0" bIns="0" rtlCol="0" anchor="t"/>
+          <a:lstStyle/>
+          <a:p>
+            <a:pPr algn="l" indent="0" marL="0">
+              <a:lnSpc>
+                <a:spcPct val="115000"/>
+              </a:lnSpc>
+              <a:buNone/>
+            </a:pPr>
+            <a:r>
+              <a:rPr lang="en-US" sz="1600" b="1" dirty="0">
+                <a:solidFill>
+                  <a:srgbClr val="14213D"/>
+                </a:solidFill>
+                <a:latin typeface="Optimist Sans" pitchFamily="34" charset="0"/>
+                <a:ea typeface="Optimist Sans" pitchFamily="34" charset="-122"/>
+                <a:cs typeface="Optimist Sans" pitchFamily="34" charset="-120"/>
+              </a:rPr>
+              <a:t>End ’28</a:t>
+            </a:r>
+            <a:endParaRPr lang="en-US" sz="1600" dirty="0"/>
+          </a:p>
+        </p:txBody>
+      </p:sp>
+      <p:sp>
+        <p:nvSpPr>
+          <p:cNvPr id="18" name="Text 16"/>
+          <p:cNvSpPr txBox="1"/>
+          <p:nvPr/>
+        </p:nvSpPr>
+        <p:spPr>
+          <a:xfrm>
+            <a:off x="812800" y="3835400"/>
+            <a:ext cx="1905000" cy="203200"/>
+          </a:xfrm>
+          <a:prstGeom prst="rect">
+            <a:avLst/>
+          </a:prstGeom>
+          <a:noFill/>
+          <a:ln/>
+        </p:spPr>
+        <p:txBody>
+          <a:bodyPr wrap="square" lIns="0" tIns="0" rIns="0" bIns="0" rtlCol="0" anchor="t"/>
+          <a:lstStyle/>
+          <a:p>
+            <a:pPr algn="l" indent="0" marL="0">
+              <a:lnSpc>
+                <a:spcPct val="115000"/>
+              </a:lnSpc>
+              <a:buNone/>
+            </a:pPr>
+            <a:r>
+              <a:rPr lang="en-US" sz="1200" dirty="0">
+                <a:solidFill>
+                  <a:srgbClr val="6B7280"/>
+                </a:solidFill>
+                <a:latin typeface="Optimist Sans" pitchFamily="34" charset="0"/>
+                <a:ea typeface="Optimist Sans" pitchFamily="34" charset="-122"/>
+                <a:cs typeface="Optimist Sans" pitchFamily="34" charset="-120"/>
+              </a:rPr>
+              <a:t>Target · ~[__] associates</a:t>
+            </a:r>
+            <a:endParaRPr lang="en-US" sz="1200" dirty="0"/>
+          </a:p>
+        </p:txBody>
+      </p:sp>
+      <p:sp>
+        <p:nvSpPr>
+          <p:cNvPr id="19" name="Shape 17"/>
+          <p:cNvSpPr/>
+          <p:nvPr/>
+        </p:nvSpPr>
+        <p:spPr>
+          <a:xfrm>
+            <a:off x="2921000" y="3606800"/>
+            <a:ext cx="3556000" cy="406400"/>
+          </a:xfrm>
+          <a:prstGeom prst="rect">
+            <a:avLst/>
+          </a:prstGeom>
+          <a:solidFill>
+            <a:srgbClr val="1F6F7E"/>
+          </a:solidFill>
+          <a:ln/>
+        </p:spPr>
+      </p:sp>
+      <p:sp>
+        <p:nvSpPr>
+          <p:cNvPr id="20" name="Text 18"/>
+          <p:cNvSpPr txBox="1"/>
+          <p:nvPr/>
+        </p:nvSpPr>
+        <p:spPr>
+          <a:xfrm>
+            <a:off x="2921000" y="3606800"/>
+            <a:ext cx="3403600" cy="406400"/>
           </a:xfrm>
           <a:prstGeom prst="rect">
             <a:avLst/>
@@ -11196,6 +11300,135 @@
           <a:bodyPr wrap="square" lIns="0" tIns="0" rIns="0" bIns="0" rtlCol="0" anchor="ctr"/>
           <a:lstStyle/>
           <a:p>
+            <a:pPr algn="r" indent="0" marL="0">
+              <a:lnSpc>
+                <a:spcPct val="115000"/>
+              </a:lnSpc>
+              <a:buNone/>
+            </a:pPr>
+            <a:r>
+              <a:rPr lang="en-US" sz="1200" b="1" dirty="0">
+                <a:solidFill>
+                  <a:srgbClr val="F7F6F2"/>
+                </a:solidFill>
+                <a:latin typeface="Optimist Sans" pitchFamily="34" charset="0"/>
+                <a:ea typeface="Optimist Sans" pitchFamily="34" charset="-122"/>
+                <a:cs typeface="Optimist Sans" pitchFamily="34" charset="-120"/>
+              </a:rPr>
+              <a:t>BAU · [__]%</a:t>
+            </a:r>
+            <a:endParaRPr lang="en-US" sz="1200" dirty="0"/>
+          </a:p>
+        </p:txBody>
+      </p:sp>
+      <p:sp>
+        <p:nvSpPr>
+          <p:cNvPr id="21" name="Shape 19"/>
+          <p:cNvSpPr/>
+          <p:nvPr/>
+        </p:nvSpPr>
+        <p:spPr>
+          <a:xfrm>
+            <a:off x="6477000" y="3606800"/>
+            <a:ext cx="3048000" cy="406400"/>
+          </a:xfrm>
+          <a:prstGeom prst="rect">
+            <a:avLst/>
+          </a:prstGeom>
+          <a:solidFill>
+            <a:srgbClr val="E3A86B"/>
+          </a:solidFill>
+          <a:ln/>
+        </p:spPr>
+      </p:sp>
+      <p:sp>
+        <p:nvSpPr>
+          <p:cNvPr id="22" name="Text 20"/>
+          <p:cNvSpPr txBox="1"/>
+          <p:nvPr/>
+        </p:nvSpPr>
+        <p:spPr>
+          <a:xfrm>
+            <a:off x="6629400" y="3606800"/>
+            <a:ext cx="2794000" cy="406400"/>
+          </a:xfrm>
+          <a:prstGeom prst="rect">
+            <a:avLst/>
+          </a:prstGeom>
+          <a:noFill/>
+          <a:ln/>
+        </p:spPr>
+        <p:txBody>
+          <a:bodyPr wrap="square" lIns="0" tIns="0" rIns="0" bIns="0" rtlCol="0" anchor="ctr"/>
+          <a:lstStyle/>
+          <a:p>
+            <a:pPr algn="l" indent="0" marL="0">
+              <a:lnSpc>
+                <a:spcPct val="115000"/>
+              </a:lnSpc>
+              <a:buNone/>
+            </a:pPr>
+            <a:r>
+              <a:rPr lang="en-US" sz="1200" b="1" dirty="0">
+                <a:solidFill>
+                  <a:srgbClr val="14213D"/>
+                </a:solidFill>
+                <a:latin typeface="Optimist Sans" pitchFamily="34" charset="0"/>
+                <a:ea typeface="Optimist Sans" pitchFamily="34" charset="-122"/>
+                <a:cs typeface="Optimist Sans" pitchFamily="34" charset="-120"/>
+              </a:rPr>
+              <a:t>AI &amp; change · [__]%</a:t>
+            </a:r>
+            <a:endParaRPr lang="en-US" sz="1200" dirty="0"/>
+          </a:p>
+        </p:txBody>
+      </p:sp>
+      <p:sp>
+        <p:nvSpPr>
+          <p:cNvPr id="23" name="Shape 21"/>
+          <p:cNvSpPr/>
+          <p:nvPr/>
+        </p:nvSpPr>
+        <p:spPr>
+          <a:xfrm>
+            <a:off x="9525000" y="3606800"/>
+            <a:ext cx="889000" cy="406400"/>
+          </a:xfrm>
+          <a:prstGeom prst="rect">
+            <a:avLst/>
+          </a:prstGeom>
+          <a:solidFill>
+            <a:srgbClr val="F7F6F2"/>
+          </a:solidFill>
+          <a:ln w="19050">
+            <a:solidFill>
+              <a:srgbClr val="8A8F98"/>
+            </a:solidFill>
+            <a:prstDash val="dash"/>
+          </a:ln>
+        </p:spPr>
+      </p:sp>
+      <p:sp>
+        <p:nvSpPr>
+          <p:cNvPr id="24" name="Text 22"/>
+          <p:cNvSpPr txBox="1"/>
+          <p:nvPr/>
+        </p:nvSpPr>
+        <p:spPr>
+          <a:xfrm>
+            <a:off x="9525000" y="3606800"/>
+            <a:ext cx="889000" cy="406400"/>
+          </a:xfrm>
+          <a:prstGeom prst="rect">
+            <a:avLst/>
+          </a:prstGeom>
+          <a:noFill/>
+          <a:ln/>
+        </p:spPr>
+        <p:txBody>
+          <a:bodyPr wrap="square" lIns="0" tIns="0" rIns="0" bIns="0" rtlCol="0" anchor="ctr"/>
+          <a:lstStyle/>
+          <a:p>
             <a:pPr algn="ctr" indent="0" marL="0">
               <a:lnSpc>
                 <a:spcPct val="115000"/>
@@ -11219,14 +11452,14 @@
       </p:sp>
       <p:sp>
         <p:nvSpPr>
-          <p:cNvPr id="18" name="BAU floor marker"/>
-          <p:cNvSpPr/>
-          <p:nvPr/>
-        </p:nvSpPr>
-        <p:spPr>
-          <a:xfrm>
-            <a:off x="4806950" y="3060700"/>
-            <a:ext cx="38100" cy="685800"/>
+          <p:cNvPr id="25" name="BAU floor marker 2027"/>
+          <p:cNvSpPr/>
+          <p:nvPr/>
+        </p:nvSpPr>
+        <p:spPr>
+          <a:xfrm>
+            <a:off x="4806950" y="3022600"/>
+            <a:ext cx="38100" cy="558800"/>
           </a:xfrm>
           <a:prstGeom prst="rect">
             <a:avLst/>
@@ -11239,13 +11472,33 @@
       </p:sp>
       <p:sp>
         <p:nvSpPr>
-          <p:cNvPr id="19" name="Text 17"/>
-          <p:cNvSpPr txBox="1"/>
-          <p:nvPr/>
-        </p:nvSpPr>
-        <p:spPr>
-          <a:xfrm>
-            <a:off x="4064000" y="3797300"/>
+          <p:cNvPr id="26" name="BAU floor marker 2028"/>
+          <p:cNvSpPr/>
+          <p:nvPr/>
+        </p:nvSpPr>
+        <p:spPr>
+          <a:xfrm>
+            <a:off x="4806950" y="3606800"/>
+            <a:ext cx="38100" cy="558800"/>
+          </a:xfrm>
+          <a:prstGeom prst="rect">
+            <a:avLst/>
+          </a:prstGeom>
+          <a:solidFill>
+            <a:srgbClr val="A0521A"/>
+          </a:solidFill>
+          <a:ln/>
+        </p:spPr>
+      </p:sp>
+      <p:sp>
+        <p:nvSpPr>
+          <p:cNvPr id="27" name="Text 25"/>
+          <p:cNvSpPr txBox="1"/>
+          <p:nvPr/>
+        </p:nvSpPr>
+        <p:spPr>
+          <a:xfrm>
+            <a:off x="4064000" y="4191000"/>
             <a:ext cx="3302000" cy="228600"/>
           </a:xfrm>
           <a:prstGeom prst="rect">
@@ -11281,49 +11534,7 @@
       </p:sp>
       <p:sp>
         <p:nvSpPr>
-          <p:cNvPr id="20" name="Text 18"/>
-          <p:cNvSpPr txBox="1"/>
-          <p:nvPr/>
-        </p:nvSpPr>
-        <p:spPr>
-          <a:xfrm>
-            <a:off x="2921000" y="4102100"/>
-            <a:ext cx="8458200" cy="228600"/>
-          </a:xfrm>
-          <a:prstGeom prst="rect">
-            <a:avLst/>
-          </a:prstGeom>
-          <a:noFill/>
-          <a:ln/>
-        </p:spPr>
-        <p:txBody>
-          <a:bodyPr wrap="square" lIns="0" tIns="0" rIns="0" bIns="0" rtlCol="0" anchor="t"/>
-          <a:lstStyle/>
-          <a:p>
-            <a:pPr algn="l" indent="0" marL="0">
-              <a:lnSpc>
-                <a:spcPct val="115000"/>
-              </a:lnSpc>
-              <a:buNone/>
-            </a:pPr>
-            <a:r>
-              <a:rPr lang="en-US" sz="1200" dirty="0">
-                <a:solidFill>
-                  <a:srgbClr val="6B7280"/>
-                </a:solidFill>
-                <a:latin typeface="Optimist Sans" pitchFamily="34" charset="0"/>
-                <a:ea typeface="Optimist Sans" pitchFamily="34" charset="-122"/>
-                <a:cs typeface="Optimist Sans" pitchFamily="34" charset="-120"/>
-              </a:rPr>
-              <a:t>Illustrative mix; fill with actual shares. BAU can shrink to the floor, never below it.</a:t>
-            </a:r>
-            <a:endParaRPr lang="en-US" sz="1200" dirty="0"/>
-          </a:p>
-        </p:txBody>
-      </p:sp>
-      <p:sp>
-        <p:nvSpPr>
-          <p:cNvPr id="21" name="Shape 19"/>
+          <p:cNvPr id="28" name="Shape 26"/>
           <p:cNvSpPr/>
           <p:nvPr/>
         </p:nvSpPr>
@@ -11350,7 +11561,7 @@
       </p:sp>
       <p:pic>
         <p:nvPicPr>
-          <p:cNvPr id="22" name="Image 0" descr="preencoded.png">    </p:cNvPr>
+          <p:cNvPr id="29" name="Image 0" descr="preencoded.png">    </p:cNvPr>
           <p:cNvPicPr>
             <a:picLocks noChangeAspect="1"/>
           </p:cNvPicPr>
@@ -11374,7 +11585,7 @@
       </p:pic>
       <p:sp>
         <p:nvSpPr>
-          <p:cNvPr id="23" name="Text 20"/>
+          <p:cNvPr id="30" name="Text 27"/>
           <p:cNvSpPr txBox="1"/>
           <p:nvPr/>
         </p:nvSpPr>
@@ -11416,7 +11627,7 @@
       </p:sp>
       <p:sp>
         <p:nvSpPr>
-          <p:cNvPr id="24" name="Text 21"/>
+          <p:cNvPr id="31" name="Text 28"/>
           <p:cNvSpPr txBox="1"/>
           <p:nvPr/>
         </p:nvSpPr>
@@ -11458,7 +11669,7 @@
       </p:sp>
       <p:sp>
         <p:nvSpPr>
-          <p:cNvPr id="25" name="Shape 22"/>
+          <p:cNvPr id="32" name="Shape 29"/>
           <p:cNvSpPr/>
           <p:nvPr/>
         </p:nvSpPr>
@@ -11485,7 +11696,7 @@
       </p:sp>
       <p:pic>
         <p:nvPicPr>
-          <p:cNvPr id="26" name="Image 1" descr="preencoded.png">    </p:cNvPr>
+          <p:cNvPr id="33" name="Image 1" descr="preencoded.png">    </p:cNvPr>
           <p:cNvPicPr>
             <a:picLocks noChangeAspect="1"/>
           </p:cNvPicPr>
@@ -11509,7 +11720,7 @@
       </p:pic>
       <p:sp>
         <p:nvSpPr>
-          <p:cNvPr id="27" name="Text 23"/>
+          <p:cNvPr id="34" name="Text 30"/>
           <p:cNvSpPr txBox="1"/>
           <p:nvPr/>
         </p:nvSpPr>
@@ -11551,7 +11762,7 @@
       </p:sp>
       <p:sp>
         <p:nvSpPr>
-          <p:cNvPr id="28" name="Text 24"/>
+          <p:cNvPr id="35" name="Text 31"/>
           <p:cNvSpPr txBox="1"/>
           <p:nvPr/>
         </p:nvSpPr>
@@ -11593,7 +11804,7 @@
       </p:sp>
       <p:sp>
         <p:nvSpPr>
-          <p:cNvPr id="29" name="Shape 25"/>
+          <p:cNvPr id="36" name="Shape 32"/>
           <p:cNvSpPr/>
           <p:nvPr/>
         </p:nvSpPr>
@@ -11620,7 +11831,7 @@
       </p:sp>
       <p:pic>
         <p:nvPicPr>
-          <p:cNvPr id="30" name="Image 2" descr="preencoded.png">    </p:cNvPr>
+          <p:cNvPr id="37" name="Image 2" descr="preencoded.png">    </p:cNvPr>
           <p:cNvPicPr>
             <a:picLocks noChangeAspect="1"/>
           </p:cNvPicPr>
@@ -11644,7 +11855,7 @@
       </p:pic>
       <p:sp>
         <p:nvSpPr>
-          <p:cNvPr id="31" name="Text 26"/>
+          <p:cNvPr id="38" name="Text 33"/>
           <p:cNvSpPr txBox="1"/>
           <p:nvPr/>
         </p:nvSpPr>
@@ -11686,7 +11897,7 @@
       </p:sp>
       <p:sp>
         <p:nvSpPr>
-          <p:cNvPr id="32" name="Text 27"/>
+          <p:cNvPr id="39" name="Text 34"/>
           <p:cNvSpPr txBox="1"/>
           <p:nvPr/>
         </p:nvSpPr>
@@ -11728,7 +11939,7 @@
       </p:sp>
       <p:sp>
         <p:nvSpPr>
-          <p:cNvPr id="33" name="Text 28"/>
+          <p:cNvPr id="40" name="Text 35"/>
           <p:cNvSpPr txBox="1"/>
           <p:nvPr/>
         </p:nvSpPr>
@@ -11762,7 +11973,7 @@
                 <a:ea typeface="Optimist Sans" pitchFamily="34" charset="-122"/>
                 <a:cs typeface="Optimist Sans" pitchFamily="34" charset="-120"/>
               </a:rPr>
-              <a:t>Draft for discussion</a:t>
+              <a:t>Draft for discussion · Illustrative mix; BAU can shrink to the floor, never below it</a:t>
             </a:r>
             <a:endParaRPr lang="en-US" sz="1200" dirty="0"/>
           </a:p>

</xml_diff>

<commit_message>
Color-code backfill vs new-investment openings; clarify staffing assumptions on headcount slide
Co-Authored-By: Claude Opus 5.5 <noreply@anthropic.com>
Claude-Session: https://claude.ai/code/session_01JXKaD9UU8MgeRWUr7sq4Za
</commit_message>
<xml_diff>
--- a/Unified Team Strategy.pptx
+++ b/Unified Team Strategy.pptx
@@ -116,13 +116,13 @@
   <p:extLst>
     <p:ext uri="{521415D9-36F7-43E2-AB2F-B90AF26B5E84}">
       <p14:sectionLst xmlns:p14="http://schemas.microsoft.com/office/powerpoint/2010/main">
-        <p14:section name="Why combine" id="{401c2f1d-28db-d781-37b0-bf015290ff83}">
+        <p14:section name="Why combine" id="{6b5c9b1c-2747-b660-ad37-f0af475094e8}">
           <p14:sldIdLst>
             <p14:sldId id="256"/>
             <p14:sldId id="257"/>
           </p14:sldIdLst>
         </p14:section>
-        <p14:section name="How we organize" id="{ac8aac3a-ed9a-20f4-d201-974d99b18566}">
+        <p14:section name="How we organize" id="{447fe89d-375e-1ad6-74fd-f3638ebf351d}">
           <p14:sldIdLst>
             <p14:sldId id="258"/>
             <p14:sldId id="259"/>
@@ -130,14 +130,14 @@
             <p14:sldId id="261"/>
           </p14:sldIdLst>
         </p14:section>
-        <p14:section name="What we do and how we grow" id="{a149054d-15f9-5212-384a-3cbf507b17f1}">
+        <p14:section name="What we do and how we grow" id="{bfb5ca6f-89bd-e184-84e8-98e9b462c95e}">
           <p14:sldIdLst>
             <p14:sldId id="262"/>
             <p14:sldId id="263"/>
             <p14:sldId id="264"/>
           </p14:sldIdLst>
         </p14:section>
-        <p14:section name="Asks" id="{f4815e03-c1f4-7d0d-9581-a89a73efa431}">
+        <p14:section name="Asks" id="{9da28ad2-3330-f158-d6d9-34e5c837d4a5}">
           <p14:sldIdLst>
             <p14:sldId id="265"/>
           </p14:sldIdLst>
@@ -898,7 +898,7 @@
           <a:p>
             <a:r>
               <a:rPr lang="en-US" dirty="0"/>
-              <a:t>This slide turns the four-function structure into the actual team: one team lead, four sub-team heads, and three sub-teams under Modeling, each with its own lead and level. Each box lists every member with their level, including open roles to backfill (expected departures of [XYZ] associates are already counted as openings), then a small bar strip with year-end headcount for this year, next year and the year after. Modeling, Data Foundation and Platform &amp; Deployment get smaller over time as AI takes on BAU work; AI Enablement grows. The next slide rolls these team-level numbers up into the overall picture.</a:t>
+              <a:t>This slide turns the four-function structure into the actual team: one team lead, four sub-team heads, and three sub-teams under Modeling, each with its own lead and level. Each box lists every member with their level, with open roles color-coded: rust for backfills of current or expected departures (expected departures of [XYZ] associates are already counted), teal for new investment roles; then a small bar strip with year-end headcount for this year, next year and the year after. Modeling, Data Foundation and Platform &amp; Deployment get smaller over time as AI takes on BAU work; AI Enablement grows. The next slide rolls these team-level numbers up into the overall picture.</a:t>
             </a:r>
             <a:endParaRPr lang="en-US" dirty="0"/>
           </a:p>
@@ -986,7 +986,7 @@
           <a:p>
             <a:r>
               <a:rPr lang="en-US" dirty="0"/>
-              <a:t>This rolls up the team-by-team plan on the previous slide. The story, from the end of this year to the end of 2028: today almost all capacity goes to BAU, and dedicated AI work is near zero. AI and new tooling let BAU shrink step by step (the end of 2027 shows the midpoint), but only down to a floor. That floor is the minimum BAU team we need to manage operational risk: critical functions like model deployment must never depend on one person whose departure takes all the knowledge with them. Rotation and cross-functional mixing keep that floor as low as safely possible, but we will not go below it. Everything freed above the floor moves to AI-focused work, the change-the-business end of the structure. Any net headcount reduction is a by-product, shown as the dashed box.</a:t>
+              <a:t>This rolls up the team-by-team plan on the previous slide. The end-2026 count includes open roles; 2027 and 2028 assume every role is filled. The story, from the end of this year to the end of 2028: today almost all capacity goes to BAU, and dedicated AI work is near zero. AI and new tooling let BAU shrink step by step (the end of 2027 shows the midpoint), but only down to a floor. That floor is the minimum BAU team we need to manage operational risk: critical functions like model deployment must never depend on one person whose departure takes all the knowledge with them. Rotation and cross-functional mixing keep that floor as low as safely possible, but we will not go below it. Everything freed above the floor moves to AI-focused work, the change-the-business end of the structure. Any net headcount reduction is a by-product, shown as the dashed box.</a:t>
             </a:r>
             <a:endParaRPr lang="en-US" dirty="0"/>
           </a:p>
@@ -7847,15 +7847,15 @@
               <a:buNone/>
             </a:pPr>
             <a:r>
-              <a:rPr lang="en-US" sz="1200" dirty="0">
-                <a:solidFill>
-                  <a:srgbClr val="4A5568"/>
-                </a:solidFill>
-                <a:latin typeface="Optimist Sans" pitchFamily="34" charset="0"/>
-                <a:ea typeface="Optimist Sans" pitchFamily="34" charset="-122"/>
-                <a:cs typeface="Optimist Sans" pitchFamily="34" charset="-120"/>
-              </a:rPr>
-              <a:t>[Opening] [Lvl]</a:t>
+              <a:rPr lang="en-US" sz="1200" b="1" dirty="0">
+                <a:solidFill>
+                  <a:srgbClr val="A0521A"/>
+                </a:solidFill>
+                <a:latin typeface="Optimist Sans" pitchFamily="34" charset="0"/>
+                <a:ea typeface="Optimist Sans" pitchFamily="34" charset="-122"/>
+                <a:cs typeface="Optimist Sans" pitchFamily="34" charset="-120"/>
+              </a:rPr>
+              <a:t>Backfill [Lvl]</a:t>
             </a:r>
             <a:endParaRPr lang="en-US" sz="1200" dirty="0"/>
           </a:p>
@@ -8291,15 +8291,15 @@
               <a:buNone/>
             </a:pPr>
             <a:r>
-              <a:rPr lang="en-US" sz="1200" dirty="0">
-                <a:solidFill>
-                  <a:srgbClr val="4A5568"/>
-                </a:solidFill>
-                <a:latin typeface="Optimist Sans" pitchFamily="34" charset="0"/>
-                <a:ea typeface="Optimist Sans" pitchFamily="34" charset="-122"/>
-                <a:cs typeface="Optimist Sans" pitchFamily="34" charset="-120"/>
-              </a:rPr>
-              <a:t>[Opening] [Lvl]</a:t>
+              <a:rPr lang="en-US" sz="1200" b="1" dirty="0">
+                <a:solidFill>
+                  <a:srgbClr val="A0521A"/>
+                </a:solidFill>
+                <a:latin typeface="Optimist Sans" pitchFamily="34" charset="0"/>
+                <a:ea typeface="Optimist Sans" pitchFamily="34" charset="-122"/>
+                <a:cs typeface="Optimist Sans" pitchFamily="34" charset="-120"/>
+              </a:rPr>
+              <a:t>Backfill [Lvl]</a:t>
             </a:r>
             <a:endParaRPr lang="en-US" sz="1200" dirty="0"/>
           </a:p>
@@ -8735,15 +8735,15 @@
               <a:buNone/>
             </a:pPr>
             <a:r>
-              <a:rPr lang="en-US" sz="1200" dirty="0">
-                <a:solidFill>
-                  <a:srgbClr val="4A5568"/>
-                </a:solidFill>
-                <a:latin typeface="Optimist Sans" pitchFamily="34" charset="0"/>
-                <a:ea typeface="Optimist Sans" pitchFamily="34" charset="-122"/>
-                <a:cs typeface="Optimist Sans" pitchFamily="34" charset="-120"/>
-              </a:rPr>
-              <a:t>[Opening] [Lvl]</a:t>
+              <a:rPr lang="en-US" sz="1200" b="1" dirty="0">
+                <a:solidFill>
+                  <a:srgbClr val="A0521A"/>
+                </a:solidFill>
+                <a:latin typeface="Optimist Sans" pitchFamily="34" charset="0"/>
+                <a:ea typeface="Optimist Sans" pitchFamily="34" charset="-122"/>
+                <a:cs typeface="Optimist Sans" pitchFamily="34" charset="-120"/>
+              </a:rPr>
+              <a:t>Backfill [Lvl]</a:t>
             </a:r>
             <a:endParaRPr lang="en-US" sz="1200" dirty="0"/>
           </a:p>
@@ -9179,9 +9179,9 @@
               <a:buNone/>
             </a:pPr>
             <a:r>
-              <a:rPr lang="en-US" sz="1200" dirty="0">
-                <a:solidFill>
-                  <a:srgbClr val="4A5568"/>
+              <a:rPr lang="en-US" sz="1200" b="1" dirty="0">
+                <a:solidFill>
+                  <a:srgbClr val="A0521A"/>
                 </a:solidFill>
                 <a:latin typeface="Optimist Sans" pitchFamily="34" charset="0"/>
                 <a:ea typeface="Optimist Sans" pitchFamily="34" charset="-122"/>
@@ -9683,15 +9683,15 @@
               <a:buNone/>
             </a:pPr>
             <a:r>
-              <a:rPr lang="en-US" sz="1200" dirty="0">
-                <a:solidFill>
-                  <a:srgbClr val="4A5568"/>
-                </a:solidFill>
-                <a:latin typeface="Optimist Sans" pitchFamily="34" charset="0"/>
-                <a:ea typeface="Optimist Sans" pitchFamily="34" charset="-122"/>
-                <a:cs typeface="Optimist Sans" pitchFamily="34" charset="-120"/>
-              </a:rPr>
-              <a:t>[Name] [Lvl]</a:t>
+              <a:rPr lang="en-US" sz="1200" b="1" dirty="0">
+                <a:solidFill>
+                  <a:srgbClr val="1F6F7E"/>
+                </a:solidFill>
+                <a:latin typeface="Optimist Sans" pitchFamily="34" charset="0"/>
+                <a:ea typeface="Optimist Sans" pitchFamily="34" charset="-122"/>
+                <a:cs typeface="Optimist Sans" pitchFamily="34" charset="-120"/>
+              </a:rPr>
+              <a:t>New role [Lvl]</a:t>
             </a:r>
             <a:endParaRPr lang="en-US" sz="1200" dirty="0"/>
           </a:p>
@@ -9703,15 +9703,15 @@
               <a:buNone/>
             </a:pPr>
             <a:r>
-              <a:rPr lang="en-US" sz="1200" dirty="0">
-                <a:solidFill>
-                  <a:srgbClr val="4A5568"/>
-                </a:solidFill>
-                <a:latin typeface="Optimist Sans" pitchFamily="34" charset="0"/>
-                <a:ea typeface="Optimist Sans" pitchFamily="34" charset="-122"/>
-                <a:cs typeface="Optimist Sans" pitchFamily="34" charset="-120"/>
-              </a:rPr>
-              <a:t>[Opening] [Lvl]</a:t>
+              <a:rPr lang="en-US" sz="1200" b="1" dirty="0">
+                <a:solidFill>
+                  <a:srgbClr val="A0521A"/>
+                </a:solidFill>
+                <a:latin typeface="Optimist Sans" pitchFamily="34" charset="0"/>
+                <a:ea typeface="Optimist Sans" pitchFamily="34" charset="-122"/>
+                <a:cs typeface="Optimist Sans" pitchFamily="34" charset="-120"/>
+              </a:rPr>
+              <a:t>Backfill [Lvl]</a:t>
             </a:r>
             <a:endParaRPr lang="en-US" sz="1200" dirty="0"/>
           </a:p>
@@ -10147,15 +10147,15 @@
               <a:buNone/>
             </a:pPr>
             <a:r>
-              <a:rPr lang="en-US" sz="1200" dirty="0">
-                <a:solidFill>
-                  <a:srgbClr val="4A5568"/>
-                </a:solidFill>
-                <a:latin typeface="Optimist Sans" pitchFamily="34" charset="0"/>
-                <a:ea typeface="Optimist Sans" pitchFamily="34" charset="-122"/>
-                <a:cs typeface="Optimist Sans" pitchFamily="34" charset="-120"/>
-              </a:rPr>
-              <a:t>[Name] [Lvl]</a:t>
+              <a:rPr lang="en-US" sz="1200" b="1" dirty="0">
+                <a:solidFill>
+                  <a:srgbClr val="1F6F7E"/>
+                </a:solidFill>
+                <a:latin typeface="Optimist Sans" pitchFamily="34" charset="0"/>
+                <a:ea typeface="Optimist Sans" pitchFamily="34" charset="-122"/>
+                <a:cs typeface="Optimist Sans" pitchFamily="34" charset="-120"/>
+              </a:rPr>
+              <a:t>New role [Lvl]</a:t>
             </a:r>
             <a:endParaRPr lang="en-US" sz="1200" dirty="0"/>
           </a:p>
@@ -10167,15 +10167,15 @@
               <a:buNone/>
             </a:pPr>
             <a:r>
-              <a:rPr lang="en-US" sz="1200" dirty="0">
-                <a:solidFill>
-                  <a:srgbClr val="4A5568"/>
-                </a:solidFill>
-                <a:latin typeface="Optimist Sans" pitchFamily="34" charset="0"/>
-                <a:ea typeface="Optimist Sans" pitchFamily="34" charset="-122"/>
-                <a:cs typeface="Optimist Sans" pitchFamily="34" charset="-120"/>
-              </a:rPr>
-              <a:t>[Name] [Lvl]</a:t>
+              <a:rPr lang="en-US" sz="1200" b="1" dirty="0">
+                <a:solidFill>
+                  <a:srgbClr val="1F6F7E"/>
+                </a:solidFill>
+                <a:latin typeface="Optimist Sans" pitchFamily="34" charset="0"/>
+                <a:ea typeface="Optimist Sans" pitchFamily="34" charset="-122"/>
+                <a:cs typeface="Optimist Sans" pitchFamily="34" charset="-120"/>
+              </a:rPr>
+              <a:t>New role [Lvl]</a:t>
             </a:r>
             <a:endParaRPr lang="en-US" sz="1200" dirty="0"/>
           </a:p>
@@ -10187,15 +10187,15 @@
               <a:buNone/>
             </a:pPr>
             <a:r>
-              <a:rPr lang="en-US" sz="1200" dirty="0">
-                <a:solidFill>
-                  <a:srgbClr val="4A5568"/>
-                </a:solidFill>
-                <a:latin typeface="Optimist Sans" pitchFamily="34" charset="0"/>
-                <a:ea typeface="Optimist Sans" pitchFamily="34" charset="-122"/>
-                <a:cs typeface="Optimist Sans" pitchFamily="34" charset="-120"/>
-              </a:rPr>
-              <a:t>[Opening] [Lvl]</a:t>
+              <a:rPr lang="en-US" sz="1200" b="1" dirty="0">
+                <a:solidFill>
+                  <a:srgbClr val="1F6F7E"/>
+                </a:solidFill>
+                <a:latin typeface="Optimist Sans" pitchFamily="34" charset="0"/>
+                <a:ea typeface="Optimist Sans" pitchFamily="34" charset="-122"/>
+                <a:cs typeface="Optimist Sans" pitchFamily="34" charset="-120"/>
+              </a:rPr>
+              <a:t>New role [Lvl]</a:t>
             </a:r>
             <a:endParaRPr lang="en-US" sz="1200" dirty="0"/>
           </a:p>
@@ -10538,7 +10538,193 @@
       </p:sp>
       <p:sp>
         <p:nvSpPr>
-          <p:cNvPr id="109" name="Text 107"/>
+          <p:cNvPr id="109" name="Shape 107"/>
+          <p:cNvSpPr/>
+          <p:nvPr/>
+        </p:nvSpPr>
+        <p:spPr>
+          <a:xfrm>
+            <a:off x="6350000" y="1949450"/>
+            <a:ext cx="127000" cy="127000"/>
+          </a:xfrm>
+          <a:prstGeom prst="rect">
+            <a:avLst/>
+          </a:prstGeom>
+          <a:solidFill>
+            <a:srgbClr val="4A5568"/>
+          </a:solidFill>
+          <a:ln/>
+        </p:spPr>
+      </p:sp>
+      <p:sp>
+        <p:nvSpPr>
+          <p:cNvPr id="110" name="Text 108"/>
+          <p:cNvSpPr txBox="1"/>
+          <p:nvPr/>
+        </p:nvSpPr>
+        <p:spPr>
+          <a:xfrm>
+            <a:off x="6540500" y="1905000"/>
+            <a:ext cx="1587500" cy="215900"/>
+          </a:xfrm>
+          <a:prstGeom prst="rect">
+            <a:avLst/>
+          </a:prstGeom>
+          <a:noFill/>
+          <a:ln/>
+        </p:spPr>
+        <p:txBody>
+          <a:bodyPr wrap="square" lIns="0" tIns="0" rIns="0" bIns="0" rtlCol="0" anchor="t"/>
+          <a:lstStyle/>
+          <a:p>
+            <a:pPr algn="l" indent="0" marL="0">
+              <a:lnSpc>
+                <a:spcPct val="115000"/>
+              </a:lnSpc>
+              <a:buNone/>
+            </a:pPr>
+            <a:r>
+              <a:rPr lang="en-US" sz="1200" dirty="0">
+                <a:solidFill>
+                  <a:srgbClr val="4A5568"/>
+                </a:solidFill>
+                <a:latin typeface="Optimist Sans" pitchFamily="34" charset="0"/>
+                <a:ea typeface="Optimist Sans" pitchFamily="34" charset="-122"/>
+                <a:cs typeface="Optimist Sans" pitchFamily="34" charset="-120"/>
+              </a:rPr>
+              <a:t>Filled</a:t>
+            </a:r>
+            <a:endParaRPr lang="en-US" sz="1200" dirty="0"/>
+          </a:p>
+        </p:txBody>
+      </p:sp>
+      <p:sp>
+        <p:nvSpPr>
+          <p:cNvPr id="111" name="Shape 109"/>
+          <p:cNvSpPr/>
+          <p:nvPr/>
+        </p:nvSpPr>
+        <p:spPr>
+          <a:xfrm>
+            <a:off x="7493000" y="1949450"/>
+            <a:ext cx="127000" cy="127000"/>
+          </a:xfrm>
+          <a:prstGeom prst="rect">
+            <a:avLst/>
+          </a:prstGeom>
+          <a:solidFill>
+            <a:srgbClr val="A0521A"/>
+          </a:solidFill>
+          <a:ln/>
+        </p:spPr>
+      </p:sp>
+      <p:sp>
+        <p:nvSpPr>
+          <p:cNvPr id="112" name="Text 110"/>
+          <p:cNvSpPr txBox="1"/>
+          <p:nvPr/>
+        </p:nvSpPr>
+        <p:spPr>
+          <a:xfrm>
+            <a:off x="7683500" y="1905000"/>
+            <a:ext cx="1587500" cy="215900"/>
+          </a:xfrm>
+          <a:prstGeom prst="rect">
+            <a:avLst/>
+          </a:prstGeom>
+          <a:noFill/>
+          <a:ln/>
+        </p:spPr>
+        <p:txBody>
+          <a:bodyPr wrap="square" lIns="0" tIns="0" rIns="0" bIns="0" rtlCol="0" anchor="t"/>
+          <a:lstStyle/>
+          <a:p>
+            <a:pPr algn="l" indent="0" marL="0">
+              <a:lnSpc>
+                <a:spcPct val="115000"/>
+              </a:lnSpc>
+              <a:buNone/>
+            </a:pPr>
+            <a:r>
+              <a:rPr lang="en-US" sz="1200" b="1" dirty="0">
+                <a:solidFill>
+                  <a:srgbClr val="A0521A"/>
+                </a:solidFill>
+                <a:latin typeface="Optimist Sans" pitchFamily="34" charset="0"/>
+                <a:ea typeface="Optimist Sans" pitchFamily="34" charset="-122"/>
+                <a:cs typeface="Optimist Sans" pitchFamily="34" charset="-120"/>
+              </a:rPr>
+              <a:t>Backfill opening</a:t>
+            </a:r>
+            <a:endParaRPr lang="en-US" sz="1200" dirty="0"/>
+          </a:p>
+        </p:txBody>
+      </p:sp>
+      <p:sp>
+        <p:nvSpPr>
+          <p:cNvPr id="113" name="Shape 111"/>
+          <p:cNvSpPr/>
+          <p:nvPr/>
+        </p:nvSpPr>
+        <p:spPr>
+          <a:xfrm>
+            <a:off x="9207500" y="1949450"/>
+            <a:ext cx="127000" cy="127000"/>
+          </a:xfrm>
+          <a:prstGeom prst="rect">
+            <a:avLst/>
+          </a:prstGeom>
+          <a:solidFill>
+            <a:srgbClr val="1F6F7E"/>
+          </a:solidFill>
+          <a:ln/>
+        </p:spPr>
+      </p:sp>
+      <p:sp>
+        <p:nvSpPr>
+          <p:cNvPr id="114" name="Text 112"/>
+          <p:cNvSpPr txBox="1"/>
+          <p:nvPr/>
+        </p:nvSpPr>
+        <p:spPr>
+          <a:xfrm>
+            <a:off x="9398000" y="1905000"/>
+            <a:ext cx="1587500" cy="215900"/>
+          </a:xfrm>
+          <a:prstGeom prst="rect">
+            <a:avLst/>
+          </a:prstGeom>
+          <a:noFill/>
+          <a:ln/>
+        </p:spPr>
+        <p:txBody>
+          <a:bodyPr wrap="square" lIns="0" tIns="0" rIns="0" bIns="0" rtlCol="0" anchor="t"/>
+          <a:lstStyle/>
+          <a:p>
+            <a:pPr algn="l" indent="0" marL="0">
+              <a:lnSpc>
+                <a:spcPct val="115000"/>
+              </a:lnSpc>
+              <a:buNone/>
+            </a:pPr>
+            <a:r>
+              <a:rPr lang="en-US" sz="1200" b="1" dirty="0">
+                <a:solidFill>
+                  <a:srgbClr val="1F6F7E"/>
+                </a:solidFill>
+                <a:latin typeface="Optimist Sans" pitchFamily="34" charset="0"/>
+                <a:ea typeface="Optimist Sans" pitchFamily="34" charset="-122"/>
+                <a:cs typeface="Optimist Sans" pitchFamily="34" charset="-120"/>
+              </a:rPr>
+              <a:t>New investment</a:t>
+            </a:r>
+            <a:endParaRPr lang="en-US" sz="1200" dirty="0"/>
+          </a:p>
+        </p:txBody>
+      </p:sp>
+      <p:sp>
+        <p:nvSpPr>
+          <p:cNvPr id="115" name="Text 113"/>
           <p:cNvSpPr txBox="1"/>
           <p:nvPr/>
         </p:nvSpPr>
@@ -10572,7 +10758,7 @@
                 <a:ea typeface="Optimist Sans" pitchFamily="34" charset="-122"/>
                 <a:cs typeface="Optimist Sans" pitchFamily="34" charset="-120"/>
               </a:rPr>
-              <a:t>Draft for discussion · Bars show year-end headcount · Expected departures of [XYZ] associates are counted as openings</a:t>
+              <a:t>Draft for discussion · Bars show year-end headcount · Expected departures of [XYZ] associates are counted as backfill openings</a:t>
             </a:r>
             <a:endParaRPr lang="en-US" sz="1200" dirty="0"/>
           </a:p>
@@ -10812,7 +10998,7 @@
                 <a:ea typeface="Optimist Sans" pitchFamily="34" charset="-122"/>
                 <a:cs typeface="Optimist Sans" pitchFamily="34" charset="-120"/>
               </a:rPr>
-              <a:t>~[30] associates</a:t>
+              <a:t>~[30] incl. [n] openings</a:t>
             </a:r>
             <a:endParaRPr lang="en-US" sz="1200" dirty="0"/>
           </a:p>
@@ -11020,7 +11206,7 @@
                 <a:ea typeface="Optimist Sans" pitchFamily="34" charset="-122"/>
                 <a:cs typeface="Optimist Sans" pitchFamily="34" charset="-120"/>
               </a:rPr>
-              <a:t>~[__] associates</a:t>
+              <a:t>~[__] · fully staffed</a:t>
             </a:r>
             <a:endParaRPr lang="en-US" sz="1200" dirty="0"/>
           </a:p>
@@ -11211,7 +11397,7 @@
                 <a:ea typeface="Optimist Sans" pitchFamily="34" charset="-122"/>
                 <a:cs typeface="Optimist Sans" pitchFamily="34" charset="-120"/>
               </a:rPr>
-              <a:t>End ’28</a:t>
+              <a:t>End ’28 target</a:t>
             </a:r>
             <a:endParaRPr lang="en-US" sz="1600" dirty="0"/>
           </a:p>
@@ -11253,7 +11439,7 @@
                 <a:ea typeface="Optimist Sans" pitchFamily="34" charset="-122"/>
                 <a:cs typeface="Optimist Sans" pitchFamily="34" charset="-120"/>
               </a:rPr>
-              <a:t>Target · ~[__] associates</a:t>
+              <a:t>~[__] · fully staffed</a:t>
             </a:r>
             <a:endParaRPr lang="en-US" sz="1200" dirty="0"/>
           </a:p>
@@ -11973,7 +12159,7 @@
                 <a:ea typeface="Optimist Sans" pitchFamily="34" charset="-122"/>
                 <a:cs typeface="Optimist Sans" pitchFamily="34" charset="-120"/>
               </a:rPr>
-              <a:t>Draft for discussion · Illustrative mix; BAU can shrink to the floor, never below it</a:t>
+              <a:t>Draft for discussion · ’26 includes open roles; ’27–’28 assume the team is fully staffed · Mix is illustrative</a:t>
             </a:r>
             <a:endParaRPr lang="en-US" sz="1200" dirty="0"/>
           </a:p>

</xml_diff>

<commit_message>
Split openings into backfill, converted backfill and new investment
Co-Authored-By: Claude Opus 5.5 <noreply@anthropic.com>
Claude-Session: https://claude.ai/code/session_01JXKaD9UU8MgeRWUr7sq4Za
</commit_message>
<xml_diff>
--- a/Unified Team Strategy.pptx
+++ b/Unified Team Strategy.pptx
@@ -116,13 +116,13 @@
   <p:extLst>
     <p:ext uri="{521415D9-36F7-43E2-AB2F-B90AF26B5E84}">
       <p14:sectionLst xmlns:p14="http://schemas.microsoft.com/office/powerpoint/2010/main">
-        <p14:section name="Why combine" id="{6b5c9b1c-2747-b660-ad37-f0af475094e8}">
+        <p14:section name="Why combine" id="{d88b3d55-a793-a15b-7955-f9b4429ca934}">
           <p14:sldIdLst>
             <p14:sldId id="256"/>
             <p14:sldId id="257"/>
           </p14:sldIdLst>
         </p14:section>
-        <p14:section name="How we organize" id="{447fe89d-375e-1ad6-74fd-f3638ebf351d}">
+        <p14:section name="How we organize" id="{184b7a42-706c-d515-58a3-5858481d927b}">
           <p14:sldIdLst>
             <p14:sldId id="258"/>
             <p14:sldId id="259"/>
@@ -130,14 +130,14 @@
             <p14:sldId id="261"/>
           </p14:sldIdLst>
         </p14:section>
-        <p14:section name="What we do and how we grow" id="{bfb5ca6f-89bd-e184-84e8-98e9b462c95e}">
+        <p14:section name="What we do and how we grow" id="{e652838a-24c9-52c9-fdde-06b9b6e176f2}">
           <p14:sldIdLst>
             <p14:sldId id="262"/>
             <p14:sldId id="263"/>
             <p14:sldId id="264"/>
           </p14:sldIdLst>
         </p14:section>
-        <p14:section name="Asks" id="{9da28ad2-3330-f158-d6d9-34e5c837d4a5}">
+        <p14:section name="Asks" id="{202c3ef4-338f-a0e5-49ff-16e215f6351f}">
           <p14:sldIdLst>
             <p14:sldId id="265"/>
           </p14:sldIdLst>
@@ -898,7 +898,7 @@
           <a:p>
             <a:r>
               <a:rPr lang="en-US" dirty="0"/>
-              <a:t>This slide turns the four-function structure into the actual team: one team lead, four sub-team heads, and three sub-teams under Modeling, each with its own lead and level. Each box lists every member with their level, with open roles color-coded: rust for backfills of current or expected departures (expected departures of [XYZ] associates are already counted), teal for new investment roles; then a small bar strip with year-end headcount for this year, next year and the year after. Modeling, Data Foundation and Platform &amp; Deployment get smaller over time as AI takes on BAU work; AI Enablement grows. The next slide rolls these team-level numbers up into the overall picture.</a:t>
+              <a:t>This slide turns the four-function structure into the actual team: one team lead, four sub-team heads, and three sub-teams under Modeling, each with its own lead and level. Each box lists every member with their level, with open roles color-coded in three types: a backfill (rust) replaces a departing person one-for-one to do the same job, and expected departures of [XYZ] associates are already counted; a converted backfill (teal) takes a departure from another team and repurposes the role, mainly into AI Enablement; a new investment (plum) is genuinely new budget and should be rare. Then a small bar strip with year-end headcount for this year, next year and the year after. Modeling, Data Foundation and Platform &amp; Deployment get smaller over time as AI takes on BAU work; AI Enablement grows. The next slide rolls these team-level numbers up into the overall picture.</a:t>
             </a:r>
             <a:endParaRPr lang="en-US" dirty="0"/>
           </a:p>
@@ -9691,7 +9691,7 @@
                 <a:ea typeface="Optimist Sans" pitchFamily="34" charset="-122"/>
                 <a:cs typeface="Optimist Sans" pitchFamily="34" charset="-120"/>
               </a:rPr>
-              <a:t>New role [Lvl]</a:t>
+              <a:t>Converted [Lvl]</a:t>
             </a:r>
             <a:endParaRPr lang="en-US" sz="1200" dirty="0"/>
           </a:p>
@@ -10155,7 +10155,7 @@
                 <a:ea typeface="Optimist Sans" pitchFamily="34" charset="-122"/>
                 <a:cs typeface="Optimist Sans" pitchFamily="34" charset="-120"/>
               </a:rPr>
-              <a:t>New role [Lvl]</a:t>
+              <a:t>Converted [Lvl]</a:t>
             </a:r>
             <a:endParaRPr lang="en-US" sz="1200" dirty="0"/>
           </a:p>
@@ -10175,7 +10175,7 @@
                 <a:ea typeface="Optimist Sans" pitchFamily="34" charset="-122"/>
                 <a:cs typeface="Optimist Sans" pitchFamily="34" charset="-120"/>
               </a:rPr>
-              <a:t>New role [Lvl]</a:t>
+              <a:t>Converted [Lvl]</a:t>
             </a:r>
             <a:endParaRPr lang="en-US" sz="1200" dirty="0"/>
           </a:p>
@@ -10189,13 +10189,13 @@
             <a:r>
               <a:rPr lang="en-US" sz="1200" b="1" dirty="0">
                 <a:solidFill>
-                  <a:srgbClr val="1F6F7E"/>
-                </a:solidFill>
-                <a:latin typeface="Optimist Sans" pitchFamily="34" charset="0"/>
-                <a:ea typeface="Optimist Sans" pitchFamily="34" charset="-122"/>
-                <a:cs typeface="Optimist Sans" pitchFamily="34" charset="-120"/>
-              </a:rPr>
-              <a:t>New role [Lvl]</a:t>
+                  <a:srgbClr val="7B3FA0"/>
+                </a:solidFill>
+                <a:latin typeface="Optimist Sans" pitchFamily="34" charset="0"/>
+                <a:ea typeface="Optimist Sans" pitchFamily="34" charset="-122"/>
+                <a:cs typeface="Optimist Sans" pitchFamily="34" charset="-120"/>
+              </a:rPr>
+              <a:t>New invest. [Lvl]</a:t>
             </a:r>
             <a:endParaRPr lang="en-US" sz="1200" dirty="0"/>
           </a:p>
@@ -10544,7 +10544,7 @@
         </p:nvSpPr>
         <p:spPr>
           <a:xfrm>
-            <a:off x="6350000" y="1949450"/>
+            <a:off x="4445000" y="1949450"/>
             <a:ext cx="127000" cy="127000"/>
           </a:xfrm>
           <a:prstGeom prst="rect">
@@ -10564,8 +10564,8 @@
         </p:nvSpPr>
         <p:spPr>
           <a:xfrm>
-            <a:off x="6540500" y="1905000"/>
-            <a:ext cx="1587500" cy="215900"/>
+            <a:off x="4635500" y="1905000"/>
+            <a:ext cx="635000" cy="215900"/>
           </a:xfrm>
           <a:prstGeom prst="rect">
             <a:avLst/>
@@ -10606,7 +10606,7 @@
         </p:nvSpPr>
         <p:spPr>
           <a:xfrm>
-            <a:off x="7493000" y="1949450"/>
+            <a:off x="5334000" y="1949450"/>
             <a:ext cx="127000" cy="127000"/>
           </a:xfrm>
           <a:prstGeom prst="rect">
@@ -10626,8 +10626,8 @@
         </p:nvSpPr>
         <p:spPr>
           <a:xfrm>
-            <a:off x="7683500" y="1905000"/>
-            <a:ext cx="1587500" cy="215900"/>
+            <a:off x="5524500" y="1905000"/>
+            <a:ext cx="1270000" cy="215900"/>
           </a:xfrm>
           <a:prstGeom prst="rect">
             <a:avLst/>
@@ -10654,7 +10654,7 @@
                 <a:ea typeface="Optimist Sans" pitchFamily="34" charset="-122"/>
                 <a:cs typeface="Optimist Sans" pitchFamily="34" charset="-120"/>
               </a:rPr>
-              <a:t>Backfill opening</a:t>
+              <a:t>Backfill (1:1)</a:t>
             </a:r>
             <a:endParaRPr lang="en-US" sz="1200" dirty="0"/>
           </a:p>
@@ -10668,7 +10668,7 @@
         </p:nvSpPr>
         <p:spPr>
           <a:xfrm>
-            <a:off x="9207500" y="1949450"/>
+            <a:off x="6858000" y="1949450"/>
             <a:ext cx="127000" cy="127000"/>
           </a:xfrm>
           <a:prstGeom prst="rect">
@@ -10688,8 +10688,8 @@
         </p:nvSpPr>
         <p:spPr>
           <a:xfrm>
-            <a:off x="9398000" y="1905000"/>
-            <a:ext cx="1587500" cy="215900"/>
+            <a:off x="7048500" y="1905000"/>
+            <a:ext cx="1651000" cy="215900"/>
           </a:xfrm>
           <a:prstGeom prst="rect">
             <a:avLst/>
@@ -10716,15 +10716,77 @@
                 <a:ea typeface="Optimist Sans" pitchFamily="34" charset="-122"/>
                 <a:cs typeface="Optimist Sans" pitchFamily="34" charset="-120"/>
               </a:rPr>
-              <a:t>New investment</a:t>
-            </a:r>
-            <a:endParaRPr lang="en-US" sz="1200" dirty="0"/>
-          </a:p>
-        </p:txBody>
-      </p:sp>
-      <p:sp>
-        <p:nvSpPr>
-          <p:cNvPr id="115" name="Text 113"/>
+              <a:t>Converted backfill</a:t>
+            </a:r>
+            <a:endParaRPr lang="en-US" sz="1200" dirty="0"/>
+          </a:p>
+        </p:txBody>
+      </p:sp>
+      <p:sp>
+        <p:nvSpPr>
+          <p:cNvPr id="115" name="Shape 113"/>
+          <p:cNvSpPr/>
+          <p:nvPr/>
+        </p:nvSpPr>
+        <p:spPr>
+          <a:xfrm>
+            <a:off x="8763000" y="1949450"/>
+            <a:ext cx="127000" cy="127000"/>
+          </a:xfrm>
+          <a:prstGeom prst="rect">
+            <a:avLst/>
+          </a:prstGeom>
+          <a:solidFill>
+            <a:srgbClr val="7B3FA0"/>
+          </a:solidFill>
+          <a:ln/>
+        </p:spPr>
+      </p:sp>
+      <p:sp>
+        <p:nvSpPr>
+          <p:cNvPr id="116" name="Text 114"/>
+          <p:cNvSpPr txBox="1"/>
+          <p:nvPr/>
+        </p:nvSpPr>
+        <p:spPr>
+          <a:xfrm>
+            <a:off x="8953500" y="1905000"/>
+            <a:ext cx="1905000" cy="215900"/>
+          </a:xfrm>
+          <a:prstGeom prst="rect">
+            <a:avLst/>
+          </a:prstGeom>
+          <a:noFill/>
+          <a:ln/>
+        </p:spPr>
+        <p:txBody>
+          <a:bodyPr wrap="square" lIns="0" tIns="0" rIns="0" bIns="0" rtlCol="0" anchor="t"/>
+          <a:lstStyle/>
+          <a:p>
+            <a:pPr algn="l" indent="0" marL="0">
+              <a:lnSpc>
+                <a:spcPct val="115000"/>
+              </a:lnSpc>
+              <a:buNone/>
+            </a:pPr>
+            <a:r>
+              <a:rPr lang="en-US" sz="1200" b="1" dirty="0">
+                <a:solidFill>
+                  <a:srgbClr val="7B3FA0"/>
+                </a:solidFill>
+                <a:latin typeface="Optimist Sans" pitchFamily="34" charset="0"/>
+                <a:ea typeface="Optimist Sans" pitchFamily="34" charset="-122"/>
+                <a:cs typeface="Optimist Sans" pitchFamily="34" charset="-120"/>
+              </a:rPr>
+              <a:t>New investment (rare)</a:t>
+            </a:r>
+            <a:endParaRPr lang="en-US" sz="1200" dirty="0"/>
+          </a:p>
+        </p:txBody>
+      </p:sp>
+      <p:sp>
+        <p:nvSpPr>
+          <p:cNvPr id="117" name="Text 115"/>
           <p:cNvSpPr txBox="1"/>
           <p:nvPr/>
         </p:nvSpPr>

</xml_diff>

<commit_message>
Show team-level BAU floors on org detail and link the sum to the headcount slide
Co-Authored-By: Claude Opus 5.5 <noreply@anthropic.com>
Claude-Session: https://claude.ai/code/session_01JXKaD9UU8MgeRWUr7sq4Za
</commit_message>
<xml_diff>
--- a/Unified Team Strategy.pptx
+++ b/Unified Team Strategy.pptx
@@ -116,13 +116,13 @@
   <p:extLst>
     <p:ext uri="{521415D9-36F7-43E2-AB2F-B90AF26B5E84}">
       <p14:sectionLst xmlns:p14="http://schemas.microsoft.com/office/powerpoint/2010/main">
-        <p14:section name="Why combine" id="{d88b3d55-a793-a15b-7955-f9b4429ca934}">
+        <p14:section name="Why combine" id="{15d7a3db-7f25-a380-bb9d-4503745113cc}">
           <p14:sldIdLst>
             <p14:sldId id="256"/>
             <p14:sldId id="257"/>
           </p14:sldIdLst>
         </p14:section>
-        <p14:section name="How we organize" id="{184b7a42-706c-d515-58a3-5858481d927b}">
+        <p14:section name="How we organize" id="{0f4c5231-9495-89af-141f-1004c6ec021d}">
           <p14:sldIdLst>
             <p14:sldId id="258"/>
             <p14:sldId id="259"/>
@@ -130,14 +130,14 @@
             <p14:sldId id="261"/>
           </p14:sldIdLst>
         </p14:section>
-        <p14:section name="What we do and how we grow" id="{e652838a-24c9-52c9-fdde-06b9b6e176f2}">
+        <p14:section name="What we do and how we grow" id="{c738f1fb-9b39-560a-de24-3e67785d9798}">
           <p14:sldIdLst>
             <p14:sldId id="262"/>
             <p14:sldId id="263"/>
             <p14:sldId id="264"/>
           </p14:sldIdLst>
         </p14:section>
-        <p14:section name="Asks" id="{202c3ef4-338f-a0e5-49ff-16e215f6351f}">
+        <p14:section name="Asks" id="{6df04c57-8b74-defb-120b-b0ea82358290}">
           <p14:sldIdLst>
             <p14:sldId id="265"/>
           </p14:sldIdLst>
@@ -898,7 +898,7 @@
           <a:p>
             <a:r>
               <a:rPr lang="en-US" dirty="0"/>
-              <a:t>This slide turns the four-function structure into the actual team: one team lead, four sub-team heads, and three sub-teams under Modeling, each with its own lead and level. Each box lists every member with their level, with open roles color-coded in three types: a backfill (rust) replaces a departing person one-for-one to do the same job, and expected departures of [XYZ] associates are already counted; a converted backfill (teal) takes a departure from another team and repurposes the role, mainly into AI Enablement; a new investment (plum) is genuinely new budget and should be rare. Then a small bar strip with year-end headcount for this year, next year and the year after. Modeling, Data Foundation and Platform &amp; Deployment get smaller over time as AI takes on BAU work; AI Enablement grows. The next slide rolls these team-level numbers up into the overall picture.</a:t>
+              <a:t>This slide turns the four-function structure into the actual team: one team lead, four sub-team heads, and three sub-teams under Modeling, each with its own lead and level. Each box lists every member with their level, with open roles color-coded in three types: a backfill (rust) replaces a departing person one-for-one to do the same job, and expected departures of [XYZ] associates are already counted; a converted backfill (teal) takes a departure from another team and repurposes the role, mainly into AI Enablement; a new investment (plum) is genuinely new budget and should be rare. Each BAU team also shows its floor: the minimum headcount it needs to manage key-person and operational risk, drawn as a dashed line on its bars. AI Enablement has no BAU floor. The team floors add up to the BAU floor on the next slide. Then a small bar strip with year-end headcount for this year, next year and the year after. Modeling, Data Foundation and Platform &amp; Deployment get smaller over time as AI takes on BAU work; AI Enablement grows. The next slide rolls these team-level numbers up into the overall picture.</a:t>
             </a:r>
             <a:endParaRPr lang="en-US" dirty="0"/>
           </a:p>
@@ -986,7 +986,7 @@
           <a:p>
             <a:r>
               <a:rPr lang="en-US" dirty="0"/>
-              <a:t>This rolls up the team-by-team plan on the previous slide. The end-2026 count includes open roles; 2027 and 2028 assume every role is filled. The story, from the end of this year to the end of 2028: today almost all capacity goes to BAU, and dedicated AI work is near zero. AI and new tooling let BAU shrink step by step (the end of 2027 shows the midpoint), but only down to a floor. That floor is the minimum BAU team we need to manage operational risk: critical functions like model deployment must never depend on one person whose departure takes all the knowledge with them. Rotation and cross-functional mixing keep that floor as low as safely possible, but we will not go below it. Everything freed above the floor moves to AI-focused work, the change-the-business end of the structure. Any net headcount reduction is a by-product, shown as the dashed box.</a:t>
+              <a:t>This rolls up the team-by-team plan on the previous slide. The end-2026 count includes open roles; 2027 and 2028 assume every role is filled. The story, from the end of this year to the end of 2028: today almost all capacity goes to BAU, and dedicated AI work is near zero. AI and new tooling let BAU shrink step by step (the end of 2027 shows the midpoint), but only down to a floor. That floor, [n] people, is the sum of the team-level floors on the previous slide: the minimum BAU team we need to manage operational risk: critical functions like model deployment must never depend on one person whose departure takes all the knowledge with them. Rotation and cross-functional mixing keep that floor as low as safely possible, but we will not go below it. Everything freed above the floor moves to AI-focused work, the change-the-business end of the structure. Any net headcount reduction is a by-product, shown as the dashed box.</a:t>
             </a:r>
             <a:endParaRPr lang="en-US" dirty="0"/>
           </a:p>
@@ -6682,7 +6682,7 @@
         </p:nvSpPr>
         <p:spPr>
           <a:xfrm>
-            <a:off x="6096000" y="2717800"/>
+            <a:off x="6096000" y="2463800"/>
             <a:ext cx="914" cy="127000"/>
           </a:xfrm>
           <a:prstGeom prst="line">
@@ -6705,7 +6705,7 @@
         </p:nvSpPr>
         <p:spPr>
           <a:xfrm>
-            <a:off x="3200400" y="2844800"/>
+            <a:off x="3200400" y="2590800"/>
             <a:ext cx="7289800" cy="914"/>
           </a:xfrm>
           <a:prstGeom prst="line">
@@ -6728,7 +6728,7 @@
         </p:nvSpPr>
         <p:spPr>
           <a:xfrm>
-            <a:off x="3200400" y="2844800"/>
+            <a:off x="3200400" y="2590800"/>
             <a:ext cx="914" cy="127000"/>
           </a:xfrm>
           <a:prstGeom prst="line">
@@ -6751,7 +6751,7 @@
         </p:nvSpPr>
         <p:spPr>
           <a:xfrm>
-            <a:off x="6629400" y="2844800"/>
+            <a:off x="6629400" y="2590800"/>
             <a:ext cx="914" cy="127000"/>
           </a:xfrm>
           <a:prstGeom prst="line">
@@ -6774,7 +6774,7 @@
         </p:nvSpPr>
         <p:spPr>
           <a:xfrm>
-            <a:off x="8559800" y="2844800"/>
+            <a:off x="8559800" y="2590800"/>
             <a:ext cx="914" cy="127000"/>
           </a:xfrm>
           <a:prstGeom prst="line">
@@ -6797,7 +6797,7 @@
         </p:nvSpPr>
         <p:spPr>
           <a:xfrm>
-            <a:off x="10490200" y="2844800"/>
+            <a:off x="10490200" y="2590800"/>
             <a:ext cx="914" cy="127000"/>
           </a:xfrm>
           <a:prstGeom prst="line">
@@ -6820,7 +6820,7 @@
         </p:nvSpPr>
         <p:spPr>
           <a:xfrm>
-            <a:off x="3200400" y="3632200"/>
+            <a:off x="3200400" y="3378200"/>
             <a:ext cx="914" cy="101600"/>
           </a:xfrm>
           <a:prstGeom prst="line">
@@ -6843,7 +6843,7 @@
         </p:nvSpPr>
         <p:spPr>
           <a:xfrm>
-            <a:off x="1574800" y="3733800"/>
+            <a:off x="1574800" y="3479800"/>
             <a:ext cx="3251200" cy="914"/>
           </a:xfrm>
           <a:prstGeom prst="line">
@@ -6866,7 +6866,7 @@
         </p:nvSpPr>
         <p:spPr>
           <a:xfrm>
-            <a:off x="1574800" y="3733800"/>
+            <a:off x="1574800" y="3479800"/>
             <a:ext cx="914" cy="101600"/>
           </a:xfrm>
           <a:prstGeom prst="line">
@@ -6889,7 +6889,7 @@
         </p:nvSpPr>
         <p:spPr>
           <a:xfrm>
-            <a:off x="1574800" y="4343400"/>
+            <a:off x="1574800" y="4089400"/>
             <a:ext cx="914" cy="101600"/>
           </a:xfrm>
           <a:prstGeom prst="line">
@@ -6912,7 +6912,7 @@
         </p:nvSpPr>
         <p:spPr>
           <a:xfrm>
-            <a:off x="3200400" y="3733800"/>
+            <a:off x="3200400" y="3479800"/>
             <a:ext cx="914" cy="101600"/>
           </a:xfrm>
           <a:prstGeom prst="line">
@@ -6935,7 +6935,7 @@
         </p:nvSpPr>
         <p:spPr>
           <a:xfrm>
-            <a:off x="3200400" y="4343400"/>
+            <a:off x="3200400" y="4089400"/>
             <a:ext cx="914" cy="101600"/>
           </a:xfrm>
           <a:prstGeom prst="line">
@@ -6958,7 +6958,7 @@
         </p:nvSpPr>
         <p:spPr>
           <a:xfrm>
-            <a:off x="4826000" y="3733800"/>
+            <a:off x="4826000" y="3479800"/>
             <a:ext cx="914" cy="101600"/>
           </a:xfrm>
           <a:prstGeom prst="line">
@@ -6981,7 +6981,7 @@
         </p:nvSpPr>
         <p:spPr>
           <a:xfrm>
-            <a:off x="4826000" y="4343400"/>
+            <a:off x="4826000" y="4089400"/>
             <a:ext cx="914" cy="101600"/>
           </a:xfrm>
           <a:prstGeom prst="line">
@@ -7004,7 +7004,7 @@
         </p:nvSpPr>
         <p:spPr>
           <a:xfrm>
-            <a:off x="6629400" y="3632200"/>
+            <a:off x="6629400" y="3378200"/>
             <a:ext cx="914" cy="203200"/>
           </a:xfrm>
           <a:prstGeom prst="line">
@@ -7027,7 +7027,7 @@
         </p:nvSpPr>
         <p:spPr>
           <a:xfrm>
-            <a:off x="8559800" y="3632200"/>
+            <a:off x="8559800" y="3378200"/>
             <a:ext cx="914" cy="203200"/>
           </a:xfrm>
           <a:prstGeom prst="line">
@@ -7050,7 +7050,7 @@
         </p:nvSpPr>
         <p:spPr>
           <a:xfrm>
-            <a:off x="10490200" y="3632200"/>
+            <a:off x="10490200" y="3378200"/>
             <a:ext cx="914" cy="203200"/>
           </a:xfrm>
           <a:prstGeom prst="line">
@@ -7073,7 +7073,7 @@
         </p:nvSpPr>
         <p:spPr>
           <a:xfrm>
-            <a:off x="4826000" y="2362200"/>
+            <a:off x="4826000" y="2108200"/>
             <a:ext cx="2540000" cy="355600"/>
           </a:xfrm>
           <a:prstGeom prst="roundRect">
@@ -7095,7 +7095,7 @@
         </p:nvSpPr>
         <p:spPr>
           <a:xfrm>
-            <a:off x="4826000" y="2362200"/>
+            <a:off x="4826000" y="2108200"/>
             <a:ext cx="2540000" cy="355600"/>
           </a:xfrm>
           <a:prstGeom prst="rect">
@@ -7137,7 +7137,7 @@
         </p:nvSpPr>
         <p:spPr>
           <a:xfrm>
-            <a:off x="812800" y="2971800"/>
+            <a:off x="812800" y="2717800"/>
             <a:ext cx="4775200" cy="660400"/>
           </a:xfrm>
           <a:prstGeom prst="roundRect">
@@ -7164,7 +7164,7 @@
         </p:nvSpPr>
         <p:spPr>
           <a:xfrm>
-            <a:off x="901700" y="3022600"/>
+            <a:off x="901700" y="2768600"/>
             <a:ext cx="4597400" cy="558800"/>
           </a:xfrm>
           <a:prstGeom prst="rect">
@@ -7226,7 +7226,7 @@
         </p:nvSpPr>
         <p:spPr>
           <a:xfrm>
-            <a:off x="5740400" y="2971800"/>
+            <a:off x="5740400" y="2717800"/>
             <a:ext cx="1778000" cy="660400"/>
           </a:xfrm>
           <a:prstGeom prst="roundRect">
@@ -7253,7 +7253,7 @@
         </p:nvSpPr>
         <p:spPr>
           <a:xfrm>
-            <a:off x="5829300" y="3022600"/>
+            <a:off x="5829300" y="2768600"/>
             <a:ext cx="1600200" cy="558800"/>
           </a:xfrm>
           <a:prstGeom prst="rect">
@@ -7315,7 +7315,7 @@
         </p:nvSpPr>
         <p:spPr>
           <a:xfrm>
-            <a:off x="7670800" y="2971800"/>
+            <a:off x="7670800" y="2717800"/>
             <a:ext cx="1778000" cy="660400"/>
           </a:xfrm>
           <a:prstGeom prst="roundRect">
@@ -7342,7 +7342,7 @@
         </p:nvSpPr>
         <p:spPr>
           <a:xfrm>
-            <a:off x="7759700" y="3022600"/>
+            <a:off x="7759700" y="2768600"/>
             <a:ext cx="1600200" cy="558800"/>
           </a:xfrm>
           <a:prstGeom prst="rect">
@@ -7404,7 +7404,7 @@
         </p:nvSpPr>
         <p:spPr>
           <a:xfrm>
-            <a:off x="9601200" y="2971800"/>
+            <a:off x="9601200" y="2717800"/>
             <a:ext cx="1778000" cy="660400"/>
           </a:xfrm>
           <a:prstGeom prst="roundRect">
@@ -7431,7 +7431,7 @@
         </p:nvSpPr>
         <p:spPr>
           <a:xfrm>
-            <a:off x="9690100" y="3022600"/>
+            <a:off x="9690100" y="2768600"/>
             <a:ext cx="1600200" cy="558800"/>
           </a:xfrm>
           <a:prstGeom prst="rect">
@@ -7493,7 +7493,7 @@
         </p:nvSpPr>
         <p:spPr>
           <a:xfrm>
-            <a:off x="812800" y="3835400"/>
+            <a:off x="812800" y="3581400"/>
             <a:ext cx="1524000" cy="508000"/>
           </a:xfrm>
           <a:prstGeom prst="roundRect">
@@ -7520,7 +7520,7 @@
         </p:nvSpPr>
         <p:spPr>
           <a:xfrm>
-            <a:off x="901700" y="3873500"/>
+            <a:off x="901700" y="3619500"/>
             <a:ext cx="1346200" cy="431800"/>
           </a:xfrm>
           <a:prstGeom prst="rect">
@@ -7582,7 +7582,7 @@
         </p:nvSpPr>
         <p:spPr>
           <a:xfrm>
-            <a:off x="2438400" y="3835400"/>
+            <a:off x="2438400" y="3581400"/>
             <a:ext cx="1524000" cy="508000"/>
           </a:xfrm>
           <a:prstGeom prst="roundRect">
@@ -7609,7 +7609,7 @@
         </p:nvSpPr>
         <p:spPr>
           <a:xfrm>
-            <a:off x="2527300" y="3873500"/>
+            <a:off x="2527300" y="3619500"/>
             <a:ext cx="1346200" cy="431800"/>
           </a:xfrm>
           <a:prstGeom prst="rect">
@@ -7671,7 +7671,7 @@
         </p:nvSpPr>
         <p:spPr>
           <a:xfrm>
-            <a:off x="4064000" y="3835400"/>
+            <a:off x="4064000" y="3581400"/>
             <a:ext cx="1524000" cy="508000"/>
           </a:xfrm>
           <a:prstGeom prst="roundRect">
@@ -7698,7 +7698,7 @@
         </p:nvSpPr>
         <p:spPr>
           <a:xfrm>
-            <a:off x="4152900" y="3873500"/>
+            <a:off x="4152900" y="3619500"/>
             <a:ext cx="1346200" cy="431800"/>
           </a:xfrm>
           <a:prstGeom prst="rect">
@@ -7760,12 +7760,12 @@
         </p:nvSpPr>
         <p:spPr>
           <a:xfrm>
-            <a:off x="812800" y="4445000"/>
-            <a:ext cx="1524000" cy="1397000"/>
+            <a:off x="812800" y="4191000"/>
+            <a:ext cx="1524000" cy="1651000"/>
           </a:xfrm>
           <a:prstGeom prst="roundRect">
             <a:avLst>
-              <a:gd name="adj" fmla="val 3927"/>
+              <a:gd name="adj" fmla="val 3600"/>
             </a:avLst>
           </a:prstGeom>
           <a:solidFill>
@@ -7787,7 +7787,7 @@
         </p:nvSpPr>
         <p:spPr>
           <a:xfrm>
-            <a:off x="914400" y="4521200"/>
+            <a:off x="914400" y="4267200"/>
             <a:ext cx="1320800" cy="590550"/>
           </a:xfrm>
           <a:prstGeom prst="rect">
@@ -7886,7 +7886,72 @@
       </p:sp>
       <p:sp>
         <p:nvSpPr>
-          <p:cNvPr id="40" name="Shape 38"/>
+          <p:cNvPr id="40" name="Text 38"/>
+          <p:cNvSpPr txBox="1"/>
+          <p:nvPr/>
+        </p:nvSpPr>
+        <p:spPr>
+          <a:xfrm>
+            <a:off x="914400" y="4972050"/>
+            <a:ext cx="1320800" cy="203200"/>
+          </a:xfrm>
+          <a:prstGeom prst="rect">
+            <a:avLst/>
+          </a:prstGeom>
+          <a:noFill/>
+          <a:ln/>
+        </p:spPr>
+        <p:txBody>
+          <a:bodyPr wrap="square" lIns="0" tIns="0" rIns="0" bIns="0" rtlCol="0" anchor="t"/>
+          <a:lstStyle/>
+          <a:p>
+            <a:pPr algn="l" indent="0" marL="0">
+              <a:lnSpc>
+                <a:spcPct val="115000"/>
+              </a:lnSpc>
+              <a:buNone/>
+            </a:pPr>
+            <a:r>
+              <a:rPr lang="en-US" sz="1200" b="1" dirty="0">
+                <a:solidFill>
+                  <a:srgbClr val="A0521A"/>
+                </a:solidFill>
+                <a:latin typeface="Optimist Sans" pitchFamily="34" charset="0"/>
+                <a:ea typeface="Optimist Sans" pitchFamily="34" charset="-122"/>
+                <a:cs typeface="Optimist Sans" pitchFamily="34" charset="-120"/>
+              </a:rPr>
+              <a:t>BAU floor: [n]</a:t>
+            </a:r>
+            <a:endParaRPr lang="en-US" sz="1200" dirty="0"/>
+          </a:p>
+        </p:txBody>
+      </p:sp>
+      <p:sp>
+        <p:nvSpPr>
+          <p:cNvPr id="41" name="Shape 39"/>
+          <p:cNvSpPr/>
+          <p:nvPr/>
+        </p:nvSpPr>
+        <p:spPr>
+          <a:xfrm>
+            <a:off x="914400" y="5327650"/>
+            <a:ext cx="1320800" cy="914"/>
+          </a:xfrm>
+          <a:prstGeom prst="line">
+            <a:avLst/>
+          </a:prstGeom>
+          <a:noFill/>
+          <a:ln w="19050">
+            <a:solidFill>
+              <a:srgbClr val="A0521A"/>
+            </a:solidFill>
+            <a:prstDash val="dash"/>
+          </a:ln>
+        </p:spPr>
+      </p:sp>
+      <p:sp>
+        <p:nvSpPr>
+          <p:cNvPr id="42" name="Shape 40"/>
           <p:cNvSpPr/>
           <p:nvPr/>
         </p:nvSpPr>
@@ -7906,7 +7971,7 @@
       </p:sp>
       <p:sp>
         <p:nvSpPr>
-          <p:cNvPr id="41" name="Text 39"/>
+          <p:cNvPr id="43" name="Text 41"/>
           <p:cNvSpPr txBox="1"/>
           <p:nvPr/>
         </p:nvSpPr>
@@ -7948,7 +8013,7 @@
       </p:sp>
       <p:sp>
         <p:nvSpPr>
-          <p:cNvPr id="42" name="Text 40"/>
+          <p:cNvPr id="44" name="Text 42"/>
           <p:cNvSpPr txBox="1"/>
           <p:nvPr/>
         </p:nvSpPr>
@@ -7990,7 +8055,7 @@
       </p:sp>
       <p:sp>
         <p:nvSpPr>
-          <p:cNvPr id="43" name="Shape 41"/>
+          <p:cNvPr id="45" name="Shape 43"/>
           <p:cNvSpPr/>
           <p:nvPr/>
         </p:nvSpPr>
@@ -8010,7 +8075,7 @@
       </p:sp>
       <p:sp>
         <p:nvSpPr>
-          <p:cNvPr id="44" name="Text 42"/>
+          <p:cNvPr id="46" name="Text 44"/>
           <p:cNvSpPr txBox="1"/>
           <p:nvPr/>
         </p:nvSpPr>
@@ -8052,7 +8117,7 @@
       </p:sp>
       <p:sp>
         <p:nvSpPr>
-          <p:cNvPr id="45" name="Text 43"/>
+          <p:cNvPr id="47" name="Text 45"/>
           <p:cNvSpPr txBox="1"/>
           <p:nvPr/>
         </p:nvSpPr>
@@ -8094,7 +8159,7 @@
       </p:sp>
       <p:sp>
         <p:nvSpPr>
-          <p:cNvPr id="46" name="Shape 44"/>
+          <p:cNvPr id="48" name="Shape 46"/>
           <p:cNvSpPr/>
           <p:nvPr/>
         </p:nvSpPr>
@@ -8114,7 +8179,7 @@
       </p:sp>
       <p:sp>
         <p:nvSpPr>
-          <p:cNvPr id="47" name="Text 45"/>
+          <p:cNvPr id="49" name="Text 47"/>
           <p:cNvSpPr txBox="1"/>
           <p:nvPr/>
         </p:nvSpPr>
@@ -8156,7 +8221,7 @@
       </p:sp>
       <p:sp>
         <p:nvSpPr>
-          <p:cNvPr id="48" name="Text 46"/>
+          <p:cNvPr id="50" name="Text 48"/>
           <p:cNvSpPr txBox="1"/>
           <p:nvPr/>
         </p:nvSpPr>
@@ -8198,18 +8263,18 @@
       </p:sp>
       <p:sp>
         <p:nvSpPr>
-          <p:cNvPr id="49" name="Shape 47"/>
-          <p:cNvSpPr/>
-          <p:nvPr/>
-        </p:nvSpPr>
-        <p:spPr>
-          <a:xfrm>
-            <a:off x="2438400" y="4445000"/>
-            <a:ext cx="1524000" cy="1397000"/>
+          <p:cNvPr id="51" name="Shape 49"/>
+          <p:cNvSpPr/>
+          <p:nvPr/>
+        </p:nvSpPr>
+        <p:spPr>
+          <a:xfrm>
+            <a:off x="2438400" y="4191000"/>
+            <a:ext cx="1524000" cy="1651000"/>
           </a:xfrm>
           <a:prstGeom prst="roundRect">
             <a:avLst>
-              <a:gd name="adj" fmla="val 3927"/>
+              <a:gd name="adj" fmla="val 3600"/>
             </a:avLst>
           </a:prstGeom>
           <a:solidFill>
@@ -8225,13 +8290,13 @@
       </p:sp>
       <p:sp>
         <p:nvSpPr>
-          <p:cNvPr id="50" name="Text 48"/>
-          <p:cNvSpPr txBox="1"/>
-          <p:nvPr/>
-        </p:nvSpPr>
-        <p:spPr>
-          <a:xfrm>
-            <a:off x="2540000" y="4521200"/>
+          <p:cNvPr id="52" name="Text 50"/>
+          <p:cNvSpPr txBox="1"/>
+          <p:nvPr/>
+        </p:nvSpPr>
+        <p:spPr>
+          <a:xfrm>
+            <a:off x="2540000" y="4267200"/>
             <a:ext cx="1320800" cy="590550"/>
           </a:xfrm>
           <a:prstGeom prst="rect">
@@ -8307,7 +8372,7 @@
       </p:sp>
       <p:sp>
         <p:nvSpPr>
-          <p:cNvPr id="51" name="Shape 49"/>
+          <p:cNvPr id="53" name="Shape 51"/>
           <p:cNvSpPr/>
           <p:nvPr/>
         </p:nvSpPr>
@@ -8330,7 +8395,72 @@
       </p:sp>
       <p:sp>
         <p:nvSpPr>
-          <p:cNvPr id="52" name="Shape 50"/>
+          <p:cNvPr id="54" name="Text 52"/>
+          <p:cNvSpPr txBox="1"/>
+          <p:nvPr/>
+        </p:nvSpPr>
+        <p:spPr>
+          <a:xfrm>
+            <a:off x="2540000" y="4972050"/>
+            <a:ext cx="1320800" cy="203200"/>
+          </a:xfrm>
+          <a:prstGeom prst="rect">
+            <a:avLst/>
+          </a:prstGeom>
+          <a:noFill/>
+          <a:ln/>
+        </p:spPr>
+        <p:txBody>
+          <a:bodyPr wrap="square" lIns="0" tIns="0" rIns="0" bIns="0" rtlCol="0" anchor="t"/>
+          <a:lstStyle/>
+          <a:p>
+            <a:pPr algn="l" indent="0" marL="0">
+              <a:lnSpc>
+                <a:spcPct val="115000"/>
+              </a:lnSpc>
+              <a:buNone/>
+            </a:pPr>
+            <a:r>
+              <a:rPr lang="en-US" sz="1200" b="1" dirty="0">
+                <a:solidFill>
+                  <a:srgbClr val="A0521A"/>
+                </a:solidFill>
+                <a:latin typeface="Optimist Sans" pitchFamily="34" charset="0"/>
+                <a:ea typeface="Optimist Sans" pitchFamily="34" charset="-122"/>
+                <a:cs typeface="Optimist Sans" pitchFamily="34" charset="-120"/>
+              </a:rPr>
+              <a:t>BAU floor: [n]</a:t>
+            </a:r>
+            <a:endParaRPr lang="en-US" sz="1200" dirty="0"/>
+          </a:p>
+        </p:txBody>
+      </p:sp>
+      <p:sp>
+        <p:nvSpPr>
+          <p:cNvPr id="55" name="Shape 53"/>
+          <p:cNvSpPr/>
+          <p:nvPr/>
+        </p:nvSpPr>
+        <p:spPr>
+          <a:xfrm>
+            <a:off x="2540000" y="5327650"/>
+            <a:ext cx="1320800" cy="914"/>
+          </a:xfrm>
+          <a:prstGeom prst="line">
+            <a:avLst/>
+          </a:prstGeom>
+          <a:noFill/>
+          <a:ln w="19050">
+            <a:solidFill>
+              <a:srgbClr val="A0521A"/>
+            </a:solidFill>
+            <a:prstDash val="dash"/>
+          </a:ln>
+        </p:spPr>
+      </p:sp>
+      <p:sp>
+        <p:nvSpPr>
+          <p:cNvPr id="56" name="Shape 54"/>
           <p:cNvSpPr/>
           <p:nvPr/>
         </p:nvSpPr>
@@ -8350,7 +8480,7 @@
       </p:sp>
       <p:sp>
         <p:nvSpPr>
-          <p:cNvPr id="53" name="Text 51"/>
+          <p:cNvPr id="57" name="Text 55"/>
           <p:cNvSpPr txBox="1"/>
           <p:nvPr/>
         </p:nvSpPr>
@@ -8392,7 +8522,7 @@
       </p:sp>
       <p:sp>
         <p:nvSpPr>
-          <p:cNvPr id="54" name="Text 52"/>
+          <p:cNvPr id="58" name="Text 56"/>
           <p:cNvSpPr txBox="1"/>
           <p:nvPr/>
         </p:nvSpPr>
@@ -8434,7 +8564,7 @@
       </p:sp>
       <p:sp>
         <p:nvSpPr>
-          <p:cNvPr id="55" name="Shape 53"/>
+          <p:cNvPr id="59" name="Shape 57"/>
           <p:cNvSpPr/>
           <p:nvPr/>
         </p:nvSpPr>
@@ -8454,7 +8584,7 @@
       </p:sp>
       <p:sp>
         <p:nvSpPr>
-          <p:cNvPr id="56" name="Text 54"/>
+          <p:cNvPr id="60" name="Text 58"/>
           <p:cNvSpPr txBox="1"/>
           <p:nvPr/>
         </p:nvSpPr>
@@ -8496,7 +8626,7 @@
       </p:sp>
       <p:sp>
         <p:nvSpPr>
-          <p:cNvPr id="57" name="Text 55"/>
+          <p:cNvPr id="61" name="Text 59"/>
           <p:cNvSpPr txBox="1"/>
           <p:nvPr/>
         </p:nvSpPr>
@@ -8538,7 +8668,7 @@
       </p:sp>
       <p:sp>
         <p:nvSpPr>
-          <p:cNvPr id="58" name="Shape 56"/>
+          <p:cNvPr id="62" name="Shape 60"/>
           <p:cNvSpPr/>
           <p:nvPr/>
         </p:nvSpPr>
@@ -8558,7 +8688,7 @@
       </p:sp>
       <p:sp>
         <p:nvSpPr>
-          <p:cNvPr id="59" name="Text 57"/>
+          <p:cNvPr id="63" name="Text 61"/>
           <p:cNvSpPr txBox="1"/>
           <p:nvPr/>
         </p:nvSpPr>
@@ -8600,7 +8730,7 @@
       </p:sp>
       <p:sp>
         <p:nvSpPr>
-          <p:cNvPr id="60" name="Text 58"/>
+          <p:cNvPr id="64" name="Text 62"/>
           <p:cNvSpPr txBox="1"/>
           <p:nvPr/>
         </p:nvSpPr>
@@ -8642,18 +8772,18 @@
       </p:sp>
       <p:sp>
         <p:nvSpPr>
-          <p:cNvPr id="61" name="Shape 59"/>
-          <p:cNvSpPr/>
-          <p:nvPr/>
-        </p:nvSpPr>
-        <p:spPr>
-          <a:xfrm>
-            <a:off x="4064000" y="4445000"/>
-            <a:ext cx="1524000" cy="1397000"/>
+          <p:cNvPr id="65" name="Shape 63"/>
+          <p:cNvSpPr/>
+          <p:nvPr/>
+        </p:nvSpPr>
+        <p:spPr>
+          <a:xfrm>
+            <a:off x="4064000" y="4191000"/>
+            <a:ext cx="1524000" cy="1651000"/>
           </a:xfrm>
           <a:prstGeom prst="roundRect">
             <a:avLst>
-              <a:gd name="adj" fmla="val 3927"/>
+              <a:gd name="adj" fmla="val 3600"/>
             </a:avLst>
           </a:prstGeom>
           <a:solidFill>
@@ -8669,13 +8799,13 @@
       </p:sp>
       <p:sp>
         <p:nvSpPr>
-          <p:cNvPr id="62" name="Text 60"/>
-          <p:cNvSpPr txBox="1"/>
-          <p:nvPr/>
-        </p:nvSpPr>
-        <p:spPr>
-          <a:xfrm>
-            <a:off x="4165600" y="4521200"/>
+          <p:cNvPr id="66" name="Text 64"/>
+          <p:cNvSpPr txBox="1"/>
+          <p:nvPr/>
+        </p:nvSpPr>
+        <p:spPr>
+          <a:xfrm>
+            <a:off x="4165600" y="4267200"/>
             <a:ext cx="1320800" cy="590550"/>
           </a:xfrm>
           <a:prstGeom prst="rect">
@@ -8751,7 +8881,7 @@
       </p:sp>
       <p:sp>
         <p:nvSpPr>
-          <p:cNvPr id="63" name="Shape 61"/>
+          <p:cNvPr id="67" name="Shape 65"/>
           <p:cNvSpPr/>
           <p:nvPr/>
         </p:nvSpPr>
@@ -8774,7 +8904,72 @@
       </p:sp>
       <p:sp>
         <p:nvSpPr>
-          <p:cNvPr id="64" name="Shape 62"/>
+          <p:cNvPr id="68" name="Text 66"/>
+          <p:cNvSpPr txBox="1"/>
+          <p:nvPr/>
+        </p:nvSpPr>
+        <p:spPr>
+          <a:xfrm>
+            <a:off x="4165600" y="4972050"/>
+            <a:ext cx="1320800" cy="203200"/>
+          </a:xfrm>
+          <a:prstGeom prst="rect">
+            <a:avLst/>
+          </a:prstGeom>
+          <a:noFill/>
+          <a:ln/>
+        </p:spPr>
+        <p:txBody>
+          <a:bodyPr wrap="square" lIns="0" tIns="0" rIns="0" bIns="0" rtlCol="0" anchor="t"/>
+          <a:lstStyle/>
+          <a:p>
+            <a:pPr algn="l" indent="0" marL="0">
+              <a:lnSpc>
+                <a:spcPct val="115000"/>
+              </a:lnSpc>
+              <a:buNone/>
+            </a:pPr>
+            <a:r>
+              <a:rPr lang="en-US" sz="1200" b="1" dirty="0">
+                <a:solidFill>
+                  <a:srgbClr val="A0521A"/>
+                </a:solidFill>
+                <a:latin typeface="Optimist Sans" pitchFamily="34" charset="0"/>
+                <a:ea typeface="Optimist Sans" pitchFamily="34" charset="-122"/>
+                <a:cs typeface="Optimist Sans" pitchFamily="34" charset="-120"/>
+              </a:rPr>
+              <a:t>BAU floor: [n]</a:t>
+            </a:r>
+            <a:endParaRPr lang="en-US" sz="1200" dirty="0"/>
+          </a:p>
+        </p:txBody>
+      </p:sp>
+      <p:sp>
+        <p:nvSpPr>
+          <p:cNvPr id="69" name="Shape 67"/>
+          <p:cNvSpPr/>
+          <p:nvPr/>
+        </p:nvSpPr>
+        <p:spPr>
+          <a:xfrm>
+            <a:off x="4165600" y="5327650"/>
+            <a:ext cx="1320800" cy="914"/>
+          </a:xfrm>
+          <a:prstGeom prst="line">
+            <a:avLst/>
+          </a:prstGeom>
+          <a:noFill/>
+          <a:ln w="19050">
+            <a:solidFill>
+              <a:srgbClr val="A0521A"/>
+            </a:solidFill>
+            <a:prstDash val="dash"/>
+          </a:ln>
+        </p:spPr>
+      </p:sp>
+      <p:sp>
+        <p:nvSpPr>
+          <p:cNvPr id="70" name="Shape 68"/>
           <p:cNvSpPr/>
           <p:nvPr/>
         </p:nvSpPr>
@@ -8794,7 +8989,7 @@
       </p:sp>
       <p:sp>
         <p:nvSpPr>
-          <p:cNvPr id="65" name="Text 63"/>
+          <p:cNvPr id="71" name="Text 69"/>
           <p:cNvSpPr txBox="1"/>
           <p:nvPr/>
         </p:nvSpPr>
@@ -8836,7 +9031,7 @@
       </p:sp>
       <p:sp>
         <p:nvSpPr>
-          <p:cNvPr id="66" name="Text 64"/>
+          <p:cNvPr id="72" name="Text 70"/>
           <p:cNvSpPr txBox="1"/>
           <p:nvPr/>
         </p:nvSpPr>
@@ -8878,7 +9073,7 @@
       </p:sp>
       <p:sp>
         <p:nvSpPr>
-          <p:cNvPr id="67" name="Shape 65"/>
+          <p:cNvPr id="73" name="Shape 71"/>
           <p:cNvSpPr/>
           <p:nvPr/>
         </p:nvSpPr>
@@ -8898,7 +9093,7 @@
       </p:sp>
       <p:sp>
         <p:nvSpPr>
-          <p:cNvPr id="68" name="Text 66"/>
+          <p:cNvPr id="74" name="Text 72"/>
           <p:cNvSpPr txBox="1"/>
           <p:nvPr/>
         </p:nvSpPr>
@@ -8940,7 +9135,7 @@
       </p:sp>
       <p:sp>
         <p:nvSpPr>
-          <p:cNvPr id="69" name="Text 67"/>
+          <p:cNvPr id="75" name="Text 73"/>
           <p:cNvSpPr txBox="1"/>
           <p:nvPr/>
         </p:nvSpPr>
@@ -8982,7 +9177,7 @@
       </p:sp>
       <p:sp>
         <p:nvSpPr>
-          <p:cNvPr id="70" name="Shape 68"/>
+          <p:cNvPr id="76" name="Shape 74"/>
           <p:cNvSpPr/>
           <p:nvPr/>
         </p:nvSpPr>
@@ -9002,7 +9197,7 @@
       </p:sp>
       <p:sp>
         <p:nvSpPr>
-          <p:cNvPr id="71" name="Text 69"/>
+          <p:cNvPr id="77" name="Text 75"/>
           <p:cNvSpPr txBox="1"/>
           <p:nvPr/>
         </p:nvSpPr>
@@ -9044,7 +9239,7 @@
       </p:sp>
       <p:sp>
         <p:nvSpPr>
-          <p:cNvPr id="72" name="Text 70"/>
+          <p:cNvPr id="78" name="Text 76"/>
           <p:cNvSpPr txBox="1"/>
           <p:nvPr/>
         </p:nvSpPr>
@@ -9086,14 +9281,14 @@
       </p:sp>
       <p:sp>
         <p:nvSpPr>
-          <p:cNvPr id="73" name="Shape 71"/>
-          <p:cNvSpPr/>
-          <p:nvPr/>
-        </p:nvSpPr>
-        <p:spPr>
-          <a:xfrm>
-            <a:off x="5740400" y="3835400"/>
-            <a:ext cx="1778000" cy="2006600"/>
+          <p:cNvPr id="79" name="Shape 77"/>
+          <p:cNvSpPr/>
+          <p:nvPr/>
+        </p:nvSpPr>
+        <p:spPr>
+          <a:xfrm>
+            <a:off x="5740400" y="3581400"/>
+            <a:ext cx="1778000" cy="2260600"/>
           </a:xfrm>
           <a:prstGeom prst="roundRect">
             <a:avLst>
@@ -9113,13 +9308,13 @@
       </p:sp>
       <p:sp>
         <p:nvSpPr>
-          <p:cNvPr id="74" name="Text 72"/>
-          <p:cNvSpPr txBox="1"/>
-          <p:nvPr/>
-        </p:nvSpPr>
-        <p:spPr>
-          <a:xfrm>
-            <a:off x="5842000" y="3911600"/>
+          <p:cNvPr id="80" name="Text 78"/>
+          <p:cNvSpPr txBox="1"/>
+          <p:nvPr/>
+        </p:nvSpPr>
+        <p:spPr>
+          <a:xfrm>
+            <a:off x="5842000" y="3657600"/>
             <a:ext cx="1574800" cy="984250"/>
           </a:xfrm>
           <a:prstGeom prst="rect">
@@ -9235,7 +9430,7 @@
       </p:sp>
       <p:sp>
         <p:nvSpPr>
-          <p:cNvPr id="75" name="Shape 73"/>
+          <p:cNvPr id="81" name="Shape 79"/>
           <p:cNvSpPr/>
           <p:nvPr/>
         </p:nvSpPr>
@@ -9258,7 +9453,72 @@
       </p:sp>
       <p:sp>
         <p:nvSpPr>
-          <p:cNvPr id="76" name="Shape 74"/>
+          <p:cNvPr id="82" name="Text 80"/>
+          <p:cNvSpPr txBox="1"/>
+          <p:nvPr/>
+        </p:nvSpPr>
+        <p:spPr>
+          <a:xfrm>
+            <a:off x="5842000" y="4972050"/>
+            <a:ext cx="1574800" cy="203200"/>
+          </a:xfrm>
+          <a:prstGeom prst="rect">
+            <a:avLst/>
+          </a:prstGeom>
+          <a:noFill/>
+          <a:ln/>
+        </p:spPr>
+        <p:txBody>
+          <a:bodyPr wrap="square" lIns="0" tIns="0" rIns="0" bIns="0" rtlCol="0" anchor="t"/>
+          <a:lstStyle/>
+          <a:p>
+            <a:pPr algn="l" indent="0" marL="0">
+              <a:lnSpc>
+                <a:spcPct val="115000"/>
+              </a:lnSpc>
+              <a:buNone/>
+            </a:pPr>
+            <a:r>
+              <a:rPr lang="en-US" sz="1200" b="1" dirty="0">
+                <a:solidFill>
+                  <a:srgbClr val="A0521A"/>
+                </a:solidFill>
+                <a:latin typeface="Optimist Sans" pitchFamily="34" charset="0"/>
+                <a:ea typeface="Optimist Sans" pitchFamily="34" charset="-122"/>
+                <a:cs typeface="Optimist Sans" pitchFamily="34" charset="-120"/>
+              </a:rPr>
+              <a:t>BAU floor: [n]</a:t>
+            </a:r>
+            <a:endParaRPr lang="en-US" sz="1200" dirty="0"/>
+          </a:p>
+        </p:txBody>
+      </p:sp>
+      <p:sp>
+        <p:nvSpPr>
+          <p:cNvPr id="83" name="Shape 81"/>
+          <p:cNvSpPr/>
+          <p:nvPr/>
+        </p:nvSpPr>
+        <p:spPr>
+          <a:xfrm>
+            <a:off x="5842000" y="5327650"/>
+            <a:ext cx="1574800" cy="914"/>
+          </a:xfrm>
+          <a:prstGeom prst="line">
+            <a:avLst/>
+          </a:prstGeom>
+          <a:noFill/>
+          <a:ln w="19050">
+            <a:solidFill>
+              <a:srgbClr val="A0521A"/>
+            </a:solidFill>
+            <a:prstDash val="dash"/>
+          </a:ln>
+        </p:spPr>
+      </p:sp>
+      <p:sp>
+        <p:nvSpPr>
+          <p:cNvPr id="84" name="Shape 82"/>
           <p:cNvSpPr/>
           <p:nvPr/>
         </p:nvSpPr>
@@ -9278,7 +9538,7 @@
       </p:sp>
       <p:sp>
         <p:nvSpPr>
-          <p:cNvPr id="77" name="Text 75"/>
+          <p:cNvPr id="85" name="Text 83"/>
           <p:cNvSpPr txBox="1"/>
           <p:nvPr/>
         </p:nvSpPr>
@@ -9320,7 +9580,7 @@
       </p:sp>
       <p:sp>
         <p:nvSpPr>
-          <p:cNvPr id="78" name="Text 76"/>
+          <p:cNvPr id="86" name="Text 84"/>
           <p:cNvSpPr txBox="1"/>
           <p:nvPr/>
         </p:nvSpPr>
@@ -9362,7 +9622,7 @@
       </p:sp>
       <p:sp>
         <p:nvSpPr>
-          <p:cNvPr id="79" name="Shape 77"/>
+          <p:cNvPr id="87" name="Shape 85"/>
           <p:cNvSpPr/>
           <p:nvPr/>
         </p:nvSpPr>
@@ -9382,7 +9642,7 @@
       </p:sp>
       <p:sp>
         <p:nvSpPr>
-          <p:cNvPr id="80" name="Text 78"/>
+          <p:cNvPr id="88" name="Text 86"/>
           <p:cNvSpPr txBox="1"/>
           <p:nvPr/>
         </p:nvSpPr>
@@ -9424,7 +9684,7 @@
       </p:sp>
       <p:sp>
         <p:nvSpPr>
-          <p:cNvPr id="81" name="Text 79"/>
+          <p:cNvPr id="89" name="Text 87"/>
           <p:cNvSpPr txBox="1"/>
           <p:nvPr/>
         </p:nvSpPr>
@@ -9466,7 +9726,7 @@
       </p:sp>
       <p:sp>
         <p:nvSpPr>
-          <p:cNvPr id="82" name="Shape 80"/>
+          <p:cNvPr id="90" name="Shape 88"/>
           <p:cNvSpPr/>
           <p:nvPr/>
         </p:nvSpPr>
@@ -9486,7 +9746,7 @@
       </p:sp>
       <p:sp>
         <p:nvSpPr>
-          <p:cNvPr id="83" name="Text 81"/>
+          <p:cNvPr id="91" name="Text 89"/>
           <p:cNvSpPr txBox="1"/>
           <p:nvPr/>
         </p:nvSpPr>
@@ -9528,7 +9788,7 @@
       </p:sp>
       <p:sp>
         <p:nvSpPr>
-          <p:cNvPr id="84" name="Text 82"/>
+          <p:cNvPr id="92" name="Text 90"/>
           <p:cNvSpPr txBox="1"/>
           <p:nvPr/>
         </p:nvSpPr>
@@ -9570,14 +9830,14 @@
       </p:sp>
       <p:sp>
         <p:nvSpPr>
-          <p:cNvPr id="85" name="Shape 83"/>
-          <p:cNvSpPr/>
-          <p:nvPr/>
-        </p:nvSpPr>
-        <p:spPr>
-          <a:xfrm>
-            <a:off x="7670800" y="3835400"/>
-            <a:ext cx="1778000" cy="2006600"/>
+          <p:cNvPr id="93" name="Shape 91"/>
+          <p:cNvSpPr/>
+          <p:nvPr/>
+        </p:nvSpPr>
+        <p:spPr>
+          <a:xfrm>
+            <a:off x="7670800" y="3581400"/>
+            <a:ext cx="1778000" cy="2260600"/>
           </a:xfrm>
           <a:prstGeom prst="roundRect">
             <a:avLst>
@@ -9597,13 +9857,13 @@
       </p:sp>
       <p:sp>
         <p:nvSpPr>
-          <p:cNvPr id="86" name="Text 84"/>
-          <p:cNvSpPr txBox="1"/>
-          <p:nvPr/>
-        </p:nvSpPr>
-        <p:spPr>
-          <a:xfrm>
-            <a:off x="7772400" y="3911600"/>
+          <p:cNvPr id="94" name="Text 92"/>
+          <p:cNvSpPr txBox="1"/>
+          <p:nvPr/>
+        </p:nvSpPr>
+        <p:spPr>
+          <a:xfrm>
+            <a:off x="7772400" y="3657600"/>
             <a:ext cx="1574800" cy="984250"/>
           </a:xfrm>
           <a:prstGeom prst="rect">
@@ -9719,7 +9979,7 @@
       </p:sp>
       <p:sp>
         <p:nvSpPr>
-          <p:cNvPr id="87" name="Shape 85"/>
+          <p:cNvPr id="95" name="Shape 93"/>
           <p:cNvSpPr/>
           <p:nvPr/>
         </p:nvSpPr>
@@ -9742,7 +10002,72 @@
       </p:sp>
       <p:sp>
         <p:nvSpPr>
-          <p:cNvPr id="88" name="Shape 86"/>
+          <p:cNvPr id="96" name="Text 94"/>
+          <p:cNvSpPr txBox="1"/>
+          <p:nvPr/>
+        </p:nvSpPr>
+        <p:spPr>
+          <a:xfrm>
+            <a:off x="7772400" y="4972050"/>
+            <a:ext cx="1574800" cy="203200"/>
+          </a:xfrm>
+          <a:prstGeom prst="rect">
+            <a:avLst/>
+          </a:prstGeom>
+          <a:noFill/>
+          <a:ln/>
+        </p:spPr>
+        <p:txBody>
+          <a:bodyPr wrap="square" lIns="0" tIns="0" rIns="0" bIns="0" rtlCol="0" anchor="t"/>
+          <a:lstStyle/>
+          <a:p>
+            <a:pPr algn="l" indent="0" marL="0">
+              <a:lnSpc>
+                <a:spcPct val="115000"/>
+              </a:lnSpc>
+              <a:buNone/>
+            </a:pPr>
+            <a:r>
+              <a:rPr lang="en-US" sz="1200" b="1" dirty="0">
+                <a:solidFill>
+                  <a:srgbClr val="A0521A"/>
+                </a:solidFill>
+                <a:latin typeface="Optimist Sans" pitchFamily="34" charset="0"/>
+                <a:ea typeface="Optimist Sans" pitchFamily="34" charset="-122"/>
+                <a:cs typeface="Optimist Sans" pitchFamily="34" charset="-120"/>
+              </a:rPr>
+              <a:t>BAU floor: [n]</a:t>
+            </a:r>
+            <a:endParaRPr lang="en-US" sz="1200" dirty="0"/>
+          </a:p>
+        </p:txBody>
+      </p:sp>
+      <p:sp>
+        <p:nvSpPr>
+          <p:cNvPr id="97" name="Shape 95"/>
+          <p:cNvSpPr/>
+          <p:nvPr/>
+        </p:nvSpPr>
+        <p:spPr>
+          <a:xfrm>
+            <a:off x="7772400" y="5327650"/>
+            <a:ext cx="1574800" cy="914"/>
+          </a:xfrm>
+          <a:prstGeom prst="line">
+            <a:avLst/>
+          </a:prstGeom>
+          <a:noFill/>
+          <a:ln w="19050">
+            <a:solidFill>
+              <a:srgbClr val="A0521A"/>
+            </a:solidFill>
+            <a:prstDash val="dash"/>
+          </a:ln>
+        </p:spPr>
+      </p:sp>
+      <p:sp>
+        <p:nvSpPr>
+          <p:cNvPr id="98" name="Shape 96"/>
           <p:cNvSpPr/>
           <p:nvPr/>
         </p:nvSpPr>
@@ -9762,7 +10087,7 @@
       </p:sp>
       <p:sp>
         <p:nvSpPr>
-          <p:cNvPr id="89" name="Text 87"/>
+          <p:cNvPr id="99" name="Text 97"/>
           <p:cNvSpPr txBox="1"/>
           <p:nvPr/>
         </p:nvSpPr>
@@ -9804,7 +10129,7 @@
       </p:sp>
       <p:sp>
         <p:nvSpPr>
-          <p:cNvPr id="90" name="Text 88"/>
+          <p:cNvPr id="100" name="Text 98"/>
           <p:cNvSpPr txBox="1"/>
           <p:nvPr/>
         </p:nvSpPr>
@@ -9846,7 +10171,7 @@
       </p:sp>
       <p:sp>
         <p:nvSpPr>
-          <p:cNvPr id="91" name="Shape 89"/>
+          <p:cNvPr id="101" name="Shape 99"/>
           <p:cNvSpPr/>
           <p:nvPr/>
         </p:nvSpPr>
@@ -9866,7 +10191,7 @@
       </p:sp>
       <p:sp>
         <p:nvSpPr>
-          <p:cNvPr id="92" name="Text 90"/>
+          <p:cNvPr id="102" name="Text 100"/>
           <p:cNvSpPr txBox="1"/>
           <p:nvPr/>
         </p:nvSpPr>
@@ -9908,7 +10233,7 @@
       </p:sp>
       <p:sp>
         <p:nvSpPr>
-          <p:cNvPr id="93" name="Text 91"/>
+          <p:cNvPr id="103" name="Text 101"/>
           <p:cNvSpPr txBox="1"/>
           <p:nvPr/>
         </p:nvSpPr>
@@ -9950,7 +10275,7 @@
       </p:sp>
       <p:sp>
         <p:nvSpPr>
-          <p:cNvPr id="94" name="Shape 92"/>
+          <p:cNvPr id="104" name="Shape 102"/>
           <p:cNvSpPr/>
           <p:nvPr/>
         </p:nvSpPr>
@@ -9970,7 +10295,7 @@
       </p:sp>
       <p:sp>
         <p:nvSpPr>
-          <p:cNvPr id="95" name="Text 93"/>
+          <p:cNvPr id="105" name="Text 103"/>
           <p:cNvSpPr txBox="1"/>
           <p:nvPr/>
         </p:nvSpPr>
@@ -10012,7 +10337,7 @@
       </p:sp>
       <p:sp>
         <p:nvSpPr>
-          <p:cNvPr id="96" name="Text 94"/>
+          <p:cNvPr id="106" name="Text 104"/>
           <p:cNvSpPr txBox="1"/>
           <p:nvPr/>
         </p:nvSpPr>
@@ -10054,14 +10379,14 @@
       </p:sp>
       <p:sp>
         <p:nvSpPr>
-          <p:cNvPr id="97" name="Shape 95"/>
-          <p:cNvSpPr/>
-          <p:nvPr/>
-        </p:nvSpPr>
-        <p:spPr>
-          <a:xfrm>
-            <a:off x="9601200" y="3835400"/>
-            <a:ext cx="1778000" cy="2006600"/>
+          <p:cNvPr id="107" name="Shape 105"/>
+          <p:cNvSpPr/>
+          <p:nvPr/>
+        </p:nvSpPr>
+        <p:spPr>
+          <a:xfrm>
+            <a:off x="9601200" y="3581400"/>
+            <a:ext cx="1778000" cy="2260600"/>
           </a:xfrm>
           <a:prstGeom prst="roundRect">
             <a:avLst>
@@ -10081,13 +10406,13 @@
       </p:sp>
       <p:sp>
         <p:nvSpPr>
-          <p:cNvPr id="98" name="Text 96"/>
-          <p:cNvSpPr txBox="1"/>
-          <p:nvPr/>
-        </p:nvSpPr>
-        <p:spPr>
-          <a:xfrm>
-            <a:off x="9702800" y="3911600"/>
+          <p:cNvPr id="108" name="Text 106"/>
+          <p:cNvSpPr txBox="1"/>
+          <p:nvPr/>
+        </p:nvSpPr>
+        <p:spPr>
+          <a:xfrm>
+            <a:off x="9702800" y="3657600"/>
             <a:ext cx="1574800" cy="984250"/>
           </a:xfrm>
           <a:prstGeom prst="rect">
@@ -10203,7 +10528,7 @@
       </p:sp>
       <p:sp>
         <p:nvSpPr>
-          <p:cNvPr id="99" name="Shape 97"/>
+          <p:cNvPr id="109" name="Shape 107"/>
           <p:cNvSpPr/>
           <p:nvPr/>
         </p:nvSpPr>
@@ -10226,7 +10551,49 @@
       </p:sp>
       <p:sp>
         <p:nvSpPr>
-          <p:cNvPr id="100" name="Shape 98"/>
+          <p:cNvPr id="110" name="Text 108"/>
+          <p:cNvSpPr txBox="1"/>
+          <p:nvPr/>
+        </p:nvSpPr>
+        <p:spPr>
+          <a:xfrm>
+            <a:off x="9702800" y="4972050"/>
+            <a:ext cx="1574800" cy="203200"/>
+          </a:xfrm>
+          <a:prstGeom prst="rect">
+            <a:avLst/>
+          </a:prstGeom>
+          <a:noFill/>
+          <a:ln/>
+        </p:spPr>
+        <p:txBody>
+          <a:bodyPr wrap="square" lIns="0" tIns="0" rIns="0" bIns="0" rtlCol="0" anchor="t"/>
+          <a:lstStyle/>
+          <a:p>
+            <a:pPr algn="l" indent="0" marL="0">
+              <a:lnSpc>
+                <a:spcPct val="115000"/>
+              </a:lnSpc>
+              <a:buNone/>
+            </a:pPr>
+            <a:r>
+              <a:rPr lang="en-US" sz="1200" dirty="0">
+                <a:solidFill>
+                  <a:srgbClr val="6B7280"/>
+                </a:solidFill>
+                <a:latin typeface="Optimist Sans" pitchFamily="34" charset="0"/>
+                <a:ea typeface="Optimist Sans" pitchFamily="34" charset="-122"/>
+                <a:cs typeface="Optimist Sans" pitchFamily="34" charset="-120"/>
+              </a:rPr>
+              <a:t>No BAU floor</a:t>
+            </a:r>
+            <a:endParaRPr lang="en-US" sz="1200" dirty="0"/>
+          </a:p>
+        </p:txBody>
+      </p:sp>
+      <p:sp>
+        <p:nvSpPr>
+          <p:cNvPr id="111" name="Shape 109"/>
           <p:cNvSpPr/>
           <p:nvPr/>
         </p:nvSpPr>
@@ -10246,7 +10613,7 @@
       </p:sp>
       <p:sp>
         <p:nvSpPr>
-          <p:cNvPr id="101" name="Text 99"/>
+          <p:cNvPr id="112" name="Text 110"/>
           <p:cNvSpPr txBox="1"/>
           <p:nvPr/>
         </p:nvSpPr>
@@ -10288,7 +10655,7 @@
       </p:sp>
       <p:sp>
         <p:nvSpPr>
-          <p:cNvPr id="102" name="Text 100"/>
+          <p:cNvPr id="113" name="Text 111"/>
           <p:cNvSpPr txBox="1"/>
           <p:nvPr/>
         </p:nvSpPr>
@@ -10330,7 +10697,7 @@
       </p:sp>
       <p:sp>
         <p:nvSpPr>
-          <p:cNvPr id="103" name="Shape 101"/>
+          <p:cNvPr id="114" name="Shape 112"/>
           <p:cNvSpPr/>
           <p:nvPr/>
         </p:nvSpPr>
@@ -10350,7 +10717,7 @@
       </p:sp>
       <p:sp>
         <p:nvSpPr>
-          <p:cNvPr id="104" name="Text 102"/>
+          <p:cNvPr id="115" name="Text 113"/>
           <p:cNvSpPr txBox="1"/>
           <p:nvPr/>
         </p:nvSpPr>
@@ -10392,7 +10759,7 @@
       </p:sp>
       <p:sp>
         <p:nvSpPr>
-          <p:cNvPr id="105" name="Text 103"/>
+          <p:cNvPr id="116" name="Text 114"/>
           <p:cNvSpPr txBox="1"/>
           <p:nvPr/>
         </p:nvSpPr>
@@ -10434,7 +10801,7 @@
       </p:sp>
       <p:sp>
         <p:nvSpPr>
-          <p:cNvPr id="106" name="Shape 104"/>
+          <p:cNvPr id="117" name="Shape 115"/>
           <p:cNvSpPr/>
           <p:nvPr/>
         </p:nvSpPr>
@@ -10454,7 +10821,7 @@
       </p:sp>
       <p:sp>
         <p:nvSpPr>
-          <p:cNvPr id="107" name="Text 105"/>
+          <p:cNvPr id="118" name="Text 116"/>
           <p:cNvSpPr txBox="1"/>
           <p:nvPr/>
         </p:nvSpPr>
@@ -10496,7 +10863,7 @@
       </p:sp>
       <p:sp>
         <p:nvSpPr>
-          <p:cNvPr id="108" name="Text 106"/>
+          <p:cNvPr id="119" name="Text 117"/>
           <p:cNvSpPr txBox="1"/>
           <p:nvPr/>
         </p:nvSpPr>
@@ -10538,13 +10905,13 @@
       </p:sp>
       <p:sp>
         <p:nvSpPr>
-          <p:cNvPr id="109" name="Shape 107"/>
-          <p:cNvSpPr/>
-          <p:nvPr/>
-        </p:nvSpPr>
-        <p:spPr>
-          <a:xfrm>
-            <a:off x="4445000" y="1949450"/>
+          <p:cNvPr id="120" name="Shape 118"/>
+          <p:cNvSpPr/>
+          <p:nvPr/>
+        </p:nvSpPr>
+        <p:spPr>
+          <a:xfrm>
+            <a:off x="4445000" y="1758950"/>
             <a:ext cx="127000" cy="127000"/>
           </a:xfrm>
           <a:prstGeom prst="rect">
@@ -10558,13 +10925,13 @@
       </p:sp>
       <p:sp>
         <p:nvSpPr>
-          <p:cNvPr id="110" name="Text 108"/>
-          <p:cNvSpPr txBox="1"/>
-          <p:nvPr/>
-        </p:nvSpPr>
-        <p:spPr>
-          <a:xfrm>
-            <a:off x="4635500" y="1905000"/>
+          <p:cNvPr id="121" name="Text 119"/>
+          <p:cNvSpPr txBox="1"/>
+          <p:nvPr/>
+        </p:nvSpPr>
+        <p:spPr>
+          <a:xfrm>
+            <a:off x="4635500" y="1714500"/>
             <a:ext cx="635000" cy="215900"/>
           </a:xfrm>
           <a:prstGeom prst="rect">
@@ -10600,13 +10967,13 @@
       </p:sp>
       <p:sp>
         <p:nvSpPr>
-          <p:cNvPr id="111" name="Shape 109"/>
-          <p:cNvSpPr/>
-          <p:nvPr/>
-        </p:nvSpPr>
-        <p:spPr>
-          <a:xfrm>
-            <a:off x="5334000" y="1949450"/>
+          <p:cNvPr id="122" name="Shape 120"/>
+          <p:cNvSpPr/>
+          <p:nvPr/>
+        </p:nvSpPr>
+        <p:spPr>
+          <a:xfrm>
+            <a:off x="5334000" y="1758950"/>
             <a:ext cx="127000" cy="127000"/>
           </a:xfrm>
           <a:prstGeom prst="rect">
@@ -10620,13 +10987,13 @@
       </p:sp>
       <p:sp>
         <p:nvSpPr>
-          <p:cNvPr id="112" name="Text 110"/>
-          <p:cNvSpPr txBox="1"/>
-          <p:nvPr/>
-        </p:nvSpPr>
-        <p:spPr>
-          <a:xfrm>
-            <a:off x="5524500" y="1905000"/>
+          <p:cNvPr id="123" name="Text 121"/>
+          <p:cNvSpPr txBox="1"/>
+          <p:nvPr/>
+        </p:nvSpPr>
+        <p:spPr>
+          <a:xfrm>
+            <a:off x="5524500" y="1714500"/>
             <a:ext cx="1270000" cy="215900"/>
           </a:xfrm>
           <a:prstGeom prst="rect">
@@ -10662,13 +11029,13 @@
       </p:sp>
       <p:sp>
         <p:nvSpPr>
-          <p:cNvPr id="113" name="Shape 111"/>
-          <p:cNvSpPr/>
-          <p:nvPr/>
-        </p:nvSpPr>
-        <p:spPr>
-          <a:xfrm>
-            <a:off x="6858000" y="1949450"/>
+          <p:cNvPr id="124" name="Shape 122"/>
+          <p:cNvSpPr/>
+          <p:nvPr/>
+        </p:nvSpPr>
+        <p:spPr>
+          <a:xfrm>
+            <a:off x="6858000" y="1758950"/>
             <a:ext cx="127000" cy="127000"/>
           </a:xfrm>
           <a:prstGeom prst="rect">
@@ -10682,13 +11049,13 @@
       </p:sp>
       <p:sp>
         <p:nvSpPr>
-          <p:cNvPr id="114" name="Text 112"/>
-          <p:cNvSpPr txBox="1"/>
-          <p:nvPr/>
-        </p:nvSpPr>
-        <p:spPr>
-          <a:xfrm>
-            <a:off x="7048500" y="1905000"/>
+          <p:cNvPr id="125" name="Text 123"/>
+          <p:cNvSpPr txBox="1"/>
+          <p:nvPr/>
+        </p:nvSpPr>
+        <p:spPr>
+          <a:xfrm>
+            <a:off x="7048500" y="1714500"/>
             <a:ext cx="1651000" cy="215900"/>
           </a:xfrm>
           <a:prstGeom prst="rect">
@@ -10724,13 +11091,13 @@
       </p:sp>
       <p:sp>
         <p:nvSpPr>
-          <p:cNvPr id="115" name="Shape 113"/>
-          <p:cNvSpPr/>
-          <p:nvPr/>
-        </p:nvSpPr>
-        <p:spPr>
-          <a:xfrm>
-            <a:off x="8763000" y="1949450"/>
+          <p:cNvPr id="126" name="Shape 124"/>
+          <p:cNvSpPr/>
+          <p:nvPr/>
+        </p:nvSpPr>
+        <p:spPr>
+          <a:xfrm>
+            <a:off x="8763000" y="1758950"/>
             <a:ext cx="127000" cy="127000"/>
           </a:xfrm>
           <a:prstGeom prst="rect">
@@ -10744,13 +11111,13 @@
       </p:sp>
       <p:sp>
         <p:nvSpPr>
-          <p:cNvPr id="116" name="Text 114"/>
-          <p:cNvSpPr txBox="1"/>
-          <p:nvPr/>
-        </p:nvSpPr>
-        <p:spPr>
-          <a:xfrm>
-            <a:off x="8953500" y="1905000"/>
+          <p:cNvPr id="127" name="Text 125"/>
+          <p:cNvSpPr txBox="1"/>
+          <p:nvPr/>
+        </p:nvSpPr>
+        <p:spPr>
+          <a:xfrm>
+            <a:off x="8953500" y="1714500"/>
             <a:ext cx="1905000" cy="215900"/>
           </a:xfrm>
           <a:prstGeom prst="rect">
@@ -10786,7 +11153,49 @@
       </p:sp>
       <p:sp>
         <p:nvSpPr>
-          <p:cNvPr id="117" name="Text 115"/>
+          <p:cNvPr id="128" name="Text 126"/>
+          <p:cNvSpPr txBox="1"/>
+          <p:nvPr/>
+        </p:nvSpPr>
+        <p:spPr>
+          <a:xfrm>
+            <a:off x="812800" y="1714500"/>
+            <a:ext cx="3556000" cy="215900"/>
+          </a:xfrm>
+          <a:prstGeom prst="rect">
+            <a:avLst/>
+          </a:prstGeom>
+          <a:noFill/>
+          <a:ln/>
+        </p:spPr>
+        <p:txBody>
+          <a:bodyPr wrap="square" lIns="0" tIns="0" rIns="0" bIns="0" rtlCol="0" anchor="t"/>
+          <a:lstStyle/>
+          <a:p>
+            <a:pPr algn="l" indent="0" marL="0">
+              <a:lnSpc>
+                <a:spcPct val="115000"/>
+              </a:lnSpc>
+              <a:buNone/>
+            </a:pPr>
+            <a:r>
+              <a:rPr lang="en-US" sz="1200" b="1" dirty="0">
+                <a:solidFill>
+                  <a:srgbClr val="A0521A"/>
+                </a:solidFill>
+                <a:latin typeface="Optimist Sans" pitchFamily="34" charset="0"/>
+                <a:ea typeface="Optimist Sans" pitchFamily="34" charset="-122"/>
+                <a:cs typeface="Optimist Sans" pitchFamily="34" charset="-120"/>
+              </a:rPr>
+              <a:t>Sum of BAU floors: [n] → slide 5</a:t>
+            </a:r>
+            <a:endParaRPr lang="en-US" sz="1200" dirty="0"/>
+          </a:p>
+        </p:txBody>
+      </p:sp>
+      <p:sp>
+        <p:nvSpPr>
+          <p:cNvPr id="129" name="Text 127"/>
           <p:cNvSpPr txBox="1"/>
           <p:nvPr/>
         </p:nvSpPr>
@@ -10820,7 +11229,7 @@
                 <a:ea typeface="Optimist Sans" pitchFamily="34" charset="-122"/>
                 <a:cs typeface="Optimist Sans" pitchFamily="34" charset="-120"/>
               </a:rPr>
-              <a:t>Draft for discussion · Bars show year-end headcount · Expected departures of [XYZ] associates are counted as backfill openings</a:t>
+              <a:t>Draft for discussion · Bars = year-end headcount; dashed line = BAU floor · Expected departures of [XYZ] are counted as backfills</a:t>
             </a:r>
             <a:endParaRPr lang="en-US" sz="1200" dirty="0"/>
           </a:p>
@@ -11747,7 +12156,7 @@
         <p:spPr>
           <a:xfrm>
             <a:off x="4064000" y="4191000"/>
-            <a:ext cx="3302000" cy="228600"/>
+            <a:ext cx="4826000" cy="228600"/>
           </a:xfrm>
           <a:prstGeom prst="rect">
             <a:avLst/>
@@ -11774,7 +12183,7 @@
                 <a:ea typeface="Optimist Sans" pitchFamily="34" charset="-122"/>
                 <a:cs typeface="Optimist Sans" pitchFamily="34" charset="-120"/>
               </a:rPr>
-              <a:t>↑ BAU floor: key-person / op risk</a:t>
+              <a:t>↑ BAU floor = [n]: sum of team floors (slide 4)</a:t>
             </a:r>
             <a:endParaRPr lang="en-US" sz="1200" dirty="0"/>
           </a:p>

</xml_diff>

<commit_message>
Keep 2028 targets visibly above each team's BAU floor
Co-Authored-By: Claude Opus 5.5 <noreply@anthropic.com>
Claude-Session: https://claude.ai/code/session_01JXKaD9UU8MgeRWUr7sq4Za
</commit_message>
<xml_diff>
--- a/Unified Team Strategy.pptx
+++ b/Unified Team Strategy.pptx
@@ -116,13 +116,13 @@
   <p:extLst>
     <p:ext uri="{521415D9-36F7-43E2-AB2F-B90AF26B5E84}">
       <p14:sectionLst xmlns:p14="http://schemas.microsoft.com/office/powerpoint/2010/main">
-        <p14:section name="Why combine" id="{15d7a3db-7f25-a380-bb9d-4503745113cc}">
+        <p14:section name="Why combine" id="{4e231e59-0a51-21a9-e6b6-79331562bc7a}">
           <p14:sldIdLst>
             <p14:sldId id="256"/>
             <p14:sldId id="257"/>
           </p14:sldIdLst>
         </p14:section>
-        <p14:section name="How we organize" id="{0f4c5231-9495-89af-141f-1004c6ec021d}">
+        <p14:section name="How we organize" id="{e077bc45-ad83-1c5f-4c42-072fbfbc0676}">
           <p14:sldIdLst>
             <p14:sldId id="258"/>
             <p14:sldId id="259"/>
@@ -130,14 +130,14 @@
             <p14:sldId id="261"/>
           </p14:sldIdLst>
         </p14:section>
-        <p14:section name="What we do and how we grow" id="{c738f1fb-9b39-560a-de24-3e67785d9798}">
+        <p14:section name="What we do and how we grow" id="{7c4b7331-3f34-8086-eb6a-05fc7c6465f7}">
           <p14:sldIdLst>
             <p14:sldId id="262"/>
             <p14:sldId id="263"/>
             <p14:sldId id="264"/>
           </p14:sldIdLst>
         </p14:section>
-        <p14:section name="Asks" id="{6df04c57-8b74-defb-120b-b0ea82358290}">
+        <p14:section name="Asks" id="{5d41eab6-910a-a556-a483-9794fb32a526}">
           <p14:sldIdLst>
             <p14:sldId id="265"/>
           </p14:sldIdLst>
@@ -898,7 +898,7 @@
           <a:p>
             <a:r>
               <a:rPr lang="en-US" dirty="0"/>
-              <a:t>This slide turns the four-function structure into the actual team: one team lead, four sub-team heads, and three sub-teams under Modeling, each with its own lead and level. Each box lists every member with their level, with open roles color-coded in three types: a backfill (rust) replaces a departing person one-for-one to do the same job, and expected departures of [XYZ] associates are already counted; a converted backfill (teal) takes a departure from another team and repurposes the role, mainly into AI Enablement; a new investment (plum) is genuinely new budget and should be rare. Each BAU team also shows its floor: the minimum headcount it needs to manage key-person and operational risk, drawn as a dashed line on its bars. AI Enablement has no BAU floor. The team floors add up to the BAU floor on the next slide. Then a small bar strip with year-end headcount for this year, next year and the year after. Modeling, Data Foundation and Platform &amp; Deployment get smaller over time as AI takes on BAU work; AI Enablement grows. The next slide rolls these team-level numbers up into the overall picture.</a:t>
+              <a:t>This slide turns the four-function structure into the actual team: one team lead, four sub-team heads, and three sub-teams under Modeling, each with its own lead and level. Each box lists every member with their level, with open roles color-coded in three types: a backfill (rust) replaces a departing person one-for-one to do the same job, and expected departures of [XYZ] associates are already counted; a converted backfill (teal) takes a departure from another team and repurposes the role, mainly into AI Enablement; a new investment (plum) is genuinely new budget and should be rare. Each BAU team also shows its floor: the minimum headcount it needs to manage key-person and operational risk, drawn as a dashed line on its bars. Each team’s 2028 target stays above its floor, never at or below it. AI Enablement has no BAU floor. The team floors add up to the BAU floor on the next slide. Then a small bar strip with year-end headcount for this year, next year and the year after. Modeling, Data Foundation and Platform &amp; Deployment get smaller over time as AI takes on BAU work; AI Enablement grows. The next slide rolls these team-level numbers up into the overall picture.</a:t>
             </a:r>
             <a:endParaRPr lang="en-US" dirty="0"/>
           </a:p>
@@ -986,7 +986,7 @@
           <a:p>
             <a:r>
               <a:rPr lang="en-US" dirty="0"/>
-              <a:t>This rolls up the team-by-team plan on the previous slide. The end-2026 count includes open roles; 2027 and 2028 assume every role is filled. The story, from the end of this year to the end of 2028: today almost all capacity goes to BAU, and dedicated AI work is near zero. AI and new tooling let BAU shrink step by step (the end of 2027 shows the midpoint), but only down to a floor. That floor, [n] people, is the sum of the team-level floors on the previous slide: the minimum BAU team we need to manage operational risk: critical functions like model deployment must never depend on one person whose departure takes all the knowledge with them. Rotation and cross-functional mixing keep that floor as low as safely possible, but we will not go below it. Everything freed above the floor moves to AI-focused work, the change-the-business end of the structure. Any net headcount reduction is a by-product, shown as the dashed box.</a:t>
+              <a:t>This rolls up the team-by-team plan on the previous slide. The end-2026 count includes open roles; 2027 and 2028 assume every role is filled. The story, from the end of this year to the end of 2028: today almost all capacity goes to BAU, and dedicated AI work is near zero. AI and new tooling let BAU shrink step by step (the end of 2027 shows the midpoint), but only down to a floor. That floor, [n] people, is the sum of the team-level floors on the previous slide: the minimum BAU team we need to manage operational risk: critical functions like model deployment must never depend on one person whose departure takes all the knowledge with them. Rotation and cross-functional mixing keep that floor as low as safely possible, but we will not go below it, and the 2028 target deliberately sits above it. Everything freed above the floor moves to AI-focused work, the change-the-business end of the structure. Any net headcount reduction is a by-product, shown as the dashed box.</a:t>
             </a:r>
             <a:endParaRPr lang="en-US" dirty="0"/>
           </a:p>
@@ -7934,7 +7934,7 @@
         </p:nvSpPr>
         <p:spPr>
           <a:xfrm>
-            <a:off x="914400" y="5327650"/>
+            <a:off x="914400" y="5365750"/>
             <a:ext cx="1320800" cy="914"/>
           </a:xfrm>
           <a:prstGeom prst="line">
@@ -7957,8 +7957,8 @@
         </p:nvSpPr>
         <p:spPr>
           <a:xfrm>
-            <a:off x="1066800" y="5264150"/>
-            <a:ext cx="203200" cy="152400"/>
+            <a:off x="1066800" y="5251450"/>
+            <a:ext cx="203200" cy="165100"/>
           </a:xfrm>
           <a:prstGeom prst="rect">
             <a:avLst/>
@@ -8061,8 +8061,8 @@
         </p:nvSpPr>
         <p:spPr>
           <a:xfrm>
-            <a:off x="1473200" y="5302250"/>
-            <a:ext cx="203200" cy="114300"/>
+            <a:off x="1473200" y="5289550"/>
+            <a:ext cx="203200" cy="127000"/>
           </a:xfrm>
           <a:prstGeom prst="rect">
             <a:avLst/>
@@ -8165,8 +8165,8 @@
         </p:nvSpPr>
         <p:spPr>
           <a:xfrm>
-            <a:off x="1879600" y="5340350"/>
-            <a:ext cx="203200" cy="76200"/>
+            <a:off x="1879600" y="5327650"/>
+            <a:ext cx="203200" cy="88900"/>
           </a:xfrm>
           <a:prstGeom prst="rect">
             <a:avLst/>
@@ -8443,7 +8443,7 @@
         </p:nvSpPr>
         <p:spPr>
           <a:xfrm>
-            <a:off x="2540000" y="5327650"/>
+            <a:off x="2540000" y="5365750"/>
             <a:ext cx="1320800" cy="914"/>
           </a:xfrm>
           <a:prstGeom prst="line">
@@ -8466,8 +8466,8 @@
         </p:nvSpPr>
         <p:spPr>
           <a:xfrm>
-            <a:off x="2692400" y="5264150"/>
-            <a:ext cx="203200" cy="152400"/>
+            <a:off x="2692400" y="5251450"/>
+            <a:ext cx="203200" cy="165100"/>
           </a:xfrm>
           <a:prstGeom prst="rect">
             <a:avLst/>
@@ -8570,8 +8570,8 @@
         </p:nvSpPr>
         <p:spPr>
           <a:xfrm>
-            <a:off x="3098800" y="5302250"/>
-            <a:ext cx="203200" cy="114300"/>
+            <a:off x="3098800" y="5289550"/>
+            <a:ext cx="203200" cy="127000"/>
           </a:xfrm>
           <a:prstGeom prst="rect">
             <a:avLst/>
@@ -8674,8 +8674,8 @@
         </p:nvSpPr>
         <p:spPr>
           <a:xfrm>
-            <a:off x="3505200" y="5340350"/>
-            <a:ext cx="203200" cy="76200"/>
+            <a:off x="3505200" y="5327650"/>
+            <a:ext cx="203200" cy="88900"/>
           </a:xfrm>
           <a:prstGeom prst="rect">
             <a:avLst/>
@@ -8952,7 +8952,7 @@
         </p:nvSpPr>
         <p:spPr>
           <a:xfrm>
-            <a:off x="4165600" y="5327650"/>
+            <a:off x="4165600" y="5365750"/>
             <a:ext cx="1320800" cy="914"/>
           </a:xfrm>
           <a:prstGeom prst="line">
@@ -8975,8 +8975,8 @@
         </p:nvSpPr>
         <p:spPr>
           <a:xfrm>
-            <a:off x="4318000" y="5264150"/>
-            <a:ext cx="203200" cy="152400"/>
+            <a:off x="4318000" y="5251450"/>
+            <a:ext cx="203200" cy="165100"/>
           </a:xfrm>
           <a:prstGeom prst="rect">
             <a:avLst/>
@@ -9079,8 +9079,8 @@
         </p:nvSpPr>
         <p:spPr>
           <a:xfrm>
-            <a:off x="4724400" y="5302250"/>
-            <a:ext cx="203200" cy="114300"/>
+            <a:off x="4724400" y="5289550"/>
+            <a:ext cx="203200" cy="127000"/>
           </a:xfrm>
           <a:prstGeom prst="rect">
             <a:avLst/>
@@ -9183,8 +9183,8 @@
         </p:nvSpPr>
         <p:spPr>
           <a:xfrm>
-            <a:off x="5130800" y="5340350"/>
-            <a:ext cx="203200" cy="76200"/>
+            <a:off x="5130800" y="5327650"/>
+            <a:ext cx="203200" cy="88900"/>
           </a:xfrm>
           <a:prstGeom prst="rect">
             <a:avLst/>
@@ -9501,7 +9501,7 @@
         </p:nvSpPr>
         <p:spPr>
           <a:xfrm>
-            <a:off x="5842000" y="5327650"/>
+            <a:off x="5842000" y="5365750"/>
             <a:ext cx="1574800" cy="914"/>
           </a:xfrm>
           <a:prstGeom prst="line">
@@ -9524,8 +9524,8 @@
         </p:nvSpPr>
         <p:spPr>
           <a:xfrm>
-            <a:off x="6121400" y="5264150"/>
-            <a:ext cx="203200" cy="152400"/>
+            <a:off x="6121400" y="5251450"/>
+            <a:ext cx="203200" cy="165100"/>
           </a:xfrm>
           <a:prstGeom prst="rect">
             <a:avLst/>
@@ -9628,8 +9628,8 @@
         </p:nvSpPr>
         <p:spPr>
           <a:xfrm>
-            <a:off x="6527800" y="5302250"/>
-            <a:ext cx="203200" cy="114300"/>
+            <a:off x="6527800" y="5289550"/>
+            <a:ext cx="203200" cy="127000"/>
           </a:xfrm>
           <a:prstGeom prst="rect">
             <a:avLst/>
@@ -9732,8 +9732,8 @@
         </p:nvSpPr>
         <p:spPr>
           <a:xfrm>
-            <a:off x="6934200" y="5340350"/>
-            <a:ext cx="203200" cy="76200"/>
+            <a:off x="6934200" y="5327650"/>
+            <a:ext cx="203200" cy="88900"/>
           </a:xfrm>
           <a:prstGeom prst="rect">
             <a:avLst/>
@@ -10050,7 +10050,7 @@
         </p:nvSpPr>
         <p:spPr>
           <a:xfrm>
-            <a:off x="7772400" y="5327650"/>
+            <a:off x="7772400" y="5365750"/>
             <a:ext cx="1574800" cy="914"/>
           </a:xfrm>
           <a:prstGeom prst="line">
@@ -10073,8 +10073,8 @@
         </p:nvSpPr>
         <p:spPr>
           <a:xfrm>
-            <a:off x="8051800" y="5264150"/>
-            <a:ext cx="203200" cy="152400"/>
+            <a:off x="8051800" y="5251450"/>
+            <a:ext cx="203200" cy="165100"/>
           </a:xfrm>
           <a:prstGeom prst="rect">
             <a:avLst/>
@@ -10177,8 +10177,8 @@
         </p:nvSpPr>
         <p:spPr>
           <a:xfrm>
-            <a:off x="8458200" y="5302250"/>
-            <a:ext cx="203200" cy="114300"/>
+            <a:off x="8458200" y="5289550"/>
+            <a:ext cx="203200" cy="127000"/>
           </a:xfrm>
           <a:prstGeom prst="rect">
             <a:avLst/>
@@ -10281,8 +10281,8 @@
         </p:nvSpPr>
         <p:spPr>
           <a:xfrm>
-            <a:off x="8864600" y="5340350"/>
-            <a:ext cx="203200" cy="76200"/>
+            <a:off x="8864600" y="5327650"/>
+            <a:ext cx="203200" cy="88900"/>
           </a:xfrm>
           <a:prstGeom prst="rect">
             <a:avLst/>

</xml_diff>